<commit_message>
Prepare verified hackathon deck and three-minute demo
</commit_message>
<xml_diff>
--- a/artifacts/scamshield-hack2skill-submission.pptx
+++ b/artifacts/scamshield-hack2skill-submission.pptx
@@ -822,7 +822,7 @@
   <p:cSld>
     <p:spTree>
       <p:nvGrpSpPr>
-        <p:cNvPr id="127" name="Shape 127"/>
+        <p:cNvPr id="150" name="Shape 150"/>
         <p:cNvGrpSpPr/>
         <p:nvPr/>
       </p:nvGrpSpPr>
@@ -836,7 +836,7 @@
       </p:grpSpPr>
       <p:sp>
         <p:nvSpPr>
-          <p:cNvPr id="128" name="Google Shape;128;g3fb085bff3c_0_41:notes"/>
+          <p:cNvPr id="151" name="Google Shape;151;g3fb085bff3c_0_41:notes"/>
           <p:cNvSpPr/>
           <p:nvPr>
             <p:ph idx="2" type="sldImg"/>
@@ -871,7 +871,7 @@
       </p:sp>
       <p:sp>
         <p:nvSpPr>
-          <p:cNvPr id="129" name="Google Shape;129;g3fb085bff3c_0_41:notes"/>
+          <p:cNvPr id="152" name="Google Shape;152;g3fb085bff3c_0_41:notes"/>
           <p:cNvSpPr txBox="1"/>
           <p:nvPr>
             <p:ph idx="1" type="body"/>
@@ -903,7 +903,7 @@
             </a:pPr>
             <a:r>
               <a:rPr lang="en-GB"/>
-              <a:t>Gemini API pricing: https://ai.google.dev/gemini-api/docs/pricing. Firebase pricing: https://firebase.google.com/pricing. Cloud Run pricing: https://cloud.google.com/run/pricing. Checked 18 Oct 2026. Free-tier content-use and rate-limit terms may change. Use synthetic invoices only.</a:t>
+              <a:t>ScamShield uses Vertex AI Gemini 2.5 Flash-Lite, Firebase Authentication, Firestore and Cloud Run. The ₹100 budget alert through 6 Nov 2026 is not a spending cap. 59 backend tests passed. Live synthetic invoice checks covered extraction, classification, explanation, Firestore reads, idempotency, restart durability and visitor isolation. Use synthetic data only.</a:t>
             </a:r>
             <a:endParaRPr/>
           </a:p>
@@ -922,7 +922,7 @@
   <p:cSld>
     <p:spTree>
       <p:nvGrpSpPr>
-        <p:cNvPr id="136" name="Shape 136"/>
+        <p:cNvPr id="159" name="Shape 159"/>
         <p:cNvGrpSpPr/>
         <p:nvPr/>
       </p:nvGrpSpPr>
@@ -936,7 +936,7 @@
       </p:grpSpPr>
       <p:sp>
         <p:nvSpPr>
-          <p:cNvPr id="137" name="Google Shape;137;g3fb085bff3c_0_46:notes"/>
+          <p:cNvPr id="160" name="Google Shape;160;g3fb085bff3c_0_46:notes"/>
           <p:cNvSpPr/>
           <p:nvPr>
             <p:ph idx="2" type="sldImg"/>
@@ -971,7 +971,7 @@
       </p:sp>
       <p:sp>
         <p:nvSpPr>
-          <p:cNvPr id="138" name="Google Shape;138;g3fb085bff3c_0_46:notes"/>
+          <p:cNvPr id="161" name="Google Shape;161;g3fb085bff3c_0_46:notes"/>
           <p:cNvSpPr txBox="1"/>
           <p:nvPr>
             <p:ph idx="1" type="body"/>
@@ -1021,7 +1021,7 @@
   <p:cSld>
     <p:spTree>
       <p:nvGrpSpPr>
-        <p:cNvPr id="146" name="Shape 146"/>
+        <p:cNvPr id="169" name="Shape 169"/>
         <p:cNvGrpSpPr/>
         <p:nvPr/>
       </p:nvGrpSpPr>
@@ -1035,7 +1035,7 @@
       </p:grpSpPr>
       <p:sp>
         <p:nvSpPr>
-          <p:cNvPr id="147" name="Google Shape;147;g3fb085bff3c_0_51:notes"/>
+          <p:cNvPr id="170" name="Google Shape;170;g3fb085bff3c_0_51:notes"/>
           <p:cNvSpPr/>
           <p:nvPr>
             <p:ph idx="2" type="sldImg"/>
@@ -1070,7 +1070,7 @@
       </p:sp>
       <p:sp>
         <p:nvSpPr>
-          <p:cNvPr id="148" name="Google Shape;148;g3fb085bff3c_0_51:notes"/>
+          <p:cNvPr id="171" name="Google Shape;171;g3fb085bff3c_0_51:notes"/>
           <p:cNvSpPr txBox="1"/>
           <p:nvPr>
             <p:ph idx="1" type="body"/>
@@ -1120,7 +1120,7 @@
   <p:cSld>
     <p:spTree>
       <p:nvGrpSpPr>
-        <p:cNvPr id="155" name="Shape 155"/>
+        <p:cNvPr id="178" name="Shape 178"/>
         <p:cNvGrpSpPr/>
         <p:nvPr/>
       </p:nvGrpSpPr>
@@ -1134,7 +1134,7 @@
       </p:grpSpPr>
       <p:sp>
         <p:nvSpPr>
-          <p:cNvPr id="156" name="Google Shape;156;g3fb085bff3c_0_56:notes"/>
+          <p:cNvPr id="179" name="Google Shape;179;g3fb085bff3c_0_56:notes"/>
           <p:cNvSpPr/>
           <p:nvPr>
             <p:ph idx="2" type="sldImg"/>
@@ -1169,7 +1169,7 @@
       </p:sp>
       <p:sp>
         <p:nvSpPr>
-          <p:cNvPr id="157" name="Google Shape;157;g3fb085bff3c_0_56:notes"/>
+          <p:cNvPr id="180" name="Google Shape;180;g3fb085bff3c_0_56:notes"/>
           <p:cNvSpPr txBox="1"/>
           <p:nvPr>
             <p:ph idx="1" type="body"/>
@@ -1219,7 +1219,7 @@
   <p:cSld>
     <p:spTree>
       <p:nvGrpSpPr>
-        <p:cNvPr id="164" name="Shape 164"/>
+        <p:cNvPr id="187" name="Shape 187"/>
         <p:cNvGrpSpPr/>
         <p:nvPr/>
       </p:nvGrpSpPr>
@@ -1233,7 +1233,7 @@
       </p:grpSpPr>
       <p:sp>
         <p:nvSpPr>
-          <p:cNvPr id="165" name="Google Shape;165;g3fb085bff3c_0_61:notes"/>
+          <p:cNvPr id="188" name="Google Shape;188;g3fb085bff3c_0_61:notes"/>
           <p:cNvSpPr/>
           <p:nvPr>
             <p:ph idx="2" type="sldImg"/>
@@ -1268,7 +1268,7 @@
       </p:sp>
       <p:sp>
         <p:nvSpPr>
-          <p:cNvPr id="166" name="Google Shape;166;g3fb085bff3c_0_61:notes"/>
+          <p:cNvPr id="189" name="Google Shape;189;g3fb085bff3c_0_61:notes"/>
           <p:cNvSpPr txBox="1"/>
           <p:nvPr>
             <p:ph idx="1" type="body"/>
@@ -1318,7 +1318,7 @@
   <p:cSld>
     <p:spTree>
       <p:nvGrpSpPr>
-        <p:cNvPr id="173" name="Shape 173"/>
+        <p:cNvPr id="196" name="Shape 196"/>
         <p:cNvGrpSpPr/>
         <p:nvPr/>
       </p:nvGrpSpPr>
@@ -1332,7 +1332,7 @@
       </p:grpSpPr>
       <p:sp>
         <p:nvSpPr>
-          <p:cNvPr id="174" name="Google Shape;174;g3fb085bff3c_0_107:notes"/>
+          <p:cNvPr id="197" name="Google Shape;197;g3fb085bff3c_0_107:notes"/>
           <p:cNvSpPr/>
           <p:nvPr>
             <p:ph idx="2" type="sldImg"/>
@@ -1367,7 +1367,7 @@
       </p:sp>
       <p:sp>
         <p:nvSpPr>
-          <p:cNvPr id="175" name="Google Shape;175;g3fb085bff3c_0_107:notes"/>
+          <p:cNvPr id="198" name="Google Shape;198;g3fb085bff3c_0_107:notes"/>
           <p:cNvSpPr txBox="1"/>
           <p:nvPr>
             <p:ph idx="1" type="body"/>
@@ -1417,7 +1417,7 @@
   <p:cSld>
     <p:spTree>
       <p:nvGrpSpPr>
-        <p:cNvPr id="180" name="Shape 180"/>
+        <p:cNvPr id="203" name="Shape 203"/>
         <p:cNvGrpSpPr/>
         <p:nvPr/>
       </p:nvGrpSpPr>
@@ -1431,7 +1431,7 @@
       </p:grpSpPr>
       <p:sp>
         <p:nvSpPr>
-          <p:cNvPr id="181" name="Google Shape;181;g3fb085bff3c_0_66:notes"/>
+          <p:cNvPr id="204" name="Google Shape;204;g3fb085bff3c_0_66:notes"/>
           <p:cNvSpPr/>
           <p:nvPr>
             <p:ph idx="2" type="sldImg"/>
@@ -1466,7 +1466,7 @@
       </p:sp>
       <p:sp>
         <p:nvSpPr>
-          <p:cNvPr id="182" name="Google Shape;182;g3fb085bff3c_0_66:notes"/>
+          <p:cNvPr id="205" name="Google Shape;205;g3fb085bff3c_0_66:notes"/>
           <p:cNvSpPr txBox="1"/>
           <p:nvPr>
             <p:ph idx="1" type="body"/>
@@ -2011,7 +2011,7 @@
   <p:cSld>
     <p:spTree>
       <p:nvGrpSpPr>
-        <p:cNvPr id="100" name="Shape 100"/>
+        <p:cNvPr id="114" name="Shape 114"/>
         <p:cNvGrpSpPr/>
         <p:nvPr/>
       </p:nvGrpSpPr>
@@ -2025,7 +2025,7 @@
       </p:grpSpPr>
       <p:sp>
         <p:nvSpPr>
-          <p:cNvPr id="101" name="Google Shape;101;g3fb085bff3c_0_26:notes"/>
+          <p:cNvPr id="115" name="Google Shape;115;g3fb085bff3c_0_26:notes"/>
           <p:cNvSpPr/>
           <p:nvPr>
             <p:ph idx="2" type="sldImg"/>
@@ -2060,7 +2060,7 @@
       </p:sp>
       <p:sp>
         <p:nvSpPr>
-          <p:cNvPr id="102" name="Google Shape;102;g3fb085bff3c_0_26:notes"/>
+          <p:cNvPr id="116" name="Google Shape;116;g3fb085bff3c_0_26:notes"/>
           <p:cNvSpPr txBox="1"/>
           <p:nvPr>
             <p:ph idx="1" type="body"/>
@@ -2110,7 +2110,7 @@
   <p:cSld>
     <p:spTree>
       <p:nvGrpSpPr>
-        <p:cNvPr id="109" name="Shape 109"/>
+        <p:cNvPr id="123" name="Shape 123"/>
         <p:cNvGrpSpPr/>
         <p:nvPr/>
       </p:nvGrpSpPr>
@@ -2124,7 +2124,7 @@
       </p:grpSpPr>
       <p:sp>
         <p:nvSpPr>
-          <p:cNvPr id="110" name="Google Shape;110;g3fb085bff3c_0_31:notes"/>
+          <p:cNvPr id="124" name="Google Shape;124;g3fb085bff3c_0_31:notes"/>
           <p:cNvSpPr/>
           <p:nvPr>
             <p:ph idx="2" type="sldImg"/>
@@ -2159,7 +2159,7 @@
       </p:sp>
       <p:sp>
         <p:nvSpPr>
-          <p:cNvPr id="111" name="Google Shape;111;g3fb085bff3c_0_31:notes"/>
+          <p:cNvPr id="125" name="Google Shape;125;g3fb085bff3c_0_31:notes"/>
           <p:cNvSpPr txBox="1"/>
           <p:nvPr>
             <p:ph idx="1" type="body"/>
@@ -2209,7 +2209,7 @@
   <p:cSld>
     <p:spTree>
       <p:nvGrpSpPr>
-        <p:cNvPr id="118" name="Shape 118"/>
+        <p:cNvPr id="141" name="Shape 141"/>
         <p:cNvGrpSpPr/>
         <p:nvPr/>
       </p:nvGrpSpPr>
@@ -2223,7 +2223,7 @@
       </p:grpSpPr>
       <p:sp>
         <p:nvSpPr>
-          <p:cNvPr id="119" name="Google Shape;119;g3fb085bff3c_0_36:notes"/>
+          <p:cNvPr id="142" name="Google Shape;142;g3fb085bff3c_0_36:notes"/>
           <p:cNvSpPr/>
           <p:nvPr>
             <p:ph idx="2" type="sldImg"/>
@@ -2258,7 +2258,7 @@
       </p:sp>
       <p:sp>
         <p:nvSpPr>
-          <p:cNvPr id="120" name="Google Shape;120;g3fb085bff3c_0_36:notes"/>
+          <p:cNvPr id="143" name="Google Shape;143;g3fb085bff3c_0_36:notes"/>
           <p:cNvSpPr txBox="1"/>
           <p:nvPr>
             <p:ph idx="1" type="body"/>
@@ -7213,7 +7213,7 @@
   <p:cSld>
     <p:spTree>
       <p:nvGrpSpPr>
-        <p:cNvPr id="130" name="Shape 130"/>
+        <p:cNvPr id="153" name="Shape 153"/>
         <p:cNvGrpSpPr/>
         <p:nvPr/>
       </p:nvGrpSpPr>
@@ -7227,7 +7227,7 @@
       </p:grpSpPr>
       <p:pic>
         <p:nvPicPr>
-          <p:cNvPr id="131" name="Google Shape;131;p22" title="Frame 144.png"/>
+          <p:cNvPr id="154" name="Google Shape;154;p22" title="Frame 144.png"/>
           <p:cNvPicPr preferRelativeResize="0"/>
           <p:nvPr/>
         </p:nvPicPr>
@@ -7254,7 +7254,7 @@
       </p:pic>
       <p:pic>
         <p:nvPicPr>
-          <p:cNvPr id="132" name="Google Shape;132;p22" title="Group 427319979.png"/>
+          <p:cNvPr id="155" name="Google Shape;155;p22" title="Group 427319979.png"/>
           <p:cNvPicPr preferRelativeResize="0"/>
           <p:nvPr/>
         </p:nvPicPr>
@@ -7282,7 +7282,7 @@
       </p:pic>
       <p:sp>
         <p:nvSpPr>
-          <p:cNvPr id="133" name="Google Shape;133;p22"/>
+          <p:cNvPr id="156" name="Google Shape;156;p22"/>
           <p:cNvSpPr/>
           <p:nvPr/>
         </p:nvSpPr>
@@ -7325,7 +7325,7 @@
       </p:sp>
       <p:sp>
         <p:nvSpPr>
-          <p:cNvPr id="134" name="Google Shape;134;p22"/>
+          <p:cNvPr id="157" name="Google Shape;157;p22"/>
           <p:cNvSpPr txBox="1"/>
           <p:nvPr/>
         </p:nvSpPr>
@@ -7377,14 +7377,14 @@
       </p:sp>
       <p:sp>
         <p:nvSpPr>
-          <p:cNvPr id="135" name="Google Shape;135;p22"/>
+          <p:cNvPr id="158" name="Google Shape;158;p22"/>
           <p:cNvSpPr txBox="1"/>
           <p:nvPr/>
         </p:nvSpPr>
         <p:spPr>
           <a:xfrm>
             <a:off x="381000" y="1320800"/>
-            <a:ext cx="8400000" cy="3000000"/>
+            <a:ext cx="8382000" cy="3365400"/>
           </a:xfrm>
           <a:prstGeom prst="rect">
             <a:avLst/>
@@ -7422,7 +7422,7 @@
                 <a:cs typeface="Google Sans Flex"/>
                 <a:sym typeface="Google Sans Flex"/>
               </a:rPr>
-              <a:t>LOCAL PROTOTYPE  Runs on a developer machine with SQLite; no hosted database is needed.</a:t>
+              <a:t>CLOUD COST STATUS</a:t>
             </a:r>
             <a:endParaRPr sz="1300">
               <a:solidFill>
@@ -7448,7 +7448,16 @@
               <a:buNone/>
             </a:pPr>
             <a:r>
-              <a:t/>
+              <a:rPr lang="en-GB" sz="1300">
+                <a:solidFill>
+                  <a:srgbClr val="1F2926"/>
+                </a:solidFill>
+                <a:latin typeface="Google Sans Flex"/>
+                <a:ea typeface="Google Sans Flex"/>
+                <a:cs typeface="Google Sans Flex"/>
+                <a:sym typeface="Google Sans Flex"/>
+              </a:rPr>
+              <a:t>Project billing is enabled. No credit coverage is confirmed. Cloud Run, Firestore and Vertex AI calls may incur charges.</a:t>
             </a:r>
             <a:endParaRPr sz="1300">
               <a:solidFill>
@@ -7474,6 +7483,32 @@
               <a:buNone/>
             </a:pPr>
             <a:r>
+              <a:t/>
+            </a:r>
+            <a:endParaRPr sz="1300">
+              <a:solidFill>
+                <a:srgbClr val="1F2926"/>
+              </a:solidFill>
+              <a:latin typeface="Google Sans Flex"/>
+              <a:ea typeface="Google Sans Flex"/>
+              <a:cs typeface="Google Sans Flex"/>
+              <a:sym typeface="Google Sans Flex"/>
+            </a:endParaRPr>
+          </a:p>
+          <a:p>
+            <a:pPr indent="0" lvl="0" marL="0" rtl="0" algn="l">
+              <a:lnSpc>
+                <a:spcPct val="112000"/>
+              </a:lnSpc>
+              <a:spcBef>
+                <a:spcPts val="600"/>
+              </a:spcBef>
+              <a:spcAft>
+                <a:spcPts val="0"/>
+              </a:spcAft>
+              <a:buNone/>
+            </a:pPr>
+            <a:r>
               <a:rPr lang="en-GB" sz="1300">
                 <a:solidFill>
                   <a:srgbClr val="1F2926"/>
@@ -7483,7 +7518,7 @@
                 <a:cs typeface="Google Sans Flex"/>
                 <a:sym typeface="Google Sans Flex"/>
               </a:rPr>
-              <a:t>GEMINI  Google lists free input and output for selected models on its Free tier, subject to model eligibility and rate limits. Google may use free-tier content to improve products. Use synthetic invoices only.</a:t>
+              <a:t>A ₹100 project budget alert is configured through 6 November 2026. Budget alerts notify; they do not stop spending.</a:t>
             </a:r>
             <a:endParaRPr sz="1300">
               <a:solidFill>
@@ -7544,7 +7579,7 @@
                 <a:cs typeface="Google Sans Flex"/>
                 <a:sym typeface="Google Sans Flex"/>
               </a:rPr>
-              <a:t>CLOUD  Firebase, Firestore and Cloud Run costs depend on project settings and usage. Billing may be required. No paid services are provisioned and no deployment cost estimate is available. Set quotas and a budget before launch.</a:t>
+              <a:t>APPLICATION REQUEST LIMITS</a:t>
             </a:r>
             <a:endParaRPr sz="1300">
               <a:solidFill>
@@ -7570,7 +7605,16 @@
               <a:buNone/>
             </a:pPr>
             <a:r>
-              <a:t/>
+              <a:rPr lang="en-GB" sz="1300">
+                <a:solidFill>
+                  <a:srgbClr val="1F2926"/>
+                </a:solidFill>
+                <a:latin typeface="Google Sans Flex"/>
+                <a:ea typeface="Google Sans Flex"/>
+                <a:cs typeface="Google Sans Flex"/>
+                <a:sym typeface="Google Sans Flex"/>
+              </a:rPr>
+              <a:t>9 model attempts per visitor per day · 50 globally per day · 200 total. These limits restrict model calls and are not a billing cap.</a:t>
             </a:r>
             <a:endParaRPr sz="1300">
               <a:solidFill>
@@ -7591,6 +7635,32 @@
                 <a:spcPts val="600"/>
               </a:spcBef>
               <a:spcAft>
+                <a:spcPts val="0"/>
+              </a:spcAft>
+              <a:buNone/>
+            </a:pPr>
+            <a:r>
+              <a:t/>
+            </a:r>
+            <a:endParaRPr sz="1300">
+              <a:solidFill>
+                <a:srgbClr val="1F2926"/>
+              </a:solidFill>
+              <a:latin typeface="Google Sans Flex"/>
+              <a:ea typeface="Google Sans Flex"/>
+              <a:cs typeface="Google Sans Flex"/>
+              <a:sym typeface="Google Sans Flex"/>
+            </a:endParaRPr>
+          </a:p>
+          <a:p>
+            <a:pPr indent="0" lvl="0" marL="0" rtl="0" algn="l">
+              <a:lnSpc>
+                <a:spcPct val="112000"/>
+              </a:lnSpc>
+              <a:spcBef>
+                <a:spcPts val="600"/>
+              </a:spcBef>
+              <a:spcAft>
                 <a:spcPts val="600"/>
               </a:spcAft>
               <a:buNone/>
@@ -7605,7 +7675,7 @@
                 <a:cs typeface="Google Sans Flex"/>
                 <a:sym typeface="Google Sans Flex"/>
               </a:rPr>
-              <a:t>Source: ai.google.dev/gemini-api/docs/pricing (checked 18 Oct 2026).</a:t>
+              <a:t>Use synthetic invoice data only.</a:t>
             </a:r>
             <a:endParaRPr sz="1300">
               <a:solidFill>
@@ -7632,7 +7702,7 @@
   <p:cSld>
     <p:spTree>
       <p:nvGrpSpPr>
-        <p:cNvPr id="139" name="Shape 139"/>
+        <p:cNvPr id="162" name="Shape 162"/>
         <p:cNvGrpSpPr/>
         <p:nvPr/>
       </p:nvGrpSpPr>
@@ -7646,7 +7716,7 @@
       </p:grpSpPr>
       <p:pic>
         <p:nvPicPr>
-          <p:cNvPr id="140" name="Google Shape;140;p23" title="Frame 144.png"/>
+          <p:cNvPr id="163" name="Google Shape;163;p23" title="Frame 144.png"/>
           <p:cNvPicPr preferRelativeResize="0"/>
           <p:nvPr/>
         </p:nvPicPr>
@@ -7673,7 +7743,7 @@
       </p:pic>
       <p:pic>
         <p:nvPicPr>
-          <p:cNvPr id="141" name="Google Shape;141;p23" title="Group 427319979.png"/>
+          <p:cNvPr id="164" name="Google Shape;164;p23" title="Group 427319979.png"/>
           <p:cNvPicPr preferRelativeResize="0"/>
           <p:nvPr/>
         </p:nvPicPr>
@@ -7701,7 +7771,7 @@
       </p:pic>
       <p:sp>
         <p:nvSpPr>
-          <p:cNvPr id="142" name="Google Shape;142;p23"/>
+          <p:cNvPr id="165" name="Google Shape;165;p23"/>
           <p:cNvSpPr/>
           <p:nvPr/>
         </p:nvSpPr>
@@ -7744,7 +7814,7 @@
       </p:sp>
       <p:sp>
         <p:nvSpPr>
-          <p:cNvPr id="143" name="Google Shape;143;p23"/>
+          <p:cNvPr id="166" name="Google Shape;166;p23"/>
           <p:cNvSpPr txBox="1"/>
           <p:nvPr/>
         </p:nvSpPr>
@@ -7783,7 +7853,7 @@
                 <a:cs typeface="Google Sans Flex Medium"/>
                 <a:sym typeface="Google Sans Flex Medium"/>
               </a:rPr>
-              <a:t>Snapshots of the prototype</a:t>
+              <a:t>Live synthetic case evidence</a:t>
             </a:r>
             <a:endParaRPr sz="1600">
               <a:latin typeface="Google Sans Flex Medium"/>
@@ -7796,7 +7866,7 @@
       </p:sp>
       <p:pic>
         <p:nvPicPr>
-          <p:cNvPr id="144" name="Google Shape;144;p23"/>
+          <p:cNvPr id="167" name="Google Shape;167;p23"/>
           <p:cNvPicPr preferRelativeResize="0"/>
           <p:nvPr/>
         </p:nvPicPr>
@@ -7810,8 +7880,8 @@
         </p:blipFill>
         <p:spPr>
           <a:xfrm>
-            <a:off x="535188" y="1320800"/>
-            <a:ext cx="2206225" cy="3479801"/>
+            <a:off x="533400" y="1321024"/>
+            <a:ext cx="2209799" cy="3479351"/>
           </a:xfrm>
           <a:prstGeom prst="rect">
             <a:avLst/>
@@ -7824,7 +7894,7 @@
       </p:pic>
       <p:sp>
         <p:nvSpPr>
-          <p:cNvPr id="145" name="Google Shape;145;p23"/>
+          <p:cNvPr id="168" name="Google Shape;168;p23"/>
           <p:cNvSpPr txBox="1"/>
           <p:nvPr/>
         </p:nvSpPr>
@@ -7849,7 +7919,7 @@
           <a:p>
             <a:pPr indent="0" lvl="0" marL="0" rtl="0" algn="l">
               <a:lnSpc>
-                <a:spcPct val="115000"/>
+                <a:spcPct val="112000"/>
               </a:lnSpc>
               <a:spcBef>
                 <a:spcPts val="0"/>
@@ -7869,7 +7939,7 @@
                 <a:cs typeface="Google Sans Flex"/>
                 <a:sym typeface="Google Sans Flex"/>
               </a:rPr>
-              <a:t>LOCAL FIXTURE-MODE DEMO</a:t>
+              <a:t>LIVE SYNTHETIC INVOICE CASE</a:t>
             </a:r>
             <a:endParaRPr>
               <a:solidFill>
@@ -7884,18 +7954,27 @@
           <a:p>
             <a:pPr indent="0" lvl="0" marL="0" rtl="0" algn="l">
               <a:lnSpc>
-                <a:spcPct val="115000"/>
+                <a:spcPct val="112000"/>
               </a:lnSpc>
               <a:spcBef>
-                <a:spcPts val="800"/>
-              </a:spcBef>
-              <a:spcAft>
-                <a:spcPts val="0"/>
-              </a:spcAft>
-              <a:buNone/>
-            </a:pPr>
-            <a:r>
-              <a:t/>
+                <a:spcPts val="600"/>
+              </a:spcBef>
+              <a:spcAft>
+                <a:spcPts val="0"/>
+              </a:spcAft>
+              <a:buNone/>
+            </a:pPr>
+            <a:r>
+              <a:rPr lang="en-GB">
+                <a:solidFill>
+                  <a:srgbClr val="1F2926"/>
+                </a:solidFill>
+                <a:latin typeface="Google Sans Flex"/>
+                <a:ea typeface="Google Sans Flex"/>
+                <a:cs typeface="Google Sans Flex"/>
+                <a:sym typeface="Google Sans Flex"/>
+              </a:rPr>
+              <a:t>The public app used Vertex Gemini to extract fields and classify request context. The person confirmed the vendor destination before assessment. Requested explanations use Gemini-ranked saved evidence and deterministic templates.</a:t>
             </a:r>
             <a:endParaRPr>
               <a:solidFill>
@@ -7910,13 +7989,39 @@
           <a:p>
             <a:pPr indent="0" lvl="0" marL="0" rtl="0" algn="l">
               <a:lnSpc>
-                <a:spcPct val="115000"/>
+                <a:spcPct val="112000"/>
               </a:lnSpc>
               <a:spcBef>
-                <a:spcPts val="800"/>
-              </a:spcBef>
-              <a:spcAft>
-                <a:spcPts val="0"/>
+                <a:spcPts val="600"/>
+              </a:spcBef>
+              <a:spcAft>
+                <a:spcPts val="0"/>
+              </a:spcAft>
+              <a:buNone/>
+            </a:pPr>
+            <a:r>
+              <a:t/>
+            </a:r>
+            <a:endParaRPr>
+              <a:solidFill>
+                <a:srgbClr val="1F2926"/>
+              </a:solidFill>
+              <a:latin typeface="Google Sans Flex"/>
+              <a:ea typeface="Google Sans Flex"/>
+              <a:cs typeface="Google Sans Flex"/>
+              <a:sym typeface="Google Sans Flex"/>
+            </a:endParaRPr>
+          </a:p>
+          <a:p>
+            <a:pPr indent="0" lvl="0" marL="0" rtl="0" algn="l">
+              <a:lnSpc>
+                <a:spcPct val="112000"/>
+              </a:lnSpc>
+              <a:spcBef>
+                <a:spcPts val="600"/>
+              </a:spcBef>
+              <a:spcAft>
+                <a:spcPts val="600"/>
               </a:spcAft>
               <a:buNone/>
             </a:pPr>
@@ -7930,68 +8035,7 @@
                 <a:cs typeface="Google Sans Flex"/>
                 <a:sym typeface="Google Sans Flex"/>
               </a:rPr>
-              <a:t>A synthetic invoice walkthrough shows candidate fields awaiting human review, vendor comparison, recorded risk evidence and a simulated decision.</a:t>
-            </a:r>
-            <a:endParaRPr>
-              <a:solidFill>
-                <a:srgbClr val="1F2926"/>
-              </a:solidFill>
-              <a:latin typeface="Google Sans Flex"/>
-              <a:ea typeface="Google Sans Flex"/>
-              <a:cs typeface="Google Sans Flex"/>
-              <a:sym typeface="Google Sans Flex"/>
-            </a:endParaRPr>
-          </a:p>
-          <a:p>
-            <a:pPr indent="0" lvl="0" marL="0" rtl="0" algn="l">
-              <a:lnSpc>
-                <a:spcPct val="115000"/>
-              </a:lnSpc>
-              <a:spcBef>
-                <a:spcPts val="800"/>
-              </a:spcBef>
-              <a:spcAft>
-                <a:spcPts val="0"/>
-              </a:spcAft>
-              <a:buNone/>
-            </a:pPr>
-            <a:r>
-              <a:t/>
-            </a:r>
-            <a:endParaRPr>
-              <a:solidFill>
-                <a:srgbClr val="1F2926"/>
-              </a:solidFill>
-              <a:latin typeface="Google Sans Flex"/>
-              <a:ea typeface="Google Sans Flex"/>
-              <a:cs typeface="Google Sans Flex"/>
-              <a:sym typeface="Google Sans Flex"/>
-            </a:endParaRPr>
-          </a:p>
-          <a:p>
-            <a:pPr indent="0" lvl="0" marL="0" rtl="0" algn="l">
-              <a:lnSpc>
-                <a:spcPct val="115000"/>
-              </a:lnSpc>
-              <a:spcBef>
-                <a:spcPts val="800"/>
-              </a:spcBef>
-              <a:spcAft>
-                <a:spcPts val="800"/>
-              </a:spcAft>
-              <a:buNone/>
-            </a:pPr>
-            <a:r>
-              <a:rPr lang="en-GB">
-                <a:solidFill>
-                  <a:srgbClr val="1F2926"/>
-                </a:solidFill>
-                <a:latin typeface="Google Sans Flex"/>
-                <a:ea typeface="Google Sans Flex"/>
-                <a:cs typeface="Google Sans Flex"/>
-                <a:sym typeface="Google Sans Flex"/>
-              </a:rPr>
-              <a:t>The screen uses a saved fixture. It does not show live Gemini extraction or a public GCP deployment. No payment moves.</a:t>
+              <a:t>One invoice matched the saved account and returned Continue. The changed destination and bypass request returned Review. Firestore retained both cases across a deployment revision. No payment moved.</a:t>
             </a:r>
             <a:endParaRPr>
               <a:solidFill>
@@ -8018,7 +8062,7 @@
   <p:cSld>
     <p:spTree>
       <p:nvGrpSpPr>
-        <p:cNvPr id="149" name="Shape 149"/>
+        <p:cNvPr id="172" name="Shape 172"/>
         <p:cNvGrpSpPr/>
         <p:nvPr/>
       </p:nvGrpSpPr>
@@ -8032,7 +8076,7 @@
       </p:grpSpPr>
       <p:pic>
         <p:nvPicPr>
-          <p:cNvPr id="150" name="Google Shape;150;p24" title="Frame 144.png"/>
+          <p:cNvPr id="173" name="Google Shape;173;p24" title="Frame 144.png"/>
           <p:cNvPicPr preferRelativeResize="0"/>
           <p:nvPr/>
         </p:nvPicPr>
@@ -8059,7 +8103,7 @@
       </p:pic>
       <p:pic>
         <p:nvPicPr>
-          <p:cNvPr id="151" name="Google Shape;151;p24" title="Group 427319979.png"/>
+          <p:cNvPr id="174" name="Google Shape;174;p24" title="Group 427319979.png"/>
           <p:cNvPicPr preferRelativeResize="0"/>
           <p:nvPr/>
         </p:nvPicPr>
@@ -8087,7 +8131,7 @@
       </p:pic>
       <p:sp>
         <p:nvSpPr>
-          <p:cNvPr id="152" name="Google Shape;152;p24"/>
+          <p:cNvPr id="175" name="Google Shape;175;p24"/>
           <p:cNvSpPr/>
           <p:nvPr/>
         </p:nvSpPr>
@@ -8130,7 +8174,7 @@
       </p:sp>
       <p:sp>
         <p:nvSpPr>
-          <p:cNvPr id="153" name="Google Shape;153;p24"/>
+          <p:cNvPr id="176" name="Google Shape;176;p24"/>
           <p:cNvSpPr txBox="1"/>
           <p:nvPr/>
         </p:nvSpPr>
@@ -8182,14 +8226,14 @@
       </p:sp>
       <p:sp>
         <p:nvSpPr>
-          <p:cNvPr id="154" name="Google Shape;154;p24"/>
+          <p:cNvPr id="177" name="Google Shape;177;p24"/>
           <p:cNvSpPr txBox="1"/>
           <p:nvPr/>
         </p:nvSpPr>
         <p:spPr>
           <a:xfrm>
             <a:off x="381000" y="1320800"/>
-            <a:ext cx="8400000" cy="3000000"/>
+            <a:ext cx="8382000" cy="3365400"/>
           </a:xfrm>
           <a:prstGeom prst="rect">
             <a:avLst/>
@@ -8227,7 +8271,7 @@
                 <a:cs typeface="Google Sans Flex"/>
                 <a:sym typeface="Google Sans Flex"/>
               </a:rPr>
-              <a:t>CURRENT LOCAL CHECKS</a:t>
+              <a:t>SOFTWARE CHECKS</a:t>
             </a:r>
             <a:endParaRPr sz="1300">
               <a:solidFill>
@@ -8262,7 +8306,7 @@
                 <a:cs typeface="Google Sans Flex"/>
                 <a:sym typeface="Google Sans Flex"/>
               </a:rPr>
-              <a:t>52 backend tests pass in the current release check.</a:t>
+              <a:t>59 backend tests pass in the release check.</a:t>
             </a:r>
             <a:endParaRPr sz="1300">
               <a:solidFill>
@@ -8288,6 +8332,32 @@
               <a:buNone/>
             </a:pPr>
             <a:r>
+              <a:t/>
+            </a:r>
+            <a:endParaRPr sz="1300">
+              <a:solidFill>
+                <a:srgbClr val="1F2926"/>
+              </a:solidFill>
+              <a:latin typeface="Google Sans Flex"/>
+              <a:ea typeface="Google Sans Flex"/>
+              <a:cs typeface="Google Sans Flex"/>
+              <a:sym typeface="Google Sans Flex"/>
+            </a:endParaRPr>
+          </a:p>
+          <a:p>
+            <a:pPr indent="0" lvl="0" marL="0" rtl="0" algn="l">
+              <a:lnSpc>
+                <a:spcPct val="112000"/>
+              </a:lnSpc>
+              <a:spcBef>
+                <a:spcPts val="600"/>
+              </a:spcBef>
+              <a:spcAft>
+                <a:spcPts val="0"/>
+              </a:spcAft>
+              <a:buNone/>
+            </a:pPr>
+            <a:r>
               <a:rPr lang="en-GB" sz="1300">
                 <a:solidFill>
                   <a:srgbClr val="1F2926"/>
@@ -8297,7 +8367,7 @@
                 <a:cs typeface="Google Sans Flex"/>
                 <a:sym typeface="Google Sans Flex"/>
               </a:rPr>
-              <a:t>HISTORICAL SYNTHETIC EVALUATION  Recorded 11 Oct 2026; 40 policy cases split into 20 development and 20 held-out examples.</a:t>
+              <a:t>LIVE INTEGRATION CHECK</a:t>
             </a:r>
             <a:endParaRPr sz="1300">
               <a:solidFill>
@@ -8332,7 +8402,7 @@
                 <a:cs typeface="Google Sans Flex"/>
                 <a:sym typeface="Google Sans Flex"/>
               </a:rPr>
-              <a:t>Classifier outputs in this evaluation were curated fixtures.</a:t>
+              <a:t>Two synthetic invoice flows completed with live Vertex Gemini extraction and classification. A requested explanation used Gemini-ranked evidence with deterministic templates. Firestore readback, retry idempotency, restart durability and visitor isolation were verified.</a:t>
             </a:r>
             <a:endParaRPr sz="1300">
               <a:solidFill>
@@ -8428,7 +8498,7 @@
                 <a:cs typeface="Google Sans Flex"/>
                 <a:sym typeface="Google Sans Flex"/>
               </a:rPr>
-              <a:t>These checks do not measure Gemini extraction accuracy or real-world fraud detection. No live extraction accuracy, public deployment, or end-to-end latency benchmark is recorded.</a:t>
+              <a:t>Tests do not measure model accuracy or real-world fraud detection. No accuracy or latency benchmark is claimed.</a:t>
             </a:r>
             <a:endParaRPr sz="1300">
               <a:solidFill>
@@ -8455,7 +8525,7 @@
   <p:cSld>
     <p:spTree>
       <p:nvGrpSpPr>
-        <p:cNvPr id="158" name="Shape 158"/>
+        <p:cNvPr id="181" name="Shape 181"/>
         <p:cNvGrpSpPr/>
         <p:nvPr/>
       </p:nvGrpSpPr>
@@ -8469,7 +8539,7 @@
       </p:grpSpPr>
       <p:pic>
         <p:nvPicPr>
-          <p:cNvPr id="159" name="Google Shape;159;p25" title="Frame 144.png"/>
+          <p:cNvPr id="182" name="Google Shape;182;p25" title="Frame 144.png"/>
           <p:cNvPicPr preferRelativeResize="0"/>
           <p:nvPr/>
         </p:nvPicPr>
@@ -8496,7 +8566,7 @@
       </p:pic>
       <p:pic>
         <p:nvPicPr>
-          <p:cNvPr id="160" name="Google Shape;160;p25" title="Group 427319979.png"/>
+          <p:cNvPr id="183" name="Google Shape;183;p25" title="Group 427319979.png"/>
           <p:cNvPicPr preferRelativeResize="0"/>
           <p:nvPr/>
         </p:nvPicPr>
@@ -8524,7 +8594,7 @@
       </p:pic>
       <p:sp>
         <p:nvSpPr>
-          <p:cNvPr id="161" name="Google Shape;161;p25"/>
+          <p:cNvPr id="184" name="Google Shape;184;p25"/>
           <p:cNvSpPr/>
           <p:nvPr/>
         </p:nvSpPr>
@@ -8567,7 +8637,7 @@
       </p:sp>
       <p:sp>
         <p:nvSpPr>
-          <p:cNvPr id="162" name="Google Shape;162;p25"/>
+          <p:cNvPr id="185" name="Google Shape;185;p25"/>
           <p:cNvSpPr txBox="1"/>
           <p:nvPr/>
         </p:nvSpPr>
@@ -8619,14 +8689,14 @@
       </p:sp>
       <p:sp>
         <p:nvSpPr>
-          <p:cNvPr id="163" name="Google Shape;163;p25"/>
+          <p:cNvPr id="186" name="Google Shape;186;p25"/>
           <p:cNvSpPr txBox="1"/>
           <p:nvPr/>
         </p:nvSpPr>
         <p:spPr>
           <a:xfrm>
             <a:off x="381000" y="1320800"/>
-            <a:ext cx="8400000" cy="3000000"/>
+            <a:ext cx="8382000" cy="3365400"/>
           </a:xfrm>
           <a:prstGeom prst="rect">
             <a:avLst/>
@@ -8699,8 +8769,31 @@
                 <a:cs typeface="Google Sans Flex"/>
                 <a:sym typeface="Google Sans Flex"/>
               </a:rPr>
-              <a:t>01  </a:t>
-            </a:r>
+              <a:t>01  Continue testing model failure, malformed files and quota exhaustion.</a:t>
+            </a:r>
+            <a:endParaRPr sz="1300">
+              <a:solidFill>
+                <a:srgbClr val="1F2926"/>
+              </a:solidFill>
+              <a:latin typeface="Google Sans Flex"/>
+              <a:ea typeface="Google Sans Flex"/>
+              <a:cs typeface="Google Sans Flex"/>
+              <a:sym typeface="Google Sans Flex"/>
+            </a:endParaRPr>
+          </a:p>
+          <a:p>
+            <a:pPr indent="0" lvl="0" marL="0" rtl="0" algn="l">
+              <a:lnSpc>
+                <a:spcPct val="112000"/>
+              </a:lnSpc>
+              <a:spcBef>
+                <a:spcPts val="600"/>
+              </a:spcBef>
+              <a:spcAft>
+                <a:spcPts val="0"/>
+              </a:spcAft>
+              <a:buNone/>
+            </a:pPr>
             <a:r>
               <a:rPr lang="en-GB" sz="1300">
                 <a:solidFill>
@@ -8711,7 +8804,7 @@
                 <a:cs typeface="Google Sans Flex"/>
                 <a:sym typeface="Google Sans Flex"/>
               </a:rPr>
-              <a:t>Verify Gemini extraction with synthetic invoices and require a person to confirm each field before assessment.</a:t>
+              <a:t>02  Expand evaluation with reviewed synthetic cases before making performance claims.</a:t>
             </a:r>
             <a:endParaRPr sz="1300">
               <a:solidFill>
@@ -8746,8 +8839,31 @@
                 <a:cs typeface="Google Sans Flex"/>
                 <a:sym typeface="Google Sans Flex"/>
               </a:rPr>
-              <a:t>02  </a:t>
-            </a:r>
+              <a:t>03  Monitor Cloud usage against the ₹100 budget alert through 6 November 2026.</a:t>
+            </a:r>
+            <a:endParaRPr sz="1300">
+              <a:solidFill>
+                <a:srgbClr val="1F2926"/>
+              </a:solidFill>
+              <a:latin typeface="Google Sans Flex"/>
+              <a:ea typeface="Google Sans Flex"/>
+              <a:cs typeface="Google Sans Flex"/>
+              <a:sym typeface="Google Sans Flex"/>
+            </a:endParaRPr>
+          </a:p>
+          <a:p>
+            <a:pPr indent="0" lvl="0" marL="0" rtl="0" algn="l">
+              <a:lnSpc>
+                <a:spcPct val="112000"/>
+              </a:lnSpc>
+              <a:spcBef>
+                <a:spcPts val="600"/>
+              </a:spcBef>
+              <a:spcAft>
+                <a:spcPts val="600"/>
+              </a:spcAft>
+              <a:buNone/>
+            </a:pPr>
             <a:r>
               <a:rPr lang="en-GB" sz="1300">
                 <a:solidFill>
@@ -8758,209 +8874,7 @@
                 <a:cs typeface="Google Sans Flex"/>
                 <a:sym typeface="Google Sans Flex"/>
               </a:rPr>
-              <a:t>Validate Firebase anonymous identity and Firestore owner-scoped cases and quotas with live credentials.</a:t>
-            </a:r>
-            <a:endParaRPr sz="1300">
-              <a:solidFill>
-                <a:srgbClr val="1F2926"/>
-              </a:solidFill>
-              <a:latin typeface="Google Sans Flex"/>
-              <a:ea typeface="Google Sans Flex"/>
-              <a:cs typeface="Google Sans Flex"/>
-              <a:sym typeface="Google Sans Flex"/>
-            </a:endParaRPr>
-          </a:p>
-          <a:p>
-            <a:pPr indent="0" lvl="0" marL="0" rtl="0" algn="l">
-              <a:lnSpc>
-                <a:spcPct val="112000"/>
-              </a:lnSpc>
-              <a:spcBef>
-                <a:spcPts val="600"/>
-              </a:spcBef>
-              <a:spcAft>
-                <a:spcPts val="0"/>
-              </a:spcAft>
-              <a:buNone/>
-            </a:pPr>
-            <a:r>
-              <a:rPr lang="en-GB" sz="1300">
-                <a:solidFill>
-                  <a:srgbClr val="1F2926"/>
-                </a:solidFill>
-                <a:latin typeface="Google Sans Flex"/>
-                <a:ea typeface="Google Sans Flex"/>
-                <a:cs typeface="Google Sans Flex"/>
-                <a:sym typeface="Google Sans Flex"/>
-              </a:rPr>
-              <a:t>03  </a:t>
-            </a:r>
-            <a:r>
-              <a:rPr lang="en-GB" sz="1300">
-                <a:solidFill>
-                  <a:srgbClr val="1F2926"/>
-                </a:solidFill>
-                <a:latin typeface="Google Sans Flex"/>
-                <a:ea typeface="Google Sans Flex"/>
-                <a:cs typeface="Google Sans Flex"/>
-                <a:sym typeface="Google Sans Flex"/>
-              </a:rPr>
-              <a:t>Deploy the API and frontend to Cloud Run after confirming credit coverage.</a:t>
-            </a:r>
-            <a:endParaRPr sz="1300">
-              <a:solidFill>
-                <a:srgbClr val="1F2926"/>
-              </a:solidFill>
-              <a:latin typeface="Google Sans Flex"/>
-              <a:ea typeface="Google Sans Flex"/>
-              <a:cs typeface="Google Sans Flex"/>
-              <a:sym typeface="Google Sans Flex"/>
-            </a:endParaRPr>
-          </a:p>
-          <a:p>
-            <a:pPr indent="0" lvl="0" marL="0" rtl="0" algn="l">
-              <a:lnSpc>
-                <a:spcPct val="112000"/>
-              </a:lnSpc>
-              <a:spcBef>
-                <a:spcPts val="600"/>
-              </a:spcBef>
-              <a:spcAft>
-                <a:spcPts val="0"/>
-              </a:spcAft>
-              <a:buNone/>
-            </a:pPr>
-            <a:r>
-              <a:rPr lang="en-GB" sz="1300">
-                <a:solidFill>
-                  <a:srgbClr val="1F2926"/>
-                </a:solidFill>
-                <a:latin typeface="Google Sans Flex"/>
-                <a:ea typeface="Google Sans Flex"/>
-                <a:cs typeface="Google Sans Flex"/>
-                <a:sym typeface="Google Sans Flex"/>
-              </a:rPr>
-              <a:t>04  </a:t>
-            </a:r>
-            <a:r>
-              <a:rPr lang="en-GB" sz="1300">
-                <a:solidFill>
-                  <a:srgbClr val="1F2926"/>
-                </a:solidFill>
-                <a:latin typeface="Google Sans Flex"/>
-                <a:ea typeface="Google Sans Flex"/>
-                <a:cs typeface="Google Sans Flex"/>
-                <a:sym typeface="Google Sans Flex"/>
-              </a:rPr>
-              <a:t>Test upload, extraction, confirmation, assessment, ownership and persistence end to end.</a:t>
-            </a:r>
-            <a:endParaRPr sz="1300">
-              <a:solidFill>
-                <a:srgbClr val="1F2926"/>
-              </a:solidFill>
-              <a:latin typeface="Google Sans Flex"/>
-              <a:ea typeface="Google Sans Flex"/>
-              <a:cs typeface="Google Sans Flex"/>
-              <a:sym typeface="Google Sans Flex"/>
-            </a:endParaRPr>
-          </a:p>
-          <a:p>
-            <a:pPr indent="0" lvl="0" marL="0" rtl="0" algn="l">
-              <a:lnSpc>
-                <a:spcPct val="112000"/>
-              </a:lnSpc>
-              <a:spcBef>
-                <a:spcPts val="600"/>
-              </a:spcBef>
-              <a:spcAft>
-                <a:spcPts val="0"/>
-              </a:spcAft>
-              <a:buNone/>
-            </a:pPr>
-            <a:r>
-              <a:rPr lang="en-GB" sz="1300">
-                <a:solidFill>
-                  <a:srgbClr val="1F2926"/>
-                </a:solidFill>
-                <a:latin typeface="Google Sans Flex"/>
-                <a:ea typeface="Google Sans Flex"/>
-                <a:cs typeface="Google Sans Flex"/>
-                <a:sym typeface="Google Sans Flex"/>
-              </a:rPr>
-              <a:t>05  </a:t>
-            </a:r>
-            <a:r>
-              <a:rPr lang="en-GB" sz="1300">
-                <a:solidFill>
-                  <a:srgbClr val="1F2926"/>
-                </a:solidFill>
-                <a:latin typeface="Google Sans Flex"/>
-                <a:ea typeface="Google Sans Flex"/>
-                <a:cs typeface="Google Sans Flex"/>
-                <a:sym typeface="Google Sans Flex"/>
-              </a:rPr>
-              <a:t>Record measured timings, capture deployed UI and publish a 3–4 minute walkthrough.</a:t>
-            </a:r>
-            <a:endParaRPr sz="1300">
-              <a:solidFill>
-                <a:srgbClr val="1F2926"/>
-              </a:solidFill>
-              <a:latin typeface="Google Sans Flex"/>
-              <a:ea typeface="Google Sans Flex"/>
-              <a:cs typeface="Google Sans Flex"/>
-              <a:sym typeface="Google Sans Flex"/>
-            </a:endParaRPr>
-          </a:p>
-          <a:p>
-            <a:pPr indent="0" lvl="0" marL="0" rtl="0" algn="l">
-              <a:lnSpc>
-                <a:spcPct val="112000"/>
-              </a:lnSpc>
-              <a:spcBef>
-                <a:spcPts val="600"/>
-              </a:spcBef>
-              <a:spcAft>
-                <a:spcPts val="0"/>
-              </a:spcAft>
-              <a:buNone/>
-            </a:pPr>
-            <a:r>
-              <a:t/>
-            </a:r>
-            <a:endParaRPr sz="1300">
-              <a:solidFill>
-                <a:srgbClr val="1F2926"/>
-              </a:solidFill>
-              <a:latin typeface="Google Sans Flex"/>
-              <a:ea typeface="Google Sans Flex"/>
-              <a:cs typeface="Google Sans Flex"/>
-              <a:sym typeface="Google Sans Flex"/>
-            </a:endParaRPr>
-          </a:p>
-          <a:p>
-            <a:pPr indent="0" lvl="0" marL="0" rtl="0" algn="l">
-              <a:lnSpc>
-                <a:spcPct val="112000"/>
-              </a:lnSpc>
-              <a:spcBef>
-                <a:spcPts val="600"/>
-              </a:spcBef>
-              <a:spcAft>
-                <a:spcPts val="600"/>
-              </a:spcAft>
-              <a:buNone/>
-            </a:pPr>
-            <a:r>
-              <a:rPr lang="en-GB" sz="1300">
-                <a:solidFill>
-                  <a:srgbClr val="1F2926"/>
-                </a:solidFill>
-                <a:latin typeface="Google Sans Flex"/>
-                <a:ea typeface="Google Sans Flex"/>
-                <a:cs typeface="Google Sans Flex"/>
-                <a:sym typeface="Google Sans Flex"/>
-              </a:rPr>
-              <a:t>Live Gemini extraction and cloud deployment remain unverified.</a:t>
+              <a:t>04  Keep a human in the review path; the app never initiates a payment.</a:t>
             </a:r>
             <a:endParaRPr sz="1300">
               <a:solidFill>
@@ -8987,7 +8901,7 @@
   <p:cSld>
     <p:spTree>
       <p:nvGrpSpPr>
-        <p:cNvPr id="167" name="Shape 167"/>
+        <p:cNvPr id="190" name="Shape 190"/>
         <p:cNvGrpSpPr/>
         <p:nvPr/>
       </p:nvGrpSpPr>
@@ -9001,7 +8915,7 @@
       </p:grpSpPr>
       <p:pic>
         <p:nvPicPr>
-          <p:cNvPr id="168" name="Google Shape;168;p26" title="Frame 144.png"/>
+          <p:cNvPr id="191" name="Google Shape;191;p26" title="Frame 144.png"/>
           <p:cNvPicPr preferRelativeResize="0"/>
           <p:nvPr/>
         </p:nvPicPr>
@@ -9028,7 +8942,7 @@
       </p:pic>
       <p:pic>
         <p:nvPicPr>
-          <p:cNvPr id="169" name="Google Shape;169;p26" title="Group 427319979.png"/>
+          <p:cNvPr id="192" name="Google Shape;192;p26" title="Group 427319979.png"/>
           <p:cNvPicPr preferRelativeResize="0"/>
           <p:nvPr/>
         </p:nvPicPr>
@@ -9056,7 +8970,7 @@
       </p:pic>
       <p:sp>
         <p:nvSpPr>
-          <p:cNvPr id="170" name="Google Shape;170;p26"/>
+          <p:cNvPr id="193" name="Google Shape;193;p26"/>
           <p:cNvSpPr/>
           <p:nvPr/>
         </p:nvSpPr>
@@ -9099,7 +9013,7 @@
       </p:sp>
       <p:sp>
         <p:nvSpPr>
-          <p:cNvPr id="171" name="Google Shape;171;p26"/>
+          <p:cNvPr id="194" name="Google Shape;194;p26"/>
           <p:cNvSpPr txBox="1"/>
           <p:nvPr/>
         </p:nvSpPr>
@@ -9168,90 +9082,6 @@
             </a:endParaRPr>
           </a:p>
           <a:p>
-            <a:pPr indent="-317500" lvl="0" marL="457200" rtl="0" algn="l">
-              <a:spcBef>
-                <a:spcPts val="0"/>
-              </a:spcBef>
-              <a:spcAft>
-                <a:spcPts val="0"/>
-              </a:spcAft>
-              <a:buSzPts val="1400"/>
-              <a:buFont typeface="Google Sans Flex Medium"/>
-              <a:buChar char="●"/>
-            </a:pPr>
-            <a:r>
-              <a:rPr lang="en-GB">
-                <a:latin typeface="Google Sans Flex Medium"/>
-                <a:ea typeface="Google Sans Flex Medium"/>
-                <a:cs typeface="Google Sans Flex Medium"/>
-                <a:sym typeface="Google Sans Flex Medium"/>
-              </a:rPr>
-              <a:t>GitHub Public Repository</a:t>
-            </a:r>
-            <a:endParaRPr>
-              <a:latin typeface="Google Sans Flex Medium"/>
-              <a:ea typeface="Google Sans Flex Medium"/>
-              <a:cs typeface="Google Sans Flex Medium"/>
-              <a:sym typeface="Google Sans Flex Medium"/>
-            </a:endParaRPr>
-          </a:p>
-          <a:p>
-            <a:pPr indent="-317500" lvl="0" marL="457200" rtl="0" algn="l">
-              <a:spcBef>
-                <a:spcPts val="0"/>
-              </a:spcBef>
-              <a:spcAft>
-                <a:spcPts val="0"/>
-              </a:spcAft>
-              <a:buSzPts val="1400"/>
-              <a:buFont typeface="Google Sans Flex Medium"/>
-              <a:buChar char="●"/>
-            </a:pPr>
-            <a:r>
-              <a:rPr lang="en-GB">
-                <a:latin typeface="Google Sans Flex Medium"/>
-                <a:ea typeface="Google Sans Flex Medium"/>
-                <a:cs typeface="Google Sans Flex Medium"/>
-                <a:sym typeface="Google Sans Flex Medium"/>
-              </a:rPr>
-              <a:t>Demo Video Link (3–4 Minutes)</a:t>
-            </a:r>
-            <a:endParaRPr>
-              <a:latin typeface="Google Sans Flex Medium"/>
-              <a:ea typeface="Google Sans Flex Medium"/>
-              <a:cs typeface="Google Sans Flex Medium"/>
-              <a:sym typeface="Google Sans Flex Medium"/>
-            </a:endParaRPr>
-          </a:p>
-          <a:p>
-            <a:pPr indent="-317500" lvl="0" marL="457200" rtl="0" algn="l">
-              <a:spcBef>
-                <a:spcPts val="0"/>
-              </a:spcBef>
-              <a:spcAft>
-                <a:spcPts val="0"/>
-              </a:spcAft>
-              <a:buSzPts val="1400"/>
-              <a:buFont typeface="Google Sans Flex Medium"/>
-              <a:buChar char="●"/>
-            </a:pPr>
-            <a:r>
-              <a:rPr lang="en-GB">
-                <a:latin typeface="Google Sans Flex Medium"/>
-                <a:ea typeface="Google Sans Flex Medium"/>
-                <a:cs typeface="Google Sans Flex Medium"/>
-                <a:sym typeface="Google Sans Flex Medium"/>
-              </a:rPr>
-              <a:t>Final Product Link</a:t>
-            </a:r>
-            <a:endParaRPr>
-              <a:latin typeface="Google Sans Flex Medium"/>
-              <a:ea typeface="Google Sans Flex Medium"/>
-              <a:cs typeface="Google Sans Flex Medium"/>
-              <a:sym typeface="Google Sans Flex Medium"/>
-            </a:endParaRPr>
-          </a:p>
-          <a:p>
             <a:pPr indent="0" lvl="0" marL="0" rtl="0" algn="l">
               <a:spcBef>
                 <a:spcPts val="0"/>
@@ -9275,14 +9105,14 @@
       </p:sp>
       <p:sp>
         <p:nvSpPr>
-          <p:cNvPr id="172" name="Google Shape;172;p26"/>
+          <p:cNvPr id="195" name="Google Shape;195;p26"/>
           <p:cNvSpPr txBox="1"/>
           <p:nvPr/>
         </p:nvSpPr>
         <p:spPr>
           <a:xfrm>
-            <a:off x="381000" y="2159000"/>
-            <a:ext cx="8400000" cy="2700000"/>
+            <a:off x="381000" y="1600200"/>
+            <a:ext cx="8382000" cy="3365400"/>
           </a:xfrm>
           <a:prstGeom prst="rect">
             <a:avLst/>
@@ -9320,7 +9150,7 @@
                 <a:cs typeface="Google Sans Flex"/>
                 <a:sym typeface="Google Sans Flex"/>
               </a:rPr>
-              <a:t>Public GitHub repository  Pending verified public URL</a:t>
+              <a:t>Public repository</a:t>
             </a:r>
             <a:endParaRPr>
               <a:solidFill>
@@ -9346,7 +9176,16 @@
               <a:buNone/>
             </a:pPr>
             <a:r>
-              <a:t/>
+              <a:rPr lang="en-GB">
+                <a:solidFill>
+                  <a:srgbClr val="1F2926"/>
+                </a:solidFill>
+                <a:latin typeface="Google Sans Flex"/>
+                <a:ea typeface="Google Sans Flex"/>
+                <a:cs typeface="Google Sans Flex"/>
+                <a:sym typeface="Google Sans Flex"/>
+              </a:rPr>
+              <a:t>https://github.com/NikhilBudaniya/scamshield</a:t>
             </a:r>
             <a:endParaRPr>
               <a:solidFill>
@@ -9372,6 +9211,32 @@
               <a:buNone/>
             </a:pPr>
             <a:r>
+              <a:t/>
+            </a:r>
+            <a:endParaRPr>
+              <a:solidFill>
+                <a:srgbClr val="1F2926"/>
+              </a:solidFill>
+              <a:latin typeface="Google Sans Flex"/>
+              <a:ea typeface="Google Sans Flex"/>
+              <a:cs typeface="Google Sans Flex"/>
+              <a:sym typeface="Google Sans Flex"/>
+            </a:endParaRPr>
+          </a:p>
+          <a:p>
+            <a:pPr indent="0" lvl="0" marL="0" rtl="0" algn="l">
+              <a:lnSpc>
+                <a:spcPct val="112000"/>
+              </a:lnSpc>
+              <a:spcBef>
+                <a:spcPts val="600"/>
+              </a:spcBef>
+              <a:spcAft>
+                <a:spcPts val="0"/>
+              </a:spcAft>
+              <a:buNone/>
+            </a:pPr>
+            <a:r>
               <a:rPr lang="en-GB">
                 <a:solidFill>
                   <a:srgbClr val="1F2926"/>
@@ -9381,7 +9246,7 @@
                 <a:cs typeface="Google Sans Flex"/>
                 <a:sym typeface="Google Sans Flex"/>
               </a:rPr>
-              <a:t>Demo video  Pending recording; current form asks for 3–4 minutes</a:t>
+              <a:t>Live Cloud Run app</a:t>
             </a:r>
             <a:endParaRPr>
               <a:solidFill>
@@ -9407,7 +9272,16 @@
               <a:buNone/>
             </a:pPr>
             <a:r>
-              <a:t/>
+              <a:rPr lang="en-GB">
+                <a:solidFill>
+                  <a:srgbClr val="1F2926"/>
+                </a:solidFill>
+                <a:latin typeface="Google Sans Flex"/>
+                <a:ea typeface="Google Sans Flex"/>
+                <a:cs typeface="Google Sans Flex"/>
+                <a:sym typeface="Google Sans Flex"/>
+              </a:rPr>
+              <a:t>https://scamshield-304420617883.us-central1.run.app</a:t>
             </a:r>
             <a:endParaRPr>
               <a:solidFill>
@@ -9433,6 +9307,32 @@
               <a:buNone/>
             </a:pPr>
             <a:r>
+              <a:t/>
+            </a:r>
+            <a:endParaRPr>
+              <a:solidFill>
+                <a:srgbClr val="1F2926"/>
+              </a:solidFill>
+              <a:latin typeface="Google Sans Flex"/>
+              <a:ea typeface="Google Sans Flex"/>
+              <a:cs typeface="Google Sans Flex"/>
+              <a:sym typeface="Google Sans Flex"/>
+            </a:endParaRPr>
+          </a:p>
+          <a:p>
+            <a:pPr indent="0" lvl="0" marL="0" rtl="0" algn="l">
+              <a:lnSpc>
+                <a:spcPct val="112000"/>
+              </a:lnSpc>
+              <a:spcBef>
+                <a:spcPts val="600"/>
+              </a:spcBef>
+              <a:spcAft>
+                <a:spcPts val="0"/>
+              </a:spcAft>
+              <a:buNone/>
+            </a:pPr>
+            <a:r>
               <a:rPr lang="en-GB">
                 <a:solidFill>
                   <a:srgbClr val="1F2926"/>
@@ -9442,7 +9342,7 @@
                 <a:cs typeface="Google Sans Flex"/>
                 <a:sym typeface="Google Sans Flex"/>
               </a:rPr>
-              <a:t>Public GCP / Cloud Run product  Pending deployment and anonymous-browser verification</a:t>
+              <a:t>3:03 demo video</a:t>
             </a:r>
             <a:endParaRPr>
               <a:solidFill>
@@ -9468,6 +9368,48 @@
               <a:buNone/>
             </a:pPr>
             <a:r>
+              <a:rPr lang="en-GB" u="sng">
+                <a:solidFill>
+                  <a:srgbClr val="14428C"/>
+                </a:solidFill>
+                <a:latin typeface="Google Sans Flex"/>
+                <a:ea typeface="Google Sans Flex"/>
+                <a:cs typeface="Google Sans Flex"/>
+                <a:sym typeface="Google Sans Flex"/>
+                <a:hlinkClick r:id="rId5">
+                  <a:extLst>
+                    <a:ext uri="{A12FA001-AC4F-418D-AE19-62706E023703}">
+                      <ahyp:hlinkClr val="tx"/>
+                    </a:ext>
+                  </a:extLst>
+                </a:hlinkClick>
+              </a:rPr>
+              <a:t>Watch demo video (3:03)</a:t>
+            </a:r>
+            <a:endParaRPr u="sng">
+              <a:solidFill>
+                <a:srgbClr val="14428C"/>
+              </a:solidFill>
+              <a:latin typeface="Google Sans Flex"/>
+              <a:ea typeface="Google Sans Flex"/>
+              <a:cs typeface="Google Sans Flex"/>
+              <a:sym typeface="Google Sans Flex"/>
+            </a:endParaRPr>
+          </a:p>
+          <a:p>
+            <a:pPr indent="0" lvl="0" marL="0" rtl="0" algn="l">
+              <a:lnSpc>
+                <a:spcPct val="112000"/>
+              </a:lnSpc>
+              <a:spcBef>
+                <a:spcPts val="600"/>
+              </a:spcBef>
+              <a:spcAft>
+                <a:spcPts val="0"/>
+              </a:spcAft>
+              <a:buNone/>
+            </a:pPr>
+            <a:r>
               <a:t/>
             </a:r>
             <a:endParaRPr>
@@ -9503,7 +9445,7 @@
                 <a:cs typeface="Google Sans Flex"/>
                 <a:sym typeface="Google Sans Flex"/>
               </a:rPr>
-              <a:t>Do not submit this draft until all three links work without a signed-in session.</a:t>
+              <a:t>Use synthetic examples only. No payment is executed.</a:t>
             </a:r>
             <a:endParaRPr>
               <a:solidFill>
@@ -9530,7 +9472,7 @@
   <p:cSld>
     <p:spTree>
       <p:nvGrpSpPr>
-        <p:cNvPr id="176" name="Shape 176"/>
+        <p:cNvPr id="199" name="Shape 199"/>
         <p:cNvGrpSpPr/>
         <p:nvPr/>
       </p:nvGrpSpPr>
@@ -9544,7 +9486,7 @@
       </p:grpSpPr>
       <p:pic>
         <p:nvPicPr>
-          <p:cNvPr id="177" name="Google Shape;177;p27" title="Frame 144.png"/>
+          <p:cNvPr id="200" name="Google Shape;200;p27" title="Frame 144.png"/>
           <p:cNvPicPr preferRelativeResize="0"/>
           <p:nvPr/>
         </p:nvPicPr>
@@ -9571,7 +9513,7 @@
       </p:pic>
       <p:pic>
         <p:nvPicPr>
-          <p:cNvPr id="178" name="Google Shape;178;p27" title="Group 427319979.png"/>
+          <p:cNvPr id="201" name="Google Shape;201;p27" title="Group 427319979.png"/>
           <p:cNvPicPr preferRelativeResize="0"/>
           <p:nvPr/>
         </p:nvPicPr>
@@ -9599,7 +9541,7 @@
       </p:pic>
       <p:sp>
         <p:nvSpPr>
-          <p:cNvPr id="179" name="Google Shape;179;p27"/>
+          <p:cNvPr id="202" name="Google Shape;202;p27"/>
           <p:cNvSpPr/>
           <p:nvPr/>
         </p:nvSpPr>
@@ -9653,7 +9595,7 @@
   <p:cSld>
     <p:spTree>
       <p:nvGrpSpPr>
-        <p:cNvPr id="183" name="Shape 183"/>
+        <p:cNvPr id="206" name="Shape 206"/>
         <p:cNvGrpSpPr/>
         <p:nvPr/>
       </p:nvGrpSpPr>
@@ -9667,7 +9609,7 @@
       </p:grpSpPr>
       <p:pic>
         <p:nvPicPr>
-          <p:cNvPr id="184" name="Google Shape;184;p28" title="Frame 144.png"/>
+          <p:cNvPr id="207" name="Google Shape;207;p28" title="Frame 144.png"/>
           <p:cNvPicPr preferRelativeResize="0"/>
           <p:nvPr/>
         </p:nvPicPr>
@@ -9694,7 +9636,7 @@
       </p:pic>
       <p:pic>
         <p:nvPicPr>
-          <p:cNvPr id="185" name="Google Shape;185;p28" title="Frame 145.png"/>
+          <p:cNvPr id="208" name="Google Shape;208;p28" title="Frame 145.png"/>
           <p:cNvPicPr preferRelativeResize="0"/>
           <p:nvPr/>
         </p:nvPicPr>
@@ -10134,7 +10076,7 @@
         <p:spPr>
           <a:xfrm>
             <a:off x="381000" y="1320800"/>
-            <a:ext cx="8400000" cy="3000000"/>
+            <a:ext cx="8382000" cy="3365400"/>
           </a:xfrm>
           <a:prstGeom prst="rect">
             <a:avLst/>
@@ -10172,7 +10114,7 @@
                 <a:cs typeface="Google Sans Flex"/>
                 <a:sym typeface="Google Sans Flex"/>
               </a:rPr>
-              <a:t>Invoice instructions can change the payment destination while the invoice still looks routine.</a:t>
+              <a:t>Invoice instructions can change the destination account while the rest of the invoice looks routine.</a:t>
             </a:r>
             <a:endParaRPr>
               <a:solidFill>
@@ -10233,7 +10175,7 @@
                 <a:cs typeface="Google Sans Flex"/>
                 <a:sym typeface="Google Sans Flex"/>
               </a:rPr>
-              <a:t>The intended live flow uses Gemini to propose candidate fields, then asks a person to confirm them before comparison with the saved vendor record. The local demo loads a saved fixture. No payment is executed.</a:t>
+              <a:t>ScamShield extracts candidate fields for human review, then compares the confirmed destination with a known vendor record. Deterministic policy returns Continue, Verify or Review with evidence.</a:t>
             </a:r>
             <a:endParaRPr>
               <a:solidFill>
@@ -10294,19 +10236,7 @@
                 <a:cs typeface="Google Sans Flex"/>
                 <a:sym typeface="Google Sans Flex"/>
               </a:rPr>
-              <a:t>CURRENT PROTOTYPE  Synthetic INR forms, a shared assessment API, deterministic rules and case evidence. </a:t>
-            </a:r>
-            <a:r>
-              <a:rPr lang="en-GB">
-                <a:solidFill>
-                  <a:srgbClr val="1F2926"/>
-                </a:solidFill>
-                <a:latin typeface="Google Sans Flex"/>
-                <a:ea typeface="Google Sans Flex"/>
-                <a:cs typeface="Google Sans Flex"/>
-                <a:sym typeface="Google Sans Flex"/>
-              </a:rPr>
-              <a:t>Local fixture-mode invoice review is available. Live Gemini extraction, hosted persistence and Cloud Run are unverified.</a:t>
+              <a:t>LIVE PROTOTYPE  Two synthetic invoice flows ran on the public service. Gemini extracts fields and classifies context. On request, it ranks saved evidence; deterministic templates render the explanation. No payment is executed.</a:t>
             </a:r>
             <a:endParaRPr>
               <a:solidFill>
@@ -10502,110 +10432,6 @@
             </a:endParaRPr>
           </a:p>
           <a:p>
-            <a:pPr indent="-311150" lvl="0" marL="457200" rtl="0" algn="l">
-              <a:spcBef>
-                <a:spcPts val="0"/>
-              </a:spcBef>
-              <a:spcAft>
-                <a:spcPts val="0"/>
-              </a:spcAft>
-              <a:buSzPts val="1300"/>
-              <a:buFont typeface="Google Sans Flex"/>
-              <a:buChar char="●"/>
-            </a:pPr>
-            <a:r>
-              <a:rPr lang="en-GB" sz="1300">
-                <a:latin typeface="Google Sans Flex"/>
-                <a:ea typeface="Google Sans Flex"/>
-                <a:cs typeface="Google Sans Flex"/>
-                <a:sym typeface="Google Sans Flex"/>
-              </a:rPr>
-              <a:t>How different is it from any of the other existing ideas?</a:t>
-            </a:r>
-            <a:endParaRPr sz="1300">
-              <a:latin typeface="Google Sans Flex"/>
-              <a:ea typeface="Google Sans Flex"/>
-              <a:cs typeface="Google Sans Flex"/>
-              <a:sym typeface="Google Sans Flex"/>
-            </a:endParaRPr>
-          </a:p>
-          <a:p>
-            <a:pPr indent="-311150" lvl="0" marL="457200" rtl="0" algn="l">
-              <a:spcBef>
-                <a:spcPts val="0"/>
-              </a:spcBef>
-              <a:spcAft>
-                <a:spcPts val="0"/>
-              </a:spcAft>
-              <a:buSzPts val="1300"/>
-              <a:buFont typeface="Google Sans Flex"/>
-              <a:buChar char="●"/>
-            </a:pPr>
-            <a:r>
-              <a:rPr lang="en-GB" sz="1300">
-                <a:latin typeface="Google Sans Flex"/>
-                <a:ea typeface="Google Sans Flex"/>
-                <a:cs typeface="Google Sans Flex"/>
-                <a:sym typeface="Google Sans Flex"/>
-              </a:rPr>
-              <a:t>How will it be able to solve the problem?</a:t>
-            </a:r>
-            <a:endParaRPr sz="1300">
-              <a:latin typeface="Google Sans Flex"/>
-              <a:ea typeface="Google Sans Flex"/>
-              <a:cs typeface="Google Sans Flex"/>
-              <a:sym typeface="Google Sans Flex"/>
-            </a:endParaRPr>
-          </a:p>
-          <a:p>
-            <a:pPr indent="-311150" lvl="0" marL="457200" rtl="0" algn="l">
-              <a:spcBef>
-                <a:spcPts val="0"/>
-              </a:spcBef>
-              <a:spcAft>
-                <a:spcPts val="0"/>
-              </a:spcAft>
-              <a:buSzPts val="1300"/>
-              <a:buFont typeface="Google Sans Flex"/>
-              <a:buChar char="●"/>
-            </a:pPr>
-            <a:r>
-              <a:rPr lang="en-GB" sz="1300">
-                <a:latin typeface="Google Sans Flex"/>
-                <a:ea typeface="Google Sans Flex"/>
-                <a:cs typeface="Google Sans Flex"/>
-                <a:sym typeface="Google Sans Flex"/>
-              </a:rPr>
-              <a:t>USP of the proposed solution</a:t>
-            </a:r>
-            <a:endParaRPr sz="1300">
-              <a:latin typeface="Google Sans Flex"/>
-              <a:ea typeface="Google Sans Flex"/>
-              <a:cs typeface="Google Sans Flex"/>
-              <a:sym typeface="Google Sans Flex"/>
-            </a:endParaRPr>
-          </a:p>
-          <a:p>
-            <a:pPr indent="0" lvl="0" marL="0" rtl="0" algn="l">
-              <a:spcBef>
-                <a:spcPts val="0"/>
-              </a:spcBef>
-              <a:spcAft>
-                <a:spcPts val="0"/>
-              </a:spcAft>
-              <a:buNone/>
-            </a:pPr>
-            <a:r>
-              <a:t/>
-            </a:r>
-            <a:endParaRPr sz="1600">
-              <a:latin typeface="Google Sans Flex Medium"/>
-              <a:ea typeface="Google Sans Flex Medium"/>
-              <a:cs typeface="Google Sans Flex Medium"/>
-              <a:sym typeface="Google Sans Flex Medium"/>
-            </a:endParaRPr>
-          </a:p>
-          <a:p>
             <a:pPr indent="0" lvl="0" marL="0" rtl="0" algn="l">
               <a:spcBef>
                 <a:spcPts val="0"/>
@@ -10635,8 +10461,8 @@
         </p:nvSpPr>
         <p:spPr>
           <a:xfrm>
-            <a:off x="381000" y="1981200"/>
-            <a:ext cx="8400000" cy="2760000"/>
+            <a:off x="381000" y="1524000"/>
+            <a:ext cx="8382000" cy="3365400"/>
           </a:xfrm>
           <a:prstGeom prst="rect">
             <a:avLst/>
@@ -10709,7 +10535,7 @@
                 <a:cs typeface="Google Sans Flex"/>
                 <a:sym typeface="Google Sans Flex"/>
               </a:rPr>
-              <a:t>Assess invoice instructions alongside the saved vendor destination before payment approval.</a:t>
+              <a:t>Invoice instructions are reviewed alongside the saved vendor destination before a simulated decision.</a:t>
             </a:r>
             <a:endParaRPr>
               <a:solidFill>
@@ -10805,7 +10631,7 @@
                 <a:cs typeface="Google Sans Flex"/>
                 <a:sym typeface="Google Sans Flex"/>
               </a:rPr>
-              <a:t>Gemini proposes structured fields. A person checks and confirms them. Deterministic rules compare the confirmed destination with vendor details and surface anomalies or missing checks.</a:t>
+              <a:t>Vertex Gemini extracts invoice fields and classifies request context. A person reviews and confirms invoice details. Deterministic rules compare the destination with vendor details and show anomalies or missing checks.</a:t>
             </a:r>
             <a:endParaRPr>
               <a:solidFill>
@@ -10901,7 +10727,7 @@
                 <a:cs typeface="Google Sans Flex"/>
                 <a:sym typeface="Google Sans Flex"/>
               </a:rPr>
-              <a:t>Evidence stays visible. A separate policy recommends continue, verify or review. The simulator moves no money and never treats extracted identity as trusted by itself.</a:t>
+              <a:t>The policy decision stays separate from model output. Requested explanations use Gemini-ranked saved evidence and deterministic templates.</a:t>
             </a:r>
             <a:endParaRPr>
               <a:solidFill>
@@ -11099,7 +10925,7 @@
         <p:spPr>
           <a:xfrm>
             <a:off x="381000" y="1320800"/>
-            <a:ext cx="8400000" cy="3000000"/>
+            <a:ext cx="8382000" cy="3365400"/>
           </a:xfrm>
           <a:prstGeom prst="rect">
             <a:avLst/>
@@ -11207,7 +11033,7 @@
                 <a:cs typeface="Google Sans Flex"/>
                 <a:sym typeface="Google Sans Flex"/>
               </a:rPr>
-              <a:t>Shared FastAPI assessment engine with deterministic rules and optional context classification</a:t>
+              <a:t>Shared FastAPI assessment engine with deterministic rules and context classification</a:t>
             </a:r>
             <a:endParaRPr>
               <a:solidFill>
@@ -11242,7 +11068,7 @@
                 <a:cs typeface="Google Sans Flex"/>
                 <a:sym typeface="Google Sans Flex"/>
               </a:rPr>
-              <a:t>Case history records evidence, missing checks and provider status</a:t>
+              <a:t>Vertex Gemini extracts invoice fields and classifies request context</a:t>
             </a:r>
             <a:endParaRPr>
               <a:solidFill>
@@ -11277,7 +11103,7 @@
                 <a:cs typeface="Google Sans Flex"/>
                 <a:sym typeface="Google Sans Flex"/>
               </a:rPr>
-              <a:t>Fixture mode keeps the local walkthrough repeatable</a:t>
+              <a:t>Case history stores evidence, missing checks and provider status</a:t>
             </a:r>
             <a:endParaRPr>
               <a:solidFill>
@@ -11338,7 +11164,7 @@
                 <a:cs typeface="Google Sans Flex"/>
                 <a:sym typeface="Google Sans Flex"/>
               </a:rPr>
-              <a:t>INVOICE REVIEW</a:t>
+              <a:t>CLOUD SERVICES</a:t>
             </a:r>
             <a:endParaRPr>
               <a:solidFill>
@@ -11373,7 +11199,7 @@
                 <a:cs typeface="Google Sans Flex"/>
                 <a:sym typeface="Google Sans Flex"/>
               </a:rPr>
-              <a:t>Local invoice review uses a saved fixture. Gemini extraction with human confirmation, vendor comparison, anomaly evidence and downloadable case JSON is the intended live path; live extraction and hosted persistence remain unverified.</a:t>
+              <a:t>Cloud Run, Firebase anonymous authentication and Firestore support the live demo. The prototype simulates decisions; no payment is executed.</a:t>
             </a:r>
             <a:endParaRPr>
               <a:solidFill>
@@ -11565,31 +11391,41 @@
       <p:sp>
         <p:nvSpPr>
           <p:cNvPr id="99" name="Google Shape;99;p18"/>
-          <p:cNvSpPr txBox="1"/>
+          <p:cNvSpPr/>
           <p:nvPr/>
         </p:nvSpPr>
         <p:spPr>
           <a:xfrm>
-            <a:off x="381000" y="1320800"/>
-            <a:ext cx="8400000" cy="3000000"/>
-          </a:xfrm>
-          <a:prstGeom prst="rect">
-            <a:avLst/>
+            <a:off x="342900" y="1752600"/>
+            <a:ext cx="1346100" cy="990600"/>
+          </a:xfrm>
+          <a:prstGeom prst="roundRect">
+            <a:avLst>
+              <a:gd fmla="val 16667" name="adj"/>
+            </a:avLst>
           </a:prstGeom>
-          <a:noFill/>
-          <a:ln>
-            <a:noFill/>
+          <a:solidFill>
+            <a:srgbClr val="E5F2ED"/>
+          </a:solidFill>
+          <a:ln cap="flat" cmpd="sng" w="9525">
+            <a:solidFill>
+              <a:srgbClr val="296157"/>
+            </a:solidFill>
+            <a:prstDash val="solid"/>
+            <a:round/>
+            <a:headEnd len="sm" w="sm" type="none"/>
+            <a:tailEnd len="sm" w="sm" type="none"/>
           </a:ln>
         </p:spPr>
         <p:txBody>
-          <a:bodyPr anchorCtr="0" anchor="t" bIns="91425" lIns="91425" spcFirstLastPara="1" rIns="91425" wrap="square" tIns="91425">
+          <a:bodyPr anchorCtr="0" anchor="ctr" bIns="91425" lIns="91425" spcFirstLastPara="1" rIns="91425" wrap="square" tIns="91425">
             <a:noAutofit/>
           </a:bodyPr>
           <a:lstStyle/>
           <a:p>
-            <a:pPr indent="0" lvl="0" marL="0" rtl="0" algn="l">
+            <a:pPr indent="0" lvl="0" marL="0" rtl="0" algn="ctr">
               <a:lnSpc>
-                <a:spcPct val="112000"/>
+                <a:spcPct val="105000"/>
               </a:lnSpc>
               <a:spcBef>
                 <a:spcPts val="0"/>
@@ -11600,7 +11436,7 @@
               <a:buNone/>
             </a:pPr>
             <a:r>
-              <a:rPr lang="en-GB">
+              <a:rPr lang="en-GB" sz="1100">
                 <a:solidFill>
                   <a:srgbClr val="1F2926"/>
                 </a:solidFill>
@@ -11609,9 +11445,9 @@
                 <a:cs typeface="Google Sans Flex"/>
                 <a:sym typeface="Google Sans Flex"/>
               </a:rPr>
-              <a:t>PROPOSED INVOICE FLOW</a:t>
-            </a:r>
-            <a:endParaRPr>
+              <a:t>Invoice upload</a:t>
+            </a:r>
+            <a:endParaRPr sz="1100">
               <a:solidFill>
                 <a:srgbClr val="1F2926"/>
               </a:solidFill>
@@ -11621,21 +11457,57 @@
               <a:sym typeface="Google Sans Flex"/>
             </a:endParaRPr>
           </a:p>
-          <a:p>
-            <a:pPr indent="0" lvl="0" marL="0" rtl="0" algn="l">
+        </p:txBody>
+      </p:sp>
+      <p:sp>
+        <p:nvSpPr>
+          <p:cNvPr id="100" name="Google Shape;100;p18"/>
+          <p:cNvSpPr/>
+          <p:nvPr/>
+        </p:nvSpPr>
+        <p:spPr>
+          <a:xfrm>
+            <a:off x="1765300" y="1752600"/>
+            <a:ext cx="1346100" cy="990600"/>
+          </a:xfrm>
+          <a:prstGeom prst="roundRect">
+            <a:avLst>
+              <a:gd fmla="val 16667" name="adj"/>
+            </a:avLst>
+          </a:prstGeom>
+          <a:solidFill>
+            <a:srgbClr val="E5F2ED"/>
+          </a:solidFill>
+          <a:ln cap="flat" cmpd="sng" w="9525">
+            <a:solidFill>
+              <a:srgbClr val="296157"/>
+            </a:solidFill>
+            <a:prstDash val="solid"/>
+            <a:round/>
+            <a:headEnd len="sm" w="sm" type="none"/>
+            <a:tailEnd len="sm" w="sm" type="none"/>
+          </a:ln>
+        </p:spPr>
+        <p:txBody>
+          <a:bodyPr anchorCtr="0" anchor="ctr" bIns="91425" lIns="91425" spcFirstLastPara="1" rIns="91425" wrap="square" tIns="91425">
+            <a:noAutofit/>
+          </a:bodyPr>
+          <a:lstStyle/>
+          <a:p>
+            <a:pPr indent="0" lvl="0" marL="0" rtl="0" algn="ctr">
               <a:lnSpc>
-                <a:spcPct val="112000"/>
+                <a:spcPct val="105000"/>
               </a:lnSpc>
               <a:spcBef>
-                <a:spcPts val="600"/>
-              </a:spcBef>
-              <a:spcAft>
-                <a:spcPts val="0"/>
-              </a:spcAft>
-              <a:buNone/>
-            </a:pPr>
-            <a:r>
-              <a:rPr lang="en-GB">
+                <a:spcPts val="0"/>
+              </a:spcBef>
+              <a:spcAft>
+                <a:spcPts val="0"/>
+              </a:spcAft>
+              <a:buNone/>
+            </a:pPr>
+            <a:r>
+              <a:rPr lang="en-GB" sz="1100">
                 <a:solidFill>
                   <a:srgbClr val="1F2926"/>
                 </a:solidFill>
@@ -11644,9 +11516,9 @@
                 <a:cs typeface="Google Sans Flex"/>
                 <a:sym typeface="Google Sans Flex"/>
               </a:rPr>
-              <a:t>01  Upload a PDF, PNG or JPEG invoice up to 5 MiB.</a:t>
-            </a:r>
-            <a:endParaRPr>
+              <a:t>Gemini field extraction</a:t>
+            </a:r>
+            <a:endParaRPr sz="1100">
               <a:solidFill>
                 <a:srgbClr val="1F2926"/>
               </a:solidFill>
@@ -11656,21 +11528,57 @@
               <a:sym typeface="Google Sans Flex"/>
             </a:endParaRPr>
           </a:p>
-          <a:p>
-            <a:pPr indent="0" lvl="0" marL="0" rtl="0" algn="l">
+        </p:txBody>
+      </p:sp>
+      <p:sp>
+        <p:nvSpPr>
+          <p:cNvPr id="101" name="Google Shape;101;p18"/>
+          <p:cNvSpPr/>
+          <p:nvPr/>
+        </p:nvSpPr>
+        <p:spPr>
+          <a:xfrm>
+            <a:off x="3187700" y="1752600"/>
+            <a:ext cx="1346100" cy="990600"/>
+          </a:xfrm>
+          <a:prstGeom prst="roundRect">
+            <a:avLst>
+              <a:gd fmla="val 16667" name="adj"/>
+            </a:avLst>
+          </a:prstGeom>
+          <a:solidFill>
+            <a:srgbClr val="E5F2ED"/>
+          </a:solidFill>
+          <a:ln cap="flat" cmpd="sng" w="9525">
+            <a:solidFill>
+              <a:srgbClr val="296157"/>
+            </a:solidFill>
+            <a:prstDash val="solid"/>
+            <a:round/>
+            <a:headEnd len="sm" w="sm" type="none"/>
+            <a:tailEnd len="sm" w="sm" type="none"/>
+          </a:ln>
+        </p:spPr>
+        <p:txBody>
+          <a:bodyPr anchorCtr="0" anchor="ctr" bIns="91425" lIns="91425" spcFirstLastPara="1" rIns="91425" wrap="square" tIns="91425">
+            <a:noAutofit/>
+          </a:bodyPr>
+          <a:lstStyle/>
+          <a:p>
+            <a:pPr indent="0" lvl="0" marL="0" rtl="0" algn="ctr">
               <a:lnSpc>
-                <a:spcPct val="112000"/>
+                <a:spcPct val="105000"/>
               </a:lnSpc>
               <a:spcBef>
-                <a:spcPts val="600"/>
-              </a:spcBef>
-              <a:spcAft>
-                <a:spcPts val="0"/>
-              </a:spcAft>
-              <a:buNone/>
-            </a:pPr>
-            <a:r>
-              <a:rPr lang="en-GB">
+                <a:spcPts val="0"/>
+              </a:spcBef>
+              <a:spcAft>
+                <a:spcPts val="0"/>
+              </a:spcAft>
+              <a:buNone/>
+            </a:pPr>
+            <a:r>
+              <a:rPr lang="en-GB" sz="1100">
                 <a:solidFill>
                   <a:srgbClr val="1F2926"/>
                 </a:solidFill>
@@ -11679,9 +11587,9 @@
                 <a:cs typeface="Google Sans Flex"/>
                 <a:sym typeface="Google Sans Flex"/>
               </a:rPr>
-              <a:t>02  The intended live path uses Gemini to propose fields; the current demo loads a saved fixture.</a:t>
-            </a:r>
-            <a:endParaRPr>
+              <a:t>Human review and confirmation</a:t>
+            </a:r>
+            <a:endParaRPr sz="1100">
               <a:solidFill>
                 <a:srgbClr val="1F2926"/>
               </a:solidFill>
@@ -11691,21 +11599,57 @@
               <a:sym typeface="Google Sans Flex"/>
             </a:endParaRPr>
           </a:p>
-          <a:p>
-            <a:pPr indent="0" lvl="0" marL="0" rtl="0" algn="l">
+        </p:txBody>
+      </p:sp>
+      <p:sp>
+        <p:nvSpPr>
+          <p:cNvPr id="102" name="Google Shape;102;p18"/>
+          <p:cNvSpPr/>
+          <p:nvPr/>
+        </p:nvSpPr>
+        <p:spPr>
+          <a:xfrm>
+            <a:off x="4610100" y="1752600"/>
+            <a:ext cx="1346100" cy="990600"/>
+          </a:xfrm>
+          <a:prstGeom prst="roundRect">
+            <a:avLst>
+              <a:gd fmla="val 16667" name="adj"/>
+            </a:avLst>
+          </a:prstGeom>
+          <a:solidFill>
+            <a:srgbClr val="E5F2ED"/>
+          </a:solidFill>
+          <a:ln cap="flat" cmpd="sng" w="9525">
+            <a:solidFill>
+              <a:srgbClr val="296157"/>
+            </a:solidFill>
+            <a:prstDash val="solid"/>
+            <a:round/>
+            <a:headEnd len="sm" w="sm" type="none"/>
+            <a:tailEnd len="sm" w="sm" type="none"/>
+          </a:ln>
+        </p:spPr>
+        <p:txBody>
+          <a:bodyPr anchorCtr="0" anchor="ctr" bIns="91425" lIns="91425" spcFirstLastPara="1" rIns="91425" wrap="square" tIns="91425">
+            <a:noAutofit/>
+          </a:bodyPr>
+          <a:lstStyle/>
+          <a:p>
+            <a:pPr indent="0" lvl="0" marL="0" rtl="0" algn="ctr">
               <a:lnSpc>
-                <a:spcPct val="112000"/>
+                <a:spcPct val="105000"/>
               </a:lnSpc>
               <a:spcBef>
-                <a:spcPts val="600"/>
-              </a:spcBef>
-              <a:spcAft>
-                <a:spcPts val="0"/>
-              </a:spcAft>
-              <a:buNone/>
-            </a:pPr>
-            <a:r>
-              <a:rPr lang="en-GB">
+                <a:spcPts val="0"/>
+              </a:spcBef>
+              <a:spcAft>
+                <a:spcPts val="0"/>
+              </a:spcAft>
+              <a:buNone/>
+            </a:pPr>
+            <a:r>
+              <a:rPr lang="en-GB" sz="1100">
                 <a:solidFill>
                   <a:srgbClr val="1F2926"/>
                 </a:solidFill>
@@ -11714,9 +11658,9 @@
                 <a:cs typeface="Google Sans Flex"/>
                 <a:sym typeface="Google Sans Flex"/>
               </a:rPr>
-              <a:t>03  A person reviews and edits the extracted fields. Nothing submits automatically.</a:t>
-            </a:r>
-            <a:endParaRPr>
+              <a:t>Rules + Gemini context</a:t>
+            </a:r>
+            <a:endParaRPr sz="1100">
               <a:solidFill>
                 <a:srgbClr val="1F2926"/>
               </a:solidFill>
@@ -11726,21 +11670,57 @@
               <a:sym typeface="Google Sans Flex"/>
             </a:endParaRPr>
           </a:p>
-          <a:p>
-            <a:pPr indent="0" lvl="0" marL="0" rtl="0" algn="l">
+        </p:txBody>
+      </p:sp>
+      <p:sp>
+        <p:nvSpPr>
+          <p:cNvPr id="103" name="Google Shape;103;p18"/>
+          <p:cNvSpPr/>
+          <p:nvPr/>
+        </p:nvSpPr>
+        <p:spPr>
+          <a:xfrm>
+            <a:off x="6032500" y="1752600"/>
+            <a:ext cx="1346100" cy="990600"/>
+          </a:xfrm>
+          <a:prstGeom prst="roundRect">
+            <a:avLst>
+              <a:gd fmla="val 16667" name="adj"/>
+            </a:avLst>
+          </a:prstGeom>
+          <a:solidFill>
+            <a:srgbClr val="E5F2ED"/>
+          </a:solidFill>
+          <a:ln cap="flat" cmpd="sng" w="9525">
+            <a:solidFill>
+              <a:srgbClr val="296157"/>
+            </a:solidFill>
+            <a:prstDash val="solid"/>
+            <a:round/>
+            <a:headEnd len="sm" w="sm" type="none"/>
+            <a:tailEnd len="sm" w="sm" type="none"/>
+          </a:ln>
+        </p:spPr>
+        <p:txBody>
+          <a:bodyPr anchorCtr="0" anchor="ctr" bIns="91425" lIns="91425" spcFirstLastPara="1" rIns="91425" wrap="square" tIns="91425">
+            <a:noAutofit/>
+          </a:bodyPr>
+          <a:lstStyle/>
+          <a:p>
+            <a:pPr indent="0" lvl="0" marL="0" rtl="0" algn="ctr">
               <a:lnSpc>
-                <a:spcPct val="112000"/>
+                <a:spcPct val="105000"/>
               </a:lnSpc>
               <a:spcBef>
-                <a:spcPts val="600"/>
-              </a:spcBef>
-              <a:spcAft>
-                <a:spcPts val="0"/>
-              </a:spcAft>
-              <a:buNone/>
-            </a:pPr>
-            <a:r>
-              <a:rPr lang="en-GB">
+                <a:spcPts val="0"/>
+              </a:spcBef>
+              <a:spcAft>
+                <a:spcPts val="0"/>
+              </a:spcAft>
+              <a:buNone/>
+            </a:pPr>
+            <a:r>
+              <a:rPr lang="en-GB" sz="1100">
                 <a:solidFill>
                   <a:srgbClr val="1F2926"/>
                 </a:solidFill>
@@ -11749,9 +11729,9 @@
                 <a:cs typeface="Google Sans Flex"/>
                 <a:sym typeface="Google Sans Flex"/>
               </a:rPr>
-              <a:t>04  The person selects a known vendor record and confirms the destination.</a:t>
-            </a:r>
-            <a:endParaRPr>
+              <a:t>Policy decision</a:t>
+            </a:r>
+            <a:endParaRPr sz="1100">
               <a:solidFill>
                 <a:srgbClr val="1F2926"/>
               </a:solidFill>
@@ -11762,20 +11742,20 @@
             </a:endParaRPr>
           </a:p>
           <a:p>
-            <a:pPr indent="0" lvl="0" marL="0" rtl="0" algn="l">
+            <a:pPr indent="0" lvl="0" marL="0" rtl="0" algn="ctr">
               <a:lnSpc>
-                <a:spcPct val="112000"/>
+                <a:spcPct val="105000"/>
               </a:lnSpc>
               <a:spcBef>
-                <a:spcPts val="600"/>
-              </a:spcBef>
-              <a:spcAft>
-                <a:spcPts val="0"/>
-              </a:spcAft>
-              <a:buNone/>
-            </a:pPr>
-            <a:r>
-              <a:rPr lang="en-GB">
+                <a:spcPts val="0"/>
+              </a:spcBef>
+              <a:spcAft>
+                <a:spcPts val="0"/>
+              </a:spcAft>
+              <a:buNone/>
+            </a:pPr>
+            <a:r>
+              <a:rPr lang="en-GB" sz="1100">
                 <a:solidFill>
                   <a:srgbClr val="1F2926"/>
                 </a:solidFill>
@@ -11784,9 +11764,9 @@
                 <a:cs typeface="Google Sans Flex"/>
                 <a:sym typeface="Google Sans Flex"/>
               </a:rPr>
-              <a:t>05  Rules check changed details, transaction history and missing data.</a:t>
-            </a:r>
-            <a:endParaRPr>
+              <a:t>Continue · Verify · Review</a:t>
+            </a:r>
+            <a:endParaRPr sz="1100">
               <a:solidFill>
                 <a:srgbClr val="1F2926"/>
               </a:solidFill>
@@ -11796,21 +11776,57 @@
               <a:sym typeface="Google Sans Flex"/>
             </a:endParaRPr>
           </a:p>
-          <a:p>
-            <a:pPr indent="0" lvl="0" marL="0" rtl="0" algn="l">
+        </p:txBody>
+      </p:sp>
+      <p:sp>
+        <p:nvSpPr>
+          <p:cNvPr id="104" name="Google Shape;104;p18"/>
+          <p:cNvSpPr/>
+          <p:nvPr/>
+        </p:nvSpPr>
+        <p:spPr>
+          <a:xfrm>
+            <a:off x="7454900" y="1752600"/>
+            <a:ext cx="1346100" cy="990600"/>
+          </a:xfrm>
+          <a:prstGeom prst="roundRect">
+            <a:avLst>
+              <a:gd fmla="val 16667" name="adj"/>
+            </a:avLst>
+          </a:prstGeom>
+          <a:solidFill>
+            <a:srgbClr val="E5F2ED"/>
+          </a:solidFill>
+          <a:ln cap="flat" cmpd="sng" w="9525">
+            <a:solidFill>
+              <a:srgbClr val="296157"/>
+            </a:solidFill>
+            <a:prstDash val="solid"/>
+            <a:round/>
+            <a:headEnd len="sm" w="sm" type="none"/>
+            <a:tailEnd len="sm" w="sm" type="none"/>
+          </a:ln>
+        </p:spPr>
+        <p:txBody>
+          <a:bodyPr anchorCtr="0" anchor="ctr" bIns="91425" lIns="91425" spcFirstLastPara="1" rIns="91425" wrap="square" tIns="91425">
+            <a:noAutofit/>
+          </a:bodyPr>
+          <a:lstStyle/>
+          <a:p>
+            <a:pPr indent="0" lvl="0" marL="0" rtl="0" algn="ctr">
               <a:lnSpc>
-                <a:spcPct val="112000"/>
+                <a:spcPct val="105000"/>
               </a:lnSpc>
               <a:spcBef>
-                <a:spcPts val="600"/>
-              </a:spcBef>
-              <a:spcAft>
-                <a:spcPts val="0"/>
-              </a:spcAft>
-              <a:buNone/>
-            </a:pPr>
-            <a:r>
-              <a:rPr lang="en-GB">
+                <a:spcPts val="0"/>
+              </a:spcBef>
+              <a:spcAft>
+                <a:spcPts val="0"/>
+              </a:spcAft>
+              <a:buNone/>
+            </a:pPr>
+            <a:r>
+              <a:rPr lang="en-GB" sz="1100">
                 <a:solidFill>
                   <a:srgbClr val="1F2926"/>
                 </a:solidFill>
@@ -11819,9 +11835,9 @@
                 <a:cs typeface="Google Sans Flex"/>
                 <a:sym typeface="Google Sans Flex"/>
               </a:rPr>
-              <a:t>06  The policy returns continue, verify or review with visible evidence.</a:t>
-            </a:r>
-            <a:endParaRPr>
+              <a:t>Firestore case record</a:t>
+            </a:r>
+            <a:endParaRPr sz="1100">
               <a:solidFill>
                 <a:srgbClr val="1F2926"/>
               </a:solidFill>
@@ -11831,21 +11847,187 @@
               <a:sym typeface="Google Sans Flex"/>
             </a:endParaRPr>
           </a:p>
-          <a:p>
-            <a:pPr indent="0" lvl="0" marL="0" rtl="0" algn="l">
+        </p:txBody>
+      </p:sp>
+      <p:cxnSp>
+        <p:nvCxnSpPr>
+          <p:cNvPr id="105" name="Google Shape;105;p18"/>
+          <p:cNvCxnSpPr/>
+          <p:nvPr/>
+        </p:nvCxnSpPr>
+        <p:spPr>
+          <a:xfrm>
+            <a:off x="1689100" y="2247900"/>
+            <a:ext cx="76200" cy="1200"/>
+          </a:xfrm>
+          <a:prstGeom prst="straightConnector1">
+            <a:avLst/>
+          </a:prstGeom>
+          <a:noFill/>
+          <a:ln cap="flat" cmpd="sng" w="19050">
+            <a:solidFill>
+              <a:srgbClr val="296157"/>
+            </a:solidFill>
+            <a:prstDash val="solid"/>
+            <a:round/>
+            <a:headEnd len="med" w="med" type="none"/>
+            <a:tailEnd len="med" w="med" type="triangle"/>
+          </a:ln>
+        </p:spPr>
+      </p:cxnSp>
+      <p:cxnSp>
+        <p:nvCxnSpPr>
+          <p:cNvPr id="106" name="Google Shape;106;p18"/>
+          <p:cNvCxnSpPr/>
+          <p:nvPr/>
+        </p:nvCxnSpPr>
+        <p:spPr>
+          <a:xfrm>
+            <a:off x="3111500" y="2247900"/>
+            <a:ext cx="76200" cy="1200"/>
+          </a:xfrm>
+          <a:prstGeom prst="straightConnector1">
+            <a:avLst/>
+          </a:prstGeom>
+          <a:noFill/>
+          <a:ln cap="flat" cmpd="sng" w="19050">
+            <a:solidFill>
+              <a:srgbClr val="296157"/>
+            </a:solidFill>
+            <a:prstDash val="solid"/>
+            <a:round/>
+            <a:headEnd len="med" w="med" type="none"/>
+            <a:tailEnd len="med" w="med" type="triangle"/>
+          </a:ln>
+        </p:spPr>
+      </p:cxnSp>
+      <p:cxnSp>
+        <p:nvCxnSpPr>
+          <p:cNvPr id="107" name="Google Shape;107;p18"/>
+          <p:cNvCxnSpPr/>
+          <p:nvPr/>
+        </p:nvCxnSpPr>
+        <p:spPr>
+          <a:xfrm>
+            <a:off x="4533900" y="2247900"/>
+            <a:ext cx="76200" cy="1200"/>
+          </a:xfrm>
+          <a:prstGeom prst="straightConnector1">
+            <a:avLst/>
+          </a:prstGeom>
+          <a:noFill/>
+          <a:ln cap="flat" cmpd="sng" w="19050">
+            <a:solidFill>
+              <a:srgbClr val="296157"/>
+            </a:solidFill>
+            <a:prstDash val="solid"/>
+            <a:round/>
+            <a:headEnd len="med" w="med" type="none"/>
+            <a:tailEnd len="med" w="med" type="triangle"/>
+          </a:ln>
+        </p:spPr>
+      </p:cxnSp>
+      <p:cxnSp>
+        <p:nvCxnSpPr>
+          <p:cNvPr id="108" name="Google Shape;108;p18"/>
+          <p:cNvCxnSpPr/>
+          <p:nvPr/>
+        </p:nvCxnSpPr>
+        <p:spPr>
+          <a:xfrm>
+            <a:off x="5956300" y="2247900"/>
+            <a:ext cx="76200" cy="1200"/>
+          </a:xfrm>
+          <a:prstGeom prst="straightConnector1">
+            <a:avLst/>
+          </a:prstGeom>
+          <a:noFill/>
+          <a:ln cap="flat" cmpd="sng" w="19050">
+            <a:solidFill>
+              <a:srgbClr val="296157"/>
+            </a:solidFill>
+            <a:prstDash val="solid"/>
+            <a:round/>
+            <a:headEnd len="med" w="med" type="none"/>
+            <a:tailEnd len="med" w="med" type="triangle"/>
+          </a:ln>
+        </p:spPr>
+      </p:cxnSp>
+      <p:cxnSp>
+        <p:nvCxnSpPr>
+          <p:cNvPr id="109" name="Google Shape;109;p18"/>
+          <p:cNvCxnSpPr/>
+          <p:nvPr/>
+        </p:nvCxnSpPr>
+        <p:spPr>
+          <a:xfrm>
+            <a:off x="7378700" y="2247900"/>
+            <a:ext cx="76200" cy="1200"/>
+          </a:xfrm>
+          <a:prstGeom prst="straightConnector1">
+            <a:avLst/>
+          </a:prstGeom>
+          <a:noFill/>
+          <a:ln cap="flat" cmpd="sng" w="19050">
+            <a:solidFill>
+              <a:srgbClr val="296157"/>
+            </a:solidFill>
+            <a:prstDash val="solid"/>
+            <a:round/>
+            <a:headEnd len="med" w="med" type="none"/>
+            <a:tailEnd len="med" w="med" type="triangle"/>
+          </a:ln>
+        </p:spPr>
+      </p:cxnSp>
+      <p:sp>
+        <p:nvSpPr>
+          <p:cNvPr id="110" name="Google Shape;110;p18"/>
+          <p:cNvSpPr/>
+          <p:nvPr/>
+        </p:nvSpPr>
+        <p:spPr>
+          <a:xfrm>
+            <a:off x="2476500" y="3175000"/>
+            <a:ext cx="2793900" cy="711300"/>
+          </a:xfrm>
+          <a:prstGeom prst="roundRect">
+            <a:avLst>
+              <a:gd fmla="val 16667" name="adj"/>
+            </a:avLst>
+          </a:prstGeom>
+          <a:solidFill>
+            <a:srgbClr val="F5F2E5"/>
+          </a:solidFill>
+          <a:ln cap="flat" cmpd="sng" w="9525">
+            <a:solidFill>
+              <a:srgbClr val="296157"/>
+            </a:solidFill>
+            <a:prstDash val="solid"/>
+            <a:round/>
+            <a:headEnd len="sm" w="sm" type="none"/>
+            <a:tailEnd len="sm" w="sm" type="none"/>
+          </a:ln>
+        </p:spPr>
+        <p:txBody>
+          <a:bodyPr anchorCtr="0" anchor="ctr" bIns="91425" lIns="91425" spcFirstLastPara="1" rIns="91425" wrap="square" tIns="91425">
+            <a:noAutofit/>
+          </a:bodyPr>
+          <a:lstStyle/>
+          <a:p>
+            <a:pPr indent="0" lvl="0" marL="0" rtl="0" algn="ctr">
               <a:lnSpc>
-                <a:spcPct val="112000"/>
+                <a:spcPct val="105000"/>
               </a:lnSpc>
               <a:spcBef>
-                <a:spcPts val="600"/>
-              </a:spcBef>
-              <a:spcAft>
-                <a:spcPts val="0"/>
-              </a:spcAft>
-              <a:buNone/>
-            </a:pPr>
-            <a:r>
-              <a:rPr lang="en-GB">
+                <a:spcPts val="0"/>
+              </a:spcBef>
+              <a:spcAft>
+                <a:spcPts val="0"/>
+              </a:spcAft>
+              <a:buNone/>
+            </a:pPr>
+            <a:r>
+              <a:rPr lang="en-GB" sz="1100">
                 <a:solidFill>
                   <a:srgbClr val="1F2926"/>
                 </a:solidFill>
@@ -11854,9 +12036,9 @@
                 <a:cs typeface="Google Sans Flex"/>
                 <a:sym typeface="Google Sans Flex"/>
               </a:rPr>
-              <a:t>07  The operator chooses a simulated next step. No payment is executed.</a:t>
-            </a:r>
-            <a:endParaRPr>
+              <a:t>On request: Gemini ranks saved evidence</a:t>
+            </a:r>
+            <a:endParaRPr sz="1100">
               <a:solidFill>
                 <a:srgbClr val="1F2926"/>
               </a:solidFill>
@@ -11866,23 +12048,68 @@
               <a:sym typeface="Google Sans Flex"/>
             </a:endParaRPr>
           </a:p>
-          <a:p>
-            <a:pPr indent="0" lvl="0" marL="0" rtl="0" algn="l">
+        </p:txBody>
+      </p:sp>
+      <p:sp>
+        <p:nvSpPr>
+          <p:cNvPr id="111" name="Google Shape;111;p18"/>
+          <p:cNvSpPr/>
+          <p:nvPr/>
+        </p:nvSpPr>
+        <p:spPr>
+          <a:xfrm>
+            <a:off x="5842000" y="3175000"/>
+            <a:ext cx="2793900" cy="711300"/>
+          </a:xfrm>
+          <a:prstGeom prst="roundRect">
+            <a:avLst>
+              <a:gd fmla="val 16667" name="adj"/>
+            </a:avLst>
+          </a:prstGeom>
+          <a:solidFill>
+            <a:srgbClr val="F5F2E5"/>
+          </a:solidFill>
+          <a:ln cap="flat" cmpd="sng" w="9525">
+            <a:solidFill>
+              <a:srgbClr val="296157"/>
+            </a:solidFill>
+            <a:prstDash val="solid"/>
+            <a:round/>
+            <a:headEnd len="sm" w="sm" type="none"/>
+            <a:tailEnd len="sm" w="sm" type="none"/>
+          </a:ln>
+        </p:spPr>
+        <p:txBody>
+          <a:bodyPr anchorCtr="0" anchor="ctr" bIns="91425" lIns="91425" spcFirstLastPara="1" rIns="91425" wrap="square" tIns="91425">
+            <a:noAutofit/>
+          </a:bodyPr>
+          <a:lstStyle/>
+          <a:p>
+            <a:pPr indent="0" lvl="0" marL="0" rtl="0" algn="ctr">
               <a:lnSpc>
-                <a:spcPct val="112000"/>
+                <a:spcPct val="105000"/>
               </a:lnSpc>
               <a:spcBef>
-                <a:spcPts val="600"/>
-              </a:spcBef>
-              <a:spcAft>
-                <a:spcPts val="0"/>
-              </a:spcAft>
-              <a:buNone/>
-            </a:pPr>
-            <a:r>
-              <a:t/>
-            </a:r>
-            <a:endParaRPr>
+                <a:spcPts val="0"/>
+              </a:spcBef>
+              <a:spcAft>
+                <a:spcPts val="0"/>
+              </a:spcAft>
+              <a:buNone/>
+            </a:pPr>
+            <a:r>
+              <a:rPr lang="en-GB" sz="1100">
+                <a:solidFill>
+                  <a:srgbClr val="1F2926"/>
+                </a:solidFill>
+                <a:latin typeface="Google Sans Flex"/>
+                <a:ea typeface="Google Sans Flex"/>
+                <a:cs typeface="Google Sans Flex"/>
+                <a:sym typeface="Google Sans Flex"/>
+              </a:rPr>
+              <a:t>Deterministic templates render the explanation</a:t>
+            </a:r>
+            <a:endParaRPr sz="1100">
               <a:solidFill>
                 <a:srgbClr val="1F2926"/>
               </a:solidFill>
@@ -11892,21 +12119,70 @@
               <a:sym typeface="Google Sans Flex"/>
             </a:endParaRPr>
           </a:p>
+        </p:txBody>
+      </p:sp>
+      <p:cxnSp>
+        <p:nvCxnSpPr>
+          <p:cNvPr id="112" name="Google Shape;112;p18"/>
+          <p:cNvCxnSpPr/>
+          <p:nvPr/>
+        </p:nvCxnSpPr>
+        <p:spPr>
+          <a:xfrm>
+            <a:off x="5270500" y="3530600"/>
+            <a:ext cx="571500" cy="1200"/>
+          </a:xfrm>
+          <a:prstGeom prst="straightConnector1">
+            <a:avLst/>
+          </a:prstGeom>
+          <a:noFill/>
+          <a:ln cap="flat" cmpd="sng" w="19050">
+            <a:solidFill>
+              <a:srgbClr val="296157"/>
+            </a:solidFill>
+            <a:prstDash val="solid"/>
+            <a:round/>
+            <a:headEnd len="med" w="med" type="none"/>
+            <a:tailEnd len="med" w="med" type="triangle"/>
+          </a:ln>
+        </p:spPr>
+      </p:cxnSp>
+      <p:sp>
+        <p:nvSpPr>
+          <p:cNvPr id="113" name="Google Shape;113;p18"/>
+          <p:cNvSpPr txBox="1"/>
+          <p:nvPr/>
+        </p:nvSpPr>
+        <p:spPr>
+          <a:xfrm>
+            <a:off x="381000" y="4114800"/>
+            <a:ext cx="8382000" cy="444600"/>
+          </a:xfrm>
+          <a:prstGeom prst="rect">
+            <a:avLst/>
+          </a:prstGeom>
+          <a:noFill/>
+          <a:ln>
+            <a:noFill/>
+          </a:ln>
+        </p:spPr>
+        <p:txBody>
+          <a:bodyPr anchorCtr="0" anchor="t" bIns="91425" lIns="91425" spcFirstLastPara="1" rIns="91425" wrap="square" tIns="91425">
+            <a:noAutofit/>
+          </a:bodyPr>
+          <a:lstStyle/>
           <a:p>
             <a:pPr indent="0" lvl="0" marL="0" rtl="0" algn="l">
-              <a:lnSpc>
-                <a:spcPct val="112000"/>
-              </a:lnSpc>
-              <a:spcBef>
-                <a:spcPts val="600"/>
-              </a:spcBef>
-              <a:spcAft>
-                <a:spcPts val="600"/>
-              </a:spcAft>
-              <a:buNone/>
-            </a:pPr>
-            <a:r>
-              <a:rPr lang="en-GB">
+              <a:spcBef>
+                <a:spcPts val="0"/>
+              </a:spcBef>
+              <a:spcAft>
+                <a:spcPts val="0"/>
+              </a:spcAft>
+              <a:buNone/>
+            </a:pPr>
+            <a:r>
+              <a:rPr lang="en-GB" sz="1100">
                 <a:solidFill>
                   <a:srgbClr val="1F2926"/>
                 </a:solidFill>
@@ -11915,9 +12191,9 @@
                 <a:cs typeface="Google Sans Flex"/>
                 <a:sym typeface="Google Sans Flex"/>
               </a:rPr>
-              <a:t>The local upload/review walkthrough uses a saved fixture. Live Gemini extraction has not been verified.</a:t>
-            </a:r>
-            <a:endParaRPr>
+              <a:t>Synthetic demo only. The recommendation is simulated; no payment is executed.</a:t>
+            </a:r>
+            <a:endParaRPr sz="1100">
               <a:solidFill>
                 <a:srgbClr val="1F2926"/>
               </a:solidFill>
@@ -11942,7 +12218,7 @@
   <p:cSld>
     <p:spTree>
       <p:nvGrpSpPr>
-        <p:cNvPr id="103" name="Shape 103"/>
+        <p:cNvPr id="117" name="Shape 117"/>
         <p:cNvGrpSpPr/>
         <p:nvPr/>
       </p:nvGrpSpPr>
@@ -11956,7 +12232,7 @@
       </p:grpSpPr>
       <p:pic>
         <p:nvPicPr>
-          <p:cNvPr id="104" name="Google Shape;104;p19" title="Frame 144.png"/>
+          <p:cNvPr id="118" name="Google Shape;118;p19" title="Frame 144.png"/>
           <p:cNvPicPr preferRelativeResize="0"/>
           <p:nvPr/>
         </p:nvPicPr>
@@ -11983,7 +12259,7 @@
       </p:pic>
       <p:pic>
         <p:nvPicPr>
-          <p:cNvPr id="105" name="Google Shape;105;p19" title="Group 427319979.png"/>
+          <p:cNvPr id="119" name="Google Shape;119;p19" title="Group 427319979.png"/>
           <p:cNvPicPr preferRelativeResize="0"/>
           <p:nvPr/>
         </p:nvPicPr>
@@ -12011,7 +12287,7 @@
       </p:pic>
       <p:sp>
         <p:nvSpPr>
-          <p:cNvPr id="106" name="Google Shape;106;p19"/>
+          <p:cNvPr id="120" name="Google Shape;120;p19"/>
           <p:cNvSpPr/>
           <p:nvPr/>
         </p:nvSpPr>
@@ -12054,7 +12330,7 @@
       </p:sp>
       <p:sp>
         <p:nvSpPr>
-          <p:cNvPr id="107" name="Google Shape;107;p19"/>
+          <p:cNvPr id="121" name="Google Shape;121;p19"/>
           <p:cNvSpPr txBox="1"/>
           <p:nvPr/>
         </p:nvSpPr>
@@ -12106,14 +12382,14 @@
       </p:sp>
       <p:sp>
         <p:nvSpPr>
-          <p:cNvPr id="108" name="Google Shape;108;p19"/>
+          <p:cNvPr id="122" name="Google Shape;122;p19"/>
           <p:cNvSpPr txBox="1"/>
           <p:nvPr/>
         </p:nvSpPr>
         <p:spPr>
           <a:xfrm>
             <a:off x="381000" y="1320800"/>
-            <a:ext cx="8400000" cy="3000000"/>
+            <a:ext cx="8382000" cy="3365400"/>
           </a:xfrm>
           <a:prstGeom prst="rect">
             <a:avLst/>
@@ -12151,7 +12427,7 @@
                 <a:cs typeface="Google Sans Flex"/>
                 <a:sym typeface="Google Sans Flex"/>
               </a:rPr>
-              <a:t>OPTIONAL FLOW SKETCH  Implemented local invoice review is shown on slide 11</a:t>
+              <a:t>INVOICE REVIEW FLOW  Live synthetic cases shown on slide 11</a:t>
             </a:r>
             <a:endParaRPr>
               <a:solidFill>
@@ -12212,7 +12488,7 @@
                 <a:cs typeface="Google Sans Flex"/>
                 <a:sym typeface="Google Sans Flex"/>
               </a:rPr>
-              <a:t>Invoice file  PDF / PNG / JPEG, maximum 5 MiB</a:t>
+              <a:t>Input  Synthetic invoice PDF, PNG or JPEG</a:t>
             </a:r>
             <a:endParaRPr>
               <a:solidFill>
@@ -12247,7 +12523,7 @@
                 <a:cs typeface="Google Sans Flex"/>
                 <a:sym typeface="Google Sans Flex"/>
               </a:rPr>
-              <a:t>Extracted fields  Vendor, invoice ID, amount, currency, destination</a:t>
+              <a:t>Extraction  Vertex Gemini returns candidate fields</a:t>
             </a:r>
             <a:endParaRPr>
               <a:solidFill>
@@ -12282,7 +12558,7 @@
                 <a:cs typeface="Google Sans Flex"/>
                 <a:sym typeface="Google Sans Flex"/>
               </a:rPr>
-              <a:t>Human review  Edit or confirm each extracted value</a:t>
+              <a:t>Human review  Confirm fields and select a vendor record</a:t>
             </a:r>
             <a:endParaRPr>
               <a:solidFill>
@@ -12317,7 +12593,7 @@
                 <a:cs typeface="Google Sans Flex"/>
                 <a:sym typeface="Google Sans Flex"/>
               </a:rPr>
-              <a:t>Vendor match  Select a known synthetic vendor record</a:t>
+              <a:t>Vendor check  Compare requested destination with the saved account</a:t>
             </a:r>
             <a:endParaRPr>
               <a:solidFill>
@@ -12352,7 +12628,7 @@
                 <a:cs typeface="Google Sans Flex"/>
                 <a:sym typeface="Google Sans Flex"/>
               </a:rPr>
-              <a:t>Evidence  Show changed bank details, anomalies and missing checks</a:t>
+              <a:t>Context  Gemini classifies the payment request</a:t>
             </a:r>
             <a:endParaRPr>
               <a:solidFill>
@@ -12387,7 +12663,7 @@
                 <a:cs typeface="Google Sans Flex"/>
                 <a:sym typeface="Google Sans Flex"/>
               </a:rPr>
-              <a:t>Decision  Continue, verify or review</a:t>
+              <a:t>Decision  Continue, Verify or Review</a:t>
             </a:r>
             <a:endParaRPr>
               <a:solidFill>
@@ -12448,7 +12724,7 @@
                 <a:cs typeface="Google Sans Flex"/>
                 <a:sym typeface="Google Sans Flex"/>
               </a:rPr>
-              <a:t>Candidate fields in the local walkthrough use a saved fixture.</a:t>
+              <a:t>The changed destination case recommends Review; the normal invoice returns Continue.</a:t>
             </a:r>
             <a:endParaRPr>
               <a:solidFill>
@@ -12475,7 +12751,7 @@
   <p:cSld>
     <p:spTree>
       <p:nvGrpSpPr>
-        <p:cNvPr id="112" name="Shape 112"/>
+        <p:cNvPr id="126" name="Shape 126"/>
         <p:cNvGrpSpPr/>
         <p:nvPr/>
       </p:nvGrpSpPr>
@@ -12489,7 +12765,7 @@
       </p:grpSpPr>
       <p:pic>
         <p:nvPicPr>
-          <p:cNvPr id="113" name="Google Shape;113;p20" title="Frame 144.png"/>
+          <p:cNvPr id="127" name="Google Shape;127;p20" title="Frame 144.png"/>
           <p:cNvPicPr preferRelativeResize="0"/>
           <p:nvPr/>
         </p:nvPicPr>
@@ -12516,7 +12792,7 @@
       </p:pic>
       <p:pic>
         <p:nvPicPr>
-          <p:cNvPr id="114" name="Google Shape;114;p20" title="Group 427319979.png"/>
+          <p:cNvPr id="128" name="Google Shape;128;p20" title="Group 427319979.png"/>
           <p:cNvPicPr preferRelativeResize="0"/>
           <p:nvPr/>
         </p:nvPicPr>
@@ -12544,7 +12820,7 @@
       </p:pic>
       <p:sp>
         <p:nvSpPr>
-          <p:cNvPr id="115" name="Google Shape;115;p20"/>
+          <p:cNvPr id="129" name="Google Shape;129;p20"/>
           <p:cNvSpPr/>
           <p:nvPr/>
         </p:nvSpPr>
@@ -12587,7 +12863,7 @@
       </p:sp>
       <p:sp>
         <p:nvSpPr>
-          <p:cNvPr id="116" name="Google Shape;116;p20"/>
+          <p:cNvPr id="130" name="Google Shape;130;p20"/>
           <p:cNvSpPr txBox="1"/>
           <p:nvPr/>
         </p:nvSpPr>
@@ -12639,32 +12915,42 @@
       </p:sp>
       <p:sp>
         <p:nvSpPr>
-          <p:cNvPr id="117" name="Google Shape;117;p20"/>
-          <p:cNvSpPr txBox="1"/>
+          <p:cNvPr id="131" name="Google Shape;131;p20"/>
+          <p:cNvSpPr/>
           <p:nvPr/>
         </p:nvSpPr>
         <p:spPr>
           <a:xfrm>
-            <a:off x="381000" y="1320800"/>
-            <a:ext cx="8400000" cy="3000000"/>
-          </a:xfrm>
-          <a:prstGeom prst="rect">
-            <a:avLst/>
+            <a:off x="381000" y="1752600"/>
+            <a:ext cx="1905000" cy="1016100"/>
+          </a:xfrm>
+          <a:prstGeom prst="roundRect">
+            <a:avLst>
+              <a:gd fmla="val 16667" name="adj"/>
+            </a:avLst>
           </a:prstGeom>
-          <a:noFill/>
-          <a:ln>
-            <a:noFill/>
+          <a:solidFill>
+            <a:srgbClr val="E5F2ED"/>
+          </a:solidFill>
+          <a:ln cap="flat" cmpd="sng" w="9525">
+            <a:solidFill>
+              <a:srgbClr val="296157"/>
+            </a:solidFill>
+            <a:prstDash val="solid"/>
+            <a:round/>
+            <a:headEnd len="sm" w="sm" type="none"/>
+            <a:tailEnd len="sm" w="sm" type="none"/>
           </a:ln>
         </p:spPr>
         <p:txBody>
-          <a:bodyPr anchorCtr="0" anchor="t" bIns="91425" lIns="91425" spcFirstLastPara="1" rIns="91425" wrap="square" tIns="91425">
+          <a:bodyPr anchorCtr="0" anchor="ctr" bIns="91425" lIns="91425" spcFirstLastPara="1" rIns="91425" wrap="square" tIns="91425">
             <a:noAutofit/>
           </a:bodyPr>
           <a:lstStyle/>
           <a:p>
-            <a:pPr indent="0" lvl="0" marL="0" rtl="0" algn="l">
+            <a:pPr indent="0" lvl="0" marL="0" rtl="0" algn="ctr">
               <a:lnSpc>
-                <a:spcPct val="112000"/>
+                <a:spcPct val="105000"/>
               </a:lnSpc>
               <a:spcBef>
                 <a:spcPts val="0"/>
@@ -12675,7 +12961,7 @@
               <a:buNone/>
             </a:pPr>
             <a:r>
-              <a:rPr lang="en-GB" sz="1300">
+              <a:rPr lang="en-GB" sz="1100">
                 <a:solidFill>
                   <a:srgbClr val="1F2926"/>
                 </a:solidFill>
@@ -12684,9 +12970,9 @@
                 <a:cs typeface="Google Sans Flex"/>
                 <a:sym typeface="Google Sans Flex"/>
               </a:rPr>
-              <a:t>TARGET GOOGLE CLOUD DESIGN  Proposed, not deployed</a:t>
-            </a:r>
-            <a:endParaRPr sz="1300">
+              <a:t>Firebase anonymous auth</a:t>
+            </a:r>
+            <a:endParaRPr sz="1100">
               <a:solidFill>
                 <a:srgbClr val="1F2926"/>
               </a:solidFill>
@@ -12696,21 +12982,57 @@
               <a:sym typeface="Google Sans Flex"/>
             </a:endParaRPr>
           </a:p>
-          <a:p>
-            <a:pPr indent="0" lvl="0" marL="0" rtl="0" algn="l">
+        </p:txBody>
+      </p:sp>
+      <p:sp>
+        <p:nvSpPr>
+          <p:cNvPr id="132" name="Google Shape;132;p20"/>
+          <p:cNvSpPr/>
+          <p:nvPr/>
+        </p:nvSpPr>
+        <p:spPr>
+          <a:xfrm>
+            <a:off x="2540000" y="1752600"/>
+            <a:ext cx="1905000" cy="1016100"/>
+          </a:xfrm>
+          <a:prstGeom prst="roundRect">
+            <a:avLst>
+              <a:gd fmla="val 16667" name="adj"/>
+            </a:avLst>
+          </a:prstGeom>
+          <a:solidFill>
+            <a:srgbClr val="E5F2ED"/>
+          </a:solidFill>
+          <a:ln cap="flat" cmpd="sng" w="9525">
+            <a:solidFill>
+              <a:srgbClr val="296157"/>
+            </a:solidFill>
+            <a:prstDash val="solid"/>
+            <a:round/>
+            <a:headEnd len="sm" w="sm" type="none"/>
+            <a:tailEnd len="sm" w="sm" type="none"/>
+          </a:ln>
+        </p:spPr>
+        <p:txBody>
+          <a:bodyPr anchorCtr="0" anchor="ctr" bIns="91425" lIns="91425" spcFirstLastPara="1" rIns="91425" wrap="square" tIns="91425">
+            <a:noAutofit/>
+          </a:bodyPr>
+          <a:lstStyle/>
+          <a:p>
+            <a:pPr indent="0" lvl="0" marL="0" rtl="0" algn="ctr">
               <a:lnSpc>
-                <a:spcPct val="112000"/>
+                <a:spcPct val="105000"/>
               </a:lnSpc>
               <a:spcBef>
-                <a:spcPts val="600"/>
-              </a:spcBef>
-              <a:spcAft>
-                <a:spcPts val="0"/>
-              </a:spcAft>
-              <a:buNone/>
-            </a:pPr>
-            <a:r>
-              <a:rPr lang="en-GB" sz="1300">
+                <a:spcPts val="0"/>
+              </a:spcBef>
+              <a:spcAft>
+                <a:spcPts val="0"/>
+              </a:spcAft>
+              <a:buNone/>
+            </a:pPr>
+            <a:r>
+              <a:rPr lang="en-GB" sz="1100">
                 <a:solidFill>
                   <a:srgbClr val="1F2926"/>
                 </a:solidFill>
@@ -12719,9 +13041,9 @@
                 <a:cs typeface="Google Sans Flex"/>
                 <a:sym typeface="Google Sans Flex"/>
               </a:rPr>
-              <a:t>01  Web client uses Firebase anonymous authentication.</a:t>
-            </a:r>
-            <a:endParaRPr sz="1300">
+              <a:t>Browser client</a:t>
+            </a:r>
+            <a:endParaRPr sz="1100">
               <a:solidFill>
                 <a:srgbClr val="1F2926"/>
               </a:solidFill>
@@ -12732,20 +13054,20 @@
             </a:endParaRPr>
           </a:p>
           <a:p>
-            <a:pPr indent="0" lvl="0" marL="0" rtl="0" algn="l">
+            <a:pPr indent="0" lvl="0" marL="0" rtl="0" algn="ctr">
               <a:lnSpc>
-                <a:spcPct val="112000"/>
+                <a:spcPct val="105000"/>
               </a:lnSpc>
               <a:spcBef>
-                <a:spcPts val="600"/>
-              </a:spcBef>
-              <a:spcAft>
-                <a:spcPts val="0"/>
-              </a:spcAft>
-              <a:buNone/>
-            </a:pPr>
-            <a:r>
-              <a:rPr lang="en-GB" sz="1300">
+                <a:spcPts val="0"/>
+              </a:spcBef>
+              <a:spcAft>
+                <a:spcPts val="0"/>
+              </a:spcAft>
+              <a:buNone/>
+            </a:pPr>
+            <a:r>
+              <a:rPr lang="en-GB" sz="1100">
                 <a:solidFill>
                   <a:srgbClr val="1F2926"/>
                 </a:solidFill>
@@ -12754,9 +13076,9 @@
                 <a:cs typeface="Google Sans Flex"/>
                 <a:sym typeface="Google Sans Flex"/>
               </a:rPr>
-              <a:t>02  FastAPI serves the app and API from Cloud Run.</a:t>
-            </a:r>
-            <a:endParaRPr sz="1300">
+              <a:t>React</a:t>
+            </a:r>
+            <a:endParaRPr sz="1100">
               <a:solidFill>
                 <a:srgbClr val="1F2926"/>
               </a:solidFill>
@@ -12766,21 +13088,57 @@
               <a:sym typeface="Google Sans Flex"/>
             </a:endParaRPr>
           </a:p>
-          <a:p>
-            <a:pPr indent="0" lvl="0" marL="0" rtl="0" algn="l">
+        </p:txBody>
+      </p:sp>
+      <p:sp>
+        <p:nvSpPr>
+          <p:cNvPr id="133" name="Google Shape;133;p20"/>
+          <p:cNvSpPr/>
+          <p:nvPr/>
+        </p:nvSpPr>
+        <p:spPr>
+          <a:xfrm>
+            <a:off x="4699000" y="1752600"/>
+            <a:ext cx="1905000" cy="1016100"/>
+          </a:xfrm>
+          <a:prstGeom prst="roundRect">
+            <a:avLst>
+              <a:gd fmla="val 16667" name="adj"/>
+            </a:avLst>
+          </a:prstGeom>
+          <a:solidFill>
+            <a:srgbClr val="E5F2ED"/>
+          </a:solidFill>
+          <a:ln cap="flat" cmpd="sng" w="9525">
+            <a:solidFill>
+              <a:srgbClr val="296157"/>
+            </a:solidFill>
+            <a:prstDash val="solid"/>
+            <a:round/>
+            <a:headEnd len="sm" w="sm" type="none"/>
+            <a:tailEnd len="sm" w="sm" type="none"/>
+          </a:ln>
+        </p:spPr>
+        <p:txBody>
+          <a:bodyPr anchorCtr="0" anchor="ctr" bIns="91425" lIns="91425" spcFirstLastPara="1" rIns="91425" wrap="square" tIns="91425">
+            <a:noAutofit/>
+          </a:bodyPr>
+          <a:lstStyle/>
+          <a:p>
+            <a:pPr indent="0" lvl="0" marL="0" rtl="0" algn="ctr">
               <a:lnSpc>
-                <a:spcPct val="112000"/>
+                <a:spcPct val="105000"/>
               </a:lnSpc>
               <a:spcBef>
-                <a:spcPts val="600"/>
-              </a:spcBef>
-              <a:spcAft>
-                <a:spcPts val="0"/>
-              </a:spcAft>
-              <a:buNone/>
-            </a:pPr>
-            <a:r>
-              <a:rPr lang="en-GB" sz="1300">
+                <a:spcPts val="0"/>
+              </a:spcBef>
+              <a:spcAft>
+                <a:spcPts val="0"/>
+              </a:spcAft>
+              <a:buNone/>
+            </a:pPr>
+            <a:r>
+              <a:rPr lang="en-GB" sz="1100">
                 <a:solidFill>
                   <a:srgbClr val="1F2926"/>
                 </a:solidFill>
@@ -12789,9 +13147,9 @@
                 <a:cs typeface="Google Sans Flex"/>
                 <a:sym typeface="Google Sans Flex"/>
               </a:rPr>
-              <a:t>03  Gemini Developer API extracts invoice fields and evaluates payment context.</a:t>
-            </a:r>
-            <a:endParaRPr sz="1300">
+              <a:t>Cloud Run</a:t>
+            </a:r>
+            <a:endParaRPr sz="1100">
               <a:solidFill>
                 <a:srgbClr val="1F2926"/>
               </a:solidFill>
@@ -12802,20 +13160,20 @@
             </a:endParaRPr>
           </a:p>
           <a:p>
-            <a:pPr indent="0" lvl="0" marL="0" rtl="0" algn="l">
+            <a:pPr indent="0" lvl="0" marL="0" rtl="0" algn="ctr">
               <a:lnSpc>
-                <a:spcPct val="112000"/>
+                <a:spcPct val="105000"/>
               </a:lnSpc>
               <a:spcBef>
-                <a:spcPts val="600"/>
-              </a:spcBef>
-              <a:spcAft>
-                <a:spcPts val="0"/>
-              </a:spcAft>
-              <a:buNone/>
-            </a:pPr>
-            <a:r>
-              <a:rPr lang="en-GB" sz="1300">
+                <a:spcPts val="0"/>
+              </a:spcBef>
+              <a:spcAft>
+                <a:spcPts val="0"/>
+              </a:spcAft>
+              <a:buNone/>
+            </a:pPr>
+            <a:r>
+              <a:rPr lang="en-GB" sz="1100">
                 <a:solidFill>
                   <a:srgbClr val="1F2926"/>
                 </a:solidFill>
@@ -12824,9 +13182,9 @@
                 <a:cs typeface="Google Sans Flex"/>
                 <a:sym typeface="Google Sans Flex"/>
               </a:rPr>
-              <a:t>04  Human confirmation precedes assessment; deterministic rules compare fields with vendor history.</a:t>
-            </a:r>
-            <a:endParaRPr sz="1300">
+              <a:t>FastAPI</a:t>
+            </a:r>
+            <a:endParaRPr sz="1100">
               <a:solidFill>
                 <a:srgbClr val="1F2926"/>
               </a:solidFill>
@@ -12836,21 +13194,57 @@
               <a:sym typeface="Google Sans Flex"/>
             </a:endParaRPr>
           </a:p>
-          <a:p>
-            <a:pPr indent="0" lvl="0" marL="0" rtl="0" algn="l">
+        </p:txBody>
+      </p:sp>
+      <p:sp>
+        <p:nvSpPr>
+          <p:cNvPr id="134" name="Google Shape;134;p20"/>
+          <p:cNvSpPr/>
+          <p:nvPr/>
+        </p:nvSpPr>
+        <p:spPr>
+          <a:xfrm>
+            <a:off x="6858000" y="1752600"/>
+            <a:ext cx="1905000" cy="1016100"/>
+          </a:xfrm>
+          <a:prstGeom prst="roundRect">
+            <a:avLst>
+              <a:gd fmla="val 16667" name="adj"/>
+            </a:avLst>
+          </a:prstGeom>
+          <a:solidFill>
+            <a:srgbClr val="E5F2ED"/>
+          </a:solidFill>
+          <a:ln cap="flat" cmpd="sng" w="9525">
+            <a:solidFill>
+              <a:srgbClr val="296157"/>
+            </a:solidFill>
+            <a:prstDash val="solid"/>
+            <a:round/>
+            <a:headEnd len="sm" w="sm" type="none"/>
+            <a:tailEnd len="sm" w="sm" type="none"/>
+          </a:ln>
+        </p:spPr>
+        <p:txBody>
+          <a:bodyPr anchorCtr="0" anchor="ctr" bIns="91425" lIns="91425" spcFirstLastPara="1" rIns="91425" wrap="square" tIns="91425">
+            <a:noAutofit/>
+          </a:bodyPr>
+          <a:lstStyle/>
+          <a:p>
+            <a:pPr indent="0" lvl="0" marL="0" rtl="0" algn="ctr">
               <a:lnSpc>
-                <a:spcPct val="112000"/>
+                <a:spcPct val="105000"/>
               </a:lnSpc>
               <a:spcBef>
-                <a:spcPts val="600"/>
-              </a:spcBef>
-              <a:spcAft>
-                <a:spcPts val="0"/>
-              </a:spcAft>
-              <a:buNone/>
-            </a:pPr>
-            <a:r>
-              <a:rPr lang="en-GB" sz="1300">
+                <a:spcPts val="0"/>
+              </a:spcBef>
+              <a:spcAft>
+                <a:spcPts val="0"/>
+              </a:spcAft>
+              <a:buNone/>
+            </a:pPr>
+            <a:r>
+              <a:rPr lang="en-GB" sz="1100">
                 <a:solidFill>
                   <a:srgbClr val="1F2926"/>
                 </a:solidFill>
@@ -12859,9 +13253,9 @@
                 <a:cs typeface="Google Sans Flex"/>
                 <a:sym typeface="Google Sans Flex"/>
               </a:rPr>
-              <a:t>05  Firestore stores owner-scoped cases and daily usage quotas.</a:t>
-            </a:r>
-            <a:endParaRPr sz="1300">
+              <a:t>Vertex AI</a:t>
+            </a:r>
+            <a:endParaRPr sz="1100">
               <a:solidFill>
                 <a:srgbClr val="1F2926"/>
               </a:solidFill>
@@ -12872,22 +13266,31 @@
             </a:endParaRPr>
           </a:p>
           <a:p>
-            <a:pPr indent="0" lvl="0" marL="0" rtl="0" algn="l">
+            <a:pPr indent="0" lvl="0" marL="0" rtl="0" algn="ctr">
               <a:lnSpc>
-                <a:spcPct val="112000"/>
+                <a:spcPct val="105000"/>
               </a:lnSpc>
               <a:spcBef>
-                <a:spcPts val="600"/>
-              </a:spcBef>
-              <a:spcAft>
-                <a:spcPts val="0"/>
-              </a:spcAft>
-              <a:buNone/>
-            </a:pPr>
-            <a:r>
-              <a:t/>
-            </a:r>
-            <a:endParaRPr sz="1300">
+                <a:spcPts val="0"/>
+              </a:spcBef>
+              <a:spcAft>
+                <a:spcPts val="0"/>
+              </a:spcAft>
+              <a:buNone/>
+            </a:pPr>
+            <a:r>
+              <a:rPr lang="en-GB" sz="1100">
+                <a:solidFill>
+                  <a:srgbClr val="1F2926"/>
+                </a:solidFill>
+                <a:latin typeface="Google Sans Flex"/>
+                <a:ea typeface="Google Sans Flex"/>
+                <a:cs typeface="Google Sans Flex"/>
+                <a:sym typeface="Google Sans Flex"/>
+              </a:rPr>
+              <a:t>Gemini 2.5 Flash-Lite</a:t>
+            </a:r>
+            <a:endParaRPr sz="1100">
               <a:solidFill>
                 <a:srgbClr val="1F2926"/>
               </a:solidFill>
@@ -12897,21 +13300,135 @@
               <a:sym typeface="Google Sans Flex"/>
             </a:endParaRPr>
           </a:p>
-          <a:p>
-            <a:pPr indent="0" lvl="0" marL="0" rtl="0" algn="l">
+        </p:txBody>
+      </p:sp>
+      <p:cxnSp>
+        <p:nvCxnSpPr>
+          <p:cNvPr id="135" name="Google Shape;135;p20"/>
+          <p:cNvCxnSpPr/>
+          <p:nvPr/>
+        </p:nvCxnSpPr>
+        <p:spPr>
+          <a:xfrm>
+            <a:off x="2286000" y="2260600"/>
+            <a:ext cx="254100" cy="1200"/>
+          </a:xfrm>
+          <a:prstGeom prst="straightConnector1">
+            <a:avLst/>
+          </a:prstGeom>
+          <a:noFill/>
+          <a:ln cap="flat" cmpd="sng" w="19050">
+            <a:solidFill>
+              <a:srgbClr val="296157"/>
+            </a:solidFill>
+            <a:prstDash val="solid"/>
+            <a:round/>
+            <a:headEnd len="med" w="med" type="none"/>
+            <a:tailEnd len="med" w="med" type="triangle"/>
+          </a:ln>
+        </p:spPr>
+      </p:cxnSp>
+      <p:cxnSp>
+        <p:nvCxnSpPr>
+          <p:cNvPr id="136" name="Google Shape;136;p20"/>
+          <p:cNvCxnSpPr/>
+          <p:nvPr/>
+        </p:nvCxnSpPr>
+        <p:spPr>
+          <a:xfrm>
+            <a:off x="4445000" y="2260600"/>
+            <a:ext cx="254100" cy="1200"/>
+          </a:xfrm>
+          <a:prstGeom prst="straightConnector1">
+            <a:avLst/>
+          </a:prstGeom>
+          <a:noFill/>
+          <a:ln cap="flat" cmpd="sng" w="19050">
+            <a:solidFill>
+              <a:srgbClr val="296157"/>
+            </a:solidFill>
+            <a:prstDash val="solid"/>
+            <a:round/>
+            <a:headEnd len="med" w="med" type="none"/>
+            <a:tailEnd len="med" w="med" type="triangle"/>
+          </a:ln>
+        </p:spPr>
+      </p:cxnSp>
+      <p:cxnSp>
+        <p:nvCxnSpPr>
+          <p:cNvPr id="137" name="Google Shape;137;p20"/>
+          <p:cNvCxnSpPr/>
+          <p:nvPr/>
+        </p:nvCxnSpPr>
+        <p:spPr>
+          <a:xfrm>
+            <a:off x="6604000" y="2260600"/>
+            <a:ext cx="254100" cy="1200"/>
+          </a:xfrm>
+          <a:prstGeom prst="straightConnector1">
+            <a:avLst/>
+          </a:prstGeom>
+          <a:noFill/>
+          <a:ln cap="flat" cmpd="sng" w="19050">
+            <a:solidFill>
+              <a:srgbClr val="296157"/>
+            </a:solidFill>
+            <a:prstDash val="solid"/>
+            <a:round/>
+            <a:headEnd len="med" w="med" type="none"/>
+            <a:tailEnd len="med" w="med" type="triangle"/>
+          </a:ln>
+        </p:spPr>
+      </p:cxnSp>
+      <p:sp>
+        <p:nvSpPr>
+          <p:cNvPr id="138" name="Google Shape;138;p20"/>
+          <p:cNvSpPr/>
+          <p:nvPr/>
+        </p:nvSpPr>
+        <p:spPr>
+          <a:xfrm>
+            <a:off x="4572000" y="3302000"/>
+            <a:ext cx="2286000" cy="762000"/>
+          </a:xfrm>
+          <a:prstGeom prst="roundRect">
+            <a:avLst>
+              <a:gd fmla="val 16667" name="adj"/>
+            </a:avLst>
+          </a:prstGeom>
+          <a:solidFill>
+            <a:srgbClr val="F5F2E5"/>
+          </a:solidFill>
+          <a:ln cap="flat" cmpd="sng" w="9525">
+            <a:solidFill>
+              <a:srgbClr val="296157"/>
+            </a:solidFill>
+            <a:prstDash val="solid"/>
+            <a:round/>
+            <a:headEnd len="sm" w="sm" type="none"/>
+            <a:tailEnd len="sm" w="sm" type="none"/>
+          </a:ln>
+        </p:spPr>
+        <p:txBody>
+          <a:bodyPr anchorCtr="0" anchor="ctr" bIns="91425" lIns="91425" spcFirstLastPara="1" rIns="91425" wrap="square" tIns="91425">
+            <a:noAutofit/>
+          </a:bodyPr>
+          <a:lstStyle/>
+          <a:p>
+            <a:pPr indent="0" lvl="0" marL="0" rtl="0" algn="ctr">
               <a:lnSpc>
-                <a:spcPct val="112000"/>
+                <a:spcPct val="105000"/>
               </a:lnSpc>
               <a:spcBef>
-                <a:spcPts val="600"/>
-              </a:spcBef>
-              <a:spcAft>
-                <a:spcPts val="600"/>
-              </a:spcAft>
-              <a:buNone/>
-            </a:pPr>
-            <a:r>
-              <a:rPr lang="en-GB" sz="1300">
+                <a:spcPts val="0"/>
+              </a:spcBef>
+              <a:spcAft>
+                <a:spcPts val="0"/>
+              </a:spcAft>
+              <a:buNone/>
+            </a:pPr>
+            <a:r>
+              <a:rPr lang="en-GB" sz="1100">
                 <a:solidFill>
                   <a:srgbClr val="1F2926"/>
                 </a:solidFill>
@@ -12920,9 +13437,128 @@
                 <a:cs typeface="Google Sans Flex"/>
                 <a:sym typeface="Google Sans Flex"/>
               </a:rPr>
-              <a:t>STATUS  Local React/FastAPI and fixture-mode invoice review work with SQLite. Firebase Auth and Firestore code are implemented; live credentials and persistence checks are unverified. Cloud Run deployment is pending credit coverage; Gemini calls are unverified.</a:t>
-            </a:r>
-            <a:endParaRPr sz="1300">
+              <a:t>Firestore</a:t>
+            </a:r>
+            <a:endParaRPr sz="1100">
+              <a:solidFill>
+                <a:srgbClr val="1F2926"/>
+              </a:solidFill>
+              <a:latin typeface="Google Sans Flex"/>
+              <a:ea typeface="Google Sans Flex"/>
+              <a:cs typeface="Google Sans Flex"/>
+              <a:sym typeface="Google Sans Flex"/>
+            </a:endParaRPr>
+          </a:p>
+          <a:p>
+            <a:pPr indent="0" lvl="0" marL="0" rtl="0" algn="ctr">
+              <a:lnSpc>
+                <a:spcPct val="105000"/>
+              </a:lnSpc>
+              <a:spcBef>
+                <a:spcPts val="0"/>
+              </a:spcBef>
+              <a:spcAft>
+                <a:spcPts val="0"/>
+              </a:spcAft>
+              <a:buNone/>
+            </a:pPr>
+            <a:r>
+              <a:rPr lang="en-GB" sz="1100">
+                <a:solidFill>
+                  <a:srgbClr val="1F2926"/>
+                </a:solidFill>
+                <a:latin typeface="Google Sans Flex"/>
+                <a:ea typeface="Google Sans Flex"/>
+                <a:cs typeface="Google Sans Flex"/>
+                <a:sym typeface="Google Sans Flex"/>
+              </a:rPr>
+              <a:t>Owner-scoped cases + quotas</a:t>
+            </a:r>
+            <a:endParaRPr sz="1100">
+              <a:solidFill>
+                <a:srgbClr val="1F2926"/>
+              </a:solidFill>
+              <a:latin typeface="Google Sans Flex"/>
+              <a:ea typeface="Google Sans Flex"/>
+              <a:cs typeface="Google Sans Flex"/>
+              <a:sym typeface="Google Sans Flex"/>
+            </a:endParaRPr>
+          </a:p>
+        </p:txBody>
+      </p:sp>
+      <p:cxnSp>
+        <p:nvCxnSpPr>
+          <p:cNvPr id="139" name="Google Shape;139;p20"/>
+          <p:cNvCxnSpPr/>
+          <p:nvPr/>
+        </p:nvCxnSpPr>
+        <p:spPr>
+          <a:xfrm>
+            <a:off x="5524500" y="2768600"/>
+            <a:ext cx="190500" cy="533400"/>
+          </a:xfrm>
+          <a:prstGeom prst="straightConnector1">
+            <a:avLst/>
+          </a:prstGeom>
+          <a:noFill/>
+          <a:ln cap="flat" cmpd="sng" w="19050">
+            <a:solidFill>
+              <a:srgbClr val="296157"/>
+            </a:solidFill>
+            <a:prstDash val="solid"/>
+            <a:round/>
+            <a:headEnd len="med" w="med" type="none"/>
+            <a:tailEnd len="med" w="med" type="triangle"/>
+          </a:ln>
+        </p:spPr>
+      </p:cxnSp>
+      <p:sp>
+        <p:nvSpPr>
+          <p:cNvPr id="140" name="Google Shape;140;p20"/>
+          <p:cNvSpPr txBox="1"/>
+          <p:nvPr/>
+        </p:nvSpPr>
+        <p:spPr>
+          <a:xfrm>
+            <a:off x="381000" y="4279900"/>
+            <a:ext cx="8382000" cy="609600"/>
+          </a:xfrm>
+          <a:prstGeom prst="rect">
+            <a:avLst/>
+          </a:prstGeom>
+          <a:noFill/>
+          <a:ln>
+            <a:noFill/>
+          </a:ln>
+        </p:spPr>
+        <p:txBody>
+          <a:bodyPr anchorCtr="0" anchor="t" bIns="91425" lIns="91425" spcFirstLastPara="1" rIns="91425" wrap="square" tIns="91425">
+            <a:noAutofit/>
+          </a:bodyPr>
+          <a:lstStyle/>
+          <a:p>
+            <a:pPr indent="0" lvl="0" marL="0" rtl="0" algn="l">
+              <a:spcBef>
+                <a:spcPts val="0"/>
+              </a:spcBef>
+              <a:spcAft>
+                <a:spcPts val="0"/>
+              </a:spcAft>
+              <a:buNone/>
+            </a:pPr>
+            <a:r>
+              <a:rPr lang="en-GB" sz="1100">
+                <a:solidFill>
+                  <a:srgbClr val="1F2926"/>
+                </a:solidFill>
+                <a:latin typeface="Google Sans Flex"/>
+                <a:ea typeface="Google Sans Flex"/>
+                <a:cs typeface="Google Sans Flex"/>
+                <a:sym typeface="Google Sans Flex"/>
+              </a:rPr>
+              <a:t>Deterministic rules set the decision. On request, Gemini ranks saved evidence and templates render the explanation. No direct browser access to Firestore; no payment executes.</a:t>
+            </a:r>
+            <a:endParaRPr sz="1100">
               <a:solidFill>
                 <a:srgbClr val="1F2926"/>
               </a:solidFill>
@@ -12947,7 +13583,7 @@
   <p:cSld>
     <p:spTree>
       <p:nvGrpSpPr>
-        <p:cNvPr id="121" name="Shape 121"/>
+        <p:cNvPr id="144" name="Shape 144"/>
         <p:cNvGrpSpPr/>
         <p:nvPr/>
       </p:nvGrpSpPr>
@@ -12961,7 +13597,7 @@
       </p:grpSpPr>
       <p:pic>
         <p:nvPicPr>
-          <p:cNvPr id="122" name="Google Shape;122;p21" title="Frame 144.png"/>
+          <p:cNvPr id="145" name="Google Shape;145;p21" title="Frame 144.png"/>
           <p:cNvPicPr preferRelativeResize="0"/>
           <p:nvPr/>
         </p:nvPicPr>
@@ -12988,7 +13624,7 @@
       </p:pic>
       <p:pic>
         <p:nvPicPr>
-          <p:cNvPr id="123" name="Google Shape;123;p21" title="Group 427319979.png"/>
+          <p:cNvPr id="146" name="Google Shape;146;p21" title="Group 427319979.png"/>
           <p:cNvPicPr preferRelativeResize="0"/>
           <p:nvPr/>
         </p:nvPicPr>
@@ -13016,7 +13652,7 @@
       </p:pic>
       <p:sp>
         <p:nvSpPr>
-          <p:cNvPr id="124" name="Google Shape;124;p21"/>
+          <p:cNvPr id="147" name="Google Shape;147;p21"/>
           <p:cNvSpPr/>
           <p:nvPr/>
         </p:nvSpPr>
@@ -13059,7 +13695,7 @@
       </p:sp>
       <p:sp>
         <p:nvSpPr>
-          <p:cNvPr id="125" name="Google Shape;125;p21"/>
+          <p:cNvPr id="148" name="Google Shape;148;p21"/>
           <p:cNvSpPr txBox="1"/>
           <p:nvPr/>
         </p:nvSpPr>
@@ -13111,14 +13747,14 @@
       </p:sp>
       <p:sp>
         <p:nvSpPr>
-          <p:cNvPr id="126" name="Google Shape;126;p21"/>
+          <p:cNvPr id="149" name="Google Shape;149;p21"/>
           <p:cNvSpPr txBox="1"/>
           <p:nvPr/>
         </p:nvSpPr>
         <p:spPr>
           <a:xfrm>
             <a:off x="381000" y="1320800"/>
-            <a:ext cx="8400000" cy="3000000"/>
+            <a:ext cx="8382000" cy="3365400"/>
           </a:xfrm>
           <a:prstGeom prst="rect">
             <a:avLst/>
@@ -13147,7 +13783,7 @@
               <a:buNone/>
             </a:pPr>
             <a:r>
-              <a:rPr lang="en-GB">
+              <a:rPr lang="en-GB" sz="1300">
                 <a:solidFill>
                   <a:srgbClr val="1F2926"/>
                 </a:solidFill>
@@ -13156,9 +13792,9 @@
                 <a:cs typeface="Google Sans Flex"/>
                 <a:sym typeface="Google Sans Flex"/>
               </a:rPr>
-              <a:t>LOCAL PROTOTYPE</a:t>
-            </a:r>
-            <a:endParaRPr>
+              <a:t>APPLICATION</a:t>
+            </a:r>
+            <a:endParaRPr sz="1300">
               <a:solidFill>
                 <a:srgbClr val="1F2926"/>
               </a:solidFill>
@@ -13182,7 +13818,7 @@
               <a:buNone/>
             </a:pPr>
             <a:r>
-              <a:rPr lang="en-GB">
+              <a:rPr lang="en-GB" sz="1300">
                 <a:solidFill>
                   <a:srgbClr val="1F2926"/>
                 </a:solidFill>
@@ -13191,9 +13827,9 @@
                 <a:cs typeface="Google Sans Flex"/>
                 <a:sym typeface="Google Sans Flex"/>
               </a:rPr>
-              <a:t>React and TypeScript interface, Python FastAPI service, SQLite, fixture-first providers and deterministic policy.</a:t>
-            </a:r>
-            <a:endParaRPr>
+              <a:t>React and TypeScript client, Python FastAPI service, deterministic policy and evidence-backed case records.</a:t>
+            </a:r>
+            <a:endParaRPr sz="1300">
               <a:solidFill>
                 <a:srgbClr val="1F2926"/>
               </a:solidFill>
@@ -13219,7 +13855,7 @@
             <a:r>
               <a:t/>
             </a:r>
-            <a:endParaRPr>
+            <a:endParaRPr sz="1300">
               <a:solidFill>
                 <a:srgbClr val="1F2926"/>
               </a:solidFill>
@@ -13243,7 +13879,7 @@
               <a:buNone/>
             </a:pPr>
             <a:r>
-              <a:rPr lang="en-GB">
+              <a:rPr lang="en-GB" sz="1300">
                 <a:solidFill>
                   <a:srgbClr val="1F2926"/>
                 </a:solidFill>
@@ -13252,9 +13888,9 @@
                 <a:cs typeface="Google Sans Flex"/>
                 <a:sym typeface="Google Sans Flex"/>
               </a:rPr>
-              <a:t>TARGET CLOUD STACK</a:t>
-            </a:r>
-            <a:endParaRPr>
+              <a:t>GOOGLE CLOUD</a:t>
+            </a:r>
+            <a:endParaRPr sz="1300">
               <a:solidFill>
                 <a:srgbClr val="1F2926"/>
               </a:solidFill>
@@ -13278,7 +13914,7 @@
               <a:buNone/>
             </a:pPr>
             <a:r>
-              <a:rPr lang="en-GB">
+              <a:rPr lang="en-GB" sz="1300">
                 <a:solidFill>
                   <a:srgbClr val="1F2926"/>
                 </a:solidFill>
@@ -13287,9 +13923,9 @@
                 <a:cs typeface="Google Sans Flex"/>
                 <a:sym typeface="Google Sans Flex"/>
               </a:rPr>
-              <a:t>Firebase Authentication, Firestore, Cloud Run and Gemini Developer API for invoice extraction and contextual analysis.</a:t>
-            </a:r>
-            <a:endParaRPr>
+              <a:t>Firebase anonymous authentication, Firestore, Cloud Run and Vertex AI Gemini 2.5 Flash-Lite. Two live synthetic invoice paths returned Continue and Review.</a:t>
+            </a:r>
+            <a:endParaRPr sz="1300">
               <a:solidFill>
                 <a:srgbClr val="1F2926"/>
               </a:solidFill>
@@ -13315,7 +13951,7 @@
             <a:r>
               <a:t/>
             </a:r>
-            <a:endParaRPr>
+            <a:endParaRPr sz="1300">
               <a:solidFill>
                 <a:srgbClr val="1F2926"/>
               </a:solidFill>
@@ -13334,12 +13970,12 @@
                 <a:spcPts val="600"/>
               </a:spcBef>
               <a:spcAft>
-                <a:spcPts val="0"/>
-              </a:spcAft>
-              <a:buNone/>
-            </a:pPr>
-            <a:r>
-              <a:rPr lang="en-GB">
+                <a:spcPts val="600"/>
+              </a:spcAft>
+              <a:buNone/>
+            </a:pPr>
+            <a:r>
+              <a:rPr lang="en-GB" sz="1300">
                 <a:solidFill>
                   <a:srgbClr val="1F2926"/>
                 </a:solidFill>
@@ -13348,44 +13984,9 @@
                 <a:cs typeface="Google Sans Flex"/>
                 <a:sym typeface="Google Sans Flex"/>
               </a:rPr>
-              <a:t>STATUS</a:t>
-            </a:r>
-            <a:endParaRPr>
-              <a:solidFill>
-                <a:srgbClr val="1F2926"/>
-              </a:solidFill>
-              <a:latin typeface="Google Sans Flex"/>
-              <a:ea typeface="Google Sans Flex"/>
-              <a:cs typeface="Google Sans Flex"/>
-              <a:sym typeface="Google Sans Flex"/>
-            </a:endParaRPr>
-          </a:p>
-          <a:p>
-            <a:pPr indent="0" lvl="0" marL="0" rtl="0" algn="l">
-              <a:lnSpc>
-                <a:spcPct val="112000"/>
-              </a:lnSpc>
-              <a:spcBef>
-                <a:spcPts val="600"/>
-              </a:spcBef>
-              <a:spcAft>
-                <a:spcPts val="600"/>
-              </a:spcAft>
-              <a:buNone/>
-            </a:pPr>
-            <a:r>
-              <a:rPr lang="en-GB">
-                <a:solidFill>
-                  <a:srgbClr val="1F2926"/>
-                </a:solidFill>
-                <a:latin typeface="Google Sans Flex"/>
-                <a:ea typeface="Google Sans Flex"/>
-                <a:cs typeface="Google Sans Flex"/>
-                <a:sym typeface="Google Sans Flex"/>
-              </a:rPr>
-              <a:t>Firebase Auth and Firestore code are implemented. Live credentials and persistence are unverified; Cloud Run deployment awaits credit coverage. No live Gemini request has been verified.</a:t>
-            </a:r>
-            <a:endParaRPr>
+              <a:t>The app is human reviewed. Requested explanations use Gemini-ranked recorded evidence rendered with deterministic templates. No real payment is initiated.</a:t>
+            </a:r>
+            <a:endParaRPr sz="1300">
               <a:solidFill>
                 <a:srgbClr val="1F2926"/>
               </a:solidFill>
@@ -13406,6 +14007,285 @@
 </file>
 
 <file path=ppt/theme/theme1.xml><?xml version="1.0" encoding="utf-8"?>
+<a:theme xmlns:a="http://schemas.openxmlformats.org/drawingml/2006/main" xmlns:r="http://schemas.openxmlformats.org/officeDocument/2006/relationships">
+  <a:themeElements>
+    <a:clrScheme name="Default">
+      <a:dk1>
+        <a:srgbClr val="000000"/>
+      </a:dk1>
+      <a:lt1>
+        <a:srgbClr val="FFFFFF"/>
+      </a:lt1>
+      <a:dk2>
+        <a:srgbClr val="158158"/>
+      </a:dk2>
+      <a:lt2>
+        <a:srgbClr val="F3F3F3"/>
+      </a:lt2>
+      <a:accent1>
+        <a:srgbClr val="058DC7"/>
+      </a:accent1>
+      <a:accent2>
+        <a:srgbClr val="50B432"/>
+      </a:accent2>
+      <a:accent3>
+        <a:srgbClr val="ED561B"/>
+      </a:accent3>
+      <a:accent4>
+        <a:srgbClr val="EDEF00"/>
+      </a:accent4>
+      <a:accent5>
+        <a:srgbClr val="24CBE5"/>
+      </a:accent5>
+      <a:accent6>
+        <a:srgbClr val="64E572"/>
+      </a:accent6>
+      <a:hlink>
+        <a:srgbClr val="2200CC"/>
+      </a:hlink>
+      <a:folHlink>
+        <a:srgbClr val="551A8B"/>
+      </a:folHlink>
+    </a:clrScheme>
+    <a:fontScheme name="Office">
+      <a:majorFont>
+        <a:latin typeface="Arial"/>
+        <a:ea typeface=""/>
+        <a:cs typeface=""/>
+        <a:font script="Jpan" typeface="ＭＳ Ｐゴシック"/>
+        <a:font script="Hang" typeface="맑은 고딕"/>
+        <a:font script="Hans" typeface="宋体"/>
+        <a:font script="Hant" typeface="新細明體"/>
+        <a:font script="Arab" typeface="Times New Roman"/>
+        <a:font script="Hebr" typeface="Times New Roman"/>
+        <a:font script="Thai" typeface="Angsana New"/>
+        <a:font script="Ethi" typeface="Nyala"/>
+        <a:font script="Beng" typeface="Vrinda"/>
+        <a:font script="Gujr" typeface="Shruti"/>
+        <a:font script="Khmr" typeface="MoolBoran"/>
+        <a:font script="Knda" typeface="Tunga"/>
+        <a:font script="Guru" typeface="Raavi"/>
+        <a:font script="Cans" typeface="Euphemia"/>
+        <a:font script="Cher" typeface="Plantagenet Cherokee"/>
+        <a:font script="Yiii" typeface="Microsoft Yi Baiti"/>
+        <a:font script="Tibt" typeface="Microsoft Himalaya"/>
+        <a:font script="Thaa" typeface="MV Boli"/>
+        <a:font script="Deva" typeface="Mangal"/>
+        <a:font script="Telu" typeface="Gautami"/>
+        <a:font script="Taml" typeface="Latha"/>
+        <a:font script="Syrc" typeface="Estrangelo Edessa"/>
+        <a:font script="Orya" typeface="Kalinga"/>
+        <a:font script="Mlym" typeface="Kartika"/>
+        <a:font script="Laoo" typeface="DokChampa"/>
+        <a:font script="Sinh" typeface="Iskoola Pota"/>
+        <a:font script="Mong" typeface="Mongolian Baiti"/>
+        <a:font script="Viet" typeface="Times New Roman"/>
+        <a:font script="Uigh" typeface="Microsoft Uighur"/>
+        <a:font script="Geor" typeface="Sylfaen"/>
+      </a:majorFont>
+      <a:minorFont>
+        <a:latin typeface="Arial"/>
+        <a:ea typeface=""/>
+        <a:cs typeface=""/>
+        <a:font script="Jpan" typeface="ＭＳ Ｐゴシック"/>
+        <a:font script="Hang" typeface="맑은 고딕"/>
+        <a:font script="Hans" typeface="宋体"/>
+        <a:font script="Hant" typeface="新細明體"/>
+        <a:font script="Arab" typeface="Arial"/>
+        <a:font script="Hebr" typeface="Arial"/>
+        <a:font script="Thai" typeface="Cordia New"/>
+        <a:font script="Ethi" typeface="Nyala"/>
+        <a:font script="Beng" typeface="Vrinda"/>
+        <a:font script="Gujr" typeface="Shruti"/>
+        <a:font script="Khmr" typeface="DaunPenh"/>
+        <a:font script="Knda" typeface="Tunga"/>
+        <a:font script="Guru" typeface="Raavi"/>
+        <a:font script="Cans" typeface="Euphemia"/>
+        <a:font script="Cher" typeface="Plantagenet Cherokee"/>
+        <a:font script="Yiii" typeface="Microsoft Yi Baiti"/>
+        <a:font script="Tibt" typeface="Microsoft Himalaya"/>
+        <a:font script="Thaa" typeface="MV Boli"/>
+        <a:font script="Deva" typeface="Mangal"/>
+        <a:font script="Telu" typeface="Gautami"/>
+        <a:font script="Taml" typeface="Latha"/>
+        <a:font script="Syrc" typeface="Estrangelo Edessa"/>
+        <a:font script="Orya" typeface="Kalinga"/>
+        <a:font script="Mlym" typeface="Kartika"/>
+        <a:font script="Laoo" typeface="DokChampa"/>
+        <a:font script="Sinh" typeface="Iskoola Pota"/>
+        <a:font script="Mong" typeface="Mongolian Baiti"/>
+        <a:font script="Viet" typeface="Arial"/>
+        <a:font script="Uigh" typeface="Microsoft Uighur"/>
+        <a:font script="Geor" typeface="Sylfaen"/>
+      </a:minorFont>
+    </a:fontScheme>
+    <a:fmtScheme name="Office">
+      <a:fillStyleLst>
+        <a:solidFill>
+          <a:schemeClr val="phClr"/>
+        </a:solidFill>
+        <a:gradFill rotWithShape="1">
+          <a:gsLst>
+            <a:gs pos="0">
+              <a:schemeClr val="phClr">
+                <a:tint val="50000"/>
+                <a:satMod val="300000"/>
+              </a:schemeClr>
+            </a:gs>
+            <a:gs pos="35000">
+              <a:schemeClr val="phClr">
+                <a:tint val="37000"/>
+                <a:satMod val="300000"/>
+              </a:schemeClr>
+            </a:gs>
+            <a:gs pos="100000">
+              <a:schemeClr val="phClr">
+                <a:tint val="15000"/>
+                <a:satMod val="350000"/>
+              </a:schemeClr>
+            </a:gs>
+          </a:gsLst>
+          <a:lin ang="16200000" scaled="1"/>
+        </a:gradFill>
+        <a:gradFill rotWithShape="1">
+          <a:gsLst>
+            <a:gs pos="0">
+              <a:schemeClr val="phClr">
+                <a:tint val="100000"/>
+                <a:shade val="100000"/>
+                <a:satMod val="130000"/>
+              </a:schemeClr>
+            </a:gs>
+            <a:gs pos="100000">
+              <a:schemeClr val="phClr">
+                <a:tint val="50000"/>
+                <a:shade val="100000"/>
+                <a:satMod val="350000"/>
+              </a:schemeClr>
+            </a:gs>
+          </a:gsLst>
+          <a:lin ang="16200000" scaled="0"/>
+        </a:gradFill>
+      </a:fillStyleLst>
+      <a:lnStyleLst>
+        <a:ln w="9525" cap="flat" cmpd="sng" algn="ctr">
+          <a:solidFill>
+            <a:schemeClr val="phClr">
+              <a:shade val="95000"/>
+              <a:satMod val="105000"/>
+            </a:schemeClr>
+          </a:solidFill>
+          <a:prstDash val="solid"/>
+        </a:ln>
+        <a:ln w="25400" cap="flat" cmpd="sng" algn="ctr">
+          <a:solidFill>
+            <a:schemeClr val="phClr"/>
+          </a:solidFill>
+          <a:prstDash val="solid"/>
+        </a:ln>
+        <a:ln w="38100" cap="flat" cmpd="sng" algn="ctr">
+          <a:solidFill>
+            <a:schemeClr val="phClr"/>
+          </a:solidFill>
+          <a:prstDash val="solid"/>
+        </a:ln>
+      </a:lnStyleLst>
+      <a:effectStyleLst>
+        <a:effectStyle>
+          <a:effectLst>
+            <a:outerShdw blurRad="40000" dist="20000" dir="5400000" rotWithShape="0">
+              <a:srgbClr val="000000">
+                <a:alpha val="38000"/>
+              </a:srgbClr>
+            </a:outerShdw>
+          </a:effectLst>
+        </a:effectStyle>
+        <a:effectStyle>
+          <a:effectLst>
+            <a:outerShdw blurRad="40000" dist="23000" dir="5400000" rotWithShape="0">
+              <a:srgbClr val="000000">
+                <a:alpha val="35000"/>
+              </a:srgbClr>
+            </a:outerShdw>
+          </a:effectLst>
+        </a:effectStyle>
+        <a:effectStyle>
+          <a:effectLst>
+            <a:outerShdw blurRad="40000" dist="23000" dir="5400000" rotWithShape="0">
+              <a:srgbClr val="000000">
+                <a:alpha val="35000"/>
+              </a:srgbClr>
+            </a:outerShdw>
+          </a:effectLst>
+          <a:scene3d>
+            <a:camera prst="orthographicFront">
+              <a:rot lat="0" lon="0" rev="0"/>
+            </a:camera>
+            <a:lightRig rig="threePt" dir="t">
+              <a:rot lat="0" lon="0" rev="1200000"/>
+            </a:lightRig>
+          </a:scene3d>
+          <a:sp3d>
+            <a:bevelT w="63500" h="25400"/>
+          </a:sp3d>
+        </a:effectStyle>
+      </a:effectStyleLst>
+      <a:bgFillStyleLst>
+        <a:solidFill>
+          <a:schemeClr val="phClr"/>
+        </a:solidFill>
+        <a:gradFill rotWithShape="1">
+          <a:gsLst>
+            <a:gs pos="0">
+              <a:schemeClr val="phClr">
+                <a:tint val="40000"/>
+                <a:satMod val="350000"/>
+              </a:schemeClr>
+            </a:gs>
+            <a:gs pos="40000">
+              <a:schemeClr val="phClr">
+                <a:tint val="45000"/>
+                <a:shade val="99000"/>
+                <a:satMod val="350000"/>
+              </a:schemeClr>
+            </a:gs>
+            <a:gs pos="100000">
+              <a:schemeClr val="phClr">
+                <a:shade val="20000"/>
+                <a:satMod val="255000"/>
+              </a:schemeClr>
+            </a:gs>
+          </a:gsLst>
+          <a:path path="circle">
+            <a:fillToRect l="50000" t="-80000" r="50000" b="180000"/>
+          </a:path>
+        </a:gradFill>
+        <a:gradFill rotWithShape="1">
+          <a:gsLst>
+            <a:gs pos="0">
+              <a:schemeClr val="phClr">
+                <a:tint val="80000"/>
+                <a:satMod val="300000"/>
+              </a:schemeClr>
+            </a:gs>
+            <a:gs pos="100000">
+              <a:schemeClr val="phClr">
+                <a:shade val="30000"/>
+                <a:satMod val="200000"/>
+              </a:schemeClr>
+            </a:gs>
+          </a:gsLst>
+          <a:path path="circle">
+            <a:fillToRect l="50000" t="50000" r="50000" b="50000"/>
+          </a:path>
+        </a:gradFill>
+      </a:bgFillStyleLst>
+    </a:fmtScheme>
+  </a:themeElements>
+</a:theme>
+</file>
+
+<file path=ppt/theme/theme2.xml><?xml version="1.0" encoding="utf-8"?>
 <a:theme xmlns:a="http://schemas.openxmlformats.org/drawingml/2006/main" xmlns:r="http://schemas.openxmlformats.org/officeDocument/2006/relationships" name="Simple Light">
   <a:themeElements>
     <a:clrScheme name="Simple Light">
@@ -13682,283 +14562,4 @@
     </a:fmtScheme>
   </a:themeElements>
 </a:theme>
-</file>
-
-<file path=ppt/theme/theme2.xml><?xml version="1.0" encoding="utf-8"?>
-<a:theme xmlns:a="http://schemas.openxmlformats.org/drawingml/2006/main" xmlns:r="http://schemas.openxmlformats.org/officeDocument/2006/relationships">
-  <a:themeElements>
-    <a:clrScheme name="Default">
-      <a:dk1>
-        <a:srgbClr val="000000"/>
-      </a:dk1>
-      <a:lt1>
-        <a:srgbClr val="FFFFFF"/>
-      </a:lt1>
-      <a:dk2>
-        <a:srgbClr val="158158"/>
-      </a:dk2>
-      <a:lt2>
-        <a:srgbClr val="F3F3F3"/>
-      </a:lt2>
-      <a:accent1>
-        <a:srgbClr val="058DC7"/>
-      </a:accent1>
-      <a:accent2>
-        <a:srgbClr val="50B432"/>
-      </a:accent2>
-      <a:accent3>
-        <a:srgbClr val="ED561B"/>
-      </a:accent3>
-      <a:accent4>
-        <a:srgbClr val="EDEF00"/>
-      </a:accent4>
-      <a:accent5>
-        <a:srgbClr val="24CBE5"/>
-      </a:accent5>
-      <a:accent6>
-        <a:srgbClr val="64E572"/>
-      </a:accent6>
-      <a:hlink>
-        <a:srgbClr val="2200CC"/>
-      </a:hlink>
-      <a:folHlink>
-        <a:srgbClr val="551A8B"/>
-      </a:folHlink>
-    </a:clrScheme>
-    <a:fontScheme name="Office">
-      <a:majorFont>
-        <a:latin typeface="Arial"/>
-        <a:ea typeface=""/>
-        <a:cs typeface=""/>
-        <a:font script="Jpan" typeface="ＭＳ Ｐゴシック"/>
-        <a:font script="Hang" typeface="맑은 고딕"/>
-        <a:font script="Hans" typeface="宋体"/>
-        <a:font script="Hant" typeface="新細明體"/>
-        <a:font script="Arab" typeface="Times New Roman"/>
-        <a:font script="Hebr" typeface="Times New Roman"/>
-        <a:font script="Thai" typeface="Angsana New"/>
-        <a:font script="Ethi" typeface="Nyala"/>
-        <a:font script="Beng" typeface="Vrinda"/>
-        <a:font script="Gujr" typeface="Shruti"/>
-        <a:font script="Khmr" typeface="MoolBoran"/>
-        <a:font script="Knda" typeface="Tunga"/>
-        <a:font script="Guru" typeface="Raavi"/>
-        <a:font script="Cans" typeface="Euphemia"/>
-        <a:font script="Cher" typeface="Plantagenet Cherokee"/>
-        <a:font script="Yiii" typeface="Microsoft Yi Baiti"/>
-        <a:font script="Tibt" typeface="Microsoft Himalaya"/>
-        <a:font script="Thaa" typeface="MV Boli"/>
-        <a:font script="Deva" typeface="Mangal"/>
-        <a:font script="Telu" typeface="Gautami"/>
-        <a:font script="Taml" typeface="Latha"/>
-        <a:font script="Syrc" typeface="Estrangelo Edessa"/>
-        <a:font script="Orya" typeface="Kalinga"/>
-        <a:font script="Mlym" typeface="Kartika"/>
-        <a:font script="Laoo" typeface="DokChampa"/>
-        <a:font script="Sinh" typeface="Iskoola Pota"/>
-        <a:font script="Mong" typeface="Mongolian Baiti"/>
-        <a:font script="Viet" typeface="Times New Roman"/>
-        <a:font script="Uigh" typeface="Microsoft Uighur"/>
-        <a:font script="Geor" typeface="Sylfaen"/>
-      </a:majorFont>
-      <a:minorFont>
-        <a:latin typeface="Arial"/>
-        <a:ea typeface=""/>
-        <a:cs typeface=""/>
-        <a:font script="Jpan" typeface="ＭＳ Ｐゴシック"/>
-        <a:font script="Hang" typeface="맑은 고딕"/>
-        <a:font script="Hans" typeface="宋体"/>
-        <a:font script="Hant" typeface="新細明體"/>
-        <a:font script="Arab" typeface="Arial"/>
-        <a:font script="Hebr" typeface="Arial"/>
-        <a:font script="Thai" typeface="Cordia New"/>
-        <a:font script="Ethi" typeface="Nyala"/>
-        <a:font script="Beng" typeface="Vrinda"/>
-        <a:font script="Gujr" typeface="Shruti"/>
-        <a:font script="Khmr" typeface="DaunPenh"/>
-        <a:font script="Knda" typeface="Tunga"/>
-        <a:font script="Guru" typeface="Raavi"/>
-        <a:font script="Cans" typeface="Euphemia"/>
-        <a:font script="Cher" typeface="Plantagenet Cherokee"/>
-        <a:font script="Yiii" typeface="Microsoft Yi Baiti"/>
-        <a:font script="Tibt" typeface="Microsoft Himalaya"/>
-        <a:font script="Thaa" typeface="MV Boli"/>
-        <a:font script="Deva" typeface="Mangal"/>
-        <a:font script="Telu" typeface="Gautami"/>
-        <a:font script="Taml" typeface="Latha"/>
-        <a:font script="Syrc" typeface="Estrangelo Edessa"/>
-        <a:font script="Orya" typeface="Kalinga"/>
-        <a:font script="Mlym" typeface="Kartika"/>
-        <a:font script="Laoo" typeface="DokChampa"/>
-        <a:font script="Sinh" typeface="Iskoola Pota"/>
-        <a:font script="Mong" typeface="Mongolian Baiti"/>
-        <a:font script="Viet" typeface="Arial"/>
-        <a:font script="Uigh" typeface="Microsoft Uighur"/>
-        <a:font script="Geor" typeface="Sylfaen"/>
-      </a:minorFont>
-    </a:fontScheme>
-    <a:fmtScheme name="Office">
-      <a:fillStyleLst>
-        <a:solidFill>
-          <a:schemeClr val="phClr"/>
-        </a:solidFill>
-        <a:gradFill rotWithShape="1">
-          <a:gsLst>
-            <a:gs pos="0">
-              <a:schemeClr val="phClr">
-                <a:tint val="50000"/>
-                <a:satMod val="300000"/>
-              </a:schemeClr>
-            </a:gs>
-            <a:gs pos="35000">
-              <a:schemeClr val="phClr">
-                <a:tint val="37000"/>
-                <a:satMod val="300000"/>
-              </a:schemeClr>
-            </a:gs>
-            <a:gs pos="100000">
-              <a:schemeClr val="phClr">
-                <a:tint val="15000"/>
-                <a:satMod val="350000"/>
-              </a:schemeClr>
-            </a:gs>
-          </a:gsLst>
-          <a:lin ang="16200000" scaled="1"/>
-        </a:gradFill>
-        <a:gradFill rotWithShape="1">
-          <a:gsLst>
-            <a:gs pos="0">
-              <a:schemeClr val="phClr">
-                <a:tint val="100000"/>
-                <a:shade val="100000"/>
-                <a:satMod val="130000"/>
-              </a:schemeClr>
-            </a:gs>
-            <a:gs pos="100000">
-              <a:schemeClr val="phClr">
-                <a:tint val="50000"/>
-                <a:shade val="100000"/>
-                <a:satMod val="350000"/>
-              </a:schemeClr>
-            </a:gs>
-          </a:gsLst>
-          <a:lin ang="16200000" scaled="0"/>
-        </a:gradFill>
-      </a:fillStyleLst>
-      <a:lnStyleLst>
-        <a:ln w="9525" cap="flat" cmpd="sng" algn="ctr">
-          <a:solidFill>
-            <a:schemeClr val="phClr">
-              <a:shade val="95000"/>
-              <a:satMod val="105000"/>
-            </a:schemeClr>
-          </a:solidFill>
-          <a:prstDash val="solid"/>
-        </a:ln>
-        <a:ln w="25400" cap="flat" cmpd="sng" algn="ctr">
-          <a:solidFill>
-            <a:schemeClr val="phClr"/>
-          </a:solidFill>
-          <a:prstDash val="solid"/>
-        </a:ln>
-        <a:ln w="38100" cap="flat" cmpd="sng" algn="ctr">
-          <a:solidFill>
-            <a:schemeClr val="phClr"/>
-          </a:solidFill>
-          <a:prstDash val="solid"/>
-        </a:ln>
-      </a:lnStyleLst>
-      <a:effectStyleLst>
-        <a:effectStyle>
-          <a:effectLst>
-            <a:outerShdw blurRad="40000" dist="20000" dir="5400000" rotWithShape="0">
-              <a:srgbClr val="000000">
-                <a:alpha val="38000"/>
-              </a:srgbClr>
-            </a:outerShdw>
-          </a:effectLst>
-        </a:effectStyle>
-        <a:effectStyle>
-          <a:effectLst>
-            <a:outerShdw blurRad="40000" dist="23000" dir="5400000" rotWithShape="0">
-              <a:srgbClr val="000000">
-                <a:alpha val="35000"/>
-              </a:srgbClr>
-            </a:outerShdw>
-          </a:effectLst>
-        </a:effectStyle>
-        <a:effectStyle>
-          <a:effectLst>
-            <a:outerShdw blurRad="40000" dist="23000" dir="5400000" rotWithShape="0">
-              <a:srgbClr val="000000">
-                <a:alpha val="35000"/>
-              </a:srgbClr>
-            </a:outerShdw>
-          </a:effectLst>
-          <a:scene3d>
-            <a:camera prst="orthographicFront">
-              <a:rot lat="0" lon="0" rev="0"/>
-            </a:camera>
-            <a:lightRig rig="threePt" dir="t">
-              <a:rot lat="0" lon="0" rev="1200000"/>
-            </a:lightRig>
-          </a:scene3d>
-          <a:sp3d>
-            <a:bevelT w="63500" h="25400"/>
-          </a:sp3d>
-        </a:effectStyle>
-      </a:effectStyleLst>
-      <a:bgFillStyleLst>
-        <a:solidFill>
-          <a:schemeClr val="phClr"/>
-        </a:solidFill>
-        <a:gradFill rotWithShape="1">
-          <a:gsLst>
-            <a:gs pos="0">
-              <a:schemeClr val="phClr">
-                <a:tint val="40000"/>
-                <a:satMod val="350000"/>
-              </a:schemeClr>
-            </a:gs>
-            <a:gs pos="40000">
-              <a:schemeClr val="phClr">
-                <a:tint val="45000"/>
-                <a:shade val="99000"/>
-                <a:satMod val="350000"/>
-              </a:schemeClr>
-            </a:gs>
-            <a:gs pos="100000">
-              <a:schemeClr val="phClr">
-                <a:shade val="20000"/>
-                <a:satMod val="255000"/>
-              </a:schemeClr>
-            </a:gs>
-          </a:gsLst>
-          <a:path path="circle">
-            <a:fillToRect l="50000" t="-80000" r="50000" b="180000"/>
-          </a:path>
-        </a:gradFill>
-        <a:gradFill rotWithShape="1">
-          <a:gsLst>
-            <a:gs pos="0">
-              <a:schemeClr val="phClr">
-                <a:tint val="80000"/>
-                <a:satMod val="300000"/>
-              </a:schemeClr>
-            </a:gs>
-            <a:gs pos="100000">
-              <a:schemeClr val="phClr">
-                <a:shade val="30000"/>
-                <a:satMod val="200000"/>
-              </a:schemeClr>
-            </a:gs>
-          </a:gsLst>
-          <a:path path="circle">
-            <a:fillToRect l="50000" t="50000" r="50000" b="50000"/>
-          </a:path>
-        </a:gradFill>
-      </a:bgFillStyleLst>
-    </a:fmtScheme>
-  </a:themeElements>
-</a:theme>
 </file>
</xml_diff>

<commit_message>
Strengthen hybrid fraud pitch with sourced invoice fraud figures
</commit_message>
<xml_diff>
--- a/artifacts/scamshield-hack2skill-submission.pptx
+++ b/artifacts/scamshield-hack2skill-submission.pptx
@@ -22,26 +22,24 @@
     <p:sldId id="267" r:id="rId17"/>
     <p:sldId id="268" r:id="rId18"/>
     <p:sldId id="269" r:id="rId19"/>
-    <p:sldId id="270" r:id="rId20"/>
-    <p:sldId id="271" r:id="rId21"/>
   </p:sldIdLst>
   <p:sldSz cy="5143500" cx="9144000"/>
   <p:notesSz cx="6858000" cy="9144000"/>
   <p:embeddedFontLst>
     <p:embeddedFont>
       <p:font typeface="Google Sans Flex Medium"/>
+      <p:regular r:id="rId20"/>
+      <p:bold r:id="rId21"/>
+    </p:embeddedFont>
+    <p:embeddedFont>
+      <p:font typeface="Google Sans Flex"/>
       <p:regular r:id="rId22"/>
       <p:bold r:id="rId23"/>
     </p:embeddedFont>
     <p:embeddedFont>
-      <p:font typeface="Google Sans Flex"/>
+      <p:font typeface="Google Sans Flex SemiBold"/>
       <p:regular r:id="rId24"/>
       <p:bold r:id="rId25"/>
-    </p:embeddedFont>
-    <p:embeddedFont>
-      <p:font typeface="Google Sans Flex SemiBold"/>
-      <p:regular r:id="rId26"/>
-      <p:bold r:id="rId27"/>
     </p:embeddedFont>
   </p:embeddedFontLst>
   <p:defaultTextStyle>
@@ -822,7 +820,7 @@
   <p:cSld>
     <p:spTree>
       <p:nvGrpSpPr>
-        <p:cNvPr id="150" name="Shape 150"/>
+        <p:cNvPr id="159" name="Shape 159"/>
         <p:cNvGrpSpPr/>
         <p:nvPr/>
       </p:nvGrpSpPr>
@@ -836,7 +834,7 @@
       </p:grpSpPr>
       <p:sp>
         <p:nvSpPr>
-          <p:cNvPr id="151" name="Google Shape;151;g3fb085bff3c_0_41:notes"/>
+          <p:cNvPr id="160" name="Google Shape;160;g3fb085bff3c_0_46:notes"/>
           <p:cNvSpPr/>
           <p:nvPr>
             <p:ph idx="2" type="sldImg"/>
@@ -871,7 +869,7 @@
       </p:sp>
       <p:sp>
         <p:nvSpPr>
-          <p:cNvPr id="152" name="Google Shape;152;g3fb085bff3c_0_41:notes"/>
+          <p:cNvPr id="161" name="Google Shape;161;g3fb085bff3c_0_46:notes"/>
           <p:cNvSpPr txBox="1"/>
           <p:nvPr>
             <p:ph idx="1" type="body"/>
@@ -902,8 +900,7 @@
               <a:buNone/>
             </a:pPr>
             <a:r>
-              <a:rPr lang="en-GB"/>
-              <a:t>ScamShield uses Vertex AI Gemini 2.5 Flash-Lite, Firebase Authentication, Firestore and Cloud Run. The ₹100 budget alert through 6 Nov 2026 is not a spending cap. 59 backend tests passed. Live synthetic invoice checks covered extraction, classification, explanation, Firestore reads, idempotency, restart durability and visitor isolation. Use synthetic data only.</a:t>
+              <a:t/>
             </a:r>
             <a:endParaRPr/>
           </a:p>
@@ -918,105 +915,6 @@
 </file>
 
 <file path=ppt/notesSlides/notesSlide11.xml><?xml version="1.0" encoding="utf-8"?>
-<p:notes xmlns:a="http://schemas.openxmlformats.org/drawingml/2006/main" xmlns:r="http://schemas.openxmlformats.org/officeDocument/2006/relationships" xmlns:mc="http://schemas.openxmlformats.org/markup-compatibility/2006" xmlns:mv="urn:schemas-microsoft-com:mac:vml" xmlns:p="http://schemas.openxmlformats.org/presentationml/2006/main" xmlns:c="http://schemas.openxmlformats.org/drawingml/2006/chart" xmlns:dgm="http://schemas.openxmlformats.org/drawingml/2006/diagram" xmlns:o="urn:schemas-microsoft-com:office:office" xmlns:v="urn:schemas-microsoft-com:vml" xmlns:pvml="urn:schemas-microsoft-com:office:powerpoint" xmlns:com="http://schemas.openxmlformats.org/drawingml/2006/compatibility" xmlns:p14="http://schemas.microsoft.com/office/powerpoint/2010/main" xmlns:p15="http://schemas.microsoft.com/office/powerpoint/2012/main" xmlns:ahyp="http://schemas.microsoft.com/office/drawing/2018/hyperlinkcolor" showMasterPhAnim="0" showMasterSp="0">
-  <p:cSld>
-    <p:spTree>
-      <p:nvGrpSpPr>
-        <p:cNvPr id="159" name="Shape 159"/>
-        <p:cNvGrpSpPr/>
-        <p:nvPr/>
-      </p:nvGrpSpPr>
-      <p:grpSpPr>
-        <a:xfrm>
-          <a:off x="0" y="0"/>
-          <a:ext cx="0" cy="0"/>
-          <a:chOff x="0" y="0"/>
-          <a:chExt cx="0" cy="0"/>
-        </a:xfrm>
-      </p:grpSpPr>
-      <p:sp>
-        <p:nvSpPr>
-          <p:cNvPr id="160" name="Google Shape;160;g3fb085bff3c_0_46:notes"/>
-          <p:cNvSpPr/>
-          <p:nvPr>
-            <p:ph idx="2" type="sldImg"/>
-          </p:nvPr>
-        </p:nvSpPr>
-        <p:spPr>
-          <a:xfrm>
-            <a:off x="381300" y="685800"/>
-            <a:ext cx="6096000" cy="3429000"/>
-          </a:xfrm>
-          <a:custGeom>
-            <a:rect b="b" l="l" r="r" t="t"/>
-            <a:pathLst>
-              <a:path extrusionOk="0" h="120000" w="120000">
-                <a:moveTo>
-                  <a:pt x="0" y="0"/>
-                </a:moveTo>
-                <a:lnTo>
-                  <a:pt x="120000" y="0"/>
-                </a:lnTo>
-                <a:lnTo>
-                  <a:pt x="120000" y="120000"/>
-                </a:lnTo>
-                <a:lnTo>
-                  <a:pt x="0" y="120000"/>
-                </a:lnTo>
-                <a:close/>
-              </a:path>
-            </a:pathLst>
-          </a:custGeom>
-        </p:spPr>
-      </p:sp>
-      <p:sp>
-        <p:nvSpPr>
-          <p:cNvPr id="161" name="Google Shape;161;g3fb085bff3c_0_46:notes"/>
-          <p:cNvSpPr txBox="1"/>
-          <p:nvPr>
-            <p:ph idx="1" type="body"/>
-          </p:nvPr>
-        </p:nvSpPr>
-        <p:spPr>
-          <a:xfrm>
-            <a:off x="685800" y="4343400"/>
-            <a:ext cx="5486400" cy="4114800"/>
-          </a:xfrm>
-          <a:prstGeom prst="rect">
-            <a:avLst/>
-          </a:prstGeom>
-        </p:spPr>
-        <p:txBody>
-          <a:bodyPr anchorCtr="0" anchor="t" bIns="91425" lIns="91425" spcFirstLastPara="1" rIns="91425" wrap="square" tIns="91425">
-            <a:noAutofit/>
-          </a:bodyPr>
-          <a:lstStyle/>
-          <a:p>
-            <a:pPr indent="0" lvl="0" marL="0" rtl="0" algn="l">
-              <a:spcBef>
-                <a:spcPts val="0"/>
-              </a:spcBef>
-              <a:spcAft>
-                <a:spcPts val="0"/>
-              </a:spcAft>
-              <a:buNone/>
-            </a:pPr>
-            <a:r>
-              <a:t/>
-            </a:r>
-            <a:endParaRPr/>
-          </a:p>
-        </p:txBody>
-      </p:sp>
-    </p:spTree>
-  </p:cSld>
-  <p:clrMapOvr>
-    <a:masterClrMapping/>
-  </p:clrMapOvr>
-</p:notes>
-</file>
-
-<file path=ppt/notesSlides/notesSlide12.xml><?xml version="1.0" encoding="utf-8"?>
 <p:notes xmlns:a="http://schemas.openxmlformats.org/drawingml/2006/main" xmlns:r="http://schemas.openxmlformats.org/officeDocument/2006/relationships" xmlns:mc="http://schemas.openxmlformats.org/markup-compatibility/2006" xmlns:mv="urn:schemas-microsoft-com:mac:vml" xmlns:p="http://schemas.openxmlformats.org/presentationml/2006/main" xmlns:c="http://schemas.openxmlformats.org/drawingml/2006/chart" xmlns:dgm="http://schemas.openxmlformats.org/drawingml/2006/diagram" xmlns:o="urn:schemas-microsoft-com:office:office" xmlns:v="urn:schemas-microsoft-com:vml" xmlns:pvml="urn:schemas-microsoft-com:office:powerpoint" xmlns:com="http://schemas.openxmlformats.org/drawingml/2006/compatibility" xmlns:p14="http://schemas.microsoft.com/office/powerpoint/2010/main" xmlns:p15="http://schemas.microsoft.com/office/powerpoint/2012/main" xmlns:ahyp="http://schemas.microsoft.com/office/drawing/2018/hyperlinkcolor" showMasterPhAnim="0" showMasterSp="0">
   <p:cSld>
     <p:spTree>
@@ -1115,7 +1013,7 @@
 </p:notes>
 </file>
 
-<file path=ppt/notesSlides/notesSlide13.xml><?xml version="1.0" encoding="utf-8"?>
+<file path=ppt/notesSlides/notesSlide12.xml><?xml version="1.0" encoding="utf-8"?>
 <p:notes xmlns:a="http://schemas.openxmlformats.org/drawingml/2006/main" xmlns:r="http://schemas.openxmlformats.org/officeDocument/2006/relationships" xmlns:mc="http://schemas.openxmlformats.org/markup-compatibility/2006" xmlns:mv="urn:schemas-microsoft-com:mac:vml" xmlns:p="http://schemas.openxmlformats.org/presentationml/2006/main" xmlns:c="http://schemas.openxmlformats.org/drawingml/2006/chart" xmlns:dgm="http://schemas.openxmlformats.org/drawingml/2006/diagram" xmlns:o="urn:schemas-microsoft-com:office:office" xmlns:v="urn:schemas-microsoft-com:vml" xmlns:pvml="urn:schemas-microsoft-com:office:powerpoint" xmlns:com="http://schemas.openxmlformats.org/drawingml/2006/compatibility" xmlns:p14="http://schemas.microsoft.com/office/powerpoint/2010/main" xmlns:p15="http://schemas.microsoft.com/office/powerpoint/2012/main" xmlns:ahyp="http://schemas.microsoft.com/office/drawing/2018/hyperlinkcolor" showMasterPhAnim="0" showMasterSp="0">
   <p:cSld>
     <p:spTree>
@@ -1214,7 +1112,7 @@
 </p:notes>
 </file>
 
-<file path=ppt/notesSlides/notesSlide14.xml><?xml version="1.0" encoding="utf-8"?>
+<file path=ppt/notesSlides/notesSlide13.xml><?xml version="1.0" encoding="utf-8"?>
 <p:notes xmlns:a="http://schemas.openxmlformats.org/drawingml/2006/main" xmlns:r="http://schemas.openxmlformats.org/officeDocument/2006/relationships" xmlns:mc="http://schemas.openxmlformats.org/markup-compatibility/2006" xmlns:mv="urn:schemas-microsoft-com:mac:vml" xmlns:p="http://schemas.openxmlformats.org/presentationml/2006/main" xmlns:c="http://schemas.openxmlformats.org/drawingml/2006/chart" xmlns:dgm="http://schemas.openxmlformats.org/drawingml/2006/diagram" xmlns:o="urn:schemas-microsoft-com:office:office" xmlns:v="urn:schemas-microsoft-com:vml" xmlns:pvml="urn:schemas-microsoft-com:office:powerpoint" xmlns:com="http://schemas.openxmlformats.org/drawingml/2006/compatibility" xmlns:p14="http://schemas.microsoft.com/office/powerpoint/2010/main" xmlns:p15="http://schemas.microsoft.com/office/powerpoint/2012/main" xmlns:ahyp="http://schemas.microsoft.com/office/drawing/2018/hyperlinkcolor" showMasterPhAnim="0" showMasterSp="0">
   <p:cSld>
     <p:spTree>
@@ -1313,7 +1211,7 @@
 </p:notes>
 </file>
 
-<file path=ppt/notesSlides/notesSlide15.xml><?xml version="1.0" encoding="utf-8"?>
+<file path=ppt/notesSlides/notesSlide14.xml><?xml version="1.0" encoding="utf-8"?>
 <p:notes xmlns:a="http://schemas.openxmlformats.org/drawingml/2006/main" xmlns:r="http://schemas.openxmlformats.org/officeDocument/2006/relationships" xmlns:mc="http://schemas.openxmlformats.org/markup-compatibility/2006" xmlns:mv="urn:schemas-microsoft-com:mac:vml" xmlns:p="http://schemas.openxmlformats.org/presentationml/2006/main" xmlns:c="http://schemas.openxmlformats.org/drawingml/2006/chart" xmlns:dgm="http://schemas.openxmlformats.org/drawingml/2006/diagram" xmlns:o="urn:schemas-microsoft-com:office:office" xmlns:v="urn:schemas-microsoft-com:vml" xmlns:pvml="urn:schemas-microsoft-com:office:powerpoint" xmlns:com="http://schemas.openxmlformats.org/drawingml/2006/compatibility" xmlns:p14="http://schemas.microsoft.com/office/powerpoint/2010/main" xmlns:p15="http://schemas.microsoft.com/office/powerpoint/2012/main" xmlns:ahyp="http://schemas.microsoft.com/office/drawing/2018/hyperlinkcolor" showMasterPhAnim="0" showMasterSp="0">
   <p:cSld>
     <p:spTree>
@@ -1332,7 +1230,7 @@
       </p:grpSpPr>
       <p:sp>
         <p:nvSpPr>
-          <p:cNvPr id="197" name="Google Shape;197;g3fb085bff3c_0_107:notes"/>
+          <p:cNvPr id="197" name="Google Shape;197;g3fb085bff3c_0_66:notes"/>
           <p:cNvSpPr/>
           <p:nvPr>
             <p:ph idx="2" type="sldImg"/>
@@ -1367,106 +1265,7 @@
       </p:sp>
       <p:sp>
         <p:nvSpPr>
-          <p:cNvPr id="198" name="Google Shape;198;g3fb085bff3c_0_107:notes"/>
-          <p:cNvSpPr txBox="1"/>
-          <p:nvPr>
-            <p:ph idx="1" type="body"/>
-          </p:nvPr>
-        </p:nvSpPr>
-        <p:spPr>
-          <a:xfrm>
-            <a:off x="685800" y="4343400"/>
-            <a:ext cx="5486400" cy="4114800"/>
-          </a:xfrm>
-          <a:prstGeom prst="rect">
-            <a:avLst/>
-          </a:prstGeom>
-        </p:spPr>
-        <p:txBody>
-          <a:bodyPr anchorCtr="0" anchor="t" bIns="91425" lIns="91425" spcFirstLastPara="1" rIns="91425" wrap="square" tIns="91425">
-            <a:noAutofit/>
-          </a:bodyPr>
-          <a:lstStyle/>
-          <a:p>
-            <a:pPr indent="0" lvl="0" marL="0" rtl="0" algn="l">
-              <a:spcBef>
-                <a:spcPts val="0"/>
-              </a:spcBef>
-              <a:spcAft>
-                <a:spcPts val="0"/>
-              </a:spcAft>
-              <a:buNone/>
-            </a:pPr>
-            <a:r>
-              <a:t/>
-            </a:r>
-            <a:endParaRPr/>
-          </a:p>
-        </p:txBody>
-      </p:sp>
-    </p:spTree>
-  </p:cSld>
-  <p:clrMapOvr>
-    <a:masterClrMapping/>
-  </p:clrMapOvr>
-</p:notes>
-</file>
-
-<file path=ppt/notesSlides/notesSlide16.xml><?xml version="1.0" encoding="utf-8"?>
-<p:notes xmlns:a="http://schemas.openxmlformats.org/drawingml/2006/main" xmlns:r="http://schemas.openxmlformats.org/officeDocument/2006/relationships" xmlns:mc="http://schemas.openxmlformats.org/markup-compatibility/2006" xmlns:mv="urn:schemas-microsoft-com:mac:vml" xmlns:p="http://schemas.openxmlformats.org/presentationml/2006/main" xmlns:c="http://schemas.openxmlformats.org/drawingml/2006/chart" xmlns:dgm="http://schemas.openxmlformats.org/drawingml/2006/diagram" xmlns:o="urn:schemas-microsoft-com:office:office" xmlns:v="urn:schemas-microsoft-com:vml" xmlns:pvml="urn:schemas-microsoft-com:office:powerpoint" xmlns:com="http://schemas.openxmlformats.org/drawingml/2006/compatibility" xmlns:p14="http://schemas.microsoft.com/office/powerpoint/2010/main" xmlns:p15="http://schemas.microsoft.com/office/powerpoint/2012/main" xmlns:ahyp="http://schemas.microsoft.com/office/drawing/2018/hyperlinkcolor" showMasterPhAnim="0" showMasterSp="0">
-  <p:cSld>
-    <p:spTree>
-      <p:nvGrpSpPr>
-        <p:cNvPr id="203" name="Shape 203"/>
-        <p:cNvGrpSpPr/>
-        <p:nvPr/>
-      </p:nvGrpSpPr>
-      <p:grpSpPr>
-        <a:xfrm>
-          <a:off x="0" y="0"/>
-          <a:ext cx="0" cy="0"/>
-          <a:chOff x="0" y="0"/>
-          <a:chExt cx="0" cy="0"/>
-        </a:xfrm>
-      </p:grpSpPr>
-      <p:sp>
-        <p:nvSpPr>
-          <p:cNvPr id="204" name="Google Shape;204;g3fb085bff3c_0_66:notes"/>
-          <p:cNvSpPr/>
-          <p:nvPr>
-            <p:ph idx="2" type="sldImg"/>
-          </p:nvPr>
-        </p:nvSpPr>
-        <p:spPr>
-          <a:xfrm>
-            <a:off x="381300" y="685800"/>
-            <a:ext cx="6096000" cy="3429000"/>
-          </a:xfrm>
-          <a:custGeom>
-            <a:rect b="b" l="l" r="r" t="t"/>
-            <a:pathLst>
-              <a:path extrusionOk="0" h="120000" w="120000">
-                <a:moveTo>
-                  <a:pt x="0" y="0"/>
-                </a:moveTo>
-                <a:lnTo>
-                  <a:pt x="120000" y="0"/>
-                </a:lnTo>
-                <a:lnTo>
-                  <a:pt x="120000" y="120000"/>
-                </a:lnTo>
-                <a:lnTo>
-                  <a:pt x="0" y="120000"/>
-                </a:lnTo>
-                <a:close/>
-              </a:path>
-            </a:pathLst>
-          </a:custGeom>
-        </p:spPr>
-      </p:sp>
-      <p:sp>
-        <p:nvSpPr>
-          <p:cNvPr id="205" name="Google Shape;205;g3fb085bff3c_0_66:notes"/>
+          <p:cNvPr id="198" name="Google Shape;198;g3fb085bff3c_0_66:notes"/>
           <p:cNvSpPr txBox="1"/>
           <p:nvPr>
             <p:ph idx="1" type="body"/>
@@ -1530,7 +1329,7 @@
       </p:grpSpPr>
       <p:sp>
         <p:nvSpPr>
-          <p:cNvPr id="58" name="Google Shape;58;g3fb085bff3c_0_134:notes"/>
+          <p:cNvPr id="58" name="Google Shape;58;g3fb085bff3c_0_4:notes"/>
           <p:cNvSpPr/>
           <p:nvPr>
             <p:ph idx="2" type="sldImg"/>
@@ -1565,7 +1364,7 @@
       </p:sp>
       <p:sp>
         <p:nvSpPr>
-          <p:cNvPr id="59" name="Google Shape;59;g3fb085bff3c_0_134:notes"/>
+          <p:cNvPr id="59" name="Google Shape;59;g3fb085bff3c_0_4:notes"/>
           <p:cNvSpPr txBox="1"/>
           <p:nvPr>
             <p:ph idx="1" type="body"/>
@@ -1629,7 +1428,7 @@
       </p:grpSpPr>
       <p:sp>
         <p:nvSpPr>
-          <p:cNvPr id="66" name="Google Shape;66;g3fb085bff3c_0_4:notes"/>
+          <p:cNvPr id="66" name="Google Shape;66;g3fb085bff3c_0_11:notes"/>
           <p:cNvSpPr/>
           <p:nvPr>
             <p:ph idx="2" type="sldImg"/>
@@ -1664,7 +1463,7 @@
       </p:sp>
       <p:sp>
         <p:nvSpPr>
-          <p:cNvPr id="67" name="Google Shape;67;g3fb085bff3c_0_4:notes"/>
+          <p:cNvPr id="67" name="Google Shape;67;g3fb085bff3c_0_11:notes"/>
           <p:cNvSpPr txBox="1"/>
           <p:nvPr>
             <p:ph idx="1" type="body"/>
@@ -1695,7 +1494,8 @@
               <a:buNone/>
             </a:pPr>
             <a:r>
-              <a:t/>
+              <a:rPr lang="en-GB"/>
+              <a:t>Source: UK Finance Fraud Report 2026, p. 41. For 2025 UK invoice and mandate fraud: £41.3m gross losses across 2,305 cases; 68% of lost value was on business and other non-personal accounts. Reported totals include value later recovered. https://www.ukfinance.org.uk/system/files/2026-06/UK%20Finance%20Fraud%20Report%202026.pdf</a:t>
             </a:r>
             <a:endParaRPr/>
           </a:p>
@@ -1714,7 +1514,7 @@
   <p:cSld>
     <p:spTree>
       <p:nvGrpSpPr>
-        <p:cNvPr id="73" name="Shape 73"/>
+        <p:cNvPr id="74" name="Shape 74"/>
         <p:cNvGrpSpPr/>
         <p:nvPr/>
       </p:nvGrpSpPr>
@@ -1728,7 +1528,7 @@
       </p:grpSpPr>
       <p:sp>
         <p:nvSpPr>
-          <p:cNvPr id="74" name="Google Shape;74;g3fb085bff3c_0_11:notes"/>
+          <p:cNvPr id="75" name="Google Shape;75;g3fb085bff3c_0_16:notes"/>
           <p:cNvSpPr/>
           <p:nvPr>
             <p:ph idx="2" type="sldImg"/>
@@ -1763,7 +1563,7 @@
       </p:sp>
       <p:sp>
         <p:nvSpPr>
-          <p:cNvPr id="75" name="Google Shape;75;g3fb085bff3c_0_11:notes"/>
+          <p:cNvPr id="76" name="Google Shape;76;g3fb085bff3c_0_16:notes"/>
           <p:cNvSpPr txBox="1"/>
           <p:nvPr>
             <p:ph idx="1" type="body"/>
@@ -1813,7 +1613,7 @@
   <p:cSld>
     <p:spTree>
       <p:nvGrpSpPr>
-        <p:cNvPr id="82" name="Shape 82"/>
+        <p:cNvPr id="83" name="Shape 83"/>
         <p:cNvGrpSpPr/>
         <p:nvPr/>
       </p:nvGrpSpPr>
@@ -1827,7 +1627,7 @@
       </p:grpSpPr>
       <p:sp>
         <p:nvSpPr>
-          <p:cNvPr id="83" name="Google Shape;83;g3fb085bff3c_0_16:notes"/>
+          <p:cNvPr id="84" name="Google Shape;84;g3fb085bff3c_0_21:notes"/>
           <p:cNvSpPr/>
           <p:nvPr>
             <p:ph idx="2" type="sldImg"/>
@@ -1862,7 +1662,7 @@
       </p:sp>
       <p:sp>
         <p:nvSpPr>
-          <p:cNvPr id="84" name="Google Shape;84;g3fb085bff3c_0_16:notes"/>
+          <p:cNvPr id="85" name="Google Shape;85;g3fb085bff3c_0_21:notes"/>
           <p:cNvSpPr txBox="1"/>
           <p:nvPr>
             <p:ph idx="1" type="body"/>
@@ -1912,7 +1712,7 @@
   <p:cSld>
     <p:spTree>
       <p:nvGrpSpPr>
-        <p:cNvPr id="91" name="Shape 91"/>
+        <p:cNvPr id="106" name="Shape 106"/>
         <p:cNvGrpSpPr/>
         <p:nvPr/>
       </p:nvGrpSpPr>
@@ -1926,7 +1726,7 @@
       </p:grpSpPr>
       <p:sp>
         <p:nvSpPr>
-          <p:cNvPr id="92" name="Google Shape;92;g3fb085bff3c_0_21:notes"/>
+          <p:cNvPr id="107" name="Google Shape;107;g3fb085bff3c_0_26:notes"/>
           <p:cNvSpPr/>
           <p:nvPr>
             <p:ph idx="2" type="sldImg"/>
@@ -1961,7 +1761,7 @@
       </p:sp>
       <p:sp>
         <p:nvSpPr>
-          <p:cNvPr id="93" name="Google Shape;93;g3fb085bff3c_0_21:notes"/>
+          <p:cNvPr id="108" name="Google Shape;108;g3fb085bff3c_0_26:notes"/>
           <p:cNvSpPr txBox="1"/>
           <p:nvPr>
             <p:ph idx="1" type="body"/>
@@ -2007,105 +1807,6 @@
 </file>
 
 <file path=ppt/notesSlides/notesSlide7.xml><?xml version="1.0" encoding="utf-8"?>
-<p:notes xmlns:a="http://schemas.openxmlformats.org/drawingml/2006/main" xmlns:r="http://schemas.openxmlformats.org/officeDocument/2006/relationships" xmlns:mc="http://schemas.openxmlformats.org/markup-compatibility/2006" xmlns:mv="urn:schemas-microsoft-com:mac:vml" xmlns:p="http://schemas.openxmlformats.org/presentationml/2006/main" xmlns:c="http://schemas.openxmlformats.org/drawingml/2006/chart" xmlns:dgm="http://schemas.openxmlformats.org/drawingml/2006/diagram" xmlns:o="urn:schemas-microsoft-com:office:office" xmlns:v="urn:schemas-microsoft-com:vml" xmlns:pvml="urn:schemas-microsoft-com:office:powerpoint" xmlns:com="http://schemas.openxmlformats.org/drawingml/2006/compatibility" xmlns:p14="http://schemas.microsoft.com/office/powerpoint/2010/main" xmlns:p15="http://schemas.microsoft.com/office/powerpoint/2012/main" xmlns:ahyp="http://schemas.microsoft.com/office/drawing/2018/hyperlinkcolor" showMasterPhAnim="0" showMasterSp="0">
-  <p:cSld>
-    <p:spTree>
-      <p:nvGrpSpPr>
-        <p:cNvPr id="114" name="Shape 114"/>
-        <p:cNvGrpSpPr/>
-        <p:nvPr/>
-      </p:nvGrpSpPr>
-      <p:grpSpPr>
-        <a:xfrm>
-          <a:off x="0" y="0"/>
-          <a:ext cx="0" cy="0"/>
-          <a:chOff x="0" y="0"/>
-          <a:chExt cx="0" cy="0"/>
-        </a:xfrm>
-      </p:grpSpPr>
-      <p:sp>
-        <p:nvSpPr>
-          <p:cNvPr id="115" name="Google Shape;115;g3fb085bff3c_0_26:notes"/>
-          <p:cNvSpPr/>
-          <p:nvPr>
-            <p:ph idx="2" type="sldImg"/>
-          </p:nvPr>
-        </p:nvSpPr>
-        <p:spPr>
-          <a:xfrm>
-            <a:off x="381300" y="685800"/>
-            <a:ext cx="6096000" cy="3429000"/>
-          </a:xfrm>
-          <a:custGeom>
-            <a:rect b="b" l="l" r="r" t="t"/>
-            <a:pathLst>
-              <a:path extrusionOk="0" h="120000" w="120000">
-                <a:moveTo>
-                  <a:pt x="0" y="0"/>
-                </a:moveTo>
-                <a:lnTo>
-                  <a:pt x="120000" y="0"/>
-                </a:lnTo>
-                <a:lnTo>
-                  <a:pt x="120000" y="120000"/>
-                </a:lnTo>
-                <a:lnTo>
-                  <a:pt x="0" y="120000"/>
-                </a:lnTo>
-                <a:close/>
-              </a:path>
-            </a:pathLst>
-          </a:custGeom>
-        </p:spPr>
-      </p:sp>
-      <p:sp>
-        <p:nvSpPr>
-          <p:cNvPr id="116" name="Google Shape;116;g3fb085bff3c_0_26:notes"/>
-          <p:cNvSpPr txBox="1"/>
-          <p:nvPr>
-            <p:ph idx="1" type="body"/>
-          </p:nvPr>
-        </p:nvSpPr>
-        <p:spPr>
-          <a:xfrm>
-            <a:off x="685800" y="4343400"/>
-            <a:ext cx="5486400" cy="4114800"/>
-          </a:xfrm>
-          <a:prstGeom prst="rect">
-            <a:avLst/>
-          </a:prstGeom>
-        </p:spPr>
-        <p:txBody>
-          <a:bodyPr anchorCtr="0" anchor="t" bIns="91425" lIns="91425" spcFirstLastPara="1" rIns="91425" wrap="square" tIns="91425">
-            <a:noAutofit/>
-          </a:bodyPr>
-          <a:lstStyle/>
-          <a:p>
-            <a:pPr indent="0" lvl="0" marL="0" rtl="0" algn="l">
-              <a:spcBef>
-                <a:spcPts val="0"/>
-              </a:spcBef>
-              <a:spcAft>
-                <a:spcPts val="0"/>
-              </a:spcAft>
-              <a:buNone/>
-            </a:pPr>
-            <a:r>
-              <a:t/>
-            </a:r>
-            <a:endParaRPr/>
-          </a:p>
-        </p:txBody>
-      </p:sp>
-    </p:spTree>
-  </p:cSld>
-  <p:clrMapOvr>
-    <a:masterClrMapping/>
-  </p:clrMapOvr>
-</p:notes>
-</file>
-
-<file path=ppt/notesSlides/notesSlide8.xml><?xml version="1.0" encoding="utf-8"?>
 <p:notes xmlns:a="http://schemas.openxmlformats.org/drawingml/2006/main" xmlns:r="http://schemas.openxmlformats.org/officeDocument/2006/relationships" xmlns:mc="http://schemas.openxmlformats.org/markup-compatibility/2006" xmlns:mv="urn:schemas-microsoft-com:mac:vml" xmlns:p="http://schemas.openxmlformats.org/presentationml/2006/main" xmlns:c="http://schemas.openxmlformats.org/drawingml/2006/chart" xmlns:dgm="http://schemas.openxmlformats.org/drawingml/2006/diagram" xmlns:o="urn:schemas-microsoft-com:office:office" xmlns:v="urn:schemas-microsoft-com:vml" xmlns:pvml="urn:schemas-microsoft-com:office:powerpoint" xmlns:com="http://schemas.openxmlformats.org/drawingml/2006/compatibility" xmlns:p14="http://schemas.microsoft.com/office/powerpoint/2010/main" xmlns:p15="http://schemas.microsoft.com/office/powerpoint/2012/main" xmlns:ahyp="http://schemas.microsoft.com/office/drawing/2018/hyperlinkcolor" showMasterPhAnim="0" showMasterSp="0">
   <p:cSld>
     <p:spTree>
@@ -2204,7 +1905,7 @@
 </p:notes>
 </file>
 
-<file path=ppt/notesSlides/notesSlide9.xml><?xml version="1.0" encoding="utf-8"?>
+<file path=ppt/notesSlides/notesSlide8.xml><?xml version="1.0" encoding="utf-8"?>
 <p:notes xmlns:a="http://schemas.openxmlformats.org/drawingml/2006/main" xmlns:r="http://schemas.openxmlformats.org/officeDocument/2006/relationships" xmlns:mc="http://schemas.openxmlformats.org/markup-compatibility/2006" xmlns:mv="urn:schemas-microsoft-com:mac:vml" xmlns:p="http://schemas.openxmlformats.org/presentationml/2006/main" xmlns:c="http://schemas.openxmlformats.org/drawingml/2006/chart" xmlns:dgm="http://schemas.openxmlformats.org/drawingml/2006/diagram" xmlns:o="urn:schemas-microsoft-com:office:office" xmlns:v="urn:schemas-microsoft-com:vml" xmlns:pvml="urn:schemas-microsoft-com:office:powerpoint" xmlns:com="http://schemas.openxmlformats.org/drawingml/2006/compatibility" xmlns:p14="http://schemas.microsoft.com/office/powerpoint/2010/main" xmlns:p15="http://schemas.microsoft.com/office/powerpoint/2012/main" xmlns:ahyp="http://schemas.microsoft.com/office/drawing/2018/hyperlinkcolor" showMasterPhAnim="0" showMasterSp="0">
   <p:cSld>
     <p:spTree>
@@ -2289,7 +1990,108 @@
               <a:buNone/>
             </a:pPr>
             <a:r>
-              <a:t/>
+              <a:rPr lang="en-GB"/>
+              <a:t>TypeSafe describes Jev as a structured probabilistic decision model intended to emit actionable structured decisions. ScamShield’s adapter passes fixture tests but is disabled on live GCP. Jev has no measured latency or quality result in this project. https://typesafe.ai/blog/introducing-system-one-models-and-jev</a:t>
+            </a:r>
+            <a:endParaRPr/>
+          </a:p>
+        </p:txBody>
+      </p:sp>
+    </p:spTree>
+  </p:cSld>
+  <p:clrMapOvr>
+    <a:masterClrMapping/>
+  </p:clrMapOvr>
+</p:notes>
+</file>
+
+<file path=ppt/notesSlides/notesSlide9.xml><?xml version="1.0" encoding="utf-8"?>
+<p:notes xmlns:a="http://schemas.openxmlformats.org/drawingml/2006/main" xmlns:r="http://schemas.openxmlformats.org/officeDocument/2006/relationships" xmlns:mc="http://schemas.openxmlformats.org/markup-compatibility/2006" xmlns:mv="urn:schemas-microsoft-com:mac:vml" xmlns:p="http://schemas.openxmlformats.org/presentationml/2006/main" xmlns:c="http://schemas.openxmlformats.org/drawingml/2006/chart" xmlns:dgm="http://schemas.openxmlformats.org/drawingml/2006/diagram" xmlns:o="urn:schemas-microsoft-com:office:office" xmlns:v="urn:schemas-microsoft-com:vml" xmlns:pvml="urn:schemas-microsoft-com:office:powerpoint" xmlns:com="http://schemas.openxmlformats.org/drawingml/2006/compatibility" xmlns:p14="http://schemas.microsoft.com/office/powerpoint/2010/main" xmlns:p15="http://schemas.microsoft.com/office/powerpoint/2012/main" xmlns:ahyp="http://schemas.microsoft.com/office/drawing/2018/hyperlinkcolor" showMasterPhAnim="0" showMasterSp="0">
+  <p:cSld>
+    <p:spTree>
+      <p:nvGrpSpPr>
+        <p:cNvPr id="150" name="Shape 150"/>
+        <p:cNvGrpSpPr/>
+        <p:nvPr/>
+      </p:nvGrpSpPr>
+      <p:grpSpPr>
+        <a:xfrm>
+          <a:off x="0" y="0"/>
+          <a:ext cx="0" cy="0"/>
+          <a:chOff x="0" y="0"/>
+          <a:chExt cx="0" cy="0"/>
+        </a:xfrm>
+      </p:grpSpPr>
+      <p:sp>
+        <p:nvSpPr>
+          <p:cNvPr id="151" name="Google Shape;151;g3fb085bff3c_0_41:notes"/>
+          <p:cNvSpPr/>
+          <p:nvPr>
+            <p:ph idx="2" type="sldImg"/>
+          </p:nvPr>
+        </p:nvSpPr>
+        <p:spPr>
+          <a:xfrm>
+            <a:off x="381300" y="685800"/>
+            <a:ext cx="6096000" cy="3429000"/>
+          </a:xfrm>
+          <a:custGeom>
+            <a:rect b="b" l="l" r="r" t="t"/>
+            <a:pathLst>
+              <a:path extrusionOk="0" h="120000" w="120000">
+                <a:moveTo>
+                  <a:pt x="0" y="0"/>
+                </a:moveTo>
+                <a:lnTo>
+                  <a:pt x="120000" y="0"/>
+                </a:lnTo>
+                <a:lnTo>
+                  <a:pt x="120000" y="120000"/>
+                </a:lnTo>
+                <a:lnTo>
+                  <a:pt x="0" y="120000"/>
+                </a:lnTo>
+                <a:close/>
+              </a:path>
+            </a:pathLst>
+          </a:custGeom>
+        </p:spPr>
+      </p:sp>
+      <p:sp>
+        <p:nvSpPr>
+          <p:cNvPr id="152" name="Google Shape;152;g3fb085bff3c_0_41:notes"/>
+          <p:cNvSpPr txBox="1"/>
+          <p:nvPr>
+            <p:ph idx="1" type="body"/>
+          </p:nvPr>
+        </p:nvSpPr>
+        <p:spPr>
+          <a:xfrm>
+            <a:off x="685800" y="4343400"/>
+            <a:ext cx="5486400" cy="4114800"/>
+          </a:xfrm>
+          <a:prstGeom prst="rect">
+            <a:avLst/>
+          </a:prstGeom>
+        </p:spPr>
+        <p:txBody>
+          <a:bodyPr anchorCtr="0" anchor="t" bIns="91425" lIns="91425" spcFirstLastPara="1" rIns="91425" wrap="square" tIns="91425">
+            <a:noAutofit/>
+          </a:bodyPr>
+          <a:lstStyle/>
+          <a:p>
+            <a:pPr indent="0" lvl="0" marL="0" rtl="0" algn="l">
+              <a:spcBef>
+                <a:spcPts val="0"/>
+              </a:spcBef>
+              <a:spcAft>
+                <a:spcPts val="0"/>
+              </a:spcAft>
+              <a:buNone/>
+            </a:pPr>
+            <a:r>
+              <a:rPr lang="en-GB"/>
+              <a:t>ScamShield uses Vertex AI Gemini 2.5 Flash-Lite, Firebase Authentication, Firestore and Cloud Run. The ₹100 budget alert through 6 Nov 2026 is not a spending cap. 59 backend tests passed. Live synthetic invoice checks covered extraction, classification, requested explanation, Firestore reads, idempotency, restart durability and visitor isolation. Use synthetic data only.</a:t>
             </a:r>
             <a:endParaRPr/>
           </a:p>
@@ -7213,495 +7015,6 @@
   <p:cSld>
     <p:spTree>
       <p:nvGrpSpPr>
-        <p:cNvPr id="153" name="Shape 153"/>
-        <p:cNvGrpSpPr/>
-        <p:nvPr/>
-      </p:nvGrpSpPr>
-      <p:grpSpPr>
-        <a:xfrm>
-          <a:off x="0" y="0"/>
-          <a:ext cx="0" cy="0"/>
-          <a:chOff x="0" y="0"/>
-          <a:chExt cx="0" cy="0"/>
-        </a:xfrm>
-      </p:grpSpPr>
-      <p:pic>
-        <p:nvPicPr>
-          <p:cNvPr id="154" name="Google Shape;154;p22" title="Frame 144.png"/>
-          <p:cNvPicPr preferRelativeResize="0"/>
-          <p:nvPr/>
-        </p:nvPicPr>
-        <p:blipFill rotWithShape="1">
-          <a:blip r:embed="rId3">
-            <a:alphaModFix/>
-          </a:blip>
-          <a:srcRect b="98001" l="0" r="0" t="0"/>
-          <a:stretch/>
-        </p:blipFill>
-        <p:spPr>
-          <a:xfrm>
-            <a:off x="0" y="5093562"/>
-            <a:ext cx="9144000" cy="54275"/>
-          </a:xfrm>
-          <a:prstGeom prst="rect">
-            <a:avLst/>
-          </a:prstGeom>
-          <a:noFill/>
-          <a:ln>
-            <a:noFill/>
-          </a:ln>
-        </p:spPr>
-      </p:pic>
-      <p:pic>
-        <p:nvPicPr>
-          <p:cNvPr id="155" name="Google Shape;155;p22" title="Group 427319979.png"/>
-          <p:cNvPicPr preferRelativeResize="0"/>
-          <p:nvPr/>
-        </p:nvPicPr>
-        <p:blipFill>
-          <a:blip r:embed="rId4">
-            <a:alphaModFix/>
-          </a:blip>
-          <a:stretch>
-            <a:fillRect/>
-          </a:stretch>
-        </p:blipFill>
-        <p:spPr>
-          <a:xfrm>
-            <a:off x="0" y="1"/>
-            <a:ext cx="9144000" cy="507359"/>
-          </a:xfrm>
-          <a:prstGeom prst="rect">
-            <a:avLst/>
-          </a:prstGeom>
-          <a:noFill/>
-          <a:ln>
-            <a:noFill/>
-          </a:ln>
-        </p:spPr>
-      </p:pic>
-      <p:sp>
-        <p:nvSpPr>
-          <p:cNvPr id="156" name="Google Shape;156;p22"/>
-          <p:cNvSpPr/>
-          <p:nvPr/>
-        </p:nvSpPr>
-        <p:spPr>
-          <a:xfrm>
-            <a:off x="-29250" y="5071875"/>
-            <a:ext cx="9173400" cy="97800"/>
-          </a:xfrm>
-          <a:prstGeom prst="rect">
-            <a:avLst/>
-          </a:prstGeom>
-          <a:solidFill>
-            <a:schemeClr val="dk1"/>
-          </a:solidFill>
-          <a:ln>
-            <a:noFill/>
-          </a:ln>
-        </p:spPr>
-        <p:txBody>
-          <a:bodyPr anchorCtr="0" anchor="ctr" bIns="91425" lIns="91425" spcFirstLastPara="1" rIns="91425" wrap="square" tIns="91425">
-            <a:noAutofit/>
-          </a:bodyPr>
-          <a:lstStyle/>
-          <a:p>
-            <a:pPr indent="0" lvl="0" marL="0" rtl="0" algn="ctr">
-              <a:spcBef>
-                <a:spcPts val="0"/>
-              </a:spcBef>
-              <a:spcAft>
-                <a:spcPts val="0"/>
-              </a:spcAft>
-              <a:buNone/>
-            </a:pPr>
-            <a:r>
-              <a:t/>
-            </a:r>
-            <a:endParaRPr/>
-          </a:p>
-        </p:txBody>
-      </p:sp>
-      <p:sp>
-        <p:nvSpPr>
-          <p:cNvPr id="157" name="Google Shape;157;p22"/>
-          <p:cNvSpPr txBox="1"/>
-          <p:nvPr/>
-        </p:nvSpPr>
-        <p:spPr>
-          <a:xfrm>
-            <a:off x="265350" y="663825"/>
-            <a:ext cx="8943000" cy="561900"/>
-          </a:xfrm>
-          <a:prstGeom prst="rect">
-            <a:avLst/>
-          </a:prstGeom>
-          <a:noFill/>
-          <a:ln>
-            <a:noFill/>
-          </a:ln>
-        </p:spPr>
-        <p:txBody>
-          <a:bodyPr anchorCtr="0" anchor="t" bIns="91425" lIns="91425" spcFirstLastPara="1" rIns="91425" wrap="square" tIns="91425">
-            <a:noAutofit/>
-          </a:bodyPr>
-          <a:lstStyle/>
-          <a:p>
-            <a:pPr indent="0" lvl="0" marL="0" rtl="0" algn="l">
-              <a:spcBef>
-                <a:spcPts val="0"/>
-              </a:spcBef>
-              <a:spcAft>
-                <a:spcPts val="0"/>
-              </a:spcAft>
-              <a:buNone/>
-            </a:pPr>
-            <a:r>
-              <a:rPr lang="en-GB" sz="1600">
-                <a:latin typeface="Google Sans Flex Medium"/>
-                <a:ea typeface="Google Sans Flex Medium"/>
-                <a:cs typeface="Google Sans Flex Medium"/>
-                <a:sym typeface="Google Sans Flex Medium"/>
-              </a:rPr>
-              <a:t>Implementation cost (optional)</a:t>
-            </a:r>
-            <a:endParaRPr sz="1600">
-              <a:latin typeface="Google Sans Flex Medium"/>
-              <a:ea typeface="Google Sans Flex Medium"/>
-              <a:cs typeface="Google Sans Flex Medium"/>
-              <a:sym typeface="Google Sans Flex Medium"/>
-            </a:endParaRPr>
-          </a:p>
-        </p:txBody>
-      </p:sp>
-      <p:sp>
-        <p:nvSpPr>
-          <p:cNvPr id="158" name="Google Shape;158;p22"/>
-          <p:cNvSpPr txBox="1"/>
-          <p:nvPr/>
-        </p:nvSpPr>
-        <p:spPr>
-          <a:xfrm>
-            <a:off x="381000" y="1320800"/>
-            <a:ext cx="8382000" cy="3365400"/>
-          </a:xfrm>
-          <a:prstGeom prst="rect">
-            <a:avLst/>
-          </a:prstGeom>
-          <a:noFill/>
-          <a:ln>
-            <a:noFill/>
-          </a:ln>
-        </p:spPr>
-        <p:txBody>
-          <a:bodyPr anchorCtr="0" anchor="t" bIns="91425" lIns="91425" spcFirstLastPara="1" rIns="91425" wrap="square" tIns="91425">
-            <a:noAutofit/>
-          </a:bodyPr>
-          <a:lstStyle/>
-          <a:p>
-            <a:pPr indent="0" lvl="0" marL="0" rtl="0" algn="l">
-              <a:lnSpc>
-                <a:spcPct val="112000"/>
-              </a:lnSpc>
-              <a:spcBef>
-                <a:spcPts val="0"/>
-              </a:spcBef>
-              <a:spcAft>
-                <a:spcPts val="0"/>
-              </a:spcAft>
-              <a:buNone/>
-            </a:pPr>
-            <a:r>
-              <a:rPr lang="en-GB" sz="1300">
-                <a:solidFill>
-                  <a:srgbClr val="1F2926"/>
-                </a:solidFill>
-                <a:latin typeface="Google Sans Flex"/>
-                <a:ea typeface="Google Sans Flex"/>
-                <a:cs typeface="Google Sans Flex"/>
-                <a:sym typeface="Google Sans Flex"/>
-              </a:rPr>
-              <a:t>CLOUD COST STATUS</a:t>
-            </a:r>
-            <a:endParaRPr sz="1300">
-              <a:solidFill>
-                <a:srgbClr val="1F2926"/>
-              </a:solidFill>
-              <a:latin typeface="Google Sans Flex"/>
-              <a:ea typeface="Google Sans Flex"/>
-              <a:cs typeface="Google Sans Flex"/>
-              <a:sym typeface="Google Sans Flex"/>
-            </a:endParaRPr>
-          </a:p>
-          <a:p>
-            <a:pPr indent="0" lvl="0" marL="0" rtl="0" algn="l">
-              <a:lnSpc>
-                <a:spcPct val="112000"/>
-              </a:lnSpc>
-              <a:spcBef>
-                <a:spcPts val="600"/>
-              </a:spcBef>
-              <a:spcAft>
-                <a:spcPts val="0"/>
-              </a:spcAft>
-              <a:buNone/>
-            </a:pPr>
-            <a:r>
-              <a:rPr lang="en-GB" sz="1300">
-                <a:solidFill>
-                  <a:srgbClr val="1F2926"/>
-                </a:solidFill>
-                <a:latin typeface="Google Sans Flex"/>
-                <a:ea typeface="Google Sans Flex"/>
-                <a:cs typeface="Google Sans Flex"/>
-                <a:sym typeface="Google Sans Flex"/>
-              </a:rPr>
-              <a:t>Project billing is enabled. No credit coverage is confirmed. Cloud Run, Firestore and Vertex AI calls may incur charges.</a:t>
-            </a:r>
-            <a:endParaRPr sz="1300">
-              <a:solidFill>
-                <a:srgbClr val="1F2926"/>
-              </a:solidFill>
-              <a:latin typeface="Google Sans Flex"/>
-              <a:ea typeface="Google Sans Flex"/>
-              <a:cs typeface="Google Sans Flex"/>
-              <a:sym typeface="Google Sans Flex"/>
-            </a:endParaRPr>
-          </a:p>
-          <a:p>
-            <a:pPr indent="0" lvl="0" marL="0" rtl="0" algn="l">
-              <a:lnSpc>
-                <a:spcPct val="112000"/>
-              </a:lnSpc>
-              <a:spcBef>
-                <a:spcPts val="600"/>
-              </a:spcBef>
-              <a:spcAft>
-                <a:spcPts val="0"/>
-              </a:spcAft>
-              <a:buNone/>
-            </a:pPr>
-            <a:r>
-              <a:t/>
-            </a:r>
-            <a:endParaRPr sz="1300">
-              <a:solidFill>
-                <a:srgbClr val="1F2926"/>
-              </a:solidFill>
-              <a:latin typeface="Google Sans Flex"/>
-              <a:ea typeface="Google Sans Flex"/>
-              <a:cs typeface="Google Sans Flex"/>
-              <a:sym typeface="Google Sans Flex"/>
-            </a:endParaRPr>
-          </a:p>
-          <a:p>
-            <a:pPr indent="0" lvl="0" marL="0" rtl="0" algn="l">
-              <a:lnSpc>
-                <a:spcPct val="112000"/>
-              </a:lnSpc>
-              <a:spcBef>
-                <a:spcPts val="600"/>
-              </a:spcBef>
-              <a:spcAft>
-                <a:spcPts val="0"/>
-              </a:spcAft>
-              <a:buNone/>
-            </a:pPr>
-            <a:r>
-              <a:rPr lang="en-GB" sz="1300">
-                <a:solidFill>
-                  <a:srgbClr val="1F2926"/>
-                </a:solidFill>
-                <a:latin typeface="Google Sans Flex"/>
-                <a:ea typeface="Google Sans Flex"/>
-                <a:cs typeface="Google Sans Flex"/>
-                <a:sym typeface="Google Sans Flex"/>
-              </a:rPr>
-              <a:t>A ₹100 project budget alert is configured through 6 November 2026. Budget alerts notify; they do not stop spending.</a:t>
-            </a:r>
-            <a:endParaRPr sz="1300">
-              <a:solidFill>
-                <a:srgbClr val="1F2926"/>
-              </a:solidFill>
-              <a:latin typeface="Google Sans Flex"/>
-              <a:ea typeface="Google Sans Flex"/>
-              <a:cs typeface="Google Sans Flex"/>
-              <a:sym typeface="Google Sans Flex"/>
-            </a:endParaRPr>
-          </a:p>
-          <a:p>
-            <a:pPr indent="0" lvl="0" marL="0" rtl="0" algn="l">
-              <a:lnSpc>
-                <a:spcPct val="112000"/>
-              </a:lnSpc>
-              <a:spcBef>
-                <a:spcPts val="600"/>
-              </a:spcBef>
-              <a:spcAft>
-                <a:spcPts val="0"/>
-              </a:spcAft>
-              <a:buNone/>
-            </a:pPr>
-            <a:r>
-              <a:t/>
-            </a:r>
-            <a:endParaRPr sz="1300">
-              <a:solidFill>
-                <a:srgbClr val="1F2926"/>
-              </a:solidFill>
-              <a:latin typeface="Google Sans Flex"/>
-              <a:ea typeface="Google Sans Flex"/>
-              <a:cs typeface="Google Sans Flex"/>
-              <a:sym typeface="Google Sans Flex"/>
-            </a:endParaRPr>
-          </a:p>
-          <a:p>
-            <a:pPr indent="0" lvl="0" marL="0" rtl="0" algn="l">
-              <a:lnSpc>
-                <a:spcPct val="112000"/>
-              </a:lnSpc>
-              <a:spcBef>
-                <a:spcPts val="600"/>
-              </a:spcBef>
-              <a:spcAft>
-                <a:spcPts val="0"/>
-              </a:spcAft>
-              <a:buNone/>
-            </a:pPr>
-            <a:r>
-              <a:rPr lang="en-GB" sz="1300">
-                <a:solidFill>
-                  <a:srgbClr val="1F2926"/>
-                </a:solidFill>
-                <a:latin typeface="Google Sans Flex"/>
-                <a:ea typeface="Google Sans Flex"/>
-                <a:cs typeface="Google Sans Flex"/>
-                <a:sym typeface="Google Sans Flex"/>
-              </a:rPr>
-              <a:t>APPLICATION REQUEST LIMITS</a:t>
-            </a:r>
-            <a:endParaRPr sz="1300">
-              <a:solidFill>
-                <a:srgbClr val="1F2926"/>
-              </a:solidFill>
-              <a:latin typeface="Google Sans Flex"/>
-              <a:ea typeface="Google Sans Flex"/>
-              <a:cs typeface="Google Sans Flex"/>
-              <a:sym typeface="Google Sans Flex"/>
-            </a:endParaRPr>
-          </a:p>
-          <a:p>
-            <a:pPr indent="0" lvl="0" marL="0" rtl="0" algn="l">
-              <a:lnSpc>
-                <a:spcPct val="112000"/>
-              </a:lnSpc>
-              <a:spcBef>
-                <a:spcPts val="600"/>
-              </a:spcBef>
-              <a:spcAft>
-                <a:spcPts val="0"/>
-              </a:spcAft>
-              <a:buNone/>
-            </a:pPr>
-            <a:r>
-              <a:rPr lang="en-GB" sz="1300">
-                <a:solidFill>
-                  <a:srgbClr val="1F2926"/>
-                </a:solidFill>
-                <a:latin typeface="Google Sans Flex"/>
-                <a:ea typeface="Google Sans Flex"/>
-                <a:cs typeface="Google Sans Flex"/>
-                <a:sym typeface="Google Sans Flex"/>
-              </a:rPr>
-              <a:t>9 model attempts per visitor per day · 50 globally per day · 200 total. These limits restrict model calls and are not a billing cap.</a:t>
-            </a:r>
-            <a:endParaRPr sz="1300">
-              <a:solidFill>
-                <a:srgbClr val="1F2926"/>
-              </a:solidFill>
-              <a:latin typeface="Google Sans Flex"/>
-              <a:ea typeface="Google Sans Flex"/>
-              <a:cs typeface="Google Sans Flex"/>
-              <a:sym typeface="Google Sans Flex"/>
-            </a:endParaRPr>
-          </a:p>
-          <a:p>
-            <a:pPr indent="0" lvl="0" marL="0" rtl="0" algn="l">
-              <a:lnSpc>
-                <a:spcPct val="112000"/>
-              </a:lnSpc>
-              <a:spcBef>
-                <a:spcPts val="600"/>
-              </a:spcBef>
-              <a:spcAft>
-                <a:spcPts val="0"/>
-              </a:spcAft>
-              <a:buNone/>
-            </a:pPr>
-            <a:r>
-              <a:t/>
-            </a:r>
-            <a:endParaRPr sz="1300">
-              <a:solidFill>
-                <a:srgbClr val="1F2926"/>
-              </a:solidFill>
-              <a:latin typeface="Google Sans Flex"/>
-              <a:ea typeface="Google Sans Flex"/>
-              <a:cs typeface="Google Sans Flex"/>
-              <a:sym typeface="Google Sans Flex"/>
-            </a:endParaRPr>
-          </a:p>
-          <a:p>
-            <a:pPr indent="0" lvl="0" marL="0" rtl="0" algn="l">
-              <a:lnSpc>
-                <a:spcPct val="112000"/>
-              </a:lnSpc>
-              <a:spcBef>
-                <a:spcPts val="600"/>
-              </a:spcBef>
-              <a:spcAft>
-                <a:spcPts val="600"/>
-              </a:spcAft>
-              <a:buNone/>
-            </a:pPr>
-            <a:r>
-              <a:rPr lang="en-GB" sz="1300">
-                <a:solidFill>
-                  <a:srgbClr val="1F2926"/>
-                </a:solidFill>
-                <a:latin typeface="Google Sans Flex"/>
-                <a:ea typeface="Google Sans Flex"/>
-                <a:cs typeface="Google Sans Flex"/>
-                <a:sym typeface="Google Sans Flex"/>
-              </a:rPr>
-              <a:t>Use synthetic invoice data only.</a:t>
-            </a:r>
-            <a:endParaRPr sz="1300">
-              <a:solidFill>
-                <a:srgbClr val="1F2926"/>
-              </a:solidFill>
-              <a:latin typeface="Google Sans Flex"/>
-              <a:ea typeface="Google Sans Flex"/>
-              <a:cs typeface="Google Sans Flex"/>
-              <a:sym typeface="Google Sans Flex"/>
-            </a:endParaRPr>
-          </a:p>
-        </p:txBody>
-      </p:sp>
-    </p:spTree>
-  </p:cSld>
-  <p:clrMapOvr>
-    <a:masterClrMapping/>
-  </p:clrMapOvr>
-</p:sld>
-</file>
-
-<file path=ppt/slides/slide11.xml><?xml version="1.0" encoding="utf-8"?>
-<p:sld xmlns:a="http://schemas.openxmlformats.org/drawingml/2006/main" xmlns:r="http://schemas.openxmlformats.org/officeDocument/2006/relationships" xmlns:mc="http://schemas.openxmlformats.org/markup-compatibility/2006" xmlns:mv="urn:schemas-microsoft-com:mac:vml" xmlns:p="http://schemas.openxmlformats.org/presentationml/2006/main" xmlns:c="http://schemas.openxmlformats.org/drawingml/2006/chart" xmlns:dgm="http://schemas.openxmlformats.org/drawingml/2006/diagram" xmlns:o="urn:schemas-microsoft-com:office:office" xmlns:v="urn:schemas-microsoft-com:vml" xmlns:pvml="urn:schemas-microsoft-com:office:powerpoint" xmlns:com="http://schemas.openxmlformats.org/drawingml/2006/compatibility" xmlns:p14="http://schemas.microsoft.com/office/powerpoint/2010/main" xmlns:p15="http://schemas.microsoft.com/office/powerpoint/2012/main" xmlns:ahyp="http://schemas.microsoft.com/office/drawing/2018/hyperlinkcolor">
-  <p:cSld>
-    <p:spTree>
-      <p:nvGrpSpPr>
         <p:cNvPr id="162" name="Shape 162"/>
         <p:cNvGrpSpPr/>
         <p:nvPr/>
@@ -7716,7 +7029,7 @@
       </p:grpSpPr>
       <p:pic>
         <p:nvPicPr>
-          <p:cNvPr id="163" name="Google Shape;163;p23" title="Frame 144.png"/>
+          <p:cNvPr id="163" name="Google Shape;163;p22" title="Frame 144.png"/>
           <p:cNvPicPr preferRelativeResize="0"/>
           <p:nvPr/>
         </p:nvPicPr>
@@ -7743,7 +7056,7 @@
       </p:pic>
       <p:pic>
         <p:nvPicPr>
-          <p:cNvPr id="164" name="Google Shape;164;p23" title="Group 427319979.png"/>
+          <p:cNvPr id="164" name="Google Shape;164;p22" title="Group 427319979.png"/>
           <p:cNvPicPr preferRelativeResize="0"/>
           <p:nvPr/>
         </p:nvPicPr>
@@ -7771,7 +7084,7 @@
       </p:pic>
       <p:sp>
         <p:nvSpPr>
-          <p:cNvPr id="165" name="Google Shape;165;p23"/>
+          <p:cNvPr id="165" name="Google Shape;165;p22"/>
           <p:cNvSpPr/>
           <p:nvPr/>
         </p:nvSpPr>
@@ -7814,7 +7127,7 @@
       </p:sp>
       <p:sp>
         <p:nvSpPr>
-          <p:cNvPr id="166" name="Google Shape;166;p23"/>
+          <p:cNvPr id="166" name="Google Shape;166;p22"/>
           <p:cNvSpPr txBox="1"/>
           <p:nvPr/>
         </p:nvSpPr>
@@ -7866,7 +7179,7 @@
       </p:sp>
       <p:pic>
         <p:nvPicPr>
-          <p:cNvPr id="167" name="Google Shape;167;p23"/>
+          <p:cNvPr id="167" name="Google Shape;167;p22"/>
           <p:cNvPicPr preferRelativeResize="0"/>
           <p:nvPr/>
         </p:nvPicPr>
@@ -7894,7 +7207,7 @@
       </p:pic>
       <p:sp>
         <p:nvSpPr>
-          <p:cNvPr id="168" name="Google Shape;168;p23"/>
+          <p:cNvPr id="168" name="Google Shape;168;p22"/>
           <p:cNvSpPr txBox="1"/>
           <p:nvPr/>
         </p:nvSpPr>
@@ -7974,7 +7287,7 @@
                 <a:cs typeface="Google Sans Flex"/>
                 <a:sym typeface="Google Sans Flex"/>
               </a:rPr>
-              <a:t>The public app used Vertex Gemini to extract fields and classify request context. The person confirmed the vendor destination before assessment. Requested explanations use Gemini-ranked saved evidence and deterministic templates.</a:t>
+              <a:t>The public app used Vertex Gemini to extract fields and classify request context. The person confirmed the vendor destination before assessment. The deterministic policy then assessed recorded evidence.</a:t>
             </a:r>
             <a:endParaRPr>
               <a:solidFill>
@@ -8035,7 +7348,7 @@
                 <a:cs typeface="Google Sans Flex"/>
                 <a:sym typeface="Google Sans Flex"/>
               </a:rPr>
-              <a:t>One invoice matched the saved account and returned Continue. The changed destination and bypass request returned Review. Firestore retained both cases across a deployment revision. No payment moved.</a:t>
+              <a:t>One invoice matched the saved account and returned Continue. The changed destination case returned Review. A requested explanation used Gemini-ranked saved evidence with deterministic templates. Firestore retained both cases across a deployment revision. No payment moved.</a:t>
             </a:r>
             <a:endParaRPr>
               <a:solidFill>
@@ -8057,7 +7370,7 @@
 </p:sld>
 </file>
 
-<file path=ppt/slides/slide12.xml><?xml version="1.0" encoding="utf-8"?>
+<file path=ppt/slides/slide11.xml><?xml version="1.0" encoding="utf-8"?>
 <p:sld xmlns:a="http://schemas.openxmlformats.org/drawingml/2006/main" xmlns:r="http://schemas.openxmlformats.org/officeDocument/2006/relationships" xmlns:mc="http://schemas.openxmlformats.org/markup-compatibility/2006" xmlns:mv="urn:schemas-microsoft-com:mac:vml" xmlns:p="http://schemas.openxmlformats.org/presentationml/2006/main" xmlns:c="http://schemas.openxmlformats.org/drawingml/2006/chart" xmlns:dgm="http://schemas.openxmlformats.org/drawingml/2006/diagram" xmlns:o="urn:schemas-microsoft-com:office:office" xmlns:v="urn:schemas-microsoft-com:vml" xmlns:pvml="urn:schemas-microsoft-com:office:powerpoint" xmlns:com="http://schemas.openxmlformats.org/drawingml/2006/compatibility" xmlns:p14="http://schemas.microsoft.com/office/powerpoint/2010/main" xmlns:p15="http://schemas.microsoft.com/office/powerpoint/2012/main" xmlns:ahyp="http://schemas.microsoft.com/office/drawing/2018/hyperlinkcolor">
   <p:cSld>
     <p:spTree>
@@ -8076,7 +7389,7 @@
       </p:grpSpPr>
       <p:pic>
         <p:nvPicPr>
-          <p:cNvPr id="173" name="Google Shape;173;p24" title="Frame 144.png"/>
+          <p:cNvPr id="173" name="Google Shape;173;p23" title="Frame 144.png"/>
           <p:cNvPicPr preferRelativeResize="0"/>
           <p:nvPr/>
         </p:nvPicPr>
@@ -8103,7 +7416,7 @@
       </p:pic>
       <p:pic>
         <p:nvPicPr>
-          <p:cNvPr id="174" name="Google Shape;174;p24" title="Group 427319979.png"/>
+          <p:cNvPr id="174" name="Google Shape;174;p23" title="Group 427319979.png"/>
           <p:cNvPicPr preferRelativeResize="0"/>
           <p:nvPr/>
         </p:nvPicPr>
@@ -8131,7 +7444,7 @@
       </p:pic>
       <p:sp>
         <p:nvSpPr>
-          <p:cNvPr id="175" name="Google Shape;175;p24"/>
+          <p:cNvPr id="175" name="Google Shape;175;p23"/>
           <p:cNvSpPr/>
           <p:nvPr/>
         </p:nvSpPr>
@@ -8174,7 +7487,7 @@
       </p:sp>
       <p:sp>
         <p:nvSpPr>
-          <p:cNvPr id="176" name="Google Shape;176;p24"/>
+          <p:cNvPr id="176" name="Google Shape;176;p23"/>
           <p:cNvSpPr txBox="1"/>
           <p:nvPr/>
         </p:nvSpPr>
@@ -8213,7 +7526,7 @@
                 <a:cs typeface="Google Sans Flex Medium"/>
                 <a:sym typeface="Google Sans Flex Medium"/>
               </a:rPr>
-              <a:t>Prototype Performance report/Benchmarking</a:t>
+              <a:t>Prototype verification</a:t>
             </a:r>
             <a:endParaRPr sz="1600">
               <a:latin typeface="Google Sans Flex Medium"/>
@@ -8226,7 +7539,7 @@
       </p:sp>
       <p:sp>
         <p:nvSpPr>
-          <p:cNvPr id="177" name="Google Shape;177;p24"/>
+          <p:cNvPr id="177" name="Google Shape;177;p23"/>
           <p:cNvSpPr txBox="1"/>
           <p:nvPr/>
         </p:nvSpPr>
@@ -8402,7 +7715,7 @@
                 <a:cs typeface="Google Sans Flex"/>
                 <a:sym typeface="Google Sans Flex"/>
               </a:rPr>
-              <a:t>Two synthetic invoice flows completed with live Vertex Gemini extraction and classification. A requested explanation used Gemini-ranked evidence with deterministic templates. Firestore readback, retry idempotency, restart durability and visitor isolation were verified.</a:t>
+              <a:t>Two synthetic invoice paths completed with live Vertex Gemini extraction and classification. A requested explanation used Gemini-ranked evidence with deterministic templates. Firestore readback, retry idempotency, restart durability and visitor isolation were verified.</a:t>
             </a:r>
             <a:endParaRPr sz="1300">
               <a:solidFill>
@@ -8463,7 +7776,7 @@
                 <a:cs typeface="Google Sans Flex"/>
                 <a:sym typeface="Google Sans Flex"/>
               </a:rPr>
-              <a:t>LIMITS</a:t>
+              <a:t>EVIDENCE LIMIT</a:t>
             </a:r>
             <a:endParaRPr sz="1300">
               <a:solidFill>
@@ -8498,7 +7811,7 @@
                 <a:cs typeface="Google Sans Flex"/>
                 <a:sym typeface="Google Sans Flex"/>
               </a:rPr>
-              <a:t>Tests do not measure model accuracy or real-world fraud detection. No accuracy or latency benchmark is claimed.</a:t>
+              <a:t>These checks establish integration behavior, not fraud-detection accuracy or model latency. No accuracy or latency benchmark is claimed.</a:t>
             </a:r>
             <a:endParaRPr sz="1300">
               <a:solidFill>
@@ -8520,7 +7833,7 @@
 </p:sld>
 </file>
 
-<file path=ppt/slides/slide13.xml><?xml version="1.0" encoding="utf-8"?>
+<file path=ppt/slides/slide12.xml><?xml version="1.0" encoding="utf-8"?>
 <p:sld xmlns:a="http://schemas.openxmlformats.org/drawingml/2006/main" xmlns:r="http://schemas.openxmlformats.org/officeDocument/2006/relationships" xmlns:mc="http://schemas.openxmlformats.org/markup-compatibility/2006" xmlns:mv="urn:schemas-microsoft-com:mac:vml" xmlns:p="http://schemas.openxmlformats.org/presentationml/2006/main" xmlns:c="http://schemas.openxmlformats.org/drawingml/2006/chart" xmlns:dgm="http://schemas.openxmlformats.org/drawingml/2006/diagram" xmlns:o="urn:schemas-microsoft-com:office:office" xmlns:v="urn:schemas-microsoft-com:vml" xmlns:pvml="urn:schemas-microsoft-com:office:powerpoint" xmlns:com="http://schemas.openxmlformats.org/drawingml/2006/compatibility" xmlns:p14="http://schemas.microsoft.com/office/powerpoint/2010/main" xmlns:p15="http://schemas.microsoft.com/office/powerpoint/2012/main" xmlns:ahyp="http://schemas.microsoft.com/office/drawing/2018/hyperlinkcolor">
   <p:cSld>
     <p:spTree>
@@ -8539,7 +7852,7 @@
       </p:grpSpPr>
       <p:pic>
         <p:nvPicPr>
-          <p:cNvPr id="182" name="Google Shape;182;p25" title="Frame 144.png"/>
+          <p:cNvPr id="182" name="Google Shape;182;p24" title="Frame 144.png"/>
           <p:cNvPicPr preferRelativeResize="0"/>
           <p:nvPr/>
         </p:nvPicPr>
@@ -8566,7 +7879,7 @@
       </p:pic>
       <p:pic>
         <p:nvPicPr>
-          <p:cNvPr id="183" name="Google Shape;183;p25" title="Group 427319979.png"/>
+          <p:cNvPr id="183" name="Google Shape;183;p24" title="Group 427319979.png"/>
           <p:cNvPicPr preferRelativeResize="0"/>
           <p:nvPr/>
         </p:nvPicPr>
@@ -8594,7 +7907,7 @@
       </p:pic>
       <p:sp>
         <p:nvSpPr>
-          <p:cNvPr id="184" name="Google Shape;184;p25"/>
+          <p:cNvPr id="184" name="Google Shape;184;p24"/>
           <p:cNvSpPr/>
           <p:nvPr/>
         </p:nvSpPr>
@@ -8637,7 +7950,7 @@
       </p:sp>
       <p:sp>
         <p:nvSpPr>
-          <p:cNvPr id="185" name="Google Shape;185;p25"/>
+          <p:cNvPr id="185" name="Google Shape;185;p24"/>
           <p:cNvSpPr txBox="1"/>
           <p:nvPr/>
         </p:nvSpPr>
@@ -8689,7 +8002,7 @@
       </p:sp>
       <p:sp>
         <p:nvSpPr>
-          <p:cNvPr id="186" name="Google Shape;186;p25"/>
+          <p:cNvPr id="186" name="Google Shape;186;p24"/>
           <p:cNvSpPr txBox="1"/>
           <p:nvPr/>
         </p:nvSpPr>
@@ -8769,7 +8082,7 @@
                 <a:cs typeface="Google Sans Flex"/>
                 <a:sym typeface="Google Sans Flex"/>
               </a:rPr>
-              <a:t>01  Continue testing model failure, malformed files and quota exhaustion.</a:t>
+              <a:t>01  Benchmark Jev against Gemini on a reviewed case set: p50/p95 latency, precision, recall, false-positive rate and calibration.</a:t>
             </a:r>
             <a:endParaRPr sz="1300">
               <a:solidFill>
@@ -8804,7 +8117,7 @@
                 <a:cs typeface="Google Sans Flex"/>
                 <a:sym typeface="Google Sans Flex"/>
               </a:rPr>
-              <a:t>02  Expand evaluation with reviewed synthetic cases before making performance claims.</a:t>
+              <a:t>02  Keep Jev disabled until quality and operational checks are complete.</a:t>
             </a:r>
             <a:endParaRPr sz="1300">
               <a:solidFill>
@@ -8839,7 +8152,7 @@
                 <a:cs typeface="Google Sans Flex"/>
                 <a:sym typeface="Google Sans Flex"/>
               </a:rPr>
-              <a:t>03  Monitor Cloud usage against the ₹100 budget alert through 6 November 2026.</a:t>
+              <a:t>03  Add verified vendor feeds and extend beyond invoices to more payment rails.</a:t>
             </a:r>
             <a:endParaRPr sz="1300">
               <a:solidFill>
@@ -8874,7 +8187,7 @@
                 <a:cs typeface="Google Sans Flex"/>
                 <a:sym typeface="Google Sans Flex"/>
               </a:rPr>
-              <a:t>04  Keep a human in the review path; the app never initiates a payment.</a:t>
+              <a:t>04  Preserve human review and deterministic policy control; the app never initiates a payment.</a:t>
             </a:r>
             <a:endParaRPr sz="1300">
               <a:solidFill>
@@ -8896,7 +8209,7 @@
 </p:sld>
 </file>
 
-<file path=ppt/slides/slide14.xml><?xml version="1.0" encoding="utf-8"?>
+<file path=ppt/slides/slide13.xml><?xml version="1.0" encoding="utf-8"?>
 <p:sld xmlns:a="http://schemas.openxmlformats.org/drawingml/2006/main" xmlns:r="http://schemas.openxmlformats.org/officeDocument/2006/relationships" xmlns:mc="http://schemas.openxmlformats.org/markup-compatibility/2006" xmlns:mv="urn:schemas-microsoft-com:mac:vml" xmlns:p="http://schemas.openxmlformats.org/presentationml/2006/main" xmlns:c="http://schemas.openxmlformats.org/drawingml/2006/chart" xmlns:dgm="http://schemas.openxmlformats.org/drawingml/2006/diagram" xmlns:o="urn:schemas-microsoft-com:office:office" xmlns:v="urn:schemas-microsoft-com:vml" xmlns:pvml="urn:schemas-microsoft-com:office:powerpoint" xmlns:com="http://schemas.openxmlformats.org/drawingml/2006/compatibility" xmlns:p14="http://schemas.microsoft.com/office/powerpoint/2010/main" xmlns:p15="http://schemas.microsoft.com/office/powerpoint/2012/main" xmlns:ahyp="http://schemas.microsoft.com/office/drawing/2018/hyperlinkcolor">
   <p:cSld>
     <p:spTree>
@@ -8915,7 +8228,7 @@
       </p:grpSpPr>
       <p:pic>
         <p:nvPicPr>
-          <p:cNvPr id="191" name="Google Shape;191;p26" title="Frame 144.png"/>
+          <p:cNvPr id="191" name="Google Shape;191;p25" title="Frame 144.png"/>
           <p:cNvPicPr preferRelativeResize="0"/>
           <p:nvPr/>
         </p:nvPicPr>
@@ -8942,7 +8255,7 @@
       </p:pic>
       <p:pic>
         <p:nvPicPr>
-          <p:cNvPr id="192" name="Google Shape;192;p26" title="Group 427319979.png"/>
+          <p:cNvPr id="192" name="Google Shape;192;p25" title="Group 427319979.png"/>
           <p:cNvPicPr preferRelativeResize="0"/>
           <p:nvPr/>
         </p:nvPicPr>
@@ -8970,7 +8283,7 @@
       </p:pic>
       <p:sp>
         <p:nvSpPr>
-          <p:cNvPr id="193" name="Google Shape;193;p26"/>
+          <p:cNvPr id="193" name="Google Shape;193;p25"/>
           <p:cNvSpPr/>
           <p:nvPr/>
         </p:nvSpPr>
@@ -9013,7 +8326,7 @@
       </p:sp>
       <p:sp>
         <p:nvSpPr>
-          <p:cNvPr id="194" name="Google Shape;194;p26"/>
+          <p:cNvPr id="194" name="Google Shape;194;p25"/>
           <p:cNvSpPr txBox="1"/>
           <p:nvPr/>
         </p:nvSpPr>
@@ -9105,7 +8418,7 @@
       </p:sp>
       <p:sp>
         <p:nvSpPr>
-          <p:cNvPr id="195" name="Google Shape;195;p26"/>
+          <p:cNvPr id="195" name="Google Shape;195;p25"/>
           <p:cNvSpPr txBox="1"/>
           <p:nvPr/>
         </p:nvSpPr>
@@ -9467,7 +8780,7 @@
 </p:sld>
 </file>
 
-<file path=ppt/slides/slide15.xml><?xml version="1.0" encoding="utf-8"?>
+<file path=ppt/slides/slide14.xml><?xml version="1.0" encoding="utf-8"?>
 <p:sld xmlns:a="http://schemas.openxmlformats.org/drawingml/2006/main" xmlns:r="http://schemas.openxmlformats.org/officeDocument/2006/relationships" xmlns:mc="http://schemas.openxmlformats.org/markup-compatibility/2006" xmlns:mv="urn:schemas-microsoft-com:mac:vml" xmlns:p="http://schemas.openxmlformats.org/presentationml/2006/main" xmlns:c="http://schemas.openxmlformats.org/drawingml/2006/chart" xmlns:dgm="http://schemas.openxmlformats.org/drawingml/2006/diagram" xmlns:o="urn:schemas-microsoft-com:office:office" xmlns:v="urn:schemas-microsoft-com:vml" xmlns:pvml="urn:schemas-microsoft-com:office:powerpoint" xmlns:com="http://schemas.openxmlformats.org/drawingml/2006/compatibility" xmlns:p14="http://schemas.microsoft.com/office/powerpoint/2010/main" xmlns:p15="http://schemas.microsoft.com/office/powerpoint/2012/main" xmlns:ahyp="http://schemas.microsoft.com/office/drawing/2018/hyperlinkcolor">
   <p:cSld>
     <p:spTree>
@@ -9486,7 +8799,7 @@
       </p:grpSpPr>
       <p:pic>
         <p:nvPicPr>
-          <p:cNvPr id="200" name="Google Shape;200;p27" title="Frame 144.png"/>
+          <p:cNvPr id="200" name="Google Shape;200;p26" title="Frame 144.png"/>
           <p:cNvPicPr preferRelativeResize="0"/>
           <p:nvPr/>
         </p:nvPicPr>
@@ -9513,130 +8826,7 @@
       </p:pic>
       <p:pic>
         <p:nvPicPr>
-          <p:cNvPr id="201" name="Google Shape;201;p27" title="Group 427319979.png"/>
-          <p:cNvPicPr preferRelativeResize="0"/>
-          <p:nvPr/>
-        </p:nvPicPr>
-        <p:blipFill>
-          <a:blip r:embed="rId4">
-            <a:alphaModFix/>
-          </a:blip>
-          <a:stretch>
-            <a:fillRect/>
-          </a:stretch>
-        </p:blipFill>
-        <p:spPr>
-          <a:xfrm>
-            <a:off x="0" y="1"/>
-            <a:ext cx="9144000" cy="507359"/>
-          </a:xfrm>
-          <a:prstGeom prst="rect">
-            <a:avLst/>
-          </a:prstGeom>
-          <a:noFill/>
-          <a:ln>
-            <a:noFill/>
-          </a:ln>
-        </p:spPr>
-      </p:pic>
-      <p:sp>
-        <p:nvSpPr>
-          <p:cNvPr id="202" name="Google Shape;202;p27"/>
-          <p:cNvSpPr/>
-          <p:nvPr/>
-        </p:nvSpPr>
-        <p:spPr>
-          <a:xfrm>
-            <a:off x="-29250" y="5071875"/>
-            <a:ext cx="9173400" cy="97800"/>
-          </a:xfrm>
-          <a:prstGeom prst="rect">
-            <a:avLst/>
-          </a:prstGeom>
-          <a:solidFill>
-            <a:schemeClr val="dk1"/>
-          </a:solidFill>
-          <a:ln>
-            <a:noFill/>
-          </a:ln>
-        </p:spPr>
-        <p:txBody>
-          <a:bodyPr anchorCtr="0" anchor="ctr" bIns="91425" lIns="91425" spcFirstLastPara="1" rIns="91425" wrap="square" tIns="91425">
-            <a:noAutofit/>
-          </a:bodyPr>
-          <a:lstStyle/>
-          <a:p>
-            <a:pPr indent="0" lvl="0" marL="0" rtl="0" algn="ctr">
-              <a:spcBef>
-                <a:spcPts val="0"/>
-              </a:spcBef>
-              <a:spcAft>
-                <a:spcPts val="0"/>
-              </a:spcAft>
-              <a:buNone/>
-            </a:pPr>
-            <a:r>
-              <a:t/>
-            </a:r>
-            <a:endParaRPr/>
-          </a:p>
-        </p:txBody>
-      </p:sp>
-    </p:spTree>
-  </p:cSld>
-  <p:clrMapOvr>
-    <a:masterClrMapping/>
-  </p:clrMapOvr>
-</p:sld>
-</file>
-
-<file path=ppt/slides/slide16.xml><?xml version="1.0" encoding="utf-8"?>
-<p:sld xmlns:a="http://schemas.openxmlformats.org/drawingml/2006/main" xmlns:r="http://schemas.openxmlformats.org/officeDocument/2006/relationships" xmlns:mc="http://schemas.openxmlformats.org/markup-compatibility/2006" xmlns:mv="urn:schemas-microsoft-com:mac:vml" xmlns:p="http://schemas.openxmlformats.org/presentationml/2006/main" xmlns:c="http://schemas.openxmlformats.org/drawingml/2006/chart" xmlns:dgm="http://schemas.openxmlformats.org/drawingml/2006/diagram" xmlns:o="urn:schemas-microsoft-com:office:office" xmlns:v="urn:schemas-microsoft-com:vml" xmlns:pvml="urn:schemas-microsoft-com:office:powerpoint" xmlns:com="http://schemas.openxmlformats.org/drawingml/2006/compatibility" xmlns:p14="http://schemas.microsoft.com/office/powerpoint/2010/main" xmlns:p15="http://schemas.microsoft.com/office/powerpoint/2012/main" xmlns:ahyp="http://schemas.microsoft.com/office/drawing/2018/hyperlinkcolor">
-  <p:cSld>
-    <p:spTree>
-      <p:nvGrpSpPr>
-        <p:cNvPr id="206" name="Shape 206"/>
-        <p:cNvGrpSpPr/>
-        <p:nvPr/>
-      </p:nvGrpSpPr>
-      <p:grpSpPr>
-        <a:xfrm>
-          <a:off x="0" y="0"/>
-          <a:ext cx="0" cy="0"/>
-          <a:chOff x="0" y="0"/>
-          <a:chExt cx="0" cy="0"/>
-        </a:xfrm>
-      </p:grpSpPr>
-      <p:pic>
-        <p:nvPicPr>
-          <p:cNvPr id="207" name="Google Shape;207;p28" title="Frame 144.png"/>
-          <p:cNvPicPr preferRelativeResize="0"/>
-          <p:nvPr/>
-        </p:nvPicPr>
-        <p:blipFill rotWithShape="1">
-          <a:blip r:embed="rId3">
-            <a:alphaModFix/>
-          </a:blip>
-          <a:srcRect b="98001" l="0" r="0" t="0"/>
-          <a:stretch/>
-        </p:blipFill>
-        <p:spPr>
-          <a:xfrm>
-            <a:off x="0" y="5093562"/>
-            <a:ext cx="9144000" cy="54275"/>
-          </a:xfrm>
-          <a:prstGeom prst="rect">
-            <a:avLst/>
-          </a:prstGeom>
-          <a:noFill/>
-          <a:ln>
-            <a:noFill/>
-          </a:ln>
-        </p:spPr>
-      </p:pic>
-      <p:pic>
-        <p:nvPicPr>
-          <p:cNvPr id="208" name="Google Shape;208;p28" title="Frame 145.png"/>
+          <p:cNvPr id="201" name="Google Shape;201;p26" title="Frame 145.png"/>
           <p:cNvPicPr preferRelativeResize="0"/>
           <p:nvPr/>
         </p:nvPicPr>
@@ -9689,21 +8879,22 @@
       </p:grpSpPr>
       <p:pic>
         <p:nvPicPr>
-          <p:cNvPr id="61" name="Google Shape;61;p14" title="Frame 144.png"/>
+          <p:cNvPr id="61" name="Google Shape;61;p14" title="Group 427319979.png"/>
           <p:cNvPicPr preferRelativeResize="0"/>
           <p:nvPr/>
         </p:nvPicPr>
-        <p:blipFill rotWithShape="1">
+        <p:blipFill>
           <a:blip r:embed="rId3">
             <a:alphaModFix/>
           </a:blip>
-          <a:srcRect b="98001" l="0" r="0" t="0"/>
-          <a:stretch/>
+          <a:stretch>
+            <a:fillRect/>
+          </a:stretch>
         </p:blipFill>
         <p:spPr>
           <a:xfrm>
-            <a:off x="0" y="5093562"/>
-            <a:ext cx="9144000" cy="54275"/>
+            <a:off x="0" y="1"/>
+            <a:ext cx="9144000" cy="507359"/>
           </a:xfrm>
           <a:prstGeom prst="rect">
             <a:avLst/>
@@ -9722,8 +8913,8 @@
         </p:nvSpPr>
         <p:spPr>
           <a:xfrm>
-            <a:off x="0" y="0"/>
-            <a:ext cx="9144000" cy="5143500"/>
+            <a:off x="-29250" y="5071875"/>
+            <a:ext cx="9173400" cy="97800"/>
           </a:xfrm>
           <a:prstGeom prst="rect">
             <a:avLst/>
@@ -9765,8 +8956,8 @@
         </p:nvSpPr>
         <p:spPr>
           <a:xfrm>
-            <a:off x="5092475" y="1968750"/>
-            <a:ext cx="3311400" cy="1206000"/>
+            <a:off x="265350" y="663825"/>
+            <a:ext cx="8943000" cy="561900"/>
           </a:xfrm>
           <a:prstGeom prst="rect">
             <a:avLst/>
@@ -9792,66 +8983,197 @@
               <a:buNone/>
             </a:pPr>
             <a:r>
-              <a:rPr lang="en-GB" sz="1100">
-                <a:solidFill>
-                  <a:schemeClr val="lt1"/>
-                </a:solidFill>
+              <a:rPr lang="en-GB" sz="1600">
                 <a:latin typeface="Google Sans Flex Medium"/>
                 <a:ea typeface="Google Sans Flex Medium"/>
                 <a:cs typeface="Google Sans Flex Medium"/>
                 <a:sym typeface="Google Sans Flex Medium"/>
               </a:rPr>
-              <a:t>Note:</a:t>
+              <a:t>ScamShield invoice intelligence</a:t>
             </a:r>
+            <a:endParaRPr sz="1600">
+              <a:latin typeface="Google Sans Flex Medium"/>
+              <a:ea typeface="Google Sans Flex Medium"/>
+              <a:cs typeface="Google Sans Flex Medium"/>
+              <a:sym typeface="Google Sans Flex Medium"/>
+            </a:endParaRPr>
+          </a:p>
+        </p:txBody>
+      </p:sp>
+      <p:sp>
+        <p:nvSpPr>
+          <p:cNvPr id="64" name="Google Shape;64;p14"/>
+          <p:cNvSpPr txBox="1"/>
+          <p:nvPr/>
+        </p:nvSpPr>
+        <p:spPr>
+          <a:xfrm>
+            <a:off x="381000" y="1320800"/>
+            <a:ext cx="8382000" cy="3365400"/>
+          </a:xfrm>
+          <a:prstGeom prst="rect">
+            <a:avLst/>
+          </a:prstGeom>
+          <a:noFill/>
+          <a:ln>
+            <a:noFill/>
+          </a:ln>
+        </p:spPr>
+        <p:txBody>
+          <a:bodyPr anchorCtr="0" anchor="t" bIns="91425" lIns="91425" spcFirstLastPara="1" rIns="91425" wrap="square" tIns="91425">
+            <a:noAutofit/>
+          </a:bodyPr>
+          <a:lstStyle/>
+          <a:p>
+            <a:pPr indent="0" lvl="0" marL="0" rtl="0" algn="l">
+              <a:lnSpc>
+                <a:spcPct val="112000"/>
+              </a:lnSpc>
+              <a:spcBef>
+                <a:spcPts val="0"/>
+              </a:spcBef>
+              <a:spcAft>
+                <a:spcPts val="0"/>
+              </a:spcAft>
+              <a:buNone/>
+            </a:pPr>
             <a:r>
-              <a:rPr lang="en-GB" sz="1100">
+              <a:rPr lang="en-GB">
                 <a:solidFill>
-                  <a:schemeClr val="lt1"/>
+                  <a:srgbClr val="1F2926"/>
                 </a:solidFill>
                 <a:latin typeface="Google Sans Flex"/>
                 <a:ea typeface="Google Sans Flex"/>
                 <a:cs typeface="Google Sans Flex"/>
                 <a:sym typeface="Google Sans Flex"/>
               </a:rPr>
-              <a:t> Please download this template to make your edits and submit the final version.</a:t>
+              <a:t>Invoice fraud hides in ordinary payment work: a familiar invoice can carry a changed bank account or a request to bypass checks.</a:t>
             </a:r>
-            <a:br>
-              <a:rPr lang="en-GB" sz="1100">
+            <a:endParaRPr>
+              <a:solidFill>
+                <a:srgbClr val="1F2926"/>
+              </a:solidFill>
+              <a:latin typeface="Google Sans Flex"/>
+              <a:ea typeface="Google Sans Flex"/>
+              <a:cs typeface="Google Sans Flex"/>
+              <a:sym typeface="Google Sans Flex"/>
+            </a:endParaRPr>
+          </a:p>
+          <a:p>
+            <a:pPr indent="0" lvl="0" marL="0" rtl="0" algn="l">
+              <a:lnSpc>
+                <a:spcPct val="112000"/>
+              </a:lnSpc>
+              <a:spcBef>
+                <a:spcPts val="600"/>
+              </a:spcBef>
+              <a:spcAft>
+                <a:spcPts val="0"/>
+              </a:spcAft>
+              <a:buNone/>
+            </a:pPr>
+            <a:r>
+              <a:t/>
+            </a:r>
+            <a:endParaRPr>
+              <a:solidFill>
+                <a:srgbClr val="1F2926"/>
+              </a:solidFill>
+              <a:latin typeface="Google Sans Flex"/>
+              <a:ea typeface="Google Sans Flex"/>
+              <a:cs typeface="Google Sans Flex"/>
+              <a:sym typeface="Google Sans Flex"/>
+            </a:endParaRPr>
+          </a:p>
+          <a:p>
+            <a:pPr indent="0" lvl="0" marL="0" rtl="0" algn="l">
+              <a:lnSpc>
+                <a:spcPct val="112000"/>
+              </a:lnSpc>
+              <a:spcBef>
+                <a:spcPts val="600"/>
+              </a:spcBef>
+              <a:spcAft>
+                <a:spcPts val="0"/>
+              </a:spcAft>
+              <a:buNone/>
+            </a:pPr>
+            <a:r>
+              <a:rPr lang="en-GB">
                 <a:solidFill>
-                  <a:schemeClr val="lt1"/>
+                  <a:srgbClr val="1F2926"/>
                 </a:solidFill>
                 <a:latin typeface="Google Sans Flex"/>
                 <a:ea typeface="Google Sans Flex"/>
                 <a:cs typeface="Google Sans Flex"/>
                 <a:sym typeface="Google Sans Flex"/>
               </a:rPr>
-            </a:br>
-            <a:br>
-              <a:rPr lang="en-GB" sz="1100">
+              <a:t>ScamShield is an invoice-first fraud intervention that combines Gemini’s semantic reading of payment instructions with deterministic transaction checks. The same pattern can extend to other payment rails.</a:t>
+            </a:r>
+            <a:endParaRPr>
+              <a:solidFill>
+                <a:srgbClr val="1F2926"/>
+              </a:solidFill>
+              <a:latin typeface="Google Sans Flex"/>
+              <a:ea typeface="Google Sans Flex"/>
+              <a:cs typeface="Google Sans Flex"/>
+              <a:sym typeface="Google Sans Flex"/>
+            </a:endParaRPr>
+          </a:p>
+          <a:p>
+            <a:pPr indent="0" lvl="0" marL="0" rtl="0" algn="l">
+              <a:lnSpc>
+                <a:spcPct val="112000"/>
+              </a:lnSpc>
+              <a:spcBef>
+                <a:spcPts val="600"/>
+              </a:spcBef>
+              <a:spcAft>
+                <a:spcPts val="0"/>
+              </a:spcAft>
+              <a:buNone/>
+            </a:pPr>
+            <a:r>
+              <a:t/>
+            </a:r>
+            <a:endParaRPr>
+              <a:solidFill>
+                <a:srgbClr val="1F2926"/>
+              </a:solidFill>
+              <a:latin typeface="Google Sans Flex"/>
+              <a:ea typeface="Google Sans Flex"/>
+              <a:cs typeface="Google Sans Flex"/>
+              <a:sym typeface="Google Sans Flex"/>
+            </a:endParaRPr>
+          </a:p>
+          <a:p>
+            <a:pPr indent="0" lvl="0" marL="0" rtl="0" algn="l">
+              <a:lnSpc>
+                <a:spcPct val="112000"/>
+              </a:lnSpc>
+              <a:spcBef>
+                <a:spcPts val="600"/>
+              </a:spcBef>
+              <a:spcAft>
+                <a:spcPts val="600"/>
+              </a:spcAft>
+              <a:buNone/>
+            </a:pPr>
+            <a:r>
+              <a:rPr lang="en-GB">
                 <a:solidFill>
-                  <a:schemeClr val="lt1"/>
+                  <a:srgbClr val="1F2926"/>
                 </a:solidFill>
                 <a:latin typeface="Google Sans Flex"/>
                 <a:ea typeface="Google Sans Flex"/>
                 <a:cs typeface="Google Sans Flex"/>
                 <a:sym typeface="Google Sans Flex"/>
               </a:rPr>
-            </a:br>
-            <a:r>
-              <a:rPr lang="en-GB" sz="1100">
-                <a:solidFill>
-                  <a:schemeClr val="lt1"/>
-                </a:solidFill>
-                <a:latin typeface="Google Sans Flex"/>
-                <a:ea typeface="Google Sans Flex"/>
-                <a:cs typeface="Google Sans Flex"/>
-                <a:sym typeface="Google Sans Flex"/>
-              </a:rPr>
-              <a:t>To download, go to File &gt; Download &gt; Microsoft PowerPoint (.PPTX). Kindly refrain from sending edit requests.</a:t>
+              <a:t>LIVE PROTOTYPE  Two synthetic invoice paths ran on the public service. People confirm extracted fields; policy returns Continue, Verify or Review. No payment is executed.</a:t>
             </a:r>
-            <a:endParaRPr sz="1100">
+            <a:endParaRPr>
               <a:solidFill>
-                <a:schemeClr val="lt1"/>
+                <a:srgbClr val="1F2926"/>
               </a:solidFill>
               <a:latin typeface="Google Sans Flex"/>
               <a:ea typeface="Google Sans Flex"/>
@@ -9859,66 +9181,8 @@
               <a:sym typeface="Google Sans Flex"/>
             </a:endParaRPr>
           </a:p>
-          <a:p>
-            <a:pPr indent="0" lvl="0" marL="0" rtl="0" algn="l">
-              <a:spcBef>
-                <a:spcPts val="0"/>
-              </a:spcBef>
-              <a:spcAft>
-                <a:spcPts val="0"/>
-              </a:spcAft>
-              <a:buNone/>
-            </a:pPr>
-            <a:r>
-              <a:t/>
-            </a:r>
-            <a:endParaRPr sz="1100">
-              <a:solidFill>
-                <a:schemeClr val="lt1"/>
-              </a:solidFill>
-              <a:latin typeface="Google Sans Flex"/>
-              <a:ea typeface="Google Sans Flex"/>
-              <a:cs typeface="Google Sans Flex"/>
-              <a:sym typeface="Google Sans Flex"/>
-            </a:endParaRPr>
-          </a:p>
         </p:txBody>
       </p:sp>
-      <p:pic>
-        <p:nvPicPr>
-          <p:cNvPr id="64" name="Google Shape;64;p14"/>
-          <p:cNvPicPr preferRelativeResize="0"/>
-          <p:nvPr/>
-        </p:nvPicPr>
-        <p:blipFill>
-          <a:blip r:embed="rId4">
-            <a:alphaModFix/>
-          </a:blip>
-          <a:stretch>
-            <a:fillRect/>
-          </a:stretch>
-        </p:blipFill>
-        <p:spPr>
-          <a:xfrm>
-            <a:off x="924203" y="1194675"/>
-            <a:ext cx="3604250" cy="2621725"/>
-          </a:xfrm>
-          <a:prstGeom prst="rect">
-            <a:avLst/>
-          </a:prstGeom>
-          <a:noFill/>
-          <a:ln>
-            <a:noFill/>
-          </a:ln>
-          <a:effectLst>
-            <a:outerShdw blurRad="971550" rotWithShape="0" algn="bl" dir="5400000" dist="19050">
-              <a:schemeClr val="lt1">
-                <a:alpha val="50000"/>
-              </a:schemeClr>
-            </a:outerShdw>
-          </a:effectLst>
-        </p:spPr>
-      </p:pic>
     </p:spTree>
   </p:cSld>
   <p:clrMapOvr>
@@ -9946,12 +9210,39 @@
       </p:grpSpPr>
       <p:pic>
         <p:nvPicPr>
-          <p:cNvPr id="69" name="Google Shape;69;p15" title="Group 427319979.png"/>
+          <p:cNvPr id="69" name="Google Shape;69;p15" title="Frame 144.png"/>
+          <p:cNvPicPr preferRelativeResize="0"/>
+          <p:nvPr/>
+        </p:nvPicPr>
+        <p:blipFill rotWithShape="1">
+          <a:blip r:embed="rId3">
+            <a:alphaModFix/>
+          </a:blip>
+          <a:srcRect b="98001" l="0" r="0" t="0"/>
+          <a:stretch/>
+        </p:blipFill>
+        <p:spPr>
+          <a:xfrm>
+            <a:off x="0" y="5093562"/>
+            <a:ext cx="9144000" cy="54275"/>
+          </a:xfrm>
+          <a:prstGeom prst="rect">
+            <a:avLst/>
+          </a:prstGeom>
+          <a:noFill/>
+          <a:ln>
+            <a:noFill/>
+          </a:ln>
+        </p:spPr>
+      </p:pic>
+      <p:pic>
+        <p:nvPicPr>
+          <p:cNvPr id="70" name="Google Shape;70;p15" title="Group 427319979.png"/>
           <p:cNvPicPr preferRelativeResize="0"/>
           <p:nvPr/>
         </p:nvPicPr>
         <p:blipFill>
-          <a:blip r:embed="rId3">
+          <a:blip r:embed="rId4">
             <a:alphaModFix/>
           </a:blip>
           <a:stretch>
@@ -9974,7 +9265,7 @@
       </p:pic>
       <p:sp>
         <p:nvSpPr>
-          <p:cNvPr id="70" name="Google Shape;70;p15"/>
+          <p:cNvPr id="71" name="Google Shape;71;p15"/>
           <p:cNvSpPr/>
           <p:nvPr/>
         </p:nvSpPr>
@@ -10012,58 +9303,6 @@
               <a:t/>
             </a:r>
             <a:endParaRPr/>
-          </a:p>
-        </p:txBody>
-      </p:sp>
-      <p:sp>
-        <p:nvSpPr>
-          <p:cNvPr id="71" name="Google Shape;71;p15"/>
-          <p:cNvSpPr txBox="1"/>
-          <p:nvPr/>
-        </p:nvSpPr>
-        <p:spPr>
-          <a:xfrm>
-            <a:off x="265350" y="663825"/>
-            <a:ext cx="8943000" cy="561900"/>
-          </a:xfrm>
-          <a:prstGeom prst="rect">
-            <a:avLst/>
-          </a:prstGeom>
-          <a:noFill/>
-          <a:ln>
-            <a:noFill/>
-          </a:ln>
-        </p:spPr>
-        <p:txBody>
-          <a:bodyPr anchorCtr="0" anchor="t" bIns="91425" lIns="91425" spcFirstLastPara="1" rIns="91425" wrap="square" tIns="91425">
-            <a:noAutofit/>
-          </a:bodyPr>
-          <a:lstStyle/>
-          <a:p>
-            <a:pPr indent="0" lvl="0" marL="0" rtl="0" algn="l">
-              <a:spcBef>
-                <a:spcPts val="0"/>
-              </a:spcBef>
-              <a:spcAft>
-                <a:spcPts val="0"/>
-              </a:spcAft>
-              <a:buNone/>
-            </a:pPr>
-            <a:r>
-              <a:rPr lang="en-GB" sz="1600">
-                <a:latin typeface="Google Sans Flex Medium"/>
-                <a:ea typeface="Google Sans Flex Medium"/>
-                <a:cs typeface="Google Sans Flex Medium"/>
-                <a:sym typeface="Google Sans Flex Medium"/>
-              </a:rPr>
-              <a:t>ScamShield invoice intelligence</a:t>
-            </a:r>
-            <a:endParaRPr sz="1600">
-              <a:latin typeface="Google Sans Flex Medium"/>
-              <a:ea typeface="Google Sans Flex Medium"/>
-              <a:cs typeface="Google Sans Flex Medium"/>
-              <a:sym typeface="Google Sans Flex Medium"/>
-            </a:endParaRPr>
           </a:p>
         </p:txBody>
       </p:sp>
@@ -10075,8 +9314,8 @@
         </p:nvSpPr>
         <p:spPr>
           <a:xfrm>
-            <a:off x="381000" y="1320800"/>
-            <a:ext cx="8382000" cy="3365400"/>
+            <a:off x="265350" y="663825"/>
+            <a:ext cx="8943000" cy="1366200"/>
           </a:xfrm>
           <a:prstGeom prst="rect">
             <a:avLst/>
@@ -10093,8 +9332,88 @@
           <a:lstStyle/>
           <a:p>
             <a:pPr indent="0" lvl="0" marL="0" rtl="0" algn="l">
+              <a:spcBef>
+                <a:spcPts val="0"/>
+              </a:spcBef>
+              <a:spcAft>
+                <a:spcPts val="0"/>
+              </a:spcAft>
+              <a:buNone/>
+            </a:pPr>
+            <a:r>
+              <a:rPr lang="en-GB" sz="1600">
+                <a:latin typeface="Google Sans Flex SemiBold"/>
+                <a:ea typeface="Google Sans Flex SemiBold"/>
+                <a:cs typeface="Google Sans Flex SemiBold"/>
+                <a:sym typeface="Google Sans Flex SemiBold"/>
+              </a:rPr>
+              <a:t>Invoice fraud in numbers</a:t>
+            </a:r>
+            <a:br>
+              <a:rPr lang="en-GB" sz="1600">
+                <a:latin typeface="Google Sans Flex SemiBold"/>
+                <a:ea typeface="Google Sans Flex SemiBold"/>
+                <a:cs typeface="Google Sans Flex SemiBold"/>
+                <a:sym typeface="Google Sans Flex SemiBold"/>
+              </a:rPr>
+            </a:br>
+            <a:endParaRPr sz="1600">
+              <a:latin typeface="Google Sans Flex SemiBold"/>
+              <a:ea typeface="Google Sans Flex SemiBold"/>
+              <a:cs typeface="Google Sans Flex SemiBold"/>
+              <a:sym typeface="Google Sans Flex SemiBold"/>
+            </a:endParaRPr>
+          </a:p>
+          <a:p>
+            <a:pPr indent="0" lvl="0" marL="0" rtl="0" algn="l">
+              <a:spcBef>
+                <a:spcPts val="0"/>
+              </a:spcBef>
+              <a:spcAft>
+                <a:spcPts val="0"/>
+              </a:spcAft>
+              <a:buNone/>
+            </a:pPr>
+            <a:r>
+              <a:t/>
+            </a:r>
+            <a:endParaRPr sz="1600">
+              <a:latin typeface="Google Sans Flex Medium"/>
+              <a:ea typeface="Google Sans Flex Medium"/>
+              <a:cs typeface="Google Sans Flex Medium"/>
+              <a:sym typeface="Google Sans Flex Medium"/>
+            </a:endParaRPr>
+          </a:p>
+        </p:txBody>
+      </p:sp>
+      <p:sp>
+        <p:nvSpPr>
+          <p:cNvPr id="73" name="Google Shape;73;p15"/>
+          <p:cNvSpPr txBox="1"/>
+          <p:nvPr/>
+        </p:nvSpPr>
+        <p:spPr>
+          <a:xfrm>
+            <a:off x="381000" y="1524000"/>
+            <a:ext cx="8382000" cy="3365400"/>
+          </a:xfrm>
+          <a:prstGeom prst="rect">
+            <a:avLst/>
+          </a:prstGeom>
+          <a:noFill/>
+          <a:ln>
+            <a:noFill/>
+          </a:ln>
+        </p:spPr>
+        <p:txBody>
+          <a:bodyPr anchorCtr="0" anchor="t" bIns="91425" lIns="91425" spcFirstLastPara="1" rIns="91425" wrap="square" tIns="91425">
+            <a:noAutofit/>
+          </a:bodyPr>
+          <a:lstStyle/>
+          <a:p>
+            <a:pPr indent="0" lvl="0" marL="0" rtl="0" algn="l">
               <a:lnSpc>
-                <a:spcPct val="112000"/>
+                <a:spcPct val="104000"/>
               </a:lnSpc>
               <a:spcBef>
                 <a:spcPts val="0"/>
@@ -10104,6 +9423,18 @@
               </a:spcAft>
               <a:buNone/>
             </a:pPr>
+            <a:r>
+              <a:rPr b="1" lang="en-GB" sz="2400">
+                <a:solidFill>
+                  <a:srgbClr val="1F2926"/>
+                </a:solidFill>
+                <a:latin typeface="Google Sans Flex"/>
+                <a:ea typeface="Google Sans Flex"/>
+                <a:cs typeface="Google Sans Flex"/>
+                <a:sym typeface="Google Sans Flex"/>
+              </a:rPr>
+              <a:t>£41.3m</a:t>
+            </a:r>
             <a:r>
               <a:rPr lang="en-GB">
                 <a:solidFill>
@@ -10114,7 +9445,7 @@
                 <a:cs typeface="Google Sans Flex"/>
                 <a:sym typeface="Google Sans Flex"/>
               </a:rPr>
-              <a:t>Invoice instructions can change the destination account while the rest of the invoice looks routine.</a:t>
+              <a:t>   UK invoice and mandate fraud losses · 2025</a:t>
             </a:r>
             <a:endParaRPr>
               <a:solidFill>
@@ -10129,10 +9460,104 @@
           <a:p>
             <a:pPr indent="0" lvl="0" marL="0" rtl="0" algn="l">
               <a:lnSpc>
-                <a:spcPct val="112000"/>
+                <a:spcPct val="104000"/>
               </a:lnSpc>
               <a:spcBef>
-                <a:spcPts val="600"/>
+                <a:spcPts val="200"/>
+              </a:spcBef>
+              <a:spcAft>
+                <a:spcPts val="0"/>
+              </a:spcAft>
+              <a:buNone/>
+            </a:pPr>
+            <a:r>
+              <a:rPr b="1" lang="en-GB" sz="2200">
+                <a:solidFill>
+                  <a:srgbClr val="1F2926"/>
+                </a:solidFill>
+                <a:latin typeface="Google Sans Flex"/>
+                <a:ea typeface="Google Sans Flex"/>
+                <a:cs typeface="Google Sans Flex"/>
+                <a:sym typeface="Google Sans Flex"/>
+              </a:rPr>
+              <a:t>2,305</a:t>
+            </a:r>
+            <a:r>
+              <a:rPr lang="en-GB">
+                <a:solidFill>
+                  <a:srgbClr val="1F2926"/>
+                </a:solidFill>
+                <a:latin typeface="Google Sans Flex"/>
+                <a:ea typeface="Google Sans Flex"/>
+                <a:cs typeface="Google Sans Flex"/>
+                <a:sym typeface="Google Sans Flex"/>
+              </a:rPr>
+              <a:t>   reported UK cases · 2025</a:t>
+            </a:r>
+            <a:endParaRPr>
+              <a:solidFill>
+                <a:srgbClr val="1F2926"/>
+              </a:solidFill>
+              <a:latin typeface="Google Sans Flex"/>
+              <a:ea typeface="Google Sans Flex"/>
+              <a:cs typeface="Google Sans Flex"/>
+              <a:sym typeface="Google Sans Flex"/>
+            </a:endParaRPr>
+          </a:p>
+          <a:p>
+            <a:pPr indent="0" lvl="0" marL="0" rtl="0" algn="l">
+              <a:lnSpc>
+                <a:spcPct val="104000"/>
+              </a:lnSpc>
+              <a:spcBef>
+                <a:spcPts val="200"/>
+              </a:spcBef>
+              <a:spcAft>
+                <a:spcPts val="0"/>
+              </a:spcAft>
+              <a:buNone/>
+            </a:pPr>
+            <a:r>
+              <a:rPr b="1" lang="en-GB" sz="2200">
+                <a:solidFill>
+                  <a:srgbClr val="1F2926"/>
+                </a:solidFill>
+                <a:latin typeface="Google Sans Flex"/>
+                <a:ea typeface="Google Sans Flex"/>
+                <a:cs typeface="Google Sans Flex"/>
+                <a:sym typeface="Google Sans Flex"/>
+              </a:rPr>
+              <a:t>68%</a:t>
+            </a:r>
+            <a:r>
+              <a:rPr lang="en-GB">
+                <a:solidFill>
+                  <a:srgbClr val="1F2926"/>
+                </a:solidFill>
+                <a:latin typeface="Google Sans Flex"/>
+                <a:ea typeface="Google Sans Flex"/>
+                <a:cs typeface="Google Sans Flex"/>
+                <a:sym typeface="Google Sans Flex"/>
+              </a:rPr>
+              <a:t>   of loss value on business and other non-personal accounts</a:t>
+            </a:r>
+            <a:endParaRPr>
+              <a:solidFill>
+                <a:srgbClr val="1F2926"/>
+              </a:solidFill>
+              <a:latin typeface="Google Sans Flex"/>
+              <a:ea typeface="Google Sans Flex"/>
+              <a:cs typeface="Google Sans Flex"/>
+              <a:sym typeface="Google Sans Flex"/>
+            </a:endParaRPr>
+          </a:p>
+          <a:p>
+            <a:pPr indent="0" lvl="0" marL="0" rtl="0" algn="l">
+              <a:lnSpc>
+                <a:spcPct val="104000"/>
+              </a:lnSpc>
+              <a:spcBef>
+                <a:spcPts val="200"/>
               </a:spcBef>
               <a:spcAft>
                 <a:spcPts val="0"/>
@@ -10155,10 +9580,10 @@
           <a:p>
             <a:pPr indent="0" lvl="0" marL="0" rtl="0" algn="l">
               <a:lnSpc>
-                <a:spcPct val="112000"/>
+                <a:spcPct val="104000"/>
               </a:lnSpc>
               <a:spcBef>
-                <a:spcPts val="600"/>
+                <a:spcPts val="200"/>
               </a:spcBef>
               <a:spcAft>
                 <a:spcPts val="0"/>
@@ -10175,7 +9600,7 @@
                 <a:cs typeface="Google Sans Flex"/>
                 <a:sym typeface="Google Sans Flex"/>
               </a:rPr>
-              <a:t>ScamShield extracts candidate fields for human review, then compares the confirmed destination with a known vendor record. Deterministic policy returns Continue, Verify or Review with evidence.</a:t>
+              <a:t>Semantic context plus transaction checks can surface risky invoice instructions before payment.</a:t>
             </a:r>
             <a:endParaRPr>
               <a:solidFill>
@@ -10190,57 +9615,38 @@
           <a:p>
             <a:pPr indent="0" lvl="0" marL="0" rtl="0" algn="l">
               <a:lnSpc>
-                <a:spcPct val="112000"/>
+                <a:spcPct val="104000"/>
               </a:lnSpc>
               <a:spcBef>
-                <a:spcPts val="600"/>
-              </a:spcBef>
-              <a:spcAft>
-                <a:spcPts val="0"/>
+                <a:spcPts val="200"/>
+              </a:spcBef>
+              <a:spcAft>
+                <a:spcPts val="200"/>
               </a:spcAft>
               <a:buNone/>
             </a:pPr>
             <a:r>
-              <a:t/>
-            </a:r>
-            <a:endParaRPr>
-              <a:solidFill>
-                <a:srgbClr val="1F2926"/>
-              </a:solidFill>
-              <a:latin typeface="Google Sans Flex"/>
-              <a:ea typeface="Google Sans Flex"/>
-              <a:cs typeface="Google Sans Flex"/>
-              <a:sym typeface="Google Sans Flex"/>
-            </a:endParaRPr>
-          </a:p>
-          <a:p>
-            <a:pPr indent="0" lvl="0" marL="0" rtl="0" algn="l">
-              <a:lnSpc>
-                <a:spcPct val="112000"/>
-              </a:lnSpc>
-              <a:spcBef>
-                <a:spcPts val="600"/>
-              </a:spcBef>
-              <a:spcAft>
-                <a:spcPts val="600"/>
-              </a:spcAft>
-              <a:buNone/>
-            </a:pPr>
-            <a:r>
-              <a:rPr lang="en-GB">
+              <a:rPr lang="en-GB" sz="900" u="sng">
                 <a:solidFill>
-                  <a:srgbClr val="1F2926"/>
+                  <a:srgbClr val="14428C"/>
                 </a:solidFill>
                 <a:latin typeface="Google Sans Flex"/>
                 <a:ea typeface="Google Sans Flex"/>
                 <a:cs typeface="Google Sans Flex"/>
                 <a:sym typeface="Google Sans Flex"/>
+                <a:hlinkClick r:id="rId5">
+                  <a:extLst>
+                    <a:ext uri="{A12FA001-AC4F-418D-AE19-62706E023703}">
+                      <ahyp:hlinkClr val="tx"/>
+                    </a:ext>
+                  </a:extLst>
+                </a:hlinkClick>
               </a:rPr>
-              <a:t>LIVE PROTOTYPE  Two synthetic invoice flows ran on the public service. Gemini extracts fields and classifies context. On request, it ranks saved evidence; deterministic templates render the explanation. No payment is executed.</a:t>
+              <a:t>Source: UK Finance, Fraud Report 2026, p. 41.</a:t>
             </a:r>
-            <a:endParaRPr>
+            <a:endParaRPr sz="900" u="sng">
               <a:solidFill>
-                <a:srgbClr val="1F2926"/>
+                <a:srgbClr val="14428C"/>
               </a:solidFill>
               <a:latin typeface="Google Sans Flex"/>
               <a:ea typeface="Google Sans Flex"/>
@@ -10263,7 +9669,7 @@
   <p:cSld>
     <p:spTree>
       <p:nvGrpSpPr>
-        <p:cNvPr id="76" name="Shape 76"/>
+        <p:cNvPr id="77" name="Shape 77"/>
         <p:cNvGrpSpPr/>
         <p:nvPr/>
       </p:nvGrpSpPr>
@@ -10277,7 +9683,7 @@
       </p:grpSpPr>
       <p:pic>
         <p:nvPicPr>
-          <p:cNvPr id="77" name="Google Shape;77;p16" title="Frame 144.png"/>
+          <p:cNvPr id="78" name="Google Shape;78;p16" title="Frame 144.png"/>
           <p:cNvPicPr preferRelativeResize="0"/>
           <p:nvPr/>
         </p:nvPicPr>
@@ -10304,7 +9710,7 @@
       </p:pic>
       <p:pic>
         <p:nvPicPr>
-          <p:cNvPr id="78" name="Google Shape;78;p16" title="Group 427319979.png"/>
+          <p:cNvPr id="79" name="Google Shape;79;p16" title="Group 427319979.png"/>
           <p:cNvPicPr preferRelativeResize="0"/>
           <p:nvPr/>
         </p:nvPicPr>
@@ -10332,7 +9738,7 @@
       </p:pic>
       <p:sp>
         <p:nvSpPr>
-          <p:cNvPr id="79" name="Google Shape;79;p16"/>
+          <p:cNvPr id="80" name="Google Shape;80;p16"/>
           <p:cNvSpPr/>
           <p:nvPr/>
         </p:nvSpPr>
@@ -10370,86 +9776,6 @@
               <a:t/>
             </a:r>
             <a:endParaRPr/>
-          </a:p>
-        </p:txBody>
-      </p:sp>
-      <p:sp>
-        <p:nvSpPr>
-          <p:cNvPr id="80" name="Google Shape;80;p16"/>
-          <p:cNvSpPr txBox="1"/>
-          <p:nvPr/>
-        </p:nvSpPr>
-        <p:spPr>
-          <a:xfrm>
-            <a:off x="265350" y="663825"/>
-            <a:ext cx="8943000" cy="1366200"/>
-          </a:xfrm>
-          <a:prstGeom prst="rect">
-            <a:avLst/>
-          </a:prstGeom>
-          <a:noFill/>
-          <a:ln>
-            <a:noFill/>
-          </a:ln>
-        </p:spPr>
-        <p:txBody>
-          <a:bodyPr anchorCtr="0" anchor="t" bIns="91425" lIns="91425" spcFirstLastPara="1" rIns="91425" wrap="square" tIns="91425">
-            <a:noAutofit/>
-          </a:bodyPr>
-          <a:lstStyle/>
-          <a:p>
-            <a:pPr indent="0" lvl="0" marL="0" rtl="0" algn="l">
-              <a:spcBef>
-                <a:spcPts val="0"/>
-              </a:spcBef>
-              <a:spcAft>
-                <a:spcPts val="0"/>
-              </a:spcAft>
-              <a:buNone/>
-            </a:pPr>
-            <a:r>
-              <a:rPr lang="en-GB" sz="1600">
-                <a:latin typeface="Google Sans Flex SemiBold"/>
-                <a:ea typeface="Google Sans Flex SemiBold"/>
-                <a:cs typeface="Google Sans Flex SemiBold"/>
-                <a:sym typeface="Google Sans Flex SemiBold"/>
-              </a:rPr>
-              <a:t>Opportunities</a:t>
-            </a:r>
-            <a:br>
-              <a:rPr lang="en-GB" sz="1600">
-                <a:latin typeface="Google Sans Flex SemiBold"/>
-                <a:ea typeface="Google Sans Flex SemiBold"/>
-                <a:cs typeface="Google Sans Flex SemiBold"/>
-                <a:sym typeface="Google Sans Flex SemiBold"/>
-              </a:rPr>
-            </a:br>
-            <a:endParaRPr sz="1600">
-              <a:latin typeface="Google Sans Flex SemiBold"/>
-              <a:ea typeface="Google Sans Flex SemiBold"/>
-              <a:cs typeface="Google Sans Flex SemiBold"/>
-              <a:sym typeface="Google Sans Flex SemiBold"/>
-            </a:endParaRPr>
-          </a:p>
-          <a:p>
-            <a:pPr indent="0" lvl="0" marL="0" rtl="0" algn="l">
-              <a:spcBef>
-                <a:spcPts val="0"/>
-              </a:spcBef>
-              <a:spcAft>
-                <a:spcPts val="0"/>
-              </a:spcAft>
-              <a:buNone/>
-            </a:pPr>
-            <a:r>
-              <a:t/>
-            </a:r>
-            <a:endParaRPr sz="1600">
-              <a:latin typeface="Google Sans Flex Medium"/>
-              <a:ea typeface="Google Sans Flex Medium"/>
-              <a:cs typeface="Google Sans Flex Medium"/>
-              <a:sym typeface="Google Sans Flex Medium"/>
-            </a:endParaRPr>
           </a:p>
         </p:txBody>
       </p:sp>
@@ -10461,7 +9787,59 @@
         </p:nvSpPr>
         <p:spPr>
           <a:xfrm>
-            <a:off x="381000" y="1524000"/>
+            <a:off x="265350" y="663825"/>
+            <a:ext cx="8943000" cy="561900"/>
+          </a:xfrm>
+          <a:prstGeom prst="rect">
+            <a:avLst/>
+          </a:prstGeom>
+          <a:noFill/>
+          <a:ln>
+            <a:noFill/>
+          </a:ln>
+        </p:spPr>
+        <p:txBody>
+          <a:bodyPr anchorCtr="0" anchor="t" bIns="91425" lIns="91425" spcFirstLastPara="1" rIns="91425" wrap="square" tIns="91425">
+            <a:noAutofit/>
+          </a:bodyPr>
+          <a:lstStyle/>
+          <a:p>
+            <a:pPr indent="0" lvl="0" marL="0" rtl="0" algn="l">
+              <a:spcBef>
+                <a:spcPts val="0"/>
+              </a:spcBef>
+              <a:spcAft>
+                <a:spcPts val="0"/>
+              </a:spcAft>
+              <a:buNone/>
+            </a:pPr>
+            <a:r>
+              <a:rPr lang="en-GB" sz="1600">
+                <a:latin typeface="Google Sans Flex Medium"/>
+                <a:ea typeface="Google Sans Flex Medium"/>
+                <a:cs typeface="Google Sans Flex Medium"/>
+                <a:sym typeface="Google Sans Flex Medium"/>
+              </a:rPr>
+              <a:t>Solution features</a:t>
+            </a:r>
+            <a:endParaRPr sz="1600">
+              <a:latin typeface="Google Sans Flex Medium"/>
+              <a:ea typeface="Google Sans Flex Medium"/>
+              <a:cs typeface="Google Sans Flex Medium"/>
+              <a:sym typeface="Google Sans Flex Medium"/>
+            </a:endParaRPr>
+          </a:p>
+        </p:txBody>
+      </p:sp>
+      <p:sp>
+        <p:nvSpPr>
+          <p:cNvPr id="82" name="Google Shape;82;p16"/>
+          <p:cNvSpPr txBox="1"/>
+          <p:nvPr/>
+        </p:nvSpPr>
+        <p:spPr>
+          <a:xfrm>
+            <a:off x="381000" y="1320800"/>
             <a:ext cx="8382000" cy="3365400"/>
           </a:xfrm>
           <a:prstGeom prst="rect">
@@ -10500,7 +9878,7 @@
                 <a:cs typeface="Google Sans Flex"/>
                 <a:sym typeface="Google Sans Flex"/>
               </a:rPr>
-              <a:t>DIFFERENTIATION</a:t>
+              <a:t>MODEL-READ SEMANTIC SIGNALS</a:t>
             </a:r>
             <a:endParaRPr>
               <a:solidFill>
@@ -10535,7 +9913,7 @@
                 <a:cs typeface="Google Sans Flex"/>
                 <a:sym typeface="Google Sans Flex"/>
               </a:rPr>
-              <a:t>Invoice instructions are reviewed alongside the saved vendor destination before a simulated decision.</a:t>
+              <a:t>Gemini classifies impersonation, safe-account claims, urgency, secrecy, upfront fees and verification bypass. For invoices, it also extracts candidate fields for a person to confirm.</a:t>
             </a:r>
             <a:endParaRPr>
               <a:solidFill>
@@ -10596,7 +9974,7 @@
                 <a:cs typeface="Google Sans Flex"/>
                 <a:sym typeface="Google Sans Flex"/>
               </a:rPr>
-              <a:t>HOW IT HELPS</a:t>
+              <a:t>DETERMINISTIC TRANSACTION CHECKS</a:t>
             </a:r>
             <a:endParaRPr>
               <a:solidFill>
@@ -10631,7 +10009,7 @@
                 <a:cs typeface="Google Sans Flex"/>
                 <a:sym typeface="Google Sans Flex"/>
               </a:rPr>
-              <a:t>Vertex Gemini extracts invoice fields and classifies request context. A person reviews and confirms invoice details. Deterministic rules compare the destination with vendor details and show anomalies or missing checks.</a:t>
+              <a:t>Rules compare amount, payment history, vendor identity and destination account with available case and vendor records.</a:t>
             </a:r>
             <a:endParaRPr>
               <a:solidFill>
@@ -10692,7 +10070,7 @@
                 <a:cs typeface="Google Sans Flex"/>
                 <a:sym typeface="Google Sans Flex"/>
               </a:rPr>
-              <a:t>USP</a:t>
+              <a:t>POLICY OUTCOMES</a:t>
             </a:r>
             <a:endParaRPr>
               <a:solidFill>
@@ -10727,7 +10105,7 @@
                 <a:cs typeface="Google Sans Flex"/>
                 <a:sym typeface="Google Sans Flex"/>
               </a:rPr>
-              <a:t>The policy decision stays separate from model output. Requested explanations use Gemini-ranked saved evidence and deterministic templates.</a:t>
+              <a:t>A deterministic policy maps the combined evidence to Continue, Verify or Review. Evidence and missing checks are saved with the case.</a:t>
             </a:r>
             <a:endParaRPr>
               <a:solidFill>
@@ -10754,7 +10132,7 @@
   <p:cSld>
     <p:spTree>
       <p:nvGrpSpPr>
-        <p:cNvPr id="85" name="Shape 85"/>
+        <p:cNvPr id="86" name="Shape 86"/>
         <p:cNvGrpSpPr/>
         <p:nvPr/>
       </p:nvGrpSpPr>
@@ -10768,7 +10146,7 @@
       </p:grpSpPr>
       <p:pic>
         <p:nvPicPr>
-          <p:cNvPr id="86" name="Google Shape;86;p17" title="Frame 144.png"/>
+          <p:cNvPr id="87" name="Google Shape;87;p17" title="Frame 144.png"/>
           <p:cNvPicPr preferRelativeResize="0"/>
           <p:nvPr/>
         </p:nvPicPr>
@@ -10795,7 +10173,7 @@
       </p:pic>
       <p:pic>
         <p:nvPicPr>
-          <p:cNvPr id="87" name="Google Shape;87;p17" title="Group 427319979.png"/>
+          <p:cNvPr id="88" name="Google Shape;88;p17" title="Group 427319979.png"/>
           <p:cNvPicPr preferRelativeResize="0"/>
           <p:nvPr/>
         </p:nvPicPr>
@@ -10823,7 +10201,7 @@
       </p:pic>
       <p:sp>
         <p:nvSpPr>
-          <p:cNvPr id="88" name="Google Shape;88;p17"/>
+          <p:cNvPr id="89" name="Google Shape;89;p17"/>
           <p:cNvSpPr/>
           <p:nvPr/>
         </p:nvSpPr>
@@ -10866,479 +10244,7 @@
       </p:sp>
       <p:sp>
         <p:nvSpPr>
-          <p:cNvPr id="89" name="Google Shape;89;p17"/>
-          <p:cNvSpPr txBox="1"/>
-          <p:nvPr/>
-        </p:nvSpPr>
-        <p:spPr>
-          <a:xfrm>
-            <a:off x="265350" y="663825"/>
-            <a:ext cx="8943000" cy="561900"/>
-          </a:xfrm>
-          <a:prstGeom prst="rect">
-            <a:avLst/>
-          </a:prstGeom>
-          <a:noFill/>
-          <a:ln>
-            <a:noFill/>
-          </a:ln>
-        </p:spPr>
-        <p:txBody>
-          <a:bodyPr anchorCtr="0" anchor="t" bIns="91425" lIns="91425" spcFirstLastPara="1" rIns="91425" wrap="square" tIns="91425">
-            <a:noAutofit/>
-          </a:bodyPr>
-          <a:lstStyle/>
-          <a:p>
-            <a:pPr indent="0" lvl="0" marL="0" rtl="0" algn="l">
-              <a:spcBef>
-                <a:spcPts val="0"/>
-              </a:spcBef>
-              <a:spcAft>
-                <a:spcPts val="0"/>
-              </a:spcAft>
-              <a:buNone/>
-            </a:pPr>
-            <a:r>
-              <a:rPr lang="en-GB" sz="1600">
-                <a:latin typeface="Google Sans Flex Medium"/>
-                <a:ea typeface="Google Sans Flex Medium"/>
-                <a:cs typeface="Google Sans Flex Medium"/>
-                <a:sym typeface="Google Sans Flex Medium"/>
-              </a:rPr>
-              <a:t>Solution features</a:t>
-            </a:r>
-            <a:endParaRPr sz="1600">
-              <a:latin typeface="Google Sans Flex Medium"/>
-              <a:ea typeface="Google Sans Flex Medium"/>
-              <a:cs typeface="Google Sans Flex Medium"/>
-              <a:sym typeface="Google Sans Flex Medium"/>
-            </a:endParaRPr>
-          </a:p>
-        </p:txBody>
-      </p:sp>
-      <p:sp>
-        <p:nvSpPr>
           <p:cNvPr id="90" name="Google Shape;90;p17"/>
-          <p:cNvSpPr txBox="1"/>
-          <p:nvPr/>
-        </p:nvSpPr>
-        <p:spPr>
-          <a:xfrm>
-            <a:off x="381000" y="1320800"/>
-            <a:ext cx="8382000" cy="3365400"/>
-          </a:xfrm>
-          <a:prstGeom prst="rect">
-            <a:avLst/>
-          </a:prstGeom>
-          <a:noFill/>
-          <a:ln>
-            <a:noFill/>
-          </a:ln>
-        </p:spPr>
-        <p:txBody>
-          <a:bodyPr anchorCtr="0" anchor="t" bIns="91425" lIns="91425" spcFirstLastPara="1" rIns="91425" wrap="square" tIns="91425">
-            <a:noAutofit/>
-          </a:bodyPr>
-          <a:lstStyle/>
-          <a:p>
-            <a:pPr indent="0" lvl="0" marL="0" rtl="0" algn="l">
-              <a:lnSpc>
-                <a:spcPct val="112000"/>
-              </a:lnSpc>
-              <a:spcBef>
-                <a:spcPts val="0"/>
-              </a:spcBef>
-              <a:spcAft>
-                <a:spcPts val="0"/>
-              </a:spcAft>
-              <a:buNone/>
-            </a:pPr>
-            <a:r>
-              <a:rPr lang="en-GB">
-                <a:solidFill>
-                  <a:srgbClr val="1F2926"/>
-                </a:solidFill>
-                <a:latin typeface="Google Sans Flex"/>
-                <a:ea typeface="Google Sans Flex"/>
-                <a:cs typeface="Google Sans Flex"/>
-                <a:sym typeface="Google Sans Flex"/>
-              </a:rPr>
-              <a:t>CURRENT PROTOTYPE</a:t>
-            </a:r>
-            <a:endParaRPr>
-              <a:solidFill>
-                <a:srgbClr val="1F2926"/>
-              </a:solidFill>
-              <a:latin typeface="Google Sans Flex"/>
-              <a:ea typeface="Google Sans Flex"/>
-              <a:cs typeface="Google Sans Flex"/>
-              <a:sym typeface="Google Sans Flex"/>
-            </a:endParaRPr>
-          </a:p>
-          <a:p>
-            <a:pPr indent="0" lvl="0" marL="0" rtl="0" algn="l">
-              <a:lnSpc>
-                <a:spcPct val="112000"/>
-              </a:lnSpc>
-              <a:spcBef>
-                <a:spcPts val="600"/>
-              </a:spcBef>
-              <a:spcAft>
-                <a:spcPts val="0"/>
-              </a:spcAft>
-              <a:buNone/>
-            </a:pPr>
-            <a:r>
-              <a:rPr lang="en-GB">
-                <a:solidFill>
-                  <a:srgbClr val="1F2926"/>
-                </a:solidFill>
-                <a:latin typeface="Google Sans Flex"/>
-                <a:ea typeface="Google Sans Flex"/>
-                <a:cs typeface="Google Sans Flex"/>
-                <a:sym typeface="Google Sans Flex"/>
-              </a:rPr>
-              <a:t>Synthetic consumer UPI and vendor-invoice assessments in INR</a:t>
-            </a:r>
-            <a:endParaRPr>
-              <a:solidFill>
-                <a:srgbClr val="1F2926"/>
-              </a:solidFill>
-              <a:latin typeface="Google Sans Flex"/>
-              <a:ea typeface="Google Sans Flex"/>
-              <a:cs typeface="Google Sans Flex"/>
-              <a:sym typeface="Google Sans Flex"/>
-            </a:endParaRPr>
-          </a:p>
-          <a:p>
-            <a:pPr indent="0" lvl="0" marL="0" rtl="0" algn="l">
-              <a:lnSpc>
-                <a:spcPct val="112000"/>
-              </a:lnSpc>
-              <a:spcBef>
-                <a:spcPts val="600"/>
-              </a:spcBef>
-              <a:spcAft>
-                <a:spcPts val="0"/>
-              </a:spcAft>
-              <a:buNone/>
-            </a:pPr>
-            <a:r>
-              <a:rPr lang="en-GB">
-                <a:solidFill>
-                  <a:srgbClr val="1F2926"/>
-                </a:solidFill>
-                <a:latin typeface="Google Sans Flex"/>
-                <a:ea typeface="Google Sans Flex"/>
-                <a:cs typeface="Google Sans Flex"/>
-                <a:sym typeface="Google Sans Flex"/>
-              </a:rPr>
-              <a:t>Shared FastAPI assessment engine with deterministic rules and context classification</a:t>
-            </a:r>
-            <a:endParaRPr>
-              <a:solidFill>
-                <a:srgbClr val="1F2926"/>
-              </a:solidFill>
-              <a:latin typeface="Google Sans Flex"/>
-              <a:ea typeface="Google Sans Flex"/>
-              <a:cs typeface="Google Sans Flex"/>
-              <a:sym typeface="Google Sans Flex"/>
-            </a:endParaRPr>
-          </a:p>
-          <a:p>
-            <a:pPr indent="0" lvl="0" marL="0" rtl="0" algn="l">
-              <a:lnSpc>
-                <a:spcPct val="112000"/>
-              </a:lnSpc>
-              <a:spcBef>
-                <a:spcPts val="600"/>
-              </a:spcBef>
-              <a:spcAft>
-                <a:spcPts val="0"/>
-              </a:spcAft>
-              <a:buNone/>
-            </a:pPr>
-            <a:r>
-              <a:rPr lang="en-GB">
-                <a:solidFill>
-                  <a:srgbClr val="1F2926"/>
-                </a:solidFill>
-                <a:latin typeface="Google Sans Flex"/>
-                <a:ea typeface="Google Sans Flex"/>
-                <a:cs typeface="Google Sans Flex"/>
-                <a:sym typeface="Google Sans Flex"/>
-              </a:rPr>
-              <a:t>Vertex Gemini extracts invoice fields and classifies request context</a:t>
-            </a:r>
-            <a:endParaRPr>
-              <a:solidFill>
-                <a:srgbClr val="1F2926"/>
-              </a:solidFill>
-              <a:latin typeface="Google Sans Flex"/>
-              <a:ea typeface="Google Sans Flex"/>
-              <a:cs typeface="Google Sans Flex"/>
-              <a:sym typeface="Google Sans Flex"/>
-            </a:endParaRPr>
-          </a:p>
-          <a:p>
-            <a:pPr indent="0" lvl="0" marL="0" rtl="0" algn="l">
-              <a:lnSpc>
-                <a:spcPct val="112000"/>
-              </a:lnSpc>
-              <a:spcBef>
-                <a:spcPts val="600"/>
-              </a:spcBef>
-              <a:spcAft>
-                <a:spcPts val="0"/>
-              </a:spcAft>
-              <a:buNone/>
-            </a:pPr>
-            <a:r>
-              <a:rPr lang="en-GB">
-                <a:solidFill>
-                  <a:srgbClr val="1F2926"/>
-                </a:solidFill>
-                <a:latin typeface="Google Sans Flex"/>
-                <a:ea typeface="Google Sans Flex"/>
-                <a:cs typeface="Google Sans Flex"/>
-                <a:sym typeface="Google Sans Flex"/>
-              </a:rPr>
-              <a:t>Case history stores evidence, missing checks and provider status</a:t>
-            </a:r>
-            <a:endParaRPr>
-              <a:solidFill>
-                <a:srgbClr val="1F2926"/>
-              </a:solidFill>
-              <a:latin typeface="Google Sans Flex"/>
-              <a:ea typeface="Google Sans Flex"/>
-              <a:cs typeface="Google Sans Flex"/>
-              <a:sym typeface="Google Sans Flex"/>
-            </a:endParaRPr>
-          </a:p>
-          <a:p>
-            <a:pPr indent="0" lvl="0" marL="0" rtl="0" algn="l">
-              <a:lnSpc>
-                <a:spcPct val="112000"/>
-              </a:lnSpc>
-              <a:spcBef>
-                <a:spcPts val="600"/>
-              </a:spcBef>
-              <a:spcAft>
-                <a:spcPts val="0"/>
-              </a:spcAft>
-              <a:buNone/>
-            </a:pPr>
-            <a:r>
-              <a:t/>
-            </a:r>
-            <a:endParaRPr>
-              <a:solidFill>
-                <a:srgbClr val="1F2926"/>
-              </a:solidFill>
-              <a:latin typeface="Google Sans Flex"/>
-              <a:ea typeface="Google Sans Flex"/>
-              <a:cs typeface="Google Sans Flex"/>
-              <a:sym typeface="Google Sans Flex"/>
-            </a:endParaRPr>
-          </a:p>
-          <a:p>
-            <a:pPr indent="0" lvl="0" marL="0" rtl="0" algn="l">
-              <a:lnSpc>
-                <a:spcPct val="112000"/>
-              </a:lnSpc>
-              <a:spcBef>
-                <a:spcPts val="600"/>
-              </a:spcBef>
-              <a:spcAft>
-                <a:spcPts val="0"/>
-              </a:spcAft>
-              <a:buNone/>
-            </a:pPr>
-            <a:r>
-              <a:rPr lang="en-GB">
-                <a:solidFill>
-                  <a:srgbClr val="1F2926"/>
-                </a:solidFill>
-                <a:latin typeface="Google Sans Flex"/>
-                <a:ea typeface="Google Sans Flex"/>
-                <a:cs typeface="Google Sans Flex"/>
-                <a:sym typeface="Google Sans Flex"/>
-              </a:rPr>
-              <a:t>CLOUD SERVICES</a:t>
-            </a:r>
-            <a:endParaRPr>
-              <a:solidFill>
-                <a:srgbClr val="1F2926"/>
-              </a:solidFill>
-              <a:latin typeface="Google Sans Flex"/>
-              <a:ea typeface="Google Sans Flex"/>
-              <a:cs typeface="Google Sans Flex"/>
-              <a:sym typeface="Google Sans Flex"/>
-            </a:endParaRPr>
-          </a:p>
-          <a:p>
-            <a:pPr indent="0" lvl="0" marL="0" rtl="0" algn="l">
-              <a:lnSpc>
-                <a:spcPct val="112000"/>
-              </a:lnSpc>
-              <a:spcBef>
-                <a:spcPts val="600"/>
-              </a:spcBef>
-              <a:spcAft>
-                <a:spcPts val="600"/>
-              </a:spcAft>
-              <a:buNone/>
-            </a:pPr>
-            <a:r>
-              <a:rPr lang="en-GB">
-                <a:solidFill>
-                  <a:srgbClr val="1F2926"/>
-                </a:solidFill>
-                <a:latin typeface="Google Sans Flex"/>
-                <a:ea typeface="Google Sans Flex"/>
-                <a:cs typeface="Google Sans Flex"/>
-                <a:sym typeface="Google Sans Flex"/>
-              </a:rPr>
-              <a:t>Cloud Run, Firebase anonymous authentication and Firestore support the live demo. The prototype simulates decisions; no payment is executed.</a:t>
-            </a:r>
-            <a:endParaRPr>
-              <a:solidFill>
-                <a:srgbClr val="1F2926"/>
-              </a:solidFill>
-              <a:latin typeface="Google Sans Flex"/>
-              <a:ea typeface="Google Sans Flex"/>
-              <a:cs typeface="Google Sans Flex"/>
-              <a:sym typeface="Google Sans Flex"/>
-            </a:endParaRPr>
-          </a:p>
-        </p:txBody>
-      </p:sp>
-    </p:spTree>
-  </p:cSld>
-  <p:clrMapOvr>
-    <a:masterClrMapping/>
-  </p:clrMapOvr>
-</p:sld>
-</file>
-
-<file path=ppt/slides/slide6.xml><?xml version="1.0" encoding="utf-8"?>
-<p:sld xmlns:a="http://schemas.openxmlformats.org/drawingml/2006/main" xmlns:r="http://schemas.openxmlformats.org/officeDocument/2006/relationships" xmlns:mc="http://schemas.openxmlformats.org/markup-compatibility/2006" xmlns:mv="urn:schemas-microsoft-com:mac:vml" xmlns:p="http://schemas.openxmlformats.org/presentationml/2006/main" xmlns:c="http://schemas.openxmlformats.org/drawingml/2006/chart" xmlns:dgm="http://schemas.openxmlformats.org/drawingml/2006/diagram" xmlns:o="urn:schemas-microsoft-com:office:office" xmlns:v="urn:schemas-microsoft-com:vml" xmlns:pvml="urn:schemas-microsoft-com:office:powerpoint" xmlns:com="http://schemas.openxmlformats.org/drawingml/2006/compatibility" xmlns:p14="http://schemas.microsoft.com/office/powerpoint/2010/main" xmlns:p15="http://schemas.microsoft.com/office/powerpoint/2012/main" xmlns:ahyp="http://schemas.microsoft.com/office/drawing/2018/hyperlinkcolor">
-  <p:cSld>
-    <p:spTree>
-      <p:nvGrpSpPr>
-        <p:cNvPr id="94" name="Shape 94"/>
-        <p:cNvGrpSpPr/>
-        <p:nvPr/>
-      </p:nvGrpSpPr>
-      <p:grpSpPr>
-        <a:xfrm>
-          <a:off x="0" y="0"/>
-          <a:ext cx="0" cy="0"/>
-          <a:chOff x="0" y="0"/>
-          <a:chExt cx="0" cy="0"/>
-        </a:xfrm>
-      </p:grpSpPr>
-      <p:pic>
-        <p:nvPicPr>
-          <p:cNvPr id="95" name="Google Shape;95;p18" title="Frame 144.png"/>
-          <p:cNvPicPr preferRelativeResize="0"/>
-          <p:nvPr/>
-        </p:nvPicPr>
-        <p:blipFill rotWithShape="1">
-          <a:blip r:embed="rId3">
-            <a:alphaModFix/>
-          </a:blip>
-          <a:srcRect b="98001" l="0" r="0" t="0"/>
-          <a:stretch/>
-        </p:blipFill>
-        <p:spPr>
-          <a:xfrm>
-            <a:off x="0" y="5093562"/>
-            <a:ext cx="9144000" cy="54275"/>
-          </a:xfrm>
-          <a:prstGeom prst="rect">
-            <a:avLst/>
-          </a:prstGeom>
-          <a:noFill/>
-          <a:ln>
-            <a:noFill/>
-          </a:ln>
-        </p:spPr>
-      </p:pic>
-      <p:pic>
-        <p:nvPicPr>
-          <p:cNvPr id="96" name="Google Shape;96;p18" title="Group 427319979.png"/>
-          <p:cNvPicPr preferRelativeResize="0"/>
-          <p:nvPr/>
-        </p:nvPicPr>
-        <p:blipFill>
-          <a:blip r:embed="rId4">
-            <a:alphaModFix/>
-          </a:blip>
-          <a:stretch>
-            <a:fillRect/>
-          </a:stretch>
-        </p:blipFill>
-        <p:spPr>
-          <a:xfrm>
-            <a:off x="0" y="1"/>
-            <a:ext cx="9144000" cy="507359"/>
-          </a:xfrm>
-          <a:prstGeom prst="rect">
-            <a:avLst/>
-          </a:prstGeom>
-          <a:noFill/>
-          <a:ln>
-            <a:noFill/>
-          </a:ln>
-        </p:spPr>
-      </p:pic>
-      <p:sp>
-        <p:nvSpPr>
-          <p:cNvPr id="97" name="Google Shape;97;p18"/>
-          <p:cNvSpPr/>
-          <p:nvPr/>
-        </p:nvSpPr>
-        <p:spPr>
-          <a:xfrm>
-            <a:off x="-29250" y="5071875"/>
-            <a:ext cx="9173400" cy="97800"/>
-          </a:xfrm>
-          <a:prstGeom prst="rect">
-            <a:avLst/>
-          </a:prstGeom>
-          <a:solidFill>
-            <a:schemeClr val="dk1"/>
-          </a:solidFill>
-          <a:ln>
-            <a:noFill/>
-          </a:ln>
-        </p:spPr>
-        <p:txBody>
-          <a:bodyPr anchorCtr="0" anchor="ctr" bIns="91425" lIns="91425" spcFirstLastPara="1" rIns="91425" wrap="square" tIns="91425">
-            <a:noAutofit/>
-          </a:bodyPr>
-          <a:lstStyle/>
-          <a:p>
-            <a:pPr indent="0" lvl="0" marL="0" rtl="0" algn="ctr">
-              <a:spcBef>
-                <a:spcPts val="0"/>
-              </a:spcBef>
-              <a:spcAft>
-                <a:spcPts val="0"/>
-              </a:spcAft>
-              <a:buNone/>
-            </a:pPr>
-            <a:r>
-              <a:t/>
-            </a:r>
-            <a:endParaRPr/>
-          </a:p>
-        </p:txBody>
-      </p:sp>
-      <p:sp>
-        <p:nvSpPr>
-          <p:cNvPr id="98" name="Google Shape;98;p18"/>
           <p:cNvSpPr txBox="1"/>
           <p:nvPr/>
         </p:nvSpPr>
@@ -11390,7 +10296,7 @@
       </p:sp>
       <p:sp>
         <p:nvSpPr>
-          <p:cNvPr id="99" name="Google Shape;99;p18"/>
+          <p:cNvPr id="91" name="Google Shape;91;p17"/>
           <p:cNvSpPr/>
           <p:nvPr/>
         </p:nvSpPr>
@@ -11461,7 +10367,7 @@
       </p:sp>
       <p:sp>
         <p:nvSpPr>
-          <p:cNvPr id="100" name="Google Shape;100;p18"/>
+          <p:cNvPr id="92" name="Google Shape;92;p17"/>
           <p:cNvSpPr/>
           <p:nvPr/>
         </p:nvSpPr>
@@ -11532,7 +10438,7 @@
       </p:sp>
       <p:sp>
         <p:nvSpPr>
-          <p:cNvPr id="101" name="Google Shape;101;p18"/>
+          <p:cNvPr id="93" name="Google Shape;93;p17"/>
           <p:cNvSpPr/>
           <p:nvPr/>
         </p:nvSpPr>
@@ -11603,7 +10509,7 @@
       </p:sp>
       <p:sp>
         <p:nvSpPr>
-          <p:cNvPr id="102" name="Google Shape;102;p18"/>
+          <p:cNvPr id="94" name="Google Shape;94;p17"/>
           <p:cNvSpPr/>
           <p:nvPr/>
         </p:nvSpPr>
@@ -11674,7 +10580,7 @@
       </p:sp>
       <p:sp>
         <p:nvSpPr>
-          <p:cNvPr id="103" name="Google Shape;103;p18"/>
+          <p:cNvPr id="95" name="Google Shape;95;p17"/>
           <p:cNvSpPr/>
           <p:nvPr/>
         </p:nvSpPr>
@@ -11780,7 +10686,7 @@
       </p:sp>
       <p:sp>
         <p:nvSpPr>
-          <p:cNvPr id="104" name="Google Shape;104;p18"/>
+          <p:cNvPr id="96" name="Google Shape;96;p17"/>
           <p:cNvSpPr/>
           <p:nvPr/>
         </p:nvSpPr>
@@ -11851,7 +10757,7 @@
       </p:sp>
       <p:cxnSp>
         <p:nvCxnSpPr>
-          <p:cNvPr id="105" name="Google Shape;105;p18"/>
+          <p:cNvPr id="97" name="Google Shape;97;p17"/>
           <p:cNvCxnSpPr/>
           <p:nvPr/>
         </p:nvCxnSpPr>
@@ -11877,7 +10783,7 @@
       </p:cxnSp>
       <p:cxnSp>
         <p:nvCxnSpPr>
-          <p:cNvPr id="106" name="Google Shape;106;p18"/>
+          <p:cNvPr id="98" name="Google Shape;98;p17"/>
           <p:cNvCxnSpPr/>
           <p:nvPr/>
         </p:nvCxnSpPr>
@@ -11903,7 +10809,7 @@
       </p:cxnSp>
       <p:cxnSp>
         <p:nvCxnSpPr>
-          <p:cNvPr id="107" name="Google Shape;107;p18"/>
+          <p:cNvPr id="99" name="Google Shape;99;p17"/>
           <p:cNvCxnSpPr/>
           <p:nvPr/>
         </p:nvCxnSpPr>
@@ -11929,7 +10835,7 @@
       </p:cxnSp>
       <p:cxnSp>
         <p:nvCxnSpPr>
-          <p:cNvPr id="108" name="Google Shape;108;p18"/>
+          <p:cNvPr id="100" name="Google Shape;100;p17"/>
           <p:cNvCxnSpPr/>
           <p:nvPr/>
         </p:nvCxnSpPr>
@@ -11955,7 +10861,7 @@
       </p:cxnSp>
       <p:cxnSp>
         <p:nvCxnSpPr>
-          <p:cNvPr id="109" name="Google Shape;109;p18"/>
+          <p:cNvPr id="101" name="Google Shape;101;p17"/>
           <p:cNvCxnSpPr/>
           <p:nvPr/>
         </p:nvCxnSpPr>
@@ -11981,7 +10887,7 @@
       </p:cxnSp>
       <p:sp>
         <p:nvSpPr>
-          <p:cNvPr id="110" name="Google Shape;110;p18"/>
+          <p:cNvPr id="102" name="Google Shape;102;p17"/>
           <p:cNvSpPr/>
           <p:nvPr/>
         </p:nvSpPr>
@@ -12052,7 +10958,7 @@
       </p:sp>
       <p:sp>
         <p:nvSpPr>
-          <p:cNvPr id="111" name="Google Shape;111;p18"/>
+          <p:cNvPr id="103" name="Google Shape;103;p17"/>
           <p:cNvSpPr/>
           <p:nvPr/>
         </p:nvSpPr>
@@ -12123,7 +11029,7 @@
       </p:sp>
       <p:cxnSp>
         <p:nvCxnSpPr>
-          <p:cNvPr id="112" name="Google Shape;112;p18"/>
+          <p:cNvPr id="104" name="Google Shape;104;p17"/>
           <p:cNvCxnSpPr/>
           <p:nvPr/>
         </p:nvCxnSpPr>
@@ -12149,7 +11055,7 @@
       </p:cxnSp>
       <p:sp>
         <p:nvSpPr>
-          <p:cNvPr id="113" name="Google Shape;113;p18"/>
+          <p:cNvPr id="105" name="Google Shape;105;p17"/>
           <p:cNvSpPr txBox="1"/>
           <p:nvPr/>
         </p:nvSpPr>
@@ -12213,12 +11119,12 @@
 </p:sld>
 </file>
 
-<file path=ppt/slides/slide7.xml><?xml version="1.0" encoding="utf-8"?>
+<file path=ppt/slides/slide6.xml><?xml version="1.0" encoding="utf-8"?>
 <p:sld xmlns:a="http://schemas.openxmlformats.org/drawingml/2006/main" xmlns:r="http://schemas.openxmlformats.org/officeDocument/2006/relationships" xmlns:mc="http://schemas.openxmlformats.org/markup-compatibility/2006" xmlns:mv="urn:schemas-microsoft-com:mac:vml" xmlns:p="http://schemas.openxmlformats.org/presentationml/2006/main" xmlns:c="http://schemas.openxmlformats.org/drawingml/2006/chart" xmlns:dgm="http://schemas.openxmlformats.org/drawingml/2006/diagram" xmlns:o="urn:schemas-microsoft-com:office:office" xmlns:v="urn:schemas-microsoft-com:vml" xmlns:pvml="urn:schemas-microsoft-com:office:powerpoint" xmlns:com="http://schemas.openxmlformats.org/drawingml/2006/compatibility" xmlns:p14="http://schemas.microsoft.com/office/powerpoint/2010/main" xmlns:p15="http://schemas.microsoft.com/office/powerpoint/2012/main" xmlns:ahyp="http://schemas.microsoft.com/office/drawing/2018/hyperlinkcolor">
   <p:cSld>
     <p:spTree>
       <p:nvGrpSpPr>
-        <p:cNvPr id="117" name="Shape 117"/>
+        <p:cNvPr id="109" name="Shape 109"/>
         <p:cNvGrpSpPr/>
         <p:nvPr/>
       </p:nvGrpSpPr>
@@ -12232,7 +11138,7 @@
       </p:grpSpPr>
       <p:pic>
         <p:nvPicPr>
-          <p:cNvPr id="118" name="Google Shape;118;p19" title="Frame 144.png"/>
+          <p:cNvPr id="110" name="Google Shape;110;p18" title="Frame 144.png"/>
           <p:cNvPicPr preferRelativeResize="0"/>
           <p:nvPr/>
         </p:nvPicPr>
@@ -12259,7 +11165,7 @@
       </p:pic>
       <p:pic>
         <p:nvPicPr>
-          <p:cNvPr id="119" name="Google Shape;119;p19" title="Group 427319979.png"/>
+          <p:cNvPr id="111" name="Google Shape;111;p18" title="Group 427319979.png"/>
           <p:cNvPicPr preferRelativeResize="0"/>
           <p:nvPr/>
         </p:nvPicPr>
@@ -12287,7 +11193,7 @@
       </p:pic>
       <p:sp>
         <p:nvSpPr>
-          <p:cNvPr id="120" name="Google Shape;120;p19"/>
+          <p:cNvPr id="112" name="Google Shape;112;p18"/>
           <p:cNvSpPr/>
           <p:nvPr/>
         </p:nvSpPr>
@@ -12330,7 +11236,7 @@
       </p:sp>
       <p:sp>
         <p:nvSpPr>
-          <p:cNvPr id="121" name="Google Shape;121;p19"/>
+          <p:cNvPr id="113" name="Google Shape;113;p18"/>
           <p:cNvSpPr txBox="1"/>
           <p:nvPr/>
         </p:nvSpPr>
@@ -12369,7 +11275,7 @@
                 <a:cs typeface="Google Sans Flex Medium"/>
                 <a:sym typeface="Google Sans Flex Medium"/>
               </a:rPr>
-              <a:t>Invoice review flow (optional)</a:t>
+              <a:t>Hybrid risk decision</a:t>
             </a:r>
             <a:endParaRPr sz="1600">
               <a:latin typeface="Google Sans Flex Medium"/>
@@ -12382,32 +11288,42 @@
       </p:sp>
       <p:sp>
         <p:nvSpPr>
-          <p:cNvPr id="122" name="Google Shape;122;p19"/>
-          <p:cNvSpPr txBox="1"/>
+          <p:cNvPr id="114" name="Google Shape;114;p18"/>
+          <p:cNvSpPr/>
           <p:nvPr/>
         </p:nvSpPr>
         <p:spPr>
           <a:xfrm>
-            <a:off x="381000" y="1320800"/>
-            <a:ext cx="8382000" cy="3365400"/>
-          </a:xfrm>
-          <a:prstGeom prst="rect">
-            <a:avLst/>
-          </a:prstGeom>
-          <a:noFill/>
-          <a:ln>
-            <a:noFill/>
+            <a:off x="431800" y="1727200"/>
+            <a:ext cx="2514600" cy="965100"/>
+          </a:xfrm>
+          <a:prstGeom prst="roundRect">
+            <a:avLst>
+              <a:gd fmla="val 16667" name="adj"/>
+            </a:avLst>
+          </a:prstGeom>
+          <a:solidFill>
+            <a:srgbClr val="E5F2ED"/>
+          </a:solidFill>
+          <a:ln cap="flat" cmpd="sng" w="9525">
+            <a:solidFill>
+              <a:srgbClr val="296157"/>
+            </a:solidFill>
+            <a:prstDash val="solid"/>
+            <a:round/>
+            <a:headEnd len="sm" w="sm" type="none"/>
+            <a:tailEnd len="sm" w="sm" type="none"/>
           </a:ln>
         </p:spPr>
         <p:txBody>
-          <a:bodyPr anchorCtr="0" anchor="t" bIns="91425" lIns="91425" spcFirstLastPara="1" rIns="91425" wrap="square" tIns="91425">
+          <a:bodyPr anchorCtr="0" anchor="ctr" bIns="91425" lIns="91425" spcFirstLastPara="1" rIns="91425" wrap="square" tIns="91425">
             <a:noAutofit/>
           </a:bodyPr>
           <a:lstStyle/>
           <a:p>
-            <a:pPr indent="0" lvl="0" marL="0" rtl="0" algn="l">
+            <a:pPr indent="0" lvl="0" marL="0" rtl="0" algn="ctr">
               <a:lnSpc>
-                <a:spcPct val="112000"/>
+                <a:spcPct val="105000"/>
               </a:lnSpc>
               <a:spcBef>
                 <a:spcPts val="0"/>
@@ -12418,7 +11334,7 @@
               <a:buNone/>
             </a:pPr>
             <a:r>
-              <a:rPr lang="en-GB">
+              <a:rPr lang="en-GB" sz="1100">
                 <a:solidFill>
                   <a:srgbClr val="1F2926"/>
                 </a:solidFill>
@@ -12427,9 +11343,9 @@
                 <a:cs typeface="Google Sans Flex"/>
                 <a:sym typeface="Google Sans Flex"/>
               </a:rPr>
-              <a:t>INVOICE REVIEW FLOW  Live synthetic cases shown on slide 11</a:t>
+              <a:t>Gemini semantic context</a:t>
             </a:r>
-            <a:endParaRPr>
+            <a:endParaRPr sz="1100">
               <a:solidFill>
                 <a:srgbClr val="1F2926"/>
               </a:solidFill>
@@ -12440,12 +11356,12 @@
             </a:endParaRPr>
           </a:p>
           <a:p>
-            <a:pPr indent="0" lvl="0" marL="0" rtl="0" algn="l">
+            <a:pPr indent="0" lvl="0" marL="0" rtl="0" algn="ctr">
               <a:lnSpc>
-                <a:spcPct val="112000"/>
+                <a:spcPct val="105000"/>
               </a:lnSpc>
               <a:spcBef>
-                <a:spcPts val="600"/>
+                <a:spcPts val="0"/>
               </a:spcBef>
               <a:spcAft>
                 <a:spcPts val="0"/>
@@ -12453,9 +11369,18 @@
               <a:buNone/>
             </a:pPr>
             <a:r>
-              <a:t/>
+              <a:rPr lang="en-GB" sz="1100">
+                <a:solidFill>
+                  <a:srgbClr val="1F2926"/>
+                </a:solidFill>
+                <a:latin typeface="Google Sans Flex"/>
+                <a:ea typeface="Google Sans Flex"/>
+                <a:cs typeface="Google Sans Flex"/>
+                <a:sym typeface="Google Sans Flex"/>
+              </a:rPr>
+              <a:t>6 signals from payment language</a:t>
             </a:r>
-            <a:endParaRPr>
+            <a:endParaRPr sz="1100">
               <a:solidFill>
                 <a:srgbClr val="1F2926"/>
               </a:solidFill>
@@ -12465,13 +11390,49 @@
               <a:sym typeface="Google Sans Flex"/>
             </a:endParaRPr>
           </a:p>
-          <a:p>
-            <a:pPr indent="0" lvl="0" marL="0" rtl="0" algn="l">
+        </p:txBody>
+      </p:sp>
+      <p:sp>
+        <p:nvSpPr>
+          <p:cNvPr id="115" name="Google Shape;115;p18"/>
+          <p:cNvSpPr/>
+          <p:nvPr/>
+        </p:nvSpPr>
+        <p:spPr>
+          <a:xfrm>
+            <a:off x="431800" y="3098800"/>
+            <a:ext cx="2514600" cy="965100"/>
+          </a:xfrm>
+          <a:prstGeom prst="roundRect">
+            <a:avLst>
+              <a:gd fmla="val 16667" name="adj"/>
+            </a:avLst>
+          </a:prstGeom>
+          <a:solidFill>
+            <a:srgbClr val="E5F2ED"/>
+          </a:solidFill>
+          <a:ln cap="flat" cmpd="sng" w="9525">
+            <a:solidFill>
+              <a:srgbClr val="296157"/>
+            </a:solidFill>
+            <a:prstDash val="solid"/>
+            <a:round/>
+            <a:headEnd len="sm" w="sm" type="none"/>
+            <a:tailEnd len="sm" w="sm" type="none"/>
+          </a:ln>
+        </p:spPr>
+        <p:txBody>
+          <a:bodyPr anchorCtr="0" anchor="ctr" bIns="91425" lIns="91425" spcFirstLastPara="1" rIns="91425" wrap="square" tIns="91425">
+            <a:noAutofit/>
+          </a:bodyPr>
+          <a:lstStyle/>
+          <a:p>
+            <a:pPr indent="0" lvl="0" marL="0" rtl="0" algn="ctr">
               <a:lnSpc>
-                <a:spcPct val="112000"/>
+                <a:spcPct val="105000"/>
               </a:lnSpc>
               <a:spcBef>
-                <a:spcPts val="600"/>
+                <a:spcPts val="0"/>
               </a:spcBef>
               <a:spcAft>
                 <a:spcPts val="0"/>
@@ -12479,7 +11440,7 @@
               <a:buNone/>
             </a:pPr>
             <a:r>
-              <a:rPr lang="en-GB">
+              <a:rPr lang="en-GB" sz="1100">
                 <a:solidFill>
                   <a:srgbClr val="1F2926"/>
                 </a:solidFill>
@@ -12488,9 +11449,9 @@
                 <a:cs typeface="Google Sans Flex"/>
                 <a:sym typeface="Google Sans Flex"/>
               </a:rPr>
-              <a:t>Input  Synthetic invoice PDF, PNG or JPEG</a:t>
+              <a:t>Transaction facts</a:t>
             </a:r>
-            <a:endParaRPr>
+            <a:endParaRPr sz="1100">
               <a:solidFill>
                 <a:srgbClr val="1F2926"/>
               </a:solidFill>
@@ -12501,12 +11462,12 @@
             </a:endParaRPr>
           </a:p>
           <a:p>
-            <a:pPr indent="0" lvl="0" marL="0" rtl="0" algn="l">
+            <a:pPr indent="0" lvl="0" marL="0" rtl="0" algn="ctr">
               <a:lnSpc>
-                <a:spcPct val="112000"/>
+                <a:spcPct val="105000"/>
               </a:lnSpc>
               <a:spcBef>
-                <a:spcPts val="600"/>
+                <a:spcPts val="0"/>
               </a:spcBef>
               <a:spcAft>
                 <a:spcPts val="0"/>
@@ -12514,7 +11475,7 @@
               <a:buNone/>
             </a:pPr>
             <a:r>
-              <a:rPr lang="en-GB">
+              <a:rPr lang="en-GB" sz="1100">
                 <a:solidFill>
                   <a:srgbClr val="1F2926"/>
                 </a:solidFill>
@@ -12523,9 +11484,9 @@
                 <a:cs typeface="Google Sans Flex"/>
                 <a:sym typeface="Google Sans Flex"/>
               </a:rPr>
-              <a:t>Extraction  Vertex Gemini returns candidate fields</a:t>
+              <a:t>Amount · history · vendor · destination</a:t>
             </a:r>
-            <a:endParaRPr>
+            <a:endParaRPr sz="1100">
               <a:solidFill>
                 <a:srgbClr val="1F2926"/>
               </a:solidFill>
@@ -12535,13 +11496,49 @@
               <a:sym typeface="Google Sans Flex"/>
             </a:endParaRPr>
           </a:p>
-          <a:p>
-            <a:pPr indent="0" lvl="0" marL="0" rtl="0" algn="l">
+        </p:txBody>
+      </p:sp>
+      <p:sp>
+        <p:nvSpPr>
+          <p:cNvPr id="116" name="Google Shape;116;p18"/>
+          <p:cNvSpPr/>
+          <p:nvPr/>
+        </p:nvSpPr>
+        <p:spPr>
+          <a:xfrm>
+            <a:off x="3708400" y="2413000"/>
+            <a:ext cx="2235300" cy="1041300"/>
+          </a:xfrm>
+          <a:prstGeom prst="roundRect">
+            <a:avLst>
+              <a:gd fmla="val 16667" name="adj"/>
+            </a:avLst>
+          </a:prstGeom>
+          <a:solidFill>
+            <a:srgbClr val="F5F2E5"/>
+          </a:solidFill>
+          <a:ln cap="flat" cmpd="sng" w="9525">
+            <a:solidFill>
+              <a:srgbClr val="296157"/>
+            </a:solidFill>
+            <a:prstDash val="solid"/>
+            <a:round/>
+            <a:headEnd len="sm" w="sm" type="none"/>
+            <a:tailEnd len="sm" w="sm" type="none"/>
+          </a:ln>
+        </p:spPr>
+        <p:txBody>
+          <a:bodyPr anchorCtr="0" anchor="ctr" bIns="91425" lIns="91425" spcFirstLastPara="1" rIns="91425" wrap="square" tIns="91425">
+            <a:noAutofit/>
+          </a:bodyPr>
+          <a:lstStyle/>
+          <a:p>
+            <a:pPr indent="0" lvl="0" marL="0" rtl="0" algn="ctr">
               <a:lnSpc>
-                <a:spcPct val="112000"/>
+                <a:spcPct val="105000"/>
               </a:lnSpc>
               <a:spcBef>
-                <a:spcPts val="600"/>
+                <a:spcPts val="0"/>
               </a:spcBef>
               <a:spcAft>
                 <a:spcPts val="0"/>
@@ -12549,7 +11546,7 @@
               <a:buNone/>
             </a:pPr>
             <a:r>
-              <a:rPr lang="en-GB">
+              <a:rPr lang="en-GB" sz="1100">
                 <a:solidFill>
                   <a:srgbClr val="1F2926"/>
                 </a:solidFill>
@@ -12558,9 +11555,9 @@
                 <a:cs typeface="Google Sans Flex"/>
                 <a:sym typeface="Google Sans Flex"/>
               </a:rPr>
-              <a:t>Human review  Confirm fields and select a vendor record</a:t>
+              <a:t>Deterministic policy</a:t>
             </a:r>
-            <a:endParaRPr>
+            <a:endParaRPr sz="1100">
               <a:solidFill>
                 <a:srgbClr val="1F2926"/>
               </a:solidFill>
@@ -12571,12 +11568,12 @@
             </a:endParaRPr>
           </a:p>
           <a:p>
-            <a:pPr indent="0" lvl="0" marL="0" rtl="0" algn="l">
+            <a:pPr indent="0" lvl="0" marL="0" rtl="0" algn="ctr">
               <a:lnSpc>
-                <a:spcPct val="112000"/>
+                <a:spcPct val="105000"/>
               </a:lnSpc>
               <a:spcBef>
-                <a:spcPts val="600"/>
+                <a:spcPts val="0"/>
               </a:spcBef>
               <a:spcAft>
                 <a:spcPts val="0"/>
@@ -12584,7 +11581,7 @@
               <a:buNone/>
             </a:pPr>
             <a:r>
-              <a:rPr lang="en-GB">
+              <a:rPr lang="en-GB" sz="1100">
                 <a:solidFill>
                   <a:srgbClr val="1F2926"/>
                 </a:solidFill>
@@ -12593,9 +11590,9 @@
                 <a:cs typeface="Google Sans Flex"/>
                 <a:sym typeface="Google Sans Flex"/>
               </a:rPr>
-              <a:t>Vendor check  Compare requested destination with the saved account</a:t>
+              <a:t>Combine available evidence</a:t>
             </a:r>
-            <a:endParaRPr>
+            <a:endParaRPr sz="1100">
               <a:solidFill>
                 <a:srgbClr val="1F2926"/>
               </a:solidFill>
@@ -12605,13 +11602,49 @@
               <a:sym typeface="Google Sans Flex"/>
             </a:endParaRPr>
           </a:p>
-          <a:p>
-            <a:pPr indent="0" lvl="0" marL="0" rtl="0" algn="l">
+        </p:txBody>
+      </p:sp>
+      <p:sp>
+        <p:nvSpPr>
+          <p:cNvPr id="117" name="Google Shape;117;p18"/>
+          <p:cNvSpPr/>
+          <p:nvPr/>
+        </p:nvSpPr>
+        <p:spPr>
+          <a:xfrm>
+            <a:off x="6680200" y="2413000"/>
+            <a:ext cx="2006700" cy="1041300"/>
+          </a:xfrm>
+          <a:prstGeom prst="roundRect">
+            <a:avLst>
+              <a:gd fmla="val 16667" name="adj"/>
+            </a:avLst>
+          </a:prstGeom>
+          <a:solidFill>
+            <a:srgbClr val="E5F2ED"/>
+          </a:solidFill>
+          <a:ln cap="flat" cmpd="sng" w="9525">
+            <a:solidFill>
+              <a:srgbClr val="296157"/>
+            </a:solidFill>
+            <a:prstDash val="solid"/>
+            <a:round/>
+            <a:headEnd len="sm" w="sm" type="none"/>
+            <a:tailEnd len="sm" w="sm" type="none"/>
+          </a:ln>
+        </p:spPr>
+        <p:txBody>
+          <a:bodyPr anchorCtr="0" anchor="ctr" bIns="91425" lIns="91425" spcFirstLastPara="1" rIns="91425" wrap="square" tIns="91425">
+            <a:noAutofit/>
+          </a:bodyPr>
+          <a:lstStyle/>
+          <a:p>
+            <a:pPr indent="0" lvl="0" marL="0" rtl="0" algn="ctr">
               <a:lnSpc>
-                <a:spcPct val="112000"/>
+                <a:spcPct val="105000"/>
               </a:lnSpc>
               <a:spcBef>
-                <a:spcPts val="600"/>
+                <a:spcPts val="0"/>
               </a:spcBef>
               <a:spcAft>
                 <a:spcPts val="0"/>
@@ -12619,7 +11652,7 @@
               <a:buNone/>
             </a:pPr>
             <a:r>
-              <a:rPr lang="en-GB">
+              <a:rPr lang="en-GB" sz="1100">
                 <a:solidFill>
                   <a:srgbClr val="1F2926"/>
                 </a:solidFill>
@@ -12628,9 +11661,9 @@
                 <a:cs typeface="Google Sans Flex"/>
                 <a:sym typeface="Google Sans Flex"/>
               </a:rPr>
-              <a:t>Context  Gemini classifies the payment request</a:t>
+              <a:t>Continue · Verify · Review</a:t>
             </a:r>
-            <a:endParaRPr>
+            <a:endParaRPr sz="1100">
               <a:solidFill>
                 <a:srgbClr val="1F2926"/>
               </a:solidFill>
@@ -12640,13 +11673,127 @@
               <a:sym typeface="Google Sans Flex"/>
             </a:endParaRPr>
           </a:p>
-          <a:p>
-            <a:pPr indent="0" lvl="0" marL="0" rtl="0" algn="l">
+        </p:txBody>
+      </p:sp>
+      <p:cxnSp>
+        <p:nvCxnSpPr>
+          <p:cNvPr id="118" name="Google Shape;118;p18"/>
+          <p:cNvCxnSpPr/>
+          <p:nvPr/>
+        </p:nvCxnSpPr>
+        <p:spPr>
+          <a:xfrm>
+            <a:off x="2946400" y="2209800"/>
+            <a:ext cx="762000" cy="495300"/>
+          </a:xfrm>
+          <a:prstGeom prst="straightConnector1">
+            <a:avLst/>
+          </a:prstGeom>
+          <a:noFill/>
+          <a:ln cap="flat" cmpd="sng" w="19050">
+            <a:solidFill>
+              <a:srgbClr val="296157"/>
+            </a:solidFill>
+            <a:prstDash val="solid"/>
+            <a:round/>
+            <a:headEnd len="med" w="med" type="none"/>
+            <a:tailEnd len="med" w="med" type="triangle"/>
+          </a:ln>
+        </p:spPr>
+      </p:cxnSp>
+      <p:cxnSp>
+        <p:nvCxnSpPr>
+          <p:cNvPr id="119" name="Google Shape;119;p18"/>
+          <p:cNvCxnSpPr/>
+          <p:nvPr/>
+        </p:nvCxnSpPr>
+        <p:spPr>
+          <a:xfrm flipH="1" rot="10800000">
+            <a:off x="2946400" y="3174900"/>
+            <a:ext cx="762000" cy="406500"/>
+          </a:xfrm>
+          <a:prstGeom prst="straightConnector1">
+            <a:avLst/>
+          </a:prstGeom>
+          <a:noFill/>
+          <a:ln cap="flat" cmpd="sng" w="19050">
+            <a:solidFill>
+              <a:srgbClr val="296157"/>
+            </a:solidFill>
+            <a:prstDash val="solid"/>
+            <a:round/>
+            <a:headEnd len="med" w="med" type="none"/>
+            <a:tailEnd len="med" w="med" type="triangle"/>
+          </a:ln>
+        </p:spPr>
+      </p:cxnSp>
+      <p:cxnSp>
+        <p:nvCxnSpPr>
+          <p:cNvPr id="120" name="Google Shape;120;p18"/>
+          <p:cNvCxnSpPr/>
+          <p:nvPr/>
+        </p:nvCxnSpPr>
+        <p:spPr>
+          <a:xfrm>
+            <a:off x="5943600" y="2933700"/>
+            <a:ext cx="736500" cy="1200"/>
+          </a:xfrm>
+          <a:prstGeom prst="straightConnector1">
+            <a:avLst/>
+          </a:prstGeom>
+          <a:noFill/>
+          <a:ln cap="flat" cmpd="sng" w="19050">
+            <a:solidFill>
+              <a:srgbClr val="296157"/>
+            </a:solidFill>
+            <a:prstDash val="solid"/>
+            <a:round/>
+            <a:headEnd len="med" w="med" type="none"/>
+            <a:tailEnd len="med" w="med" type="triangle"/>
+          </a:ln>
+        </p:spPr>
+      </p:cxnSp>
+      <p:sp>
+        <p:nvSpPr>
+          <p:cNvPr id="121" name="Google Shape;121;p18"/>
+          <p:cNvSpPr/>
+          <p:nvPr/>
+        </p:nvSpPr>
+        <p:spPr>
+          <a:xfrm>
+            <a:off x="1168400" y="4241800"/>
+            <a:ext cx="6807300" cy="507900"/>
+          </a:xfrm>
+          <a:prstGeom prst="roundRect">
+            <a:avLst>
+              <a:gd fmla="val 16667" name="adj"/>
+            </a:avLst>
+          </a:prstGeom>
+          <a:solidFill>
+            <a:srgbClr val="F5F2E5"/>
+          </a:solidFill>
+          <a:ln cap="flat" cmpd="sng" w="9525">
+            <a:solidFill>
+              <a:srgbClr val="296157"/>
+            </a:solidFill>
+            <a:prstDash val="solid"/>
+            <a:round/>
+            <a:headEnd len="sm" w="sm" type="none"/>
+            <a:tailEnd len="sm" w="sm" type="none"/>
+          </a:ln>
+        </p:spPr>
+        <p:txBody>
+          <a:bodyPr anchorCtr="0" anchor="ctr" bIns="91425" lIns="91425" spcFirstLastPara="1" rIns="91425" wrap="square" tIns="91425">
+            <a:noAutofit/>
+          </a:bodyPr>
+          <a:lstStyle/>
+          <a:p>
+            <a:pPr indent="0" lvl="0" marL="0" rtl="0" algn="ctr">
               <a:lnSpc>
-                <a:spcPct val="112000"/>
+                <a:spcPct val="105000"/>
               </a:lnSpc>
               <a:spcBef>
-                <a:spcPts val="600"/>
+                <a:spcPts val="0"/>
               </a:spcBef>
               <a:spcAft>
                 <a:spcPts val="0"/>
@@ -12654,7 +11801,7 @@
               <a:buNone/>
             </a:pPr>
             <a:r>
-              <a:rPr lang="en-GB">
+              <a:rPr lang="en-GB" sz="1100">
                 <a:solidFill>
                   <a:srgbClr val="1F2926"/>
                 </a:solidFill>
@@ -12663,9 +11810,9 @@
                 <a:cs typeface="Google Sans Flex"/>
                 <a:sym typeface="Google Sans Flex"/>
               </a:rPr>
-              <a:t>Decision  Continue, Verify or Review</a:t>
+              <a:t>Policy example: impersonation + secrecy scores each ≥ 0.8 → Review</a:t>
             </a:r>
-            <a:endParaRPr>
+            <a:endParaRPr sz="1100">
               <a:solidFill>
                 <a:srgbClr val="1F2926"/>
               </a:solidFill>
@@ -12675,13 +11822,36 @@
               <a:sym typeface="Google Sans Flex"/>
             </a:endParaRPr>
           </a:p>
+        </p:txBody>
+      </p:sp>
+      <p:sp>
+        <p:nvSpPr>
+          <p:cNvPr id="122" name="Google Shape;122;p18"/>
+          <p:cNvSpPr txBox="1"/>
+          <p:nvPr/>
+        </p:nvSpPr>
+        <p:spPr>
+          <a:xfrm>
+            <a:off x="381000" y="4787900"/>
+            <a:ext cx="8382000" cy="228600"/>
+          </a:xfrm>
+          <a:prstGeom prst="rect">
+            <a:avLst/>
+          </a:prstGeom>
+          <a:noFill/>
+          <a:ln>
+            <a:noFill/>
+          </a:ln>
+        </p:spPr>
+        <p:txBody>
+          <a:bodyPr anchorCtr="0" anchor="t" bIns="91425" lIns="91425" spcFirstLastPara="1" rIns="91425" wrap="square" tIns="91425">
+            <a:noAutofit/>
+          </a:bodyPr>
+          <a:lstStyle/>
           <a:p>
             <a:pPr indent="0" lvl="0" marL="0" rtl="0" algn="l">
-              <a:lnSpc>
-                <a:spcPct val="112000"/>
-              </a:lnSpc>
-              <a:spcBef>
-                <a:spcPts val="600"/>
+              <a:spcBef>
+                <a:spcPts val="0"/>
               </a:spcBef>
               <a:spcAft>
                 <a:spcPts val="0"/>
@@ -12689,33 +11859,7 @@
               <a:buNone/>
             </a:pPr>
             <a:r>
-              <a:t/>
-            </a:r>
-            <a:endParaRPr>
-              <a:solidFill>
-                <a:srgbClr val="1F2926"/>
-              </a:solidFill>
-              <a:latin typeface="Google Sans Flex"/>
-              <a:ea typeface="Google Sans Flex"/>
-              <a:cs typeface="Google Sans Flex"/>
-              <a:sym typeface="Google Sans Flex"/>
-            </a:endParaRPr>
-          </a:p>
-          <a:p>
-            <a:pPr indent="0" lvl="0" marL="0" rtl="0" algn="l">
-              <a:lnSpc>
-                <a:spcPct val="112000"/>
-              </a:lnSpc>
-              <a:spcBef>
-                <a:spcPts val="600"/>
-              </a:spcBef>
-              <a:spcAft>
-                <a:spcPts val="600"/>
-              </a:spcAft>
-              <a:buNone/>
-            </a:pPr>
-            <a:r>
-              <a:rPr lang="en-GB">
+              <a:rPr lang="en-GB" sz="800">
                 <a:solidFill>
                   <a:srgbClr val="1F2926"/>
                 </a:solidFill>
@@ -12724,9 +11868,9 @@
                 <a:cs typeface="Google Sans Flex"/>
                 <a:sym typeface="Google Sans Flex"/>
               </a:rPr>
-              <a:t>The changed destination case recommends Review; the normal invoice returns Continue.</a:t>
+              <a:t>Scores describe language signals, not fraud probability.</a:t>
             </a:r>
-            <a:endParaRPr>
+            <a:endParaRPr sz="800">
               <a:solidFill>
                 <a:srgbClr val="1F2926"/>
               </a:solidFill>
@@ -12746,7 +11890,7 @@
 </p:sld>
 </file>
 
-<file path=ppt/slides/slide8.xml><?xml version="1.0" encoding="utf-8"?>
+<file path=ppt/slides/slide7.xml><?xml version="1.0" encoding="utf-8"?>
 <p:sld xmlns:a="http://schemas.openxmlformats.org/drawingml/2006/main" xmlns:r="http://schemas.openxmlformats.org/officeDocument/2006/relationships" xmlns:mc="http://schemas.openxmlformats.org/markup-compatibility/2006" xmlns:mv="urn:schemas-microsoft-com:mac:vml" xmlns:p="http://schemas.openxmlformats.org/presentationml/2006/main" xmlns:c="http://schemas.openxmlformats.org/drawingml/2006/chart" xmlns:dgm="http://schemas.openxmlformats.org/drawingml/2006/diagram" xmlns:o="urn:schemas-microsoft-com:office:office" xmlns:v="urn:schemas-microsoft-com:vml" xmlns:pvml="urn:schemas-microsoft-com:office:powerpoint" xmlns:com="http://schemas.openxmlformats.org/drawingml/2006/compatibility" xmlns:p14="http://schemas.microsoft.com/office/powerpoint/2010/main" xmlns:p15="http://schemas.microsoft.com/office/powerpoint/2012/main" xmlns:ahyp="http://schemas.microsoft.com/office/drawing/2018/hyperlinkcolor">
   <p:cSld>
     <p:spTree>
@@ -12765,7 +11909,7 @@
       </p:grpSpPr>
       <p:pic>
         <p:nvPicPr>
-          <p:cNvPr id="127" name="Google Shape;127;p20" title="Frame 144.png"/>
+          <p:cNvPr id="127" name="Google Shape;127;p19" title="Frame 144.png"/>
           <p:cNvPicPr preferRelativeResize="0"/>
           <p:nvPr/>
         </p:nvPicPr>
@@ -12792,7 +11936,7 @@
       </p:pic>
       <p:pic>
         <p:nvPicPr>
-          <p:cNvPr id="128" name="Google Shape;128;p20" title="Group 427319979.png"/>
+          <p:cNvPr id="128" name="Google Shape;128;p19" title="Group 427319979.png"/>
           <p:cNvPicPr preferRelativeResize="0"/>
           <p:nvPr/>
         </p:nvPicPr>
@@ -12820,7 +11964,7 @@
       </p:pic>
       <p:sp>
         <p:nvSpPr>
-          <p:cNvPr id="129" name="Google Shape;129;p20"/>
+          <p:cNvPr id="129" name="Google Shape;129;p19"/>
           <p:cNvSpPr/>
           <p:nvPr/>
         </p:nvSpPr>
@@ -12863,7 +12007,7 @@
       </p:sp>
       <p:sp>
         <p:nvSpPr>
-          <p:cNvPr id="130" name="Google Shape;130;p20"/>
+          <p:cNvPr id="130" name="Google Shape;130;p19"/>
           <p:cNvSpPr txBox="1"/>
           <p:nvPr/>
         </p:nvSpPr>
@@ -12902,7 +12046,7 @@
                 <a:cs typeface="Google Sans Flex Medium"/>
                 <a:sym typeface="Google Sans Flex Medium"/>
               </a:rPr>
-              <a:t>Target Google Cloud architecture</a:t>
+              <a:t>Live Google Cloud architecture</a:t>
             </a:r>
             <a:endParaRPr sz="1600">
               <a:latin typeface="Google Sans Flex Medium"/>
@@ -12915,14 +12059,14 @@
       </p:sp>
       <p:sp>
         <p:nvSpPr>
-          <p:cNvPr id="131" name="Google Shape;131;p20"/>
+          <p:cNvPr id="131" name="Google Shape;131;p19"/>
           <p:cNvSpPr/>
           <p:nvPr/>
         </p:nvSpPr>
         <p:spPr>
           <a:xfrm>
-            <a:off x="381000" y="1752600"/>
-            <a:ext cx="1905000" cy="1016100"/>
+            <a:off x="381000" y="1879600"/>
+            <a:ext cx="1905000" cy="965100"/>
           </a:xfrm>
           <a:prstGeom prst="roundRect">
             <a:avLst>
@@ -12986,14 +12130,14 @@
       </p:sp>
       <p:sp>
         <p:nvSpPr>
-          <p:cNvPr id="132" name="Google Shape;132;p20"/>
+          <p:cNvPr id="132" name="Google Shape;132;p19"/>
           <p:cNvSpPr/>
           <p:nvPr/>
         </p:nvSpPr>
         <p:spPr>
           <a:xfrm>
-            <a:off x="2540000" y="1752600"/>
-            <a:ext cx="1905000" cy="1016100"/>
+            <a:off x="2844800" y="1879600"/>
+            <a:ext cx="1905000" cy="965100"/>
           </a:xfrm>
           <a:prstGeom prst="roundRect">
             <a:avLst>
@@ -13092,14 +12236,14 @@
       </p:sp>
       <p:sp>
         <p:nvSpPr>
-          <p:cNvPr id="133" name="Google Shape;133;p20"/>
+          <p:cNvPr id="133" name="Google Shape;133;p19"/>
           <p:cNvSpPr/>
           <p:nvPr/>
         </p:nvSpPr>
         <p:spPr>
           <a:xfrm>
-            <a:off x="4699000" y="1752600"/>
-            <a:ext cx="1905000" cy="1016100"/>
+            <a:off x="5308600" y="1879600"/>
+            <a:ext cx="1905000" cy="965100"/>
           </a:xfrm>
           <a:prstGeom prst="roundRect">
             <a:avLst>
@@ -13196,16 +12340,68 @@
           </a:p>
         </p:txBody>
       </p:sp>
+      <p:cxnSp>
+        <p:nvCxnSpPr>
+          <p:cNvPr id="134" name="Google Shape;134;p19"/>
+          <p:cNvCxnSpPr/>
+          <p:nvPr/>
+        </p:nvCxnSpPr>
+        <p:spPr>
+          <a:xfrm>
+            <a:off x="2286000" y="2362200"/>
+            <a:ext cx="558900" cy="1200"/>
+          </a:xfrm>
+          <a:prstGeom prst="straightConnector1">
+            <a:avLst/>
+          </a:prstGeom>
+          <a:noFill/>
+          <a:ln cap="flat" cmpd="sng" w="19050">
+            <a:solidFill>
+              <a:srgbClr val="296157"/>
+            </a:solidFill>
+            <a:prstDash val="solid"/>
+            <a:round/>
+            <a:headEnd len="med" w="med" type="none"/>
+            <a:tailEnd len="med" w="med" type="triangle"/>
+          </a:ln>
+        </p:spPr>
+      </p:cxnSp>
+      <p:cxnSp>
+        <p:nvCxnSpPr>
+          <p:cNvPr id="135" name="Google Shape;135;p19"/>
+          <p:cNvCxnSpPr/>
+          <p:nvPr/>
+        </p:nvCxnSpPr>
+        <p:spPr>
+          <a:xfrm>
+            <a:off x="4749800" y="2362200"/>
+            <a:ext cx="558900" cy="1200"/>
+          </a:xfrm>
+          <a:prstGeom prst="straightConnector1">
+            <a:avLst/>
+          </a:prstGeom>
+          <a:noFill/>
+          <a:ln cap="flat" cmpd="sng" w="19050">
+            <a:solidFill>
+              <a:srgbClr val="296157"/>
+            </a:solidFill>
+            <a:prstDash val="solid"/>
+            <a:round/>
+            <a:headEnd len="med" w="med" type="none"/>
+            <a:tailEnd len="med" w="med" type="triangle"/>
+          </a:ln>
+        </p:spPr>
+      </p:cxnSp>
       <p:sp>
         <p:nvSpPr>
-          <p:cNvPr id="134" name="Google Shape;134;p20"/>
+          <p:cNvPr id="136" name="Google Shape;136;p19"/>
           <p:cNvSpPr/>
           <p:nvPr/>
         </p:nvSpPr>
         <p:spPr>
           <a:xfrm>
-            <a:off x="6858000" y="1752600"/>
-            <a:ext cx="1905000" cy="1016100"/>
+            <a:off x="1803400" y="3479800"/>
+            <a:ext cx="2463900" cy="787500"/>
           </a:xfrm>
           <a:prstGeom prst="roundRect">
             <a:avLst>
@@ -13213,7 +12409,7 @@
             </a:avLst>
           </a:prstGeom>
           <a:solidFill>
-            <a:srgbClr val="E5F2ED"/>
+            <a:srgbClr val="F5F2E5"/>
           </a:solidFill>
           <a:ln cap="flat" cmpd="sng" w="9525">
             <a:solidFill>
@@ -13302,94 +12498,16 @@
           </a:p>
         </p:txBody>
       </p:sp>
-      <p:cxnSp>
-        <p:nvCxnSpPr>
-          <p:cNvPr id="135" name="Google Shape;135;p20"/>
-          <p:cNvCxnSpPr/>
-          <p:nvPr/>
-        </p:nvCxnSpPr>
-        <p:spPr>
-          <a:xfrm>
-            <a:off x="2286000" y="2260600"/>
-            <a:ext cx="254100" cy="1200"/>
-          </a:xfrm>
-          <a:prstGeom prst="straightConnector1">
-            <a:avLst/>
-          </a:prstGeom>
-          <a:noFill/>
-          <a:ln cap="flat" cmpd="sng" w="19050">
-            <a:solidFill>
-              <a:srgbClr val="296157"/>
-            </a:solidFill>
-            <a:prstDash val="solid"/>
-            <a:round/>
-            <a:headEnd len="med" w="med" type="none"/>
-            <a:tailEnd len="med" w="med" type="triangle"/>
-          </a:ln>
-        </p:spPr>
-      </p:cxnSp>
-      <p:cxnSp>
-        <p:nvCxnSpPr>
-          <p:cNvPr id="136" name="Google Shape;136;p20"/>
-          <p:cNvCxnSpPr/>
-          <p:nvPr/>
-        </p:nvCxnSpPr>
-        <p:spPr>
-          <a:xfrm>
-            <a:off x="4445000" y="2260600"/>
-            <a:ext cx="254100" cy="1200"/>
-          </a:xfrm>
-          <a:prstGeom prst="straightConnector1">
-            <a:avLst/>
-          </a:prstGeom>
-          <a:noFill/>
-          <a:ln cap="flat" cmpd="sng" w="19050">
-            <a:solidFill>
-              <a:srgbClr val="296157"/>
-            </a:solidFill>
-            <a:prstDash val="solid"/>
-            <a:round/>
-            <a:headEnd len="med" w="med" type="none"/>
-            <a:tailEnd len="med" w="med" type="triangle"/>
-          </a:ln>
-        </p:spPr>
-      </p:cxnSp>
-      <p:cxnSp>
-        <p:nvCxnSpPr>
-          <p:cNvPr id="137" name="Google Shape;137;p20"/>
-          <p:cNvCxnSpPr/>
-          <p:nvPr/>
-        </p:nvCxnSpPr>
-        <p:spPr>
-          <a:xfrm>
-            <a:off x="6604000" y="2260600"/>
-            <a:ext cx="254100" cy="1200"/>
-          </a:xfrm>
-          <a:prstGeom prst="straightConnector1">
-            <a:avLst/>
-          </a:prstGeom>
-          <a:noFill/>
-          <a:ln cap="flat" cmpd="sng" w="19050">
-            <a:solidFill>
-              <a:srgbClr val="296157"/>
-            </a:solidFill>
-            <a:prstDash val="solid"/>
-            <a:round/>
-            <a:headEnd len="med" w="med" type="none"/>
-            <a:tailEnd len="med" w="med" type="triangle"/>
-          </a:ln>
-        </p:spPr>
-      </p:cxnSp>
       <p:sp>
         <p:nvSpPr>
-          <p:cNvPr id="138" name="Google Shape;138;p20"/>
+          <p:cNvPr id="137" name="Google Shape;137;p19"/>
           <p:cNvSpPr/>
           <p:nvPr/>
         </p:nvSpPr>
         <p:spPr>
           <a:xfrm>
-            <a:off x="4572000" y="3302000"/>
-            <a:ext cx="2286000" cy="762000"/>
+            <a:off x="4953000" y="3479800"/>
+            <a:ext cx="2463900" cy="787500"/>
           </a:xfrm>
           <a:prstGeom prst="roundRect">
             <a:avLst>
@@ -13488,14 +12606,14 @@
       </p:sp>
       <p:cxnSp>
         <p:nvCxnSpPr>
-          <p:cNvPr id="139" name="Google Shape;139;p20"/>
+          <p:cNvPr id="138" name="Google Shape;138;p19"/>
           <p:cNvCxnSpPr/>
           <p:nvPr/>
         </p:nvCxnSpPr>
         <p:spPr>
-          <a:xfrm>
-            <a:off x="5524500" y="2768600"/>
-            <a:ext cx="190500" cy="533400"/>
+          <a:xfrm flipH="1">
+            <a:off x="3682900" y="2844800"/>
+            <a:ext cx="2578200" cy="635100"/>
           </a:xfrm>
           <a:prstGeom prst="straightConnector1">
             <a:avLst/>
@@ -13512,16 +12630,42 @@
           </a:ln>
         </p:spPr>
       </p:cxnSp>
+      <p:cxnSp>
+        <p:nvCxnSpPr>
+          <p:cNvPr id="139" name="Google Shape;139;p19"/>
+          <p:cNvCxnSpPr/>
+          <p:nvPr/>
+        </p:nvCxnSpPr>
+        <p:spPr>
+          <a:xfrm flipH="1">
+            <a:off x="6184900" y="2844800"/>
+            <a:ext cx="76200" cy="635100"/>
+          </a:xfrm>
+          <a:prstGeom prst="straightConnector1">
+            <a:avLst/>
+          </a:prstGeom>
+          <a:noFill/>
+          <a:ln cap="flat" cmpd="sng" w="19050">
+            <a:solidFill>
+              <a:srgbClr val="296157"/>
+            </a:solidFill>
+            <a:prstDash val="solid"/>
+            <a:round/>
+            <a:headEnd len="med" w="med" type="none"/>
+            <a:tailEnd len="med" w="med" type="triangle"/>
+          </a:ln>
+        </p:spPr>
+      </p:cxnSp>
       <p:sp>
         <p:nvSpPr>
-          <p:cNvPr id="140" name="Google Shape;140;p20"/>
+          <p:cNvPr id="140" name="Google Shape;140;p19"/>
           <p:cNvSpPr txBox="1"/>
           <p:nvPr/>
         </p:nvSpPr>
         <p:spPr>
           <a:xfrm>
-            <a:off x="381000" y="4279900"/>
-            <a:ext cx="8382000" cy="609600"/>
+            <a:off x="381000" y="4394200"/>
+            <a:ext cx="8382000" cy="457200"/>
           </a:xfrm>
           <a:prstGeom prst="rect">
             <a:avLst/>
@@ -13556,7 +12700,7 @@
                 <a:cs typeface="Google Sans Flex"/>
                 <a:sym typeface="Google Sans Flex"/>
               </a:rPr>
-              <a:t>Deterministic rules set the decision. On request, Gemini ranks saved evidence and templates render the explanation. No direct browser access to Firestore; no payment executes.</a:t>
+              <a:t>Cloud Run owns deterministic policy and Firestore writes. Gemini classifies context and orders recorded evidence on request; templates render explanations. No payment executes.</a:t>
             </a:r>
             <a:endParaRPr sz="1100">
               <a:solidFill>
@@ -13578,7 +12722,7 @@
 </p:sld>
 </file>
 
-<file path=ppt/slides/slide9.xml><?xml version="1.0" encoding="utf-8"?>
+<file path=ppt/slides/slide8.xml><?xml version="1.0" encoding="utf-8"?>
 <p:sld xmlns:a="http://schemas.openxmlformats.org/drawingml/2006/main" xmlns:r="http://schemas.openxmlformats.org/officeDocument/2006/relationships" xmlns:mc="http://schemas.openxmlformats.org/markup-compatibility/2006" xmlns:mv="urn:schemas-microsoft-com:mac:vml" xmlns:p="http://schemas.openxmlformats.org/presentationml/2006/main" xmlns:c="http://schemas.openxmlformats.org/drawingml/2006/chart" xmlns:dgm="http://schemas.openxmlformats.org/drawingml/2006/diagram" xmlns:o="urn:schemas-microsoft-com:office:office" xmlns:v="urn:schemas-microsoft-com:vml" xmlns:pvml="urn:schemas-microsoft-com:office:powerpoint" xmlns:com="http://schemas.openxmlformats.org/drawingml/2006/compatibility" xmlns:p14="http://schemas.microsoft.com/office/powerpoint/2010/main" xmlns:p15="http://schemas.microsoft.com/office/powerpoint/2012/main" xmlns:ahyp="http://schemas.microsoft.com/office/drawing/2018/hyperlinkcolor">
   <p:cSld>
     <p:spTree>
@@ -13597,7 +12741,7 @@
       </p:grpSpPr>
       <p:pic>
         <p:nvPicPr>
-          <p:cNvPr id="145" name="Google Shape;145;p21" title="Frame 144.png"/>
+          <p:cNvPr id="145" name="Google Shape;145;p20" title="Frame 144.png"/>
           <p:cNvPicPr preferRelativeResize="0"/>
           <p:nvPr/>
         </p:nvPicPr>
@@ -13624,7 +12768,7 @@
       </p:pic>
       <p:pic>
         <p:nvPicPr>
-          <p:cNvPr id="146" name="Google Shape;146;p21" title="Group 427319979.png"/>
+          <p:cNvPr id="146" name="Google Shape;146;p20" title="Group 427319979.png"/>
           <p:cNvPicPr preferRelativeResize="0"/>
           <p:nvPr/>
         </p:nvPicPr>
@@ -13652,7 +12796,7 @@
       </p:pic>
       <p:sp>
         <p:nvSpPr>
-          <p:cNvPr id="147" name="Google Shape;147;p21"/>
+          <p:cNvPr id="147" name="Google Shape;147;p20"/>
           <p:cNvSpPr/>
           <p:nvPr/>
         </p:nvSpPr>
@@ -13695,7 +12839,7 @@
       </p:sp>
       <p:sp>
         <p:nvSpPr>
-          <p:cNvPr id="148" name="Google Shape;148;p21"/>
+          <p:cNvPr id="148" name="Google Shape;148;p20"/>
           <p:cNvSpPr txBox="1"/>
           <p:nvPr/>
         </p:nvSpPr>
@@ -13747,7 +12891,7 @@
       </p:sp>
       <p:sp>
         <p:nvSpPr>
-          <p:cNvPr id="149" name="Google Shape;149;p21"/>
+          <p:cNvPr id="149" name="Google Shape;149;p20"/>
           <p:cNvSpPr txBox="1"/>
           <p:nvPr/>
         </p:nvSpPr>
@@ -13792,7 +12936,7 @@
                 <a:cs typeface="Google Sans Flex"/>
                 <a:sym typeface="Google Sans Flex"/>
               </a:rPr>
-              <a:t>APPLICATION</a:t>
+              <a:t>LIVE PROTOTYPE</a:t>
             </a:r>
             <a:endParaRPr sz="1300">
               <a:solidFill>
@@ -13827,7 +12971,77 @@
                 <a:cs typeface="Google Sans Flex"/>
                 <a:sym typeface="Google Sans Flex"/>
               </a:rPr>
-              <a:t>React and TypeScript client, Python FastAPI service, deterministic policy and evidence-backed case records.</a:t>
+              <a:t>React and TypeScript · Python FastAPI · deterministic policy</a:t>
+            </a:r>
+            <a:endParaRPr sz="1300">
+              <a:solidFill>
+                <a:srgbClr val="1F2926"/>
+              </a:solidFill>
+              <a:latin typeface="Google Sans Flex"/>
+              <a:ea typeface="Google Sans Flex"/>
+              <a:cs typeface="Google Sans Flex"/>
+              <a:sym typeface="Google Sans Flex"/>
+            </a:endParaRPr>
+          </a:p>
+          <a:p>
+            <a:pPr indent="0" lvl="0" marL="0" rtl="0" algn="l">
+              <a:lnSpc>
+                <a:spcPct val="112000"/>
+              </a:lnSpc>
+              <a:spcBef>
+                <a:spcPts val="600"/>
+              </a:spcBef>
+              <a:spcAft>
+                <a:spcPts val="0"/>
+              </a:spcAft>
+              <a:buNone/>
+            </a:pPr>
+            <a:r>
+              <a:rPr lang="en-GB" sz="1300">
+                <a:solidFill>
+                  <a:srgbClr val="1F2926"/>
+                </a:solidFill>
+                <a:latin typeface="Google Sans Flex"/>
+                <a:ea typeface="Google Sans Flex"/>
+                <a:cs typeface="Google Sans Flex"/>
+                <a:sym typeface="Google Sans Flex"/>
+              </a:rPr>
+              <a:t>Firebase anonymous authentication · Firestore · Cloud Run</a:t>
+            </a:r>
+            <a:endParaRPr sz="1300">
+              <a:solidFill>
+                <a:srgbClr val="1F2926"/>
+              </a:solidFill>
+              <a:latin typeface="Google Sans Flex"/>
+              <a:ea typeface="Google Sans Flex"/>
+              <a:cs typeface="Google Sans Flex"/>
+              <a:sym typeface="Google Sans Flex"/>
+            </a:endParaRPr>
+          </a:p>
+          <a:p>
+            <a:pPr indent="0" lvl="0" marL="0" rtl="0" algn="l">
+              <a:lnSpc>
+                <a:spcPct val="112000"/>
+              </a:lnSpc>
+              <a:spcBef>
+                <a:spcPts val="600"/>
+              </a:spcBef>
+              <a:spcAft>
+                <a:spcPts val="0"/>
+              </a:spcAft>
+              <a:buNone/>
+            </a:pPr>
+            <a:r>
+              <a:rPr lang="en-GB" sz="1300">
+                <a:solidFill>
+                  <a:srgbClr val="1F2926"/>
+                </a:solidFill>
+                <a:latin typeface="Google Sans Flex"/>
+                <a:ea typeface="Google Sans Flex"/>
+                <a:cs typeface="Google Sans Flex"/>
+                <a:sym typeface="Google Sans Flex"/>
+              </a:rPr>
+              <a:t>Vertex AI Gemini 2.5 Flash-Lite for invoice extraction and semantic classification</a:t>
             </a:r>
             <a:endParaRPr sz="1300">
               <a:solidFill>
@@ -13888,7 +13102,7 @@
                 <a:cs typeface="Google Sans Flex"/>
                 <a:sym typeface="Google Sans Flex"/>
               </a:rPr>
-              <a:t>GOOGLE CLOUD</a:t>
+              <a:t>NEXT CLASSIFIER: JEV</a:t>
             </a:r>
             <a:endParaRPr sz="1300">
               <a:solidFill>
@@ -13909,7 +13123,7 @@
                 <a:spcPts val="600"/>
               </a:spcBef>
               <a:spcAft>
-                <a:spcPts val="0"/>
+                <a:spcPts val="600"/>
               </a:spcAft>
               <a:buNone/>
             </a:pPr>
@@ -13923,7 +13137,278 @@
                 <a:cs typeface="Google Sans Flex"/>
                 <a:sym typeface="Google Sans Flex"/>
               </a:rPr>
-              <a:t>Firebase anonymous authentication, Firestore, Cloud Run and Vertex AI Gemini 2.5 Flash-Lite. Two live synthetic invoice paths returned Continue and Review.</a:t>
+              <a:t>Jev is a candidate structured decision model for a low-latency classification path. Its adapter passes fixture tests but is disabled on live GCP. Latency and quality remain unmeasured.</a:t>
+            </a:r>
+            <a:endParaRPr sz="1300">
+              <a:solidFill>
+                <a:srgbClr val="1F2926"/>
+              </a:solidFill>
+              <a:latin typeface="Google Sans Flex"/>
+              <a:ea typeface="Google Sans Flex"/>
+              <a:cs typeface="Google Sans Flex"/>
+              <a:sym typeface="Google Sans Flex"/>
+            </a:endParaRPr>
+          </a:p>
+        </p:txBody>
+      </p:sp>
+    </p:spTree>
+  </p:cSld>
+  <p:clrMapOvr>
+    <a:masterClrMapping/>
+  </p:clrMapOvr>
+</p:sld>
+</file>
+
+<file path=ppt/slides/slide9.xml><?xml version="1.0" encoding="utf-8"?>
+<p:sld xmlns:a="http://schemas.openxmlformats.org/drawingml/2006/main" xmlns:r="http://schemas.openxmlformats.org/officeDocument/2006/relationships" xmlns:mc="http://schemas.openxmlformats.org/markup-compatibility/2006" xmlns:mv="urn:schemas-microsoft-com:mac:vml" xmlns:p="http://schemas.openxmlformats.org/presentationml/2006/main" xmlns:c="http://schemas.openxmlformats.org/drawingml/2006/chart" xmlns:dgm="http://schemas.openxmlformats.org/drawingml/2006/diagram" xmlns:o="urn:schemas-microsoft-com:office:office" xmlns:v="urn:schemas-microsoft-com:vml" xmlns:pvml="urn:schemas-microsoft-com:office:powerpoint" xmlns:com="http://schemas.openxmlformats.org/drawingml/2006/compatibility" xmlns:p14="http://schemas.microsoft.com/office/powerpoint/2010/main" xmlns:p15="http://schemas.microsoft.com/office/powerpoint/2012/main" xmlns:ahyp="http://schemas.microsoft.com/office/drawing/2018/hyperlinkcolor">
+  <p:cSld>
+    <p:spTree>
+      <p:nvGrpSpPr>
+        <p:cNvPr id="153" name="Shape 153"/>
+        <p:cNvGrpSpPr/>
+        <p:nvPr/>
+      </p:nvGrpSpPr>
+      <p:grpSpPr>
+        <a:xfrm>
+          <a:off x="0" y="0"/>
+          <a:ext cx="0" cy="0"/>
+          <a:chOff x="0" y="0"/>
+          <a:chExt cx="0" cy="0"/>
+        </a:xfrm>
+      </p:grpSpPr>
+      <p:pic>
+        <p:nvPicPr>
+          <p:cNvPr id="154" name="Google Shape;154;p21" title="Frame 144.png"/>
+          <p:cNvPicPr preferRelativeResize="0"/>
+          <p:nvPr/>
+        </p:nvPicPr>
+        <p:blipFill rotWithShape="1">
+          <a:blip r:embed="rId3">
+            <a:alphaModFix/>
+          </a:blip>
+          <a:srcRect b="98001" l="0" r="0" t="0"/>
+          <a:stretch/>
+        </p:blipFill>
+        <p:spPr>
+          <a:xfrm>
+            <a:off x="0" y="5093562"/>
+            <a:ext cx="9144000" cy="54275"/>
+          </a:xfrm>
+          <a:prstGeom prst="rect">
+            <a:avLst/>
+          </a:prstGeom>
+          <a:noFill/>
+          <a:ln>
+            <a:noFill/>
+          </a:ln>
+        </p:spPr>
+      </p:pic>
+      <p:pic>
+        <p:nvPicPr>
+          <p:cNvPr id="155" name="Google Shape;155;p21" title="Group 427319979.png"/>
+          <p:cNvPicPr preferRelativeResize="0"/>
+          <p:nvPr/>
+        </p:nvPicPr>
+        <p:blipFill>
+          <a:blip r:embed="rId4">
+            <a:alphaModFix/>
+          </a:blip>
+          <a:stretch>
+            <a:fillRect/>
+          </a:stretch>
+        </p:blipFill>
+        <p:spPr>
+          <a:xfrm>
+            <a:off x="0" y="1"/>
+            <a:ext cx="9144000" cy="507359"/>
+          </a:xfrm>
+          <a:prstGeom prst="rect">
+            <a:avLst/>
+          </a:prstGeom>
+          <a:noFill/>
+          <a:ln>
+            <a:noFill/>
+          </a:ln>
+        </p:spPr>
+      </p:pic>
+      <p:sp>
+        <p:nvSpPr>
+          <p:cNvPr id="156" name="Google Shape;156;p21"/>
+          <p:cNvSpPr/>
+          <p:nvPr/>
+        </p:nvSpPr>
+        <p:spPr>
+          <a:xfrm>
+            <a:off x="-29250" y="5071875"/>
+            <a:ext cx="9173400" cy="97800"/>
+          </a:xfrm>
+          <a:prstGeom prst="rect">
+            <a:avLst/>
+          </a:prstGeom>
+          <a:solidFill>
+            <a:schemeClr val="dk1"/>
+          </a:solidFill>
+          <a:ln>
+            <a:noFill/>
+          </a:ln>
+        </p:spPr>
+        <p:txBody>
+          <a:bodyPr anchorCtr="0" anchor="ctr" bIns="91425" lIns="91425" spcFirstLastPara="1" rIns="91425" wrap="square" tIns="91425">
+            <a:noAutofit/>
+          </a:bodyPr>
+          <a:lstStyle/>
+          <a:p>
+            <a:pPr indent="0" lvl="0" marL="0" rtl="0" algn="ctr">
+              <a:spcBef>
+                <a:spcPts val="0"/>
+              </a:spcBef>
+              <a:spcAft>
+                <a:spcPts val="0"/>
+              </a:spcAft>
+              <a:buNone/>
+            </a:pPr>
+            <a:r>
+              <a:t/>
+            </a:r>
+            <a:endParaRPr/>
+          </a:p>
+        </p:txBody>
+      </p:sp>
+      <p:sp>
+        <p:nvSpPr>
+          <p:cNvPr id="157" name="Google Shape;157;p21"/>
+          <p:cNvSpPr txBox="1"/>
+          <p:nvPr/>
+        </p:nvSpPr>
+        <p:spPr>
+          <a:xfrm>
+            <a:off x="265350" y="663825"/>
+            <a:ext cx="8943000" cy="561900"/>
+          </a:xfrm>
+          <a:prstGeom prst="rect">
+            <a:avLst/>
+          </a:prstGeom>
+          <a:noFill/>
+          <a:ln>
+            <a:noFill/>
+          </a:ln>
+        </p:spPr>
+        <p:txBody>
+          <a:bodyPr anchorCtr="0" anchor="t" bIns="91425" lIns="91425" spcFirstLastPara="1" rIns="91425" wrap="square" tIns="91425">
+            <a:noAutofit/>
+          </a:bodyPr>
+          <a:lstStyle/>
+          <a:p>
+            <a:pPr indent="0" lvl="0" marL="0" rtl="0" algn="l">
+              <a:spcBef>
+                <a:spcPts val="0"/>
+              </a:spcBef>
+              <a:spcAft>
+                <a:spcPts val="0"/>
+              </a:spcAft>
+              <a:buNone/>
+            </a:pPr>
+            <a:r>
+              <a:rPr lang="en-GB" sz="1600">
+                <a:latin typeface="Google Sans Flex Medium"/>
+                <a:ea typeface="Google Sans Flex Medium"/>
+                <a:cs typeface="Google Sans Flex Medium"/>
+                <a:sym typeface="Google Sans Flex Medium"/>
+              </a:rPr>
+              <a:t>Cost and data safeguards</a:t>
+            </a:r>
+            <a:endParaRPr sz="1600">
+              <a:latin typeface="Google Sans Flex Medium"/>
+              <a:ea typeface="Google Sans Flex Medium"/>
+              <a:cs typeface="Google Sans Flex Medium"/>
+              <a:sym typeface="Google Sans Flex Medium"/>
+            </a:endParaRPr>
+          </a:p>
+        </p:txBody>
+      </p:sp>
+      <p:sp>
+        <p:nvSpPr>
+          <p:cNvPr id="158" name="Google Shape;158;p21"/>
+          <p:cNvSpPr txBox="1"/>
+          <p:nvPr/>
+        </p:nvSpPr>
+        <p:spPr>
+          <a:xfrm>
+            <a:off x="381000" y="1320800"/>
+            <a:ext cx="8382000" cy="3365400"/>
+          </a:xfrm>
+          <a:prstGeom prst="rect">
+            <a:avLst/>
+          </a:prstGeom>
+          <a:noFill/>
+          <a:ln>
+            <a:noFill/>
+          </a:ln>
+        </p:spPr>
+        <p:txBody>
+          <a:bodyPr anchorCtr="0" anchor="t" bIns="91425" lIns="91425" spcFirstLastPara="1" rIns="91425" wrap="square" tIns="91425">
+            <a:noAutofit/>
+          </a:bodyPr>
+          <a:lstStyle/>
+          <a:p>
+            <a:pPr indent="0" lvl="0" marL="0" rtl="0" algn="l">
+              <a:lnSpc>
+                <a:spcPct val="112000"/>
+              </a:lnSpc>
+              <a:spcBef>
+                <a:spcPts val="0"/>
+              </a:spcBef>
+              <a:spcAft>
+                <a:spcPts val="0"/>
+              </a:spcAft>
+              <a:buNone/>
+            </a:pPr>
+            <a:r>
+              <a:rPr lang="en-GB" sz="1300">
+                <a:solidFill>
+                  <a:srgbClr val="1F2926"/>
+                </a:solidFill>
+                <a:latin typeface="Google Sans Flex"/>
+                <a:ea typeface="Google Sans Flex"/>
+                <a:cs typeface="Google Sans Flex"/>
+                <a:sym typeface="Google Sans Flex"/>
+              </a:rPr>
+              <a:t>CLOUD COST STATUS</a:t>
+            </a:r>
+            <a:endParaRPr sz="1300">
+              <a:solidFill>
+                <a:srgbClr val="1F2926"/>
+              </a:solidFill>
+              <a:latin typeface="Google Sans Flex"/>
+              <a:ea typeface="Google Sans Flex"/>
+              <a:cs typeface="Google Sans Flex"/>
+              <a:sym typeface="Google Sans Flex"/>
+            </a:endParaRPr>
+          </a:p>
+          <a:p>
+            <a:pPr indent="0" lvl="0" marL="0" rtl="0" algn="l">
+              <a:lnSpc>
+                <a:spcPct val="112000"/>
+              </a:lnSpc>
+              <a:spcBef>
+                <a:spcPts val="600"/>
+              </a:spcBef>
+              <a:spcAft>
+                <a:spcPts val="0"/>
+              </a:spcAft>
+              <a:buNone/>
+            </a:pPr>
+            <a:r>
+              <a:rPr lang="en-GB" sz="1300">
+                <a:solidFill>
+                  <a:srgbClr val="1F2926"/>
+                </a:solidFill>
+                <a:latin typeface="Google Sans Flex"/>
+                <a:ea typeface="Google Sans Flex"/>
+                <a:cs typeface="Google Sans Flex"/>
+                <a:sym typeface="Google Sans Flex"/>
+              </a:rPr>
+              <a:t>Cloud Run, Firestore and Vertex AI calls may incur charges. Credit coverage is unconfirmed.</a:t>
             </a:r>
             <a:endParaRPr sz="1300">
               <a:solidFill>
@@ -13970,7 +13455,7 @@
                 <a:spcPts val="600"/>
               </a:spcBef>
               <a:spcAft>
-                <a:spcPts val="600"/>
+                <a:spcPts val="0"/>
               </a:spcAft>
               <a:buNone/>
             </a:pPr>
@@ -13984,7 +13469,164 @@
                 <a:cs typeface="Google Sans Flex"/>
                 <a:sym typeface="Google Sans Flex"/>
               </a:rPr>
-              <a:t>The app is human reviewed. Requested explanations use Gemini-ranked recorded evidence rendered with deterministic templates. No real payment is initiated.</a:t>
+              <a:t>A ₹100 project budget alert is configured through 6 November 2026. Alerts notify; they do not stop spending.</a:t>
+            </a:r>
+            <a:endParaRPr sz="1300">
+              <a:solidFill>
+                <a:srgbClr val="1F2926"/>
+              </a:solidFill>
+              <a:latin typeface="Google Sans Flex"/>
+              <a:ea typeface="Google Sans Flex"/>
+              <a:cs typeface="Google Sans Flex"/>
+              <a:sym typeface="Google Sans Flex"/>
+            </a:endParaRPr>
+          </a:p>
+          <a:p>
+            <a:pPr indent="0" lvl="0" marL="0" rtl="0" algn="l">
+              <a:lnSpc>
+                <a:spcPct val="112000"/>
+              </a:lnSpc>
+              <a:spcBef>
+                <a:spcPts val="600"/>
+              </a:spcBef>
+              <a:spcAft>
+                <a:spcPts val="0"/>
+              </a:spcAft>
+              <a:buNone/>
+            </a:pPr>
+            <a:r>
+              <a:t/>
+            </a:r>
+            <a:endParaRPr sz="1300">
+              <a:solidFill>
+                <a:srgbClr val="1F2926"/>
+              </a:solidFill>
+              <a:latin typeface="Google Sans Flex"/>
+              <a:ea typeface="Google Sans Flex"/>
+              <a:cs typeface="Google Sans Flex"/>
+              <a:sym typeface="Google Sans Flex"/>
+            </a:endParaRPr>
+          </a:p>
+          <a:p>
+            <a:pPr indent="0" lvl="0" marL="0" rtl="0" algn="l">
+              <a:lnSpc>
+                <a:spcPct val="112000"/>
+              </a:lnSpc>
+              <a:spcBef>
+                <a:spcPts val="600"/>
+              </a:spcBef>
+              <a:spcAft>
+                <a:spcPts val="0"/>
+              </a:spcAft>
+              <a:buNone/>
+            </a:pPr>
+            <a:r>
+              <a:rPr lang="en-GB" sz="1300">
+                <a:solidFill>
+                  <a:srgbClr val="1F2926"/>
+                </a:solidFill>
+                <a:latin typeface="Google Sans Flex"/>
+                <a:ea typeface="Google Sans Flex"/>
+                <a:cs typeface="Google Sans Flex"/>
+                <a:sym typeface="Google Sans Flex"/>
+              </a:rPr>
+              <a:t>MODEL REQUEST LIMITS</a:t>
+            </a:r>
+            <a:endParaRPr sz="1300">
+              <a:solidFill>
+                <a:srgbClr val="1F2926"/>
+              </a:solidFill>
+              <a:latin typeface="Google Sans Flex"/>
+              <a:ea typeface="Google Sans Flex"/>
+              <a:cs typeface="Google Sans Flex"/>
+              <a:sym typeface="Google Sans Flex"/>
+            </a:endParaRPr>
+          </a:p>
+          <a:p>
+            <a:pPr indent="0" lvl="0" marL="0" rtl="0" algn="l">
+              <a:lnSpc>
+                <a:spcPct val="112000"/>
+              </a:lnSpc>
+              <a:spcBef>
+                <a:spcPts val="600"/>
+              </a:spcBef>
+              <a:spcAft>
+                <a:spcPts val="0"/>
+              </a:spcAft>
+              <a:buNone/>
+            </a:pPr>
+            <a:r>
+              <a:rPr lang="en-GB" sz="1300">
+                <a:solidFill>
+                  <a:srgbClr val="1F2926"/>
+                </a:solidFill>
+                <a:latin typeface="Google Sans Flex"/>
+                <a:ea typeface="Google Sans Flex"/>
+                <a:cs typeface="Google Sans Flex"/>
+                <a:sym typeface="Google Sans Flex"/>
+              </a:rPr>
+              <a:t>9 attempts per visitor per day · 50 globally per day · 200 total. These restrict model calls and are not a billing cap.</a:t>
+            </a:r>
+            <a:endParaRPr sz="1300">
+              <a:solidFill>
+                <a:srgbClr val="1F2926"/>
+              </a:solidFill>
+              <a:latin typeface="Google Sans Flex"/>
+              <a:ea typeface="Google Sans Flex"/>
+              <a:cs typeface="Google Sans Flex"/>
+              <a:sym typeface="Google Sans Flex"/>
+            </a:endParaRPr>
+          </a:p>
+          <a:p>
+            <a:pPr indent="0" lvl="0" marL="0" rtl="0" algn="l">
+              <a:lnSpc>
+                <a:spcPct val="112000"/>
+              </a:lnSpc>
+              <a:spcBef>
+                <a:spcPts val="600"/>
+              </a:spcBef>
+              <a:spcAft>
+                <a:spcPts val="0"/>
+              </a:spcAft>
+              <a:buNone/>
+            </a:pPr>
+            <a:r>
+              <a:t/>
+            </a:r>
+            <a:endParaRPr sz="1300">
+              <a:solidFill>
+                <a:srgbClr val="1F2926"/>
+              </a:solidFill>
+              <a:latin typeface="Google Sans Flex"/>
+              <a:ea typeface="Google Sans Flex"/>
+              <a:cs typeface="Google Sans Flex"/>
+              <a:sym typeface="Google Sans Flex"/>
+            </a:endParaRPr>
+          </a:p>
+          <a:p>
+            <a:pPr indent="0" lvl="0" marL="0" rtl="0" algn="l">
+              <a:lnSpc>
+                <a:spcPct val="112000"/>
+              </a:lnSpc>
+              <a:spcBef>
+                <a:spcPts val="600"/>
+              </a:spcBef>
+              <a:spcAft>
+                <a:spcPts val="600"/>
+              </a:spcAft>
+              <a:buNone/>
+            </a:pPr>
+            <a:r>
+              <a:rPr lang="en-GB" sz="1300">
+                <a:solidFill>
+                  <a:srgbClr val="1F2926"/>
+                </a:solidFill>
+                <a:latin typeface="Google Sans Flex"/>
+                <a:ea typeface="Google Sans Flex"/>
+                <a:cs typeface="Google Sans Flex"/>
+                <a:sym typeface="Google Sans Flex"/>
+              </a:rPr>
+              <a:t>Use synthetic invoice data only.</a:t>
             </a:r>
             <a:endParaRPr sz="1300">
               <a:solidFill>

</xml_diff>

<commit_message>
Finalize Loom demo and clickable submission materials
</commit_message>
<xml_diff>
--- a/artifacts/scamshield-hack2skill-submission.pptx
+++ b/artifacts/scamshield-hack2skill-submission.pptx
@@ -2091,7 +2091,7 @@
             </a:pPr>
             <a:r>
               <a:rPr lang="en-GB"/>
-              <a:t>ScamShield uses Vertex AI Gemini 2.5 Flash-Lite, Firebase Authentication, Firestore and Cloud Run. The ₹100 budget alert through 6 Nov 2026 is not a spending cap. 59 backend tests passed. Live synthetic invoice checks covered extraction, classification, requested explanation, Firestore reads, idempotency, restart durability and visitor isolation. Use synthetic data only.</a:t>
+              <a:t>ScamShield uses Vertex AI Gemini 2.5 Flash-Lite, Firebase Authentication, Firestore and Cloud Run. 59 backend tests passed. Live synthetic invoice checks covered extraction, classification, requested explanation, Firestore reads, idempotency, restart durability and visitor isolation. Use synthetic data only.</a:t>
             </a:r>
             <a:endParaRPr/>
           </a:p>
@@ -8489,20 +8489,27 @@
               <a:buNone/>
             </a:pPr>
             <a:r>
-              <a:rPr lang="en-GB">
+              <a:rPr lang="en-GB" u="sng">
                 <a:solidFill>
-                  <a:srgbClr val="1F2926"/>
+                  <a:srgbClr val="14428C"/>
                 </a:solidFill>
                 <a:latin typeface="Google Sans Flex"/>
                 <a:ea typeface="Google Sans Flex"/>
                 <a:cs typeface="Google Sans Flex"/>
                 <a:sym typeface="Google Sans Flex"/>
+                <a:hlinkClick r:id="rId5">
+                  <a:extLst>
+                    <a:ext uri="{A12FA001-AC4F-418D-AE19-62706E023703}">
+                      <ahyp:hlinkClr val="tx"/>
+                    </a:ext>
+                  </a:extLst>
+                </a:hlinkClick>
               </a:rPr>
               <a:t>https://github.com/NikhilBudaniya/scamshield</a:t>
             </a:r>
             <a:endParaRPr>
               <a:solidFill>
-                <a:srgbClr val="1F2926"/>
+                <a:srgbClr val="14428C"/>
               </a:solidFill>
               <a:latin typeface="Google Sans Flex"/>
               <a:ea typeface="Google Sans Flex"/>
@@ -8585,20 +8592,27 @@
               <a:buNone/>
             </a:pPr>
             <a:r>
-              <a:rPr lang="en-GB">
+              <a:rPr lang="en-GB" u="sng">
                 <a:solidFill>
-                  <a:srgbClr val="1F2926"/>
+                  <a:srgbClr val="14428C"/>
                 </a:solidFill>
                 <a:latin typeface="Google Sans Flex"/>
                 <a:ea typeface="Google Sans Flex"/>
                 <a:cs typeface="Google Sans Flex"/>
                 <a:sym typeface="Google Sans Flex"/>
+                <a:hlinkClick r:id="rId6">
+                  <a:extLst>
+                    <a:ext uri="{A12FA001-AC4F-418D-AE19-62706E023703}">
+                      <ahyp:hlinkClr val="tx"/>
+                    </a:ext>
+                  </a:extLst>
+                </a:hlinkClick>
               </a:rPr>
               <a:t>https://scamshield-304420617883.us-central1.run.app</a:t>
             </a:r>
             <a:endParaRPr>
               <a:solidFill>
-                <a:srgbClr val="1F2926"/>
+                <a:srgbClr val="14428C"/>
               </a:solidFill>
               <a:latin typeface="Google Sans Flex"/>
               <a:ea typeface="Google Sans Flex"/>
@@ -8655,7 +8669,7 @@
                 <a:cs typeface="Google Sans Flex"/>
                 <a:sym typeface="Google Sans Flex"/>
               </a:rPr>
-              <a:t>3:03 demo video</a:t>
+              <a:t>Demo video</a:t>
             </a:r>
             <a:endParaRPr>
               <a:solidFill>
@@ -8689,7 +8703,7 @@
                 <a:ea typeface="Google Sans Flex"/>
                 <a:cs typeface="Google Sans Flex"/>
                 <a:sym typeface="Google Sans Flex"/>
-                <a:hlinkClick r:id="rId5">
+                <a:hlinkClick r:id="rId7">
                   <a:extLst>
                     <a:ext uri="{A12FA001-AC4F-418D-AE19-62706E023703}">
                       <ahyp:hlinkClr val="tx"/>
@@ -8697,9 +8711,9 @@
                   </a:extLst>
                 </a:hlinkClick>
               </a:rPr>
-              <a:t>Watch demo video (3:03)</a:t>
+              <a:t>Watch recorded demo</a:t>
             </a:r>
-            <a:endParaRPr u="sng">
+            <a:endParaRPr>
               <a:solidFill>
                 <a:srgbClr val="14428C"/>
               </a:solidFill>
@@ -13409,67 +13423,6 @@
                 <a:sym typeface="Google Sans Flex"/>
               </a:rPr>
               <a:t>Cloud Run, Firestore and Vertex AI calls may incur charges. Credit coverage is unconfirmed.</a:t>
-            </a:r>
-            <a:endParaRPr sz="1300">
-              <a:solidFill>
-                <a:srgbClr val="1F2926"/>
-              </a:solidFill>
-              <a:latin typeface="Google Sans Flex"/>
-              <a:ea typeface="Google Sans Flex"/>
-              <a:cs typeface="Google Sans Flex"/>
-              <a:sym typeface="Google Sans Flex"/>
-            </a:endParaRPr>
-          </a:p>
-          <a:p>
-            <a:pPr indent="0" lvl="0" marL="0" rtl="0" algn="l">
-              <a:lnSpc>
-                <a:spcPct val="112000"/>
-              </a:lnSpc>
-              <a:spcBef>
-                <a:spcPts val="600"/>
-              </a:spcBef>
-              <a:spcAft>
-                <a:spcPts val="0"/>
-              </a:spcAft>
-              <a:buNone/>
-            </a:pPr>
-            <a:r>
-              <a:t/>
-            </a:r>
-            <a:endParaRPr sz="1300">
-              <a:solidFill>
-                <a:srgbClr val="1F2926"/>
-              </a:solidFill>
-              <a:latin typeface="Google Sans Flex"/>
-              <a:ea typeface="Google Sans Flex"/>
-              <a:cs typeface="Google Sans Flex"/>
-              <a:sym typeface="Google Sans Flex"/>
-            </a:endParaRPr>
-          </a:p>
-          <a:p>
-            <a:pPr indent="0" lvl="0" marL="0" rtl="0" algn="l">
-              <a:lnSpc>
-                <a:spcPct val="112000"/>
-              </a:lnSpc>
-              <a:spcBef>
-                <a:spcPts val="600"/>
-              </a:spcBef>
-              <a:spcAft>
-                <a:spcPts val="0"/>
-              </a:spcAft>
-              <a:buNone/>
-            </a:pPr>
-            <a:r>
-              <a:rPr lang="en-GB" sz="1300">
-                <a:solidFill>
-                  <a:srgbClr val="1F2926"/>
-                </a:solidFill>
-                <a:latin typeface="Google Sans Flex"/>
-                <a:ea typeface="Google Sans Flex"/>
-                <a:cs typeface="Google Sans Flex"/>
-                <a:sym typeface="Google Sans Flex"/>
-              </a:rPr>
-              <a:t>A ₹100 project budget alert is configured through 6 November 2026. Alerts notify; they do not stop spending.</a:t>
             </a:r>
             <a:endParaRPr sz="1300">
               <a:solidFill>

</xml_diff>